<commit_message>
Add multi-model and ensemble SDM workflow
</commit_message>
<xml_diff>
--- a/slides/intro_sdm_dengue_brazil.pptx
+++ b/slides/intro_sdm_dengue_brazil.pptx
@@ -2,22 +2,22 @@
 <file path=ppt/presentation.xml><?xml version="1.0" encoding="utf-8"?>
 <p:presentation xmlns:p="http://schemas.openxmlformats.org/presentationml/2006/main">
   <p:sldMasterIdLst>
-    <p:sldMasterId xmlns:r="http://schemas.openxmlformats.org/officeDocument/2006/relationships" id="2147483648" r:id="R6606f66909a94957"/>
+    <p:sldMasterId xmlns:r="http://schemas.openxmlformats.org/officeDocument/2006/relationships" id="2147483648" r:id="Re2e056561f8d47d5"/>
   </p:sldMasterIdLst>
   <p:notesMasterIdLst>
-    <p:notesMasterId xmlns:r="http://schemas.openxmlformats.org/officeDocument/2006/relationships" r:id="R987e506a1b254012"/>
+    <p:notesMasterId xmlns:r="http://schemas.openxmlformats.org/officeDocument/2006/relationships" r:id="R0f6598530e7e4250"/>
   </p:notesMasterIdLst>
   <p:sldIdLst>
-    <p:sldId xmlns:r="http://schemas.openxmlformats.org/officeDocument/2006/relationships" id="256" r:id="Rdeeb74de1bb04ebd"/>
-    <p:sldId xmlns:r="http://schemas.openxmlformats.org/officeDocument/2006/relationships" id="257" r:id="R769f9ae7030245df"/>
-    <p:sldId xmlns:r="http://schemas.openxmlformats.org/officeDocument/2006/relationships" id="258" r:id="Re84508016f79478f"/>
-    <p:sldId xmlns:r="http://schemas.openxmlformats.org/officeDocument/2006/relationships" id="259" r:id="R030ec5105d0b4675"/>
-    <p:sldId xmlns:r="http://schemas.openxmlformats.org/officeDocument/2006/relationships" id="260" r:id="R7f7ba24a60fa4ffc"/>
-    <p:sldId xmlns:r="http://schemas.openxmlformats.org/officeDocument/2006/relationships" id="261" r:id="R6a52d9d3e3d7448f"/>
-    <p:sldId xmlns:r="http://schemas.openxmlformats.org/officeDocument/2006/relationships" id="262" r:id="R27758ede17b34698"/>
-    <p:sldId xmlns:r="http://schemas.openxmlformats.org/officeDocument/2006/relationships" id="263" r:id="R70d7119735114959"/>
-    <p:sldId xmlns:r="http://schemas.openxmlformats.org/officeDocument/2006/relationships" id="264" r:id="R720bcb7401634e21"/>
-    <p:sldId xmlns:r="http://schemas.openxmlformats.org/officeDocument/2006/relationships" id="265" r:id="Rdaa122435f3c4e44"/>
+    <p:sldId xmlns:r="http://schemas.openxmlformats.org/officeDocument/2006/relationships" id="256" r:id="R647ddcdf42494560"/>
+    <p:sldId xmlns:r="http://schemas.openxmlformats.org/officeDocument/2006/relationships" id="257" r:id="Ra1fb7341959f4fc3"/>
+    <p:sldId xmlns:r="http://schemas.openxmlformats.org/officeDocument/2006/relationships" id="258" r:id="R5ad380be495442c1"/>
+    <p:sldId xmlns:r="http://schemas.openxmlformats.org/officeDocument/2006/relationships" id="259" r:id="R239ca7b60ebc4985"/>
+    <p:sldId xmlns:r="http://schemas.openxmlformats.org/officeDocument/2006/relationships" id="260" r:id="R01d1d09f6ff84f37"/>
+    <p:sldId xmlns:r="http://schemas.openxmlformats.org/officeDocument/2006/relationships" id="261" r:id="R387f0c63bb9644b9"/>
+    <p:sldId xmlns:r="http://schemas.openxmlformats.org/officeDocument/2006/relationships" id="262" r:id="Re75d9bd905974f5b"/>
+    <p:sldId xmlns:r="http://schemas.openxmlformats.org/officeDocument/2006/relationships" id="263" r:id="R0d52f88ee21041f6"/>
+    <p:sldId xmlns:r="http://schemas.openxmlformats.org/officeDocument/2006/relationships" id="264" r:id="R4f086e7650114168"/>
+    <p:sldId xmlns:r="http://schemas.openxmlformats.org/officeDocument/2006/relationships" id="265" r:id="Rd87965b515dd40d5"/>
   </p:sldIdLst>
   <p:sldSz cx="12192000" cy="6858000"/>
   <p:notesSz cx="6858000" cy="9144000"/>
@@ -1001,7 +1001,12 @@
           </a:p>
           <a:p xmlns:a="http://schemas.openxmlformats.org/drawingml/2006/main">
             <a:r>
-              <a:t>Mention that RF/ensembles are useful extensions once the first workflow is stable.</a:t>
+              <a:t>Mention that GLM, GBM, and RF are examples, not automatic recommendations.</a:t>
+            </a:r>
+          </a:p>
+          <a:p xmlns:a="http://schemas.openxmlformats.org/drawingml/2006/main">
+            <a:r>
+              <a:t>Preview that the ensemble combines predictions from the individual models.</a:t>
             </a:r>
           </a:p>
         </p:txBody>
@@ -1294,7 +1299,7 @@
   </p:cSld>
   <p:clrMap bg1="lt1" tx1="dk1" bg2="lt2" tx2="dk2" accent1="accent1" accent2="accent2" accent3="accent3" accent4="accent4" accent5="accent5" accent6="accent6" hlink="hlink" folHlink="folHlink"/>
   <p:sldLayoutIdLst>
-    <p:sldLayoutId xmlns:r="http://schemas.openxmlformats.org/officeDocument/2006/relationships" id="2147483649" r:id="R9f4bddd36b3e4c1f"/>
+    <p:sldLayoutId xmlns:r="http://schemas.openxmlformats.org/officeDocument/2006/relationships" id="2147483649" r:id="R98096d28a66848ce"/>
   </p:sldLayoutIdLst>
   <p:txStyles>
     <p:titleStyle>
@@ -1849,7 +1854,7 @@
           <p:nvPr/>
         </p:nvPicPr>
         <p:blipFill>
-          <a:blip xmlns:r="http://schemas.openxmlformats.org/officeDocument/2006/relationships" xmlns:a="http://schemas.openxmlformats.org/drawingml/2006/main" r:embed="R35b13379eb564748"/>
+          <a:blip xmlns:r="http://schemas.openxmlformats.org/officeDocument/2006/relationships" xmlns:a="http://schemas.openxmlformats.org/drawingml/2006/main" r:embed="Rb383b3904c054f45"/>
           <a:stretch xmlns:a="http://schemas.openxmlformats.org/drawingml/2006/main"/>
         </p:blipFill>
         <p:spPr>
@@ -1867,7 +1872,7 @@
           <p:cNvPr id="2" name="">
             <a:extLst xmlns:a="http://schemas.openxmlformats.org/drawingml/2006/main">
               <a:ext uri="{FF2B5EF4-FFF2-40B4-BE49-F238E27FC236}">
-                <a16:creationId xmlns:a16="http://schemas.microsoft.com/office/drawing/2014/main" id="{5F93B7D8-F87F-446C-99F2-BF398848EE39}"/>
+                <a16:creationId xmlns:a16="http://schemas.microsoft.com/office/drawing/2014/main" id="{18E94CCF-AB47-47AE-AFFF-50B61C77C248}"/>
               </a:ext>
             </a:extLst>
           </p:cNvPr>
@@ -1902,7 +1907,7 @@
           <p:cNvPr id="3" name="">
             <a:extLst xmlns:a="http://schemas.openxmlformats.org/drawingml/2006/main">
               <a:ext uri="{FF2B5EF4-FFF2-40B4-BE49-F238E27FC236}">
-                <a16:creationId xmlns:a16="http://schemas.microsoft.com/office/drawing/2014/main" id="{9EF1A495-7A10-4F31-90DC-08253809CAED}"/>
+                <a16:creationId xmlns:a16="http://schemas.microsoft.com/office/drawing/2014/main" id="{892A6406-7640-41B6-9F0A-FCCB421F6AE8}"/>
               </a:ext>
             </a:extLst>
           </p:cNvPr>
@@ -1935,7 +1940,7 @@
           <p:cNvPr id="4" name="">
             <a:extLst xmlns:a="http://schemas.openxmlformats.org/drawingml/2006/main">
               <a:ext uri="{FF2B5EF4-FFF2-40B4-BE49-F238E27FC236}">
-                <a16:creationId xmlns:a16="http://schemas.microsoft.com/office/drawing/2014/main" id="{C8DA8437-82B4-4EC0-A141-1B64E241681E}"/>
+                <a16:creationId xmlns:a16="http://schemas.microsoft.com/office/drawing/2014/main" id="{6654909F-44BB-40B9-9CD9-F68224501390}"/>
               </a:ext>
             </a:extLst>
           </p:cNvPr>
@@ -1985,7 +1990,7 @@
           <p:cNvPr id="5" name="">
             <a:extLst xmlns:a="http://schemas.openxmlformats.org/drawingml/2006/main">
               <a:ext uri="{FF2B5EF4-FFF2-40B4-BE49-F238E27FC236}">
-                <a16:creationId xmlns:a16="http://schemas.microsoft.com/office/drawing/2014/main" id="{3B2B34D0-39CC-418C-9434-2731608EA8E7}"/>
+                <a16:creationId xmlns:a16="http://schemas.microsoft.com/office/drawing/2014/main" id="{AFF51604-C906-4CD4-B6D5-23E091A8A365}"/>
               </a:ext>
             </a:extLst>
           </p:cNvPr>
@@ -2035,7 +2040,7 @@
           <p:cNvPr id="6" name="">
             <a:extLst xmlns:a="http://schemas.openxmlformats.org/drawingml/2006/main">
               <a:ext uri="{FF2B5EF4-FFF2-40B4-BE49-F238E27FC236}">
-                <a16:creationId xmlns:a16="http://schemas.microsoft.com/office/drawing/2014/main" id="{FCFC09E6-21C6-4B88-B15E-6E29E8C6030B}"/>
+                <a16:creationId xmlns:a16="http://schemas.microsoft.com/office/drawing/2014/main" id="{1FBB7160-51E2-41F3-9063-1F01C65E7B47}"/>
               </a:ext>
             </a:extLst>
           </p:cNvPr>
@@ -2083,7 +2088,7 @@
     </p:spTree>
     <p:extLst>
       <p:ext uri="{BB962C8B-B14F-4D97-AF65-F5344CB8AC3E}">
-        <p14:creationId xmlns:p14="http://schemas.microsoft.com/office/powerpoint/2010/main" val="883039520"/>
+        <p14:creationId xmlns:p14="http://schemas.microsoft.com/office/powerpoint/2010/main" val="1785259073"/>
       </p:ext>
     </p:extLst>
   </p:cSld>
@@ -2114,7 +2119,7 @@
           <p:cNvPr id="1" name="">
             <a:extLst xmlns:a="http://schemas.openxmlformats.org/drawingml/2006/main">
               <a:ext uri="{FF2B5EF4-FFF2-40B4-BE49-F238E27FC236}">
-                <a16:creationId xmlns:a16="http://schemas.microsoft.com/office/drawing/2014/main" id="{55E830F8-2F22-4783-AFCA-475540104858}"/>
+                <a16:creationId xmlns:a16="http://schemas.microsoft.com/office/drawing/2014/main" id="{E0B5FA7B-EA15-4082-B48A-C9C74755B59F}"/>
               </a:ext>
             </a:extLst>
           </p:cNvPr>
@@ -2164,7 +2169,7 @@
           <p:cNvPr id="2" name="">
             <a:extLst xmlns:a="http://schemas.openxmlformats.org/drawingml/2006/main">
               <a:ext uri="{FF2B5EF4-FFF2-40B4-BE49-F238E27FC236}">
-                <a16:creationId xmlns:a16="http://schemas.microsoft.com/office/drawing/2014/main" id="{8D20C4E8-1C73-4552-B70F-9D3A3E894D14}"/>
+                <a16:creationId xmlns:a16="http://schemas.microsoft.com/office/drawing/2014/main" id="{73BEB852-B362-4B5E-BAE4-637505291D58}"/>
               </a:ext>
             </a:extLst>
           </p:cNvPr>
@@ -2214,7 +2219,7 @@
           <p:cNvPr id="3" name="">
             <a:extLst xmlns:a="http://schemas.openxmlformats.org/drawingml/2006/main">
               <a:ext uri="{FF2B5EF4-FFF2-40B4-BE49-F238E27FC236}">
-                <a16:creationId xmlns:a16="http://schemas.microsoft.com/office/drawing/2014/main" id="{A242680E-EF5D-4F3D-AD0D-C8883FDAEAA0}"/>
+                <a16:creationId xmlns:a16="http://schemas.microsoft.com/office/drawing/2014/main" id="{EA3C2CB5-A765-4A1B-AA2B-7727799E2A6D}"/>
               </a:ext>
             </a:extLst>
           </p:cNvPr>
@@ -2249,7 +2254,7 @@
           <p:cNvPr id="4" name="">
             <a:extLst xmlns:a="http://schemas.openxmlformats.org/drawingml/2006/main">
               <a:ext uri="{FF2B5EF4-FFF2-40B4-BE49-F238E27FC236}">
-                <a16:creationId xmlns:a16="http://schemas.microsoft.com/office/drawing/2014/main" id="{0B1E6433-C5A4-43E9-85DA-C6F19F78995D}"/>
+                <a16:creationId xmlns:a16="http://schemas.microsoft.com/office/drawing/2014/main" id="{5A3088D6-3344-4799-9BD7-E3A7B6620BF8}"/>
               </a:ext>
             </a:extLst>
           </p:cNvPr>
@@ -2299,7 +2304,7 @@
           <p:cNvPr id="5" name="">
             <a:extLst xmlns:a="http://schemas.openxmlformats.org/drawingml/2006/main">
               <a:ext uri="{FF2B5EF4-FFF2-40B4-BE49-F238E27FC236}">
-                <a16:creationId xmlns:a16="http://schemas.microsoft.com/office/drawing/2014/main" id="{C47B97E1-F024-44A4-87CD-1CE94FA7F61E}"/>
+                <a16:creationId xmlns:a16="http://schemas.microsoft.com/office/drawing/2014/main" id="{2FB0759F-42B8-4F39-A4ED-E3BC8073A229}"/>
               </a:ext>
             </a:extLst>
           </p:cNvPr>
@@ -2349,7 +2354,7 @@
           <p:cNvPr id="6" name="">
             <a:extLst xmlns:a="http://schemas.openxmlformats.org/drawingml/2006/main">
               <a:ext uri="{FF2B5EF4-FFF2-40B4-BE49-F238E27FC236}">
-                <a16:creationId xmlns:a16="http://schemas.microsoft.com/office/drawing/2014/main" id="{29AF8057-7153-4470-9244-0E6B9659908C}"/>
+                <a16:creationId xmlns:a16="http://schemas.microsoft.com/office/drawing/2014/main" id="{D6788452-438B-419C-8B6D-701D74904C5C}"/>
               </a:ext>
             </a:extLst>
           </p:cNvPr>
@@ -2384,7 +2389,7 @@
           <p:cNvPr id="7" name="">
             <a:extLst xmlns:a="http://schemas.openxmlformats.org/drawingml/2006/main">
               <a:ext uri="{FF2B5EF4-FFF2-40B4-BE49-F238E27FC236}">
-                <a16:creationId xmlns:a16="http://schemas.microsoft.com/office/drawing/2014/main" id="{160C4C11-34B8-4373-8A9C-1186A89D603C}"/>
+                <a16:creationId xmlns:a16="http://schemas.microsoft.com/office/drawing/2014/main" id="{B88FC5DA-D38A-4211-8AE6-826FBBBEEB6C}"/>
               </a:ext>
             </a:extLst>
           </p:cNvPr>
@@ -2434,7 +2439,7 @@
           <p:cNvPr id="8" name="">
             <a:extLst xmlns:a="http://schemas.openxmlformats.org/drawingml/2006/main">
               <a:ext uri="{FF2B5EF4-FFF2-40B4-BE49-F238E27FC236}">
-                <a16:creationId xmlns:a16="http://schemas.microsoft.com/office/drawing/2014/main" id="{A61A3081-1021-4A8F-B91F-103CA219BC91}"/>
+                <a16:creationId xmlns:a16="http://schemas.microsoft.com/office/drawing/2014/main" id="{20ED8C9B-3516-4A1D-B18C-A9BAA2A469A0}"/>
               </a:ext>
             </a:extLst>
           </p:cNvPr>
@@ -2484,7 +2489,7 @@
           <p:cNvPr id="9" name="">
             <a:extLst xmlns:a="http://schemas.openxmlformats.org/drawingml/2006/main">
               <a:ext uri="{FF2B5EF4-FFF2-40B4-BE49-F238E27FC236}">
-                <a16:creationId xmlns:a16="http://schemas.microsoft.com/office/drawing/2014/main" id="{FF3093AE-30A4-4680-A311-F82C2B457A31}"/>
+                <a16:creationId xmlns:a16="http://schemas.microsoft.com/office/drawing/2014/main" id="{C3810706-C08E-4CF4-A702-A16A84D06619}"/>
               </a:ext>
             </a:extLst>
           </p:cNvPr>
@@ -2519,7 +2524,7 @@
           <p:cNvPr id="10" name="">
             <a:extLst xmlns:a="http://schemas.openxmlformats.org/drawingml/2006/main">
               <a:ext uri="{FF2B5EF4-FFF2-40B4-BE49-F238E27FC236}">
-                <a16:creationId xmlns:a16="http://schemas.microsoft.com/office/drawing/2014/main" id="{EACEDB1F-15EE-495E-B1EA-F2E1ECC2DB07}"/>
+                <a16:creationId xmlns:a16="http://schemas.microsoft.com/office/drawing/2014/main" id="{96EEB950-7B76-4D60-9936-ED9789018A18}"/>
               </a:ext>
             </a:extLst>
           </p:cNvPr>
@@ -2569,7 +2574,7 @@
           <p:cNvPr id="11" name="">
             <a:extLst xmlns:a="http://schemas.openxmlformats.org/drawingml/2006/main">
               <a:ext uri="{FF2B5EF4-FFF2-40B4-BE49-F238E27FC236}">
-                <a16:creationId xmlns:a16="http://schemas.microsoft.com/office/drawing/2014/main" id="{0216112D-07EA-453C-892F-4672480DC102}"/>
+                <a16:creationId xmlns:a16="http://schemas.microsoft.com/office/drawing/2014/main" id="{B701EF54-2AFF-4A33-897F-394AF4A20A5B}"/>
               </a:ext>
             </a:extLst>
           </p:cNvPr>
@@ -2619,7 +2624,7 @@
           <p:cNvPr id="12" name="">
             <a:extLst xmlns:a="http://schemas.openxmlformats.org/drawingml/2006/main">
               <a:ext uri="{FF2B5EF4-FFF2-40B4-BE49-F238E27FC236}">
-                <a16:creationId xmlns:a16="http://schemas.microsoft.com/office/drawing/2014/main" id="{063B6AF5-BC70-4E6B-ABB4-EA03A264934B}"/>
+                <a16:creationId xmlns:a16="http://schemas.microsoft.com/office/drawing/2014/main" id="{FF064792-03E1-43BE-AF7B-44F447BB6742}"/>
               </a:ext>
             </a:extLst>
           </p:cNvPr>
@@ -2667,7 +2672,7 @@
     </p:spTree>
     <p:extLst>
       <p:ext uri="{BB962C8B-B14F-4D97-AF65-F5344CB8AC3E}">
-        <p14:creationId xmlns:p14="http://schemas.microsoft.com/office/powerpoint/2010/main" val="584084600"/>
+        <p14:creationId xmlns:p14="http://schemas.microsoft.com/office/powerpoint/2010/main" val="2031312814"/>
       </p:ext>
     </p:extLst>
   </p:cSld>
@@ -2698,7 +2703,7 @@
           <p:cNvPr id="1" name="">
             <a:extLst xmlns:a="http://schemas.openxmlformats.org/drawingml/2006/main">
               <a:ext uri="{FF2B5EF4-FFF2-40B4-BE49-F238E27FC236}">
-                <a16:creationId xmlns:a16="http://schemas.microsoft.com/office/drawing/2014/main" id="{E30BE5E9-3C24-4A62-B589-D6DE717860A0}"/>
+                <a16:creationId xmlns:a16="http://schemas.microsoft.com/office/drawing/2014/main" id="{90585706-A029-4D0B-AA0F-A38C6D1FB8DA}"/>
               </a:ext>
             </a:extLst>
           </p:cNvPr>
@@ -2748,7 +2753,7 @@
           <p:cNvPr id="2" name="">
             <a:extLst xmlns:a="http://schemas.openxmlformats.org/drawingml/2006/main">
               <a:ext uri="{FF2B5EF4-FFF2-40B4-BE49-F238E27FC236}">
-                <a16:creationId xmlns:a16="http://schemas.microsoft.com/office/drawing/2014/main" id="{4879D6E6-9ED8-4115-91FE-9852E0F2BF3F}"/>
+                <a16:creationId xmlns:a16="http://schemas.microsoft.com/office/drawing/2014/main" id="{5FD06458-F796-4248-AF6D-01EFA6953285}"/>
               </a:ext>
             </a:extLst>
           </p:cNvPr>
@@ -2798,7 +2803,7 @@
           <p:cNvPr id="3" name="">
             <a:extLst xmlns:a="http://schemas.openxmlformats.org/drawingml/2006/main">
               <a:ext uri="{FF2B5EF4-FFF2-40B4-BE49-F238E27FC236}">
-                <a16:creationId xmlns:a16="http://schemas.microsoft.com/office/drawing/2014/main" id="{455ECC56-2300-4BC4-9502-E21E2BF5E31F}"/>
+                <a16:creationId xmlns:a16="http://schemas.microsoft.com/office/drawing/2014/main" id="{19DF14C6-E0FB-4BE7-8B41-5DD2F0592C84}"/>
               </a:ext>
             </a:extLst>
           </p:cNvPr>
@@ -2848,7 +2853,7 @@
           <p:cNvPr id="4" name="">
             <a:extLst xmlns:a="http://schemas.openxmlformats.org/drawingml/2006/main">
               <a:ext uri="{FF2B5EF4-FFF2-40B4-BE49-F238E27FC236}">
-                <a16:creationId xmlns:a16="http://schemas.microsoft.com/office/drawing/2014/main" id="{D856A2DD-B3F1-418B-A856-9B453600B852}"/>
+                <a16:creationId xmlns:a16="http://schemas.microsoft.com/office/drawing/2014/main" id="{0D87E6EA-40BE-4971-BFEE-3667CF019FDD}"/>
               </a:ext>
             </a:extLst>
           </p:cNvPr>
@@ -2883,7 +2888,7 @@
           <p:cNvPr id="5" name="">
             <a:extLst xmlns:a="http://schemas.openxmlformats.org/drawingml/2006/main">
               <a:ext uri="{FF2B5EF4-FFF2-40B4-BE49-F238E27FC236}">
-                <a16:creationId xmlns:a16="http://schemas.microsoft.com/office/drawing/2014/main" id="{548D4664-6925-4585-924B-321F90ED6AB9}"/>
+                <a16:creationId xmlns:a16="http://schemas.microsoft.com/office/drawing/2014/main" id="{E781F155-39CF-44C7-9095-856ECEB42980}"/>
               </a:ext>
             </a:extLst>
           </p:cNvPr>
@@ -2933,7 +2938,7 @@
           <p:cNvPr id="6" name="">
             <a:extLst xmlns:a="http://schemas.openxmlformats.org/drawingml/2006/main">
               <a:ext uri="{FF2B5EF4-FFF2-40B4-BE49-F238E27FC236}">
-                <a16:creationId xmlns:a16="http://schemas.microsoft.com/office/drawing/2014/main" id="{07D18DFC-2EEA-4661-9988-B9F8A9B4C143}"/>
+                <a16:creationId xmlns:a16="http://schemas.microsoft.com/office/drawing/2014/main" id="{C8B9AC36-59E9-4772-A474-8DD2F4754DAE}"/>
               </a:ext>
             </a:extLst>
           </p:cNvPr>
@@ -2983,7 +2988,7 @@
           <p:cNvPr id="7" name="">
             <a:extLst xmlns:a="http://schemas.openxmlformats.org/drawingml/2006/main">
               <a:ext uri="{FF2B5EF4-FFF2-40B4-BE49-F238E27FC236}">
-                <a16:creationId xmlns:a16="http://schemas.microsoft.com/office/drawing/2014/main" id="{46621130-85E4-4EA9-85E6-D7CCD0674C18}"/>
+                <a16:creationId xmlns:a16="http://schemas.microsoft.com/office/drawing/2014/main" id="{FDA89945-5796-496F-9FEE-3B00D79C74D7}"/>
               </a:ext>
             </a:extLst>
           </p:cNvPr>
@@ -3018,7 +3023,7 @@
           <p:cNvPr id="8" name="">
             <a:extLst xmlns:a="http://schemas.openxmlformats.org/drawingml/2006/main">
               <a:ext uri="{FF2B5EF4-FFF2-40B4-BE49-F238E27FC236}">
-                <a16:creationId xmlns:a16="http://schemas.microsoft.com/office/drawing/2014/main" id="{466439F0-0B17-417D-B0A7-6CF1240B9B76}"/>
+                <a16:creationId xmlns:a16="http://schemas.microsoft.com/office/drawing/2014/main" id="{DFE722DE-1015-423E-8A3A-2446ED8FDC26}"/>
               </a:ext>
             </a:extLst>
           </p:cNvPr>
@@ -3068,7 +3073,7 @@
           <p:cNvPr id="9" name="">
             <a:extLst xmlns:a="http://schemas.openxmlformats.org/drawingml/2006/main">
               <a:ext uri="{FF2B5EF4-FFF2-40B4-BE49-F238E27FC236}">
-                <a16:creationId xmlns:a16="http://schemas.microsoft.com/office/drawing/2014/main" id="{C0DC8D05-7D23-4626-88F9-D98E68383781}"/>
+                <a16:creationId xmlns:a16="http://schemas.microsoft.com/office/drawing/2014/main" id="{D527F5BB-7AA6-463F-8C21-52922C15F878}"/>
               </a:ext>
             </a:extLst>
           </p:cNvPr>
@@ -3118,7 +3123,7 @@
           <p:cNvPr id="10" name="">
             <a:extLst xmlns:a="http://schemas.openxmlformats.org/drawingml/2006/main">
               <a:ext uri="{FF2B5EF4-FFF2-40B4-BE49-F238E27FC236}">
-                <a16:creationId xmlns:a16="http://schemas.microsoft.com/office/drawing/2014/main" id="{7EB582FC-03AE-4678-85F2-124F2187EDD4}"/>
+                <a16:creationId xmlns:a16="http://schemas.microsoft.com/office/drawing/2014/main" id="{044B90C6-2776-4E26-B1C8-0ACB0F0EA9B7}"/>
               </a:ext>
             </a:extLst>
           </p:cNvPr>
@@ -3153,7 +3158,7 @@
           <p:cNvPr id="11" name="">
             <a:extLst xmlns:a="http://schemas.openxmlformats.org/drawingml/2006/main">
               <a:ext uri="{FF2B5EF4-FFF2-40B4-BE49-F238E27FC236}">
-                <a16:creationId xmlns:a16="http://schemas.microsoft.com/office/drawing/2014/main" id="{983BE1BA-F19D-49D1-858F-A44146194F63}"/>
+                <a16:creationId xmlns:a16="http://schemas.microsoft.com/office/drawing/2014/main" id="{D1D75B6E-C086-4B51-8B4E-12DA8E66797E}"/>
               </a:ext>
             </a:extLst>
           </p:cNvPr>
@@ -3203,7 +3208,7 @@
           <p:cNvPr id="12" name="">
             <a:extLst xmlns:a="http://schemas.openxmlformats.org/drawingml/2006/main">
               <a:ext uri="{FF2B5EF4-FFF2-40B4-BE49-F238E27FC236}">
-                <a16:creationId xmlns:a16="http://schemas.microsoft.com/office/drawing/2014/main" id="{AAA9A96F-3CC7-458C-9ADD-3487166CEF12}"/>
+                <a16:creationId xmlns:a16="http://schemas.microsoft.com/office/drawing/2014/main" id="{518A6CB3-7D89-44A1-A657-86F1EBC7FD3D}"/>
               </a:ext>
             </a:extLst>
           </p:cNvPr>
@@ -3253,7 +3258,7 @@
           <p:cNvPr id="13" name="">
             <a:extLst xmlns:a="http://schemas.openxmlformats.org/drawingml/2006/main">
               <a:ext uri="{FF2B5EF4-FFF2-40B4-BE49-F238E27FC236}">
-                <a16:creationId xmlns:a16="http://schemas.microsoft.com/office/drawing/2014/main" id="{1252053B-EC43-43EC-93BE-F864045587F5}"/>
+                <a16:creationId xmlns:a16="http://schemas.microsoft.com/office/drawing/2014/main" id="{CBD5A4C5-DE85-4176-A29D-59ED007085A6}"/>
               </a:ext>
             </a:extLst>
           </p:cNvPr>
@@ -3303,7 +3308,7 @@
           <p:cNvPr id="14" name="">
             <a:extLst xmlns:a="http://schemas.openxmlformats.org/drawingml/2006/main">
               <a:ext uri="{FF2B5EF4-FFF2-40B4-BE49-F238E27FC236}">
-                <a16:creationId xmlns:a16="http://schemas.microsoft.com/office/drawing/2014/main" id="{65F5130E-3D45-4B9A-BAB4-6C0C03300371}"/>
+                <a16:creationId xmlns:a16="http://schemas.microsoft.com/office/drawing/2014/main" id="{10FE0336-BD5C-408F-8050-FCBCF0493600}"/>
               </a:ext>
             </a:extLst>
           </p:cNvPr>
@@ -3351,7 +3356,7 @@
     </p:spTree>
     <p:extLst>
       <p:ext uri="{BB962C8B-B14F-4D97-AF65-F5344CB8AC3E}">
-        <p14:creationId xmlns:p14="http://schemas.microsoft.com/office/powerpoint/2010/main" val="1545461813"/>
+        <p14:creationId xmlns:p14="http://schemas.microsoft.com/office/powerpoint/2010/main" val="330491617"/>
       </p:ext>
     </p:extLst>
   </p:cSld>
@@ -3382,7 +3387,7 @@
           <p:cNvPr id="1" name="">
             <a:extLst xmlns:a="http://schemas.openxmlformats.org/drawingml/2006/main">
               <a:ext uri="{FF2B5EF4-FFF2-40B4-BE49-F238E27FC236}">
-                <a16:creationId xmlns:a16="http://schemas.microsoft.com/office/drawing/2014/main" id="{51A43108-529E-457D-BA8D-5ACE4F89745E}"/>
+                <a16:creationId xmlns:a16="http://schemas.microsoft.com/office/drawing/2014/main" id="{3698B463-4EA6-421B-BFC9-51B3F70B6AF4}"/>
               </a:ext>
             </a:extLst>
           </p:cNvPr>
@@ -3432,7 +3437,7 @@
           <p:cNvPr id="2" name="">
             <a:extLst xmlns:a="http://schemas.openxmlformats.org/drawingml/2006/main">
               <a:ext uri="{FF2B5EF4-FFF2-40B4-BE49-F238E27FC236}">
-                <a16:creationId xmlns:a16="http://schemas.microsoft.com/office/drawing/2014/main" id="{E13374E5-38C0-41E2-99E6-2BE015282185}"/>
+                <a16:creationId xmlns:a16="http://schemas.microsoft.com/office/drawing/2014/main" id="{E390A3C1-42B0-48D1-B4C6-F51513E2D876}"/>
               </a:ext>
             </a:extLst>
           </p:cNvPr>
@@ -3482,7 +3487,7 @@
           <p:cNvPr id="3" name="">
             <a:extLst xmlns:a="http://schemas.openxmlformats.org/drawingml/2006/main">
               <a:ext uri="{FF2B5EF4-FFF2-40B4-BE49-F238E27FC236}">
-                <a16:creationId xmlns:a16="http://schemas.microsoft.com/office/drawing/2014/main" id="{56E40F6C-D4A9-440E-B98B-26E0A0147E5E}"/>
+                <a16:creationId xmlns:a16="http://schemas.microsoft.com/office/drawing/2014/main" id="{00D39FBE-58FD-4243-B058-83D359179432}"/>
               </a:ext>
             </a:extLst>
           </p:cNvPr>
@@ -3517,7 +3522,7 @@
           <p:cNvPr id="4" name="">
             <a:extLst xmlns:a="http://schemas.openxmlformats.org/drawingml/2006/main">
               <a:ext uri="{FF2B5EF4-FFF2-40B4-BE49-F238E27FC236}">
-                <a16:creationId xmlns:a16="http://schemas.microsoft.com/office/drawing/2014/main" id="{3CC4D98A-CC26-41FC-9A29-165682D28C29}"/>
+                <a16:creationId xmlns:a16="http://schemas.microsoft.com/office/drawing/2014/main" id="{BE9B4A1C-9CD9-4075-93A3-14F556DA0420}"/>
               </a:ext>
             </a:extLst>
           </p:cNvPr>
@@ -3567,7 +3572,7 @@
           <p:cNvPr id="5" name="">
             <a:extLst xmlns:a="http://schemas.openxmlformats.org/drawingml/2006/main">
               <a:ext uri="{FF2B5EF4-FFF2-40B4-BE49-F238E27FC236}">
-                <a16:creationId xmlns:a16="http://schemas.microsoft.com/office/drawing/2014/main" id="{B9BEDA3B-5BC9-4EE1-ADEA-1174A9E10159}"/>
+                <a16:creationId xmlns:a16="http://schemas.microsoft.com/office/drawing/2014/main" id="{11F9E014-095E-464B-8C94-FC0F8C9DD234}"/>
               </a:ext>
             </a:extLst>
           </p:cNvPr>
@@ -3617,7 +3622,7 @@
           <p:cNvPr id="6" name="">
             <a:extLst xmlns:a="http://schemas.openxmlformats.org/drawingml/2006/main">
               <a:ext uri="{FF2B5EF4-FFF2-40B4-BE49-F238E27FC236}">
-                <a16:creationId xmlns:a16="http://schemas.microsoft.com/office/drawing/2014/main" id="{5D16325F-76BF-4ADC-A7FD-30A4E12B2B54}"/>
+                <a16:creationId xmlns:a16="http://schemas.microsoft.com/office/drawing/2014/main" id="{629C985B-E21F-46A9-AB07-55ED31040C34}"/>
               </a:ext>
             </a:extLst>
           </p:cNvPr>
@@ -3667,7 +3672,7 @@
           <p:cNvPr id="7" name="">
             <a:extLst xmlns:a="http://schemas.openxmlformats.org/drawingml/2006/main">
               <a:ext uri="{FF2B5EF4-FFF2-40B4-BE49-F238E27FC236}">
-                <a16:creationId xmlns:a16="http://schemas.microsoft.com/office/drawing/2014/main" id="{C2D473ED-998D-4D94-8FEB-134CA0BFB47E}"/>
+                <a16:creationId xmlns:a16="http://schemas.microsoft.com/office/drawing/2014/main" id="{595C276E-0BB9-4139-B4B8-03785427B606}"/>
               </a:ext>
             </a:extLst>
           </p:cNvPr>
@@ -3700,7 +3705,7 @@
           <p:cNvPr id="8" name="">
             <a:extLst xmlns:a="http://schemas.openxmlformats.org/drawingml/2006/main">
               <a:ext uri="{FF2B5EF4-FFF2-40B4-BE49-F238E27FC236}">
-                <a16:creationId xmlns:a16="http://schemas.microsoft.com/office/drawing/2014/main" id="{F87CBF94-B7A4-431D-919C-A57DE2253775}"/>
+                <a16:creationId xmlns:a16="http://schemas.microsoft.com/office/drawing/2014/main" id="{9048C1B9-D2DE-4114-948E-4B1CF0C5F426}"/>
               </a:ext>
             </a:extLst>
           </p:cNvPr>
@@ -3735,7 +3740,7 @@
           <p:cNvPr id="9" name="">
             <a:extLst xmlns:a="http://schemas.openxmlformats.org/drawingml/2006/main">
               <a:ext uri="{FF2B5EF4-FFF2-40B4-BE49-F238E27FC236}">
-                <a16:creationId xmlns:a16="http://schemas.microsoft.com/office/drawing/2014/main" id="{976A043B-F778-4CA0-9B1F-AE95783E3340}"/>
+                <a16:creationId xmlns:a16="http://schemas.microsoft.com/office/drawing/2014/main" id="{D97C4FDE-7F38-4CFD-A2A6-89D50D859D75}"/>
               </a:ext>
             </a:extLst>
           </p:cNvPr>
@@ -3785,7 +3790,7 @@
           <p:cNvPr id="10" name="">
             <a:extLst xmlns:a="http://schemas.openxmlformats.org/drawingml/2006/main">
               <a:ext uri="{FF2B5EF4-FFF2-40B4-BE49-F238E27FC236}">
-                <a16:creationId xmlns:a16="http://schemas.microsoft.com/office/drawing/2014/main" id="{5189CA51-A349-4E90-B054-B8497DAEF628}"/>
+                <a16:creationId xmlns:a16="http://schemas.microsoft.com/office/drawing/2014/main" id="{BCD5F18D-7EFA-4DDB-9BFE-4216F6B08092}"/>
               </a:ext>
             </a:extLst>
           </p:cNvPr>
@@ -3835,7 +3840,7 @@
           <p:cNvPr id="11" name="">
             <a:extLst xmlns:a="http://schemas.openxmlformats.org/drawingml/2006/main">
               <a:ext uri="{FF2B5EF4-FFF2-40B4-BE49-F238E27FC236}">
-                <a16:creationId xmlns:a16="http://schemas.microsoft.com/office/drawing/2014/main" id="{736FE4F0-5EF9-4FC2-8769-AA198F33827D}"/>
+                <a16:creationId xmlns:a16="http://schemas.microsoft.com/office/drawing/2014/main" id="{CD59FAA0-696D-4475-A215-C8526B8B83B2}"/>
               </a:ext>
             </a:extLst>
           </p:cNvPr>
@@ -3885,7 +3890,7 @@
           <p:cNvPr id="12" name="">
             <a:extLst xmlns:a="http://schemas.openxmlformats.org/drawingml/2006/main">
               <a:ext uri="{FF2B5EF4-FFF2-40B4-BE49-F238E27FC236}">
-                <a16:creationId xmlns:a16="http://schemas.microsoft.com/office/drawing/2014/main" id="{621964F0-3ED9-41BF-9C07-867A754B48F3}"/>
+                <a16:creationId xmlns:a16="http://schemas.microsoft.com/office/drawing/2014/main" id="{E638122C-FA09-41DE-90AB-B26B6CF6E87E}"/>
               </a:ext>
             </a:extLst>
           </p:cNvPr>
@@ -3918,7 +3923,7 @@
           <p:cNvPr id="13" name="">
             <a:extLst xmlns:a="http://schemas.openxmlformats.org/drawingml/2006/main">
               <a:ext uri="{FF2B5EF4-FFF2-40B4-BE49-F238E27FC236}">
-                <a16:creationId xmlns:a16="http://schemas.microsoft.com/office/drawing/2014/main" id="{897F62F0-8D04-4C3B-AAAC-97AE9250B937}"/>
+                <a16:creationId xmlns:a16="http://schemas.microsoft.com/office/drawing/2014/main" id="{D40FB49F-D724-4B2E-AF89-4B0AF21601FB}"/>
               </a:ext>
             </a:extLst>
           </p:cNvPr>
@@ -3953,7 +3958,7 @@
           <p:cNvPr id="14" name="">
             <a:extLst xmlns:a="http://schemas.openxmlformats.org/drawingml/2006/main">
               <a:ext uri="{FF2B5EF4-FFF2-40B4-BE49-F238E27FC236}">
-                <a16:creationId xmlns:a16="http://schemas.microsoft.com/office/drawing/2014/main" id="{50571603-E309-46FF-A053-A0FB6F64FDC0}"/>
+                <a16:creationId xmlns:a16="http://schemas.microsoft.com/office/drawing/2014/main" id="{5F62415E-76D8-4951-81DF-57CC3B370304}"/>
               </a:ext>
             </a:extLst>
           </p:cNvPr>
@@ -4003,7 +4008,7 @@
           <p:cNvPr id="15" name="">
             <a:extLst xmlns:a="http://schemas.openxmlformats.org/drawingml/2006/main">
               <a:ext uri="{FF2B5EF4-FFF2-40B4-BE49-F238E27FC236}">
-                <a16:creationId xmlns:a16="http://schemas.microsoft.com/office/drawing/2014/main" id="{3390D83E-CD71-4820-B1CE-6A60852798FC}"/>
+                <a16:creationId xmlns:a16="http://schemas.microsoft.com/office/drawing/2014/main" id="{F82F37D1-8180-4FF1-BF79-480F171C227A}"/>
               </a:ext>
             </a:extLst>
           </p:cNvPr>
@@ -4053,7 +4058,7 @@
           <p:cNvPr id="16" name="">
             <a:extLst xmlns:a="http://schemas.openxmlformats.org/drawingml/2006/main">
               <a:ext uri="{FF2B5EF4-FFF2-40B4-BE49-F238E27FC236}">
-                <a16:creationId xmlns:a16="http://schemas.microsoft.com/office/drawing/2014/main" id="{78380931-C428-4DB1-BF0E-22D81221EE75}"/>
+                <a16:creationId xmlns:a16="http://schemas.microsoft.com/office/drawing/2014/main" id="{C4492FE1-FA02-4D69-97E2-9E2A22220EFC}"/>
               </a:ext>
             </a:extLst>
           </p:cNvPr>
@@ -4103,7 +4108,7 @@
           <p:cNvPr id="17" name="">
             <a:extLst xmlns:a="http://schemas.openxmlformats.org/drawingml/2006/main">
               <a:ext uri="{FF2B5EF4-FFF2-40B4-BE49-F238E27FC236}">
-                <a16:creationId xmlns:a16="http://schemas.microsoft.com/office/drawing/2014/main" id="{272FC98D-B18C-4937-96E6-80467AFD3576}"/>
+                <a16:creationId xmlns:a16="http://schemas.microsoft.com/office/drawing/2014/main" id="{F8A966D6-435B-4226-8C6B-1B044D650358}"/>
               </a:ext>
             </a:extLst>
           </p:cNvPr>
@@ -4136,7 +4141,7 @@
           <p:cNvPr id="18" name="">
             <a:extLst xmlns:a="http://schemas.openxmlformats.org/drawingml/2006/main">
               <a:ext uri="{FF2B5EF4-FFF2-40B4-BE49-F238E27FC236}">
-                <a16:creationId xmlns:a16="http://schemas.microsoft.com/office/drawing/2014/main" id="{8F32B97B-B56E-4832-B8AA-096C37F3343E}"/>
+                <a16:creationId xmlns:a16="http://schemas.microsoft.com/office/drawing/2014/main" id="{FBA15262-DAD6-41C5-AE7B-88BDF9138615}"/>
               </a:ext>
             </a:extLst>
           </p:cNvPr>
@@ -4171,7 +4176,7 @@
           <p:cNvPr id="19" name="">
             <a:extLst xmlns:a="http://schemas.openxmlformats.org/drawingml/2006/main">
               <a:ext uri="{FF2B5EF4-FFF2-40B4-BE49-F238E27FC236}">
-                <a16:creationId xmlns:a16="http://schemas.microsoft.com/office/drawing/2014/main" id="{86F56E5F-58A7-4D7F-98ED-43E2A195FC1E}"/>
+                <a16:creationId xmlns:a16="http://schemas.microsoft.com/office/drawing/2014/main" id="{8FB58A0D-AFE4-4F7C-89E6-E6BEB2952F61}"/>
               </a:ext>
             </a:extLst>
           </p:cNvPr>
@@ -4221,7 +4226,7 @@
           <p:cNvPr id="20" name="">
             <a:extLst xmlns:a="http://schemas.openxmlformats.org/drawingml/2006/main">
               <a:ext uri="{FF2B5EF4-FFF2-40B4-BE49-F238E27FC236}">
-                <a16:creationId xmlns:a16="http://schemas.microsoft.com/office/drawing/2014/main" id="{A013E71F-E766-4B8C-BFFC-72563AFC8FCA}"/>
+                <a16:creationId xmlns:a16="http://schemas.microsoft.com/office/drawing/2014/main" id="{876102E6-BD7A-4C32-8D29-27A18D6FA8B4}"/>
               </a:ext>
             </a:extLst>
           </p:cNvPr>
@@ -4271,7 +4276,7 @@
           <p:cNvPr id="21" name="">
             <a:extLst xmlns:a="http://schemas.openxmlformats.org/drawingml/2006/main">
               <a:ext uri="{FF2B5EF4-FFF2-40B4-BE49-F238E27FC236}">
-                <a16:creationId xmlns:a16="http://schemas.microsoft.com/office/drawing/2014/main" id="{8E0BBD82-BB49-4524-9453-1DB8D0DBA466}"/>
+                <a16:creationId xmlns:a16="http://schemas.microsoft.com/office/drawing/2014/main" id="{2E8DA490-B759-4B8A-B692-8809A32A6C7C}"/>
               </a:ext>
             </a:extLst>
           </p:cNvPr>
@@ -4321,7 +4326,7 @@
           <p:cNvPr id="22" name="">
             <a:extLst xmlns:a="http://schemas.openxmlformats.org/drawingml/2006/main">
               <a:ext uri="{FF2B5EF4-FFF2-40B4-BE49-F238E27FC236}">
-                <a16:creationId xmlns:a16="http://schemas.microsoft.com/office/drawing/2014/main" id="{EB2A40FA-1B35-4E5A-B6CB-143443E2F152}"/>
+                <a16:creationId xmlns:a16="http://schemas.microsoft.com/office/drawing/2014/main" id="{FE2508ED-E4DB-4336-9E8C-39316EFF22BF}"/>
               </a:ext>
             </a:extLst>
           </p:cNvPr>
@@ -4354,7 +4359,7 @@
           <p:cNvPr id="23" name="">
             <a:extLst xmlns:a="http://schemas.openxmlformats.org/drawingml/2006/main">
               <a:ext uri="{FF2B5EF4-FFF2-40B4-BE49-F238E27FC236}">
-                <a16:creationId xmlns:a16="http://schemas.microsoft.com/office/drawing/2014/main" id="{B3B5EBD4-5DEF-4B5D-8AFA-B5BFD33C82B2}"/>
+                <a16:creationId xmlns:a16="http://schemas.microsoft.com/office/drawing/2014/main" id="{2384C16C-592A-4D2A-AD4A-F948D744614D}"/>
               </a:ext>
             </a:extLst>
           </p:cNvPr>
@@ -4389,7 +4394,7 @@
           <p:cNvPr id="24" name="">
             <a:extLst xmlns:a="http://schemas.openxmlformats.org/drawingml/2006/main">
               <a:ext uri="{FF2B5EF4-FFF2-40B4-BE49-F238E27FC236}">
-                <a16:creationId xmlns:a16="http://schemas.microsoft.com/office/drawing/2014/main" id="{6F14302C-E6A5-4370-A94A-C74F4C7F87C9}"/>
+                <a16:creationId xmlns:a16="http://schemas.microsoft.com/office/drawing/2014/main" id="{46AA8E7F-6C13-4DA4-A5D2-179086A390C6}"/>
               </a:ext>
             </a:extLst>
           </p:cNvPr>
@@ -4439,7 +4444,7 @@
           <p:cNvPr id="25" name="">
             <a:extLst xmlns:a="http://schemas.openxmlformats.org/drawingml/2006/main">
               <a:ext uri="{FF2B5EF4-FFF2-40B4-BE49-F238E27FC236}">
-                <a16:creationId xmlns:a16="http://schemas.microsoft.com/office/drawing/2014/main" id="{DB1D7AC5-9F28-4CF6-A731-A0C009F9DF8C}"/>
+                <a16:creationId xmlns:a16="http://schemas.microsoft.com/office/drawing/2014/main" id="{3EE005B0-39F9-406F-AC9F-3A27D9361685}"/>
               </a:ext>
             </a:extLst>
           </p:cNvPr>
@@ -4489,7 +4494,7 @@
           <p:cNvPr id="26" name="">
             <a:extLst xmlns:a="http://schemas.openxmlformats.org/drawingml/2006/main">
               <a:ext uri="{FF2B5EF4-FFF2-40B4-BE49-F238E27FC236}">
-                <a16:creationId xmlns:a16="http://schemas.microsoft.com/office/drawing/2014/main" id="{2AA376D4-FA14-4FB8-9917-650AF6DE4612}"/>
+                <a16:creationId xmlns:a16="http://schemas.microsoft.com/office/drawing/2014/main" id="{1B787558-A306-497A-854F-103D27DFFC0D}"/>
               </a:ext>
             </a:extLst>
           </p:cNvPr>
@@ -4539,7 +4544,7 @@
           <p:cNvPr id="27" name="">
             <a:extLst xmlns:a="http://schemas.openxmlformats.org/drawingml/2006/main">
               <a:ext uri="{FF2B5EF4-FFF2-40B4-BE49-F238E27FC236}">
-                <a16:creationId xmlns:a16="http://schemas.microsoft.com/office/drawing/2014/main" id="{C8B143E1-52D2-4008-94A7-8A7172484ED3}"/>
+                <a16:creationId xmlns:a16="http://schemas.microsoft.com/office/drawing/2014/main" id="{7A283BE3-DACD-4B85-B80F-B2D3C4036B5E}"/>
               </a:ext>
             </a:extLst>
           </p:cNvPr>
@@ -4572,7 +4577,7 @@
           <p:cNvPr id="28" name="">
             <a:extLst xmlns:a="http://schemas.openxmlformats.org/drawingml/2006/main">
               <a:ext uri="{FF2B5EF4-FFF2-40B4-BE49-F238E27FC236}">
-                <a16:creationId xmlns:a16="http://schemas.microsoft.com/office/drawing/2014/main" id="{CF1B537F-A48A-4FD7-9C4B-B8DB85124F3D}"/>
+                <a16:creationId xmlns:a16="http://schemas.microsoft.com/office/drawing/2014/main" id="{968EC9D8-033F-4D1C-90FB-958D038C0DBE}"/>
               </a:ext>
             </a:extLst>
           </p:cNvPr>
@@ -4607,7 +4612,7 @@
           <p:cNvPr id="29" name="">
             <a:extLst xmlns:a="http://schemas.openxmlformats.org/drawingml/2006/main">
               <a:ext uri="{FF2B5EF4-FFF2-40B4-BE49-F238E27FC236}">
-                <a16:creationId xmlns:a16="http://schemas.microsoft.com/office/drawing/2014/main" id="{2A2670E0-2E04-4998-B941-22596A112A27}"/>
+                <a16:creationId xmlns:a16="http://schemas.microsoft.com/office/drawing/2014/main" id="{8D721C9A-3AD9-498B-9AA7-FE408DAFD1DF}"/>
               </a:ext>
             </a:extLst>
           </p:cNvPr>
@@ -4657,7 +4662,7 @@
           <p:cNvPr id="30" name="">
             <a:extLst xmlns:a="http://schemas.openxmlformats.org/drawingml/2006/main">
               <a:ext uri="{FF2B5EF4-FFF2-40B4-BE49-F238E27FC236}">
-                <a16:creationId xmlns:a16="http://schemas.microsoft.com/office/drawing/2014/main" id="{D5FB376F-9066-48E7-9554-093FAD676F3F}"/>
+                <a16:creationId xmlns:a16="http://schemas.microsoft.com/office/drawing/2014/main" id="{45244BCA-8E5D-43C1-8FF6-3559437E0B60}"/>
               </a:ext>
             </a:extLst>
           </p:cNvPr>
@@ -4707,7 +4712,7 @@
           <p:cNvPr id="31" name="">
             <a:extLst xmlns:a="http://schemas.openxmlformats.org/drawingml/2006/main">
               <a:ext uri="{FF2B5EF4-FFF2-40B4-BE49-F238E27FC236}">
-                <a16:creationId xmlns:a16="http://schemas.microsoft.com/office/drawing/2014/main" id="{FCEA44E3-26D0-4306-91BD-F6AE96B313B6}"/>
+                <a16:creationId xmlns:a16="http://schemas.microsoft.com/office/drawing/2014/main" id="{D8354915-27D5-4704-974B-7875776A837A}"/>
               </a:ext>
             </a:extLst>
           </p:cNvPr>
@@ -4757,7 +4762,7 @@
           <p:cNvPr id="32" name="">
             <a:extLst xmlns:a="http://schemas.openxmlformats.org/drawingml/2006/main">
               <a:ext uri="{FF2B5EF4-FFF2-40B4-BE49-F238E27FC236}">
-                <a16:creationId xmlns:a16="http://schemas.microsoft.com/office/drawing/2014/main" id="{75BBD1AE-F8D5-434A-93C8-A8DF95C12CB8}"/>
+                <a16:creationId xmlns:a16="http://schemas.microsoft.com/office/drawing/2014/main" id="{1755756F-3D57-4C6C-9238-AB7D690CD76E}"/>
               </a:ext>
             </a:extLst>
           </p:cNvPr>
@@ -4807,7 +4812,7 @@
           <p:cNvPr id="33" name="">
             <a:extLst xmlns:a="http://schemas.openxmlformats.org/drawingml/2006/main">
               <a:ext uri="{FF2B5EF4-FFF2-40B4-BE49-F238E27FC236}">
-                <a16:creationId xmlns:a16="http://schemas.microsoft.com/office/drawing/2014/main" id="{3B5A96A8-D780-4C52-8F72-8AF358605DC6}"/>
+                <a16:creationId xmlns:a16="http://schemas.microsoft.com/office/drawing/2014/main" id="{56EB25A5-566B-4003-AA11-DA2E21DF7343}"/>
               </a:ext>
             </a:extLst>
           </p:cNvPr>
@@ -4857,7 +4862,7 @@
           <p:cNvPr id="34" name="">
             <a:extLst xmlns:a="http://schemas.openxmlformats.org/drawingml/2006/main">
               <a:ext uri="{FF2B5EF4-FFF2-40B4-BE49-F238E27FC236}">
-                <a16:creationId xmlns:a16="http://schemas.microsoft.com/office/drawing/2014/main" id="{21015A55-5588-4C22-A83E-804FF0320C6C}"/>
+                <a16:creationId xmlns:a16="http://schemas.microsoft.com/office/drawing/2014/main" id="{69BEAA22-1DF2-4CC6-B22F-BAD209DCEAB1}"/>
               </a:ext>
             </a:extLst>
           </p:cNvPr>
@@ -4905,7 +4910,7 @@
     </p:spTree>
     <p:extLst>
       <p:ext uri="{BB962C8B-B14F-4D97-AF65-F5344CB8AC3E}">
-        <p14:creationId xmlns:p14="http://schemas.microsoft.com/office/powerpoint/2010/main" val="2145781805"/>
+        <p14:creationId xmlns:p14="http://schemas.microsoft.com/office/powerpoint/2010/main" val="1682265658"/>
       </p:ext>
     </p:extLst>
   </p:cSld>
@@ -4936,7 +4941,7 @@
           <p:cNvPr id="1" name="">
             <a:extLst xmlns:a="http://schemas.openxmlformats.org/drawingml/2006/main">
               <a:ext uri="{FF2B5EF4-FFF2-40B4-BE49-F238E27FC236}">
-                <a16:creationId xmlns:a16="http://schemas.microsoft.com/office/drawing/2014/main" id="{B26E5433-F960-4454-8E93-94BD216FFCDB}"/>
+                <a16:creationId xmlns:a16="http://schemas.microsoft.com/office/drawing/2014/main" id="{CC85458D-8F07-4DFF-93E5-C8BF9B50C9B1}"/>
               </a:ext>
             </a:extLst>
           </p:cNvPr>
@@ -4986,7 +4991,7 @@
           <p:cNvPr id="2" name="">
             <a:extLst xmlns:a="http://schemas.openxmlformats.org/drawingml/2006/main">
               <a:ext uri="{FF2B5EF4-FFF2-40B4-BE49-F238E27FC236}">
-                <a16:creationId xmlns:a16="http://schemas.microsoft.com/office/drawing/2014/main" id="{925CFB4C-207D-4EB0-A094-9231FD53C4FF}"/>
+                <a16:creationId xmlns:a16="http://schemas.microsoft.com/office/drawing/2014/main" id="{3E2FFF73-A5C0-4A1B-A320-58963CEA4C53}"/>
               </a:ext>
             </a:extLst>
           </p:cNvPr>
@@ -5040,7 +5045,7 @@
           <p:nvPr/>
         </p:nvPicPr>
         <p:blipFill>
-          <a:blip xmlns:r="http://schemas.openxmlformats.org/officeDocument/2006/relationships" xmlns:a="http://schemas.openxmlformats.org/drawingml/2006/main" r:embed="Rb81c92b7f28a4f7f"/>
+          <a:blip xmlns:r="http://schemas.openxmlformats.org/officeDocument/2006/relationships" xmlns:a="http://schemas.openxmlformats.org/drawingml/2006/main" r:embed="Rb5d3b92949ec4b64"/>
           <a:stretch xmlns:a="http://schemas.openxmlformats.org/drawingml/2006/main"/>
         </p:blipFill>
         <p:spPr>
@@ -5058,7 +5063,7 @@
           <p:cNvPr id="4" name="">
             <a:extLst xmlns:a="http://schemas.openxmlformats.org/drawingml/2006/main">
               <a:ext uri="{FF2B5EF4-FFF2-40B4-BE49-F238E27FC236}">
-                <a16:creationId xmlns:a16="http://schemas.microsoft.com/office/drawing/2014/main" id="{082123F1-9B6B-4AB2-8120-AAC2C7922A25}"/>
+                <a16:creationId xmlns:a16="http://schemas.microsoft.com/office/drawing/2014/main" id="{626807D1-3C9B-4A69-B597-32FCF1C82344}"/>
               </a:ext>
             </a:extLst>
           </p:cNvPr>
@@ -5091,7 +5096,7 @@
           <p:cNvPr id="5" name="">
             <a:extLst xmlns:a="http://schemas.openxmlformats.org/drawingml/2006/main">
               <a:ext uri="{FF2B5EF4-FFF2-40B4-BE49-F238E27FC236}">
-                <a16:creationId xmlns:a16="http://schemas.microsoft.com/office/drawing/2014/main" id="{C0B36BDA-E4CD-4470-BF96-F4995D913C9E}"/>
+                <a16:creationId xmlns:a16="http://schemas.microsoft.com/office/drawing/2014/main" id="{772BE20B-E595-4613-B0CA-1023C0F61B71}"/>
               </a:ext>
             </a:extLst>
           </p:cNvPr>
@@ -5141,7 +5146,7 @@
           <p:cNvPr id="6" name="">
             <a:extLst xmlns:a="http://schemas.openxmlformats.org/drawingml/2006/main">
               <a:ext uri="{FF2B5EF4-FFF2-40B4-BE49-F238E27FC236}">
-                <a16:creationId xmlns:a16="http://schemas.microsoft.com/office/drawing/2014/main" id="{B8EF5669-B814-4A39-9F63-52E5F14827A1}"/>
+                <a16:creationId xmlns:a16="http://schemas.microsoft.com/office/drawing/2014/main" id="{F5A907B7-3E59-4FEB-8F4D-2AD3B6ACFECF}"/>
               </a:ext>
             </a:extLst>
           </p:cNvPr>
@@ -5191,7 +5196,7 @@
           <p:cNvPr id="7" name="">
             <a:extLst xmlns:a="http://schemas.openxmlformats.org/drawingml/2006/main">
               <a:ext uri="{FF2B5EF4-FFF2-40B4-BE49-F238E27FC236}">
-                <a16:creationId xmlns:a16="http://schemas.microsoft.com/office/drawing/2014/main" id="{A1971FDD-35B6-48E5-B760-2D767D58CCDE}"/>
+                <a16:creationId xmlns:a16="http://schemas.microsoft.com/office/drawing/2014/main" id="{07B9C565-F74A-4D2A-9313-242DC0715213}"/>
               </a:ext>
             </a:extLst>
           </p:cNvPr>
@@ -5224,7 +5229,7 @@
           <p:cNvPr id="8" name="">
             <a:extLst xmlns:a="http://schemas.openxmlformats.org/drawingml/2006/main">
               <a:ext uri="{FF2B5EF4-FFF2-40B4-BE49-F238E27FC236}">
-                <a16:creationId xmlns:a16="http://schemas.microsoft.com/office/drawing/2014/main" id="{1A291CC9-5B73-4D96-AA9B-DACABCFD3333}"/>
+                <a16:creationId xmlns:a16="http://schemas.microsoft.com/office/drawing/2014/main" id="{F65FFCDD-2804-4C54-8B49-27A08522FFAB}"/>
               </a:ext>
             </a:extLst>
           </p:cNvPr>
@@ -5274,7 +5279,7 @@
           <p:cNvPr id="9" name="">
             <a:extLst xmlns:a="http://schemas.openxmlformats.org/drawingml/2006/main">
               <a:ext uri="{FF2B5EF4-FFF2-40B4-BE49-F238E27FC236}">
-                <a16:creationId xmlns:a16="http://schemas.microsoft.com/office/drawing/2014/main" id="{93F109AF-1129-4C17-B0C9-76CCBCC4AFB8}"/>
+                <a16:creationId xmlns:a16="http://schemas.microsoft.com/office/drawing/2014/main" id="{F8B129C3-800C-44EF-8F25-8FDEDA63B77B}"/>
               </a:ext>
             </a:extLst>
           </p:cNvPr>
@@ -5324,7 +5329,7 @@
           <p:cNvPr id="10" name="">
             <a:extLst xmlns:a="http://schemas.openxmlformats.org/drawingml/2006/main">
               <a:ext uri="{FF2B5EF4-FFF2-40B4-BE49-F238E27FC236}">
-                <a16:creationId xmlns:a16="http://schemas.microsoft.com/office/drawing/2014/main" id="{A7BBFD0A-EC35-41B1-B343-B559CE83E5FD}"/>
+                <a16:creationId xmlns:a16="http://schemas.microsoft.com/office/drawing/2014/main" id="{6B156086-A922-48B9-993B-D6ADBA4B9409}"/>
               </a:ext>
             </a:extLst>
           </p:cNvPr>
@@ -5357,7 +5362,7 @@
           <p:cNvPr id="11" name="">
             <a:extLst xmlns:a="http://schemas.openxmlformats.org/drawingml/2006/main">
               <a:ext uri="{FF2B5EF4-FFF2-40B4-BE49-F238E27FC236}">
-                <a16:creationId xmlns:a16="http://schemas.microsoft.com/office/drawing/2014/main" id="{3E2FCB4F-3EF4-46C6-AFF3-B53E52796454}"/>
+                <a16:creationId xmlns:a16="http://schemas.microsoft.com/office/drawing/2014/main" id="{3D936421-D7C3-423D-925E-F6B2A7AF176A}"/>
               </a:ext>
             </a:extLst>
           </p:cNvPr>
@@ -5407,7 +5412,7 @@
           <p:cNvPr id="12" name="">
             <a:extLst xmlns:a="http://schemas.openxmlformats.org/drawingml/2006/main">
               <a:ext uri="{FF2B5EF4-FFF2-40B4-BE49-F238E27FC236}">
-                <a16:creationId xmlns:a16="http://schemas.microsoft.com/office/drawing/2014/main" id="{1E9928C2-1B23-4BC7-B4B6-948578441905}"/>
+                <a16:creationId xmlns:a16="http://schemas.microsoft.com/office/drawing/2014/main" id="{FCB8A97E-5819-4521-8E8E-79145E40362C}"/>
               </a:ext>
             </a:extLst>
           </p:cNvPr>
@@ -5457,7 +5462,7 @@
           <p:cNvPr id="13" name="">
             <a:extLst xmlns:a="http://schemas.openxmlformats.org/drawingml/2006/main">
               <a:ext uri="{FF2B5EF4-FFF2-40B4-BE49-F238E27FC236}">
-                <a16:creationId xmlns:a16="http://schemas.microsoft.com/office/drawing/2014/main" id="{219DBB0A-644E-4855-9F4D-ECA7956BFC16}"/>
+                <a16:creationId xmlns:a16="http://schemas.microsoft.com/office/drawing/2014/main" id="{B13231CD-782B-4D01-B107-A37DD3D954EE}"/>
               </a:ext>
             </a:extLst>
           </p:cNvPr>
@@ -5507,7 +5512,7 @@
           <p:cNvPr id="14" name="">
             <a:extLst xmlns:a="http://schemas.openxmlformats.org/drawingml/2006/main">
               <a:ext uri="{FF2B5EF4-FFF2-40B4-BE49-F238E27FC236}">
-                <a16:creationId xmlns:a16="http://schemas.microsoft.com/office/drawing/2014/main" id="{FC239887-B126-469F-B882-272DD9D95B0A}"/>
+                <a16:creationId xmlns:a16="http://schemas.microsoft.com/office/drawing/2014/main" id="{BB80E374-75ED-4677-AC87-C3AECA5335E4}"/>
               </a:ext>
             </a:extLst>
           </p:cNvPr>
@@ -5555,7 +5560,7 @@
     </p:spTree>
     <p:extLst>
       <p:ext uri="{BB962C8B-B14F-4D97-AF65-F5344CB8AC3E}">
-        <p14:creationId xmlns:p14="http://schemas.microsoft.com/office/powerpoint/2010/main" val="1755403157"/>
+        <p14:creationId xmlns:p14="http://schemas.microsoft.com/office/powerpoint/2010/main" val="1234430332"/>
       </p:ext>
     </p:extLst>
   </p:cSld>
@@ -5586,7 +5591,7 @@
           <p:cNvPr id="1" name="">
             <a:extLst xmlns:a="http://schemas.openxmlformats.org/drawingml/2006/main">
               <a:ext uri="{FF2B5EF4-FFF2-40B4-BE49-F238E27FC236}">
-                <a16:creationId xmlns:a16="http://schemas.microsoft.com/office/drawing/2014/main" id="{F1BB2D32-E200-4874-9507-795AD2CF8CF1}"/>
+                <a16:creationId xmlns:a16="http://schemas.microsoft.com/office/drawing/2014/main" id="{533F5A47-F438-4D9F-9997-97B511D79E0D}"/>
               </a:ext>
             </a:extLst>
           </p:cNvPr>
@@ -5636,7 +5641,7 @@
           <p:cNvPr id="2" name="">
             <a:extLst xmlns:a="http://schemas.openxmlformats.org/drawingml/2006/main">
               <a:ext uri="{FF2B5EF4-FFF2-40B4-BE49-F238E27FC236}">
-                <a16:creationId xmlns:a16="http://schemas.microsoft.com/office/drawing/2014/main" id="{708D1D0F-5220-44A5-8B06-7328E9B696B0}"/>
+                <a16:creationId xmlns:a16="http://schemas.microsoft.com/office/drawing/2014/main" id="{B48C725C-AF94-409E-B9D9-AD028661D806}"/>
               </a:ext>
             </a:extLst>
           </p:cNvPr>
@@ -5690,7 +5695,7 @@
           <p:nvPr/>
         </p:nvPicPr>
         <p:blipFill>
-          <a:blip xmlns:r="http://schemas.openxmlformats.org/officeDocument/2006/relationships" xmlns:a="http://schemas.openxmlformats.org/drawingml/2006/main" r:embed="Rb45dcfd3fc5d4536"/>
+          <a:blip xmlns:r="http://schemas.openxmlformats.org/officeDocument/2006/relationships" xmlns:a="http://schemas.openxmlformats.org/drawingml/2006/main" r:embed="Rd2236f8232494b45"/>
           <a:stretch xmlns:a="http://schemas.openxmlformats.org/drawingml/2006/main"/>
         </p:blipFill>
         <p:spPr>
@@ -5708,7 +5713,7 @@
           <p:cNvPr id="4" name="">
             <a:extLst xmlns:a="http://schemas.openxmlformats.org/drawingml/2006/main">
               <a:ext uri="{FF2B5EF4-FFF2-40B4-BE49-F238E27FC236}">
-                <a16:creationId xmlns:a16="http://schemas.microsoft.com/office/drawing/2014/main" id="{2EAA54E6-AB3D-41EE-AF50-9DF028BBD94D}"/>
+                <a16:creationId xmlns:a16="http://schemas.microsoft.com/office/drawing/2014/main" id="{A7036C32-3602-4579-858F-67CCFB19328D}"/>
               </a:ext>
             </a:extLst>
           </p:cNvPr>
@@ -5743,7 +5748,7 @@
           <p:cNvPr id="5" name="">
             <a:extLst xmlns:a="http://schemas.openxmlformats.org/drawingml/2006/main">
               <a:ext uri="{FF2B5EF4-FFF2-40B4-BE49-F238E27FC236}">
-                <a16:creationId xmlns:a16="http://schemas.microsoft.com/office/drawing/2014/main" id="{97D8A9C2-78BD-4609-B246-A9C587C6229E}"/>
+                <a16:creationId xmlns:a16="http://schemas.microsoft.com/office/drawing/2014/main" id="{64DA7500-6CA0-47E8-A67A-670C3FAD9F88}"/>
               </a:ext>
             </a:extLst>
           </p:cNvPr>
@@ -5793,7 +5798,7 @@
           <p:cNvPr id="6" name="">
             <a:extLst xmlns:a="http://schemas.openxmlformats.org/drawingml/2006/main">
               <a:ext uri="{FF2B5EF4-FFF2-40B4-BE49-F238E27FC236}">
-                <a16:creationId xmlns:a16="http://schemas.microsoft.com/office/drawing/2014/main" id="{CBAB0ABD-7406-4078-9140-7DFD8507F5E4}"/>
+                <a16:creationId xmlns:a16="http://schemas.microsoft.com/office/drawing/2014/main" id="{469D8051-807F-4910-AD23-EBFFCF81826D}"/>
               </a:ext>
             </a:extLst>
           </p:cNvPr>
@@ -5828,7 +5833,7 @@
           <p:cNvPr id="7" name="">
             <a:extLst xmlns:a="http://schemas.openxmlformats.org/drawingml/2006/main">
               <a:ext uri="{FF2B5EF4-FFF2-40B4-BE49-F238E27FC236}">
-                <a16:creationId xmlns:a16="http://schemas.microsoft.com/office/drawing/2014/main" id="{A5A24F76-5E90-4BC4-A1BC-A44F3920B483}"/>
+                <a16:creationId xmlns:a16="http://schemas.microsoft.com/office/drawing/2014/main" id="{B10C795B-2FBD-44CA-BC7D-4B07D48B698C}"/>
               </a:ext>
             </a:extLst>
           </p:cNvPr>
@@ -5878,7 +5883,7 @@
           <p:cNvPr id="8" name="">
             <a:extLst xmlns:a="http://schemas.openxmlformats.org/drawingml/2006/main">
               <a:ext uri="{FF2B5EF4-FFF2-40B4-BE49-F238E27FC236}">
-                <a16:creationId xmlns:a16="http://schemas.microsoft.com/office/drawing/2014/main" id="{977AA9D3-F110-42C2-9CF0-B7F905FE8A6E}"/>
+                <a16:creationId xmlns:a16="http://schemas.microsoft.com/office/drawing/2014/main" id="{862AA18F-9383-4F57-8FBA-55C0C6CE8367}"/>
               </a:ext>
             </a:extLst>
           </p:cNvPr>
@@ -5913,7 +5918,7 @@
           <p:cNvPr id="9" name="">
             <a:extLst xmlns:a="http://schemas.openxmlformats.org/drawingml/2006/main">
               <a:ext uri="{FF2B5EF4-FFF2-40B4-BE49-F238E27FC236}">
-                <a16:creationId xmlns:a16="http://schemas.microsoft.com/office/drawing/2014/main" id="{4F5A5B2E-3A68-49DD-9424-654E32E097C9}"/>
+                <a16:creationId xmlns:a16="http://schemas.microsoft.com/office/drawing/2014/main" id="{6F4DA05A-F7B0-4FB6-8900-6161A5865100}"/>
               </a:ext>
             </a:extLst>
           </p:cNvPr>
@@ -5963,7 +5968,7 @@
           <p:cNvPr id="10" name="">
             <a:extLst xmlns:a="http://schemas.openxmlformats.org/drawingml/2006/main">
               <a:ext uri="{FF2B5EF4-FFF2-40B4-BE49-F238E27FC236}">
-                <a16:creationId xmlns:a16="http://schemas.microsoft.com/office/drawing/2014/main" id="{34F57876-5FA2-487F-A8DD-CF0E2C29D162}"/>
+                <a16:creationId xmlns:a16="http://schemas.microsoft.com/office/drawing/2014/main" id="{E5F5DE07-F29A-437B-91BD-39F18F9AAAF8}"/>
               </a:ext>
             </a:extLst>
           </p:cNvPr>
@@ -5998,7 +6003,7 @@
           <p:cNvPr id="11" name="">
             <a:extLst xmlns:a="http://schemas.openxmlformats.org/drawingml/2006/main">
               <a:ext uri="{FF2B5EF4-FFF2-40B4-BE49-F238E27FC236}">
-                <a16:creationId xmlns:a16="http://schemas.microsoft.com/office/drawing/2014/main" id="{9A9C03FC-C643-4786-89C4-FB5A0679A670}"/>
+                <a16:creationId xmlns:a16="http://schemas.microsoft.com/office/drawing/2014/main" id="{AB4B3149-21C0-4144-BE39-303E026A9D01}"/>
               </a:ext>
             </a:extLst>
           </p:cNvPr>
@@ -6048,7 +6053,7 @@
           <p:cNvPr id="12" name="">
             <a:extLst xmlns:a="http://schemas.openxmlformats.org/drawingml/2006/main">
               <a:ext uri="{FF2B5EF4-FFF2-40B4-BE49-F238E27FC236}">
-                <a16:creationId xmlns:a16="http://schemas.microsoft.com/office/drawing/2014/main" id="{BC91127B-5EFC-40DB-A844-62E0364FDE11}"/>
+                <a16:creationId xmlns:a16="http://schemas.microsoft.com/office/drawing/2014/main" id="{EDF844D2-85CF-4389-9137-1F0EAA007690}"/>
               </a:ext>
             </a:extLst>
           </p:cNvPr>
@@ -6098,7 +6103,7 @@
           <p:cNvPr id="13" name="">
             <a:extLst xmlns:a="http://schemas.openxmlformats.org/drawingml/2006/main">
               <a:ext uri="{FF2B5EF4-FFF2-40B4-BE49-F238E27FC236}">
-                <a16:creationId xmlns:a16="http://schemas.microsoft.com/office/drawing/2014/main" id="{91A961BF-D416-4543-A32D-D664BA4254CC}"/>
+                <a16:creationId xmlns:a16="http://schemas.microsoft.com/office/drawing/2014/main" id="{646388AB-71E8-4856-B503-B93CFE6A38A9}"/>
               </a:ext>
             </a:extLst>
           </p:cNvPr>
@@ -6148,7 +6153,7 @@
           <p:cNvPr id="14" name="">
             <a:extLst xmlns:a="http://schemas.openxmlformats.org/drawingml/2006/main">
               <a:ext uri="{FF2B5EF4-FFF2-40B4-BE49-F238E27FC236}">
-                <a16:creationId xmlns:a16="http://schemas.microsoft.com/office/drawing/2014/main" id="{1FE6A3A3-E2C2-4449-A337-D8CF102CF2D8}"/>
+                <a16:creationId xmlns:a16="http://schemas.microsoft.com/office/drawing/2014/main" id="{A5549100-EAD1-47C2-8765-34B12FFB852E}"/>
               </a:ext>
             </a:extLst>
           </p:cNvPr>
@@ -6196,7 +6201,7 @@
     </p:spTree>
     <p:extLst>
       <p:ext uri="{BB962C8B-B14F-4D97-AF65-F5344CB8AC3E}">
-        <p14:creationId xmlns:p14="http://schemas.microsoft.com/office/powerpoint/2010/main" val="277319951"/>
+        <p14:creationId xmlns:p14="http://schemas.microsoft.com/office/powerpoint/2010/main" val="654856469"/>
       </p:ext>
     </p:extLst>
   </p:cSld>
@@ -6227,7 +6232,7 @@
           <p:cNvPr id="1" name="">
             <a:extLst xmlns:a="http://schemas.openxmlformats.org/drawingml/2006/main">
               <a:ext uri="{FF2B5EF4-FFF2-40B4-BE49-F238E27FC236}">
-                <a16:creationId xmlns:a16="http://schemas.microsoft.com/office/drawing/2014/main" id="{D34C88A7-8A61-4CBB-974B-38279930B1C8}"/>
+                <a16:creationId xmlns:a16="http://schemas.microsoft.com/office/drawing/2014/main" id="{DF107BE8-6FF8-43F6-8C59-30D7B7BB3CAF}"/>
               </a:ext>
             </a:extLst>
           </p:cNvPr>
@@ -6277,7 +6282,7 @@
           <p:cNvPr id="2" name="">
             <a:extLst xmlns:a="http://schemas.openxmlformats.org/drawingml/2006/main">
               <a:ext uri="{FF2B5EF4-FFF2-40B4-BE49-F238E27FC236}">
-                <a16:creationId xmlns:a16="http://schemas.microsoft.com/office/drawing/2014/main" id="{4E01AA6D-9DDF-451C-87FA-C1220A57E89D}"/>
+                <a16:creationId xmlns:a16="http://schemas.microsoft.com/office/drawing/2014/main" id="{FBA26D10-5D88-460A-9654-A42AEE9E94CC}"/>
               </a:ext>
             </a:extLst>
           </p:cNvPr>
@@ -6327,7 +6332,7 @@
           <p:cNvPr id="3" name="">
             <a:extLst xmlns:a="http://schemas.openxmlformats.org/drawingml/2006/main">
               <a:ext uri="{FF2B5EF4-FFF2-40B4-BE49-F238E27FC236}">
-                <a16:creationId xmlns:a16="http://schemas.microsoft.com/office/drawing/2014/main" id="{43209356-7F5E-410D-A7E6-D0A78B1ACB70}"/>
+                <a16:creationId xmlns:a16="http://schemas.microsoft.com/office/drawing/2014/main" id="{A9C0FF8A-A3EC-43EA-A6E8-24EB75B9CD29}"/>
               </a:ext>
             </a:extLst>
           </p:cNvPr>
@@ -6377,7 +6382,7 @@
           <p:cNvPr id="4" name="">
             <a:extLst xmlns:a="http://schemas.openxmlformats.org/drawingml/2006/main">
               <a:ext uri="{FF2B5EF4-FFF2-40B4-BE49-F238E27FC236}">
-                <a16:creationId xmlns:a16="http://schemas.microsoft.com/office/drawing/2014/main" id="{8A541BED-E887-4AED-A3D7-2A65F2AB0D11}"/>
+                <a16:creationId xmlns:a16="http://schemas.microsoft.com/office/drawing/2014/main" id="{B238D564-E3F8-4F51-B0CB-9EFCBA86D9C4}"/>
               </a:ext>
             </a:extLst>
           </p:cNvPr>
@@ -6427,7 +6432,7 @@
           <p:cNvPr id="5" name="">
             <a:extLst xmlns:a="http://schemas.openxmlformats.org/drawingml/2006/main">
               <a:ext uri="{FF2B5EF4-FFF2-40B4-BE49-F238E27FC236}">
-                <a16:creationId xmlns:a16="http://schemas.microsoft.com/office/drawing/2014/main" id="{1474FF03-B52F-4A0E-AE56-D6851A158034}"/>
+                <a16:creationId xmlns:a16="http://schemas.microsoft.com/office/drawing/2014/main" id="{B133A93C-D3C3-4DDF-895A-0ACDFB833234}"/>
               </a:ext>
             </a:extLst>
           </p:cNvPr>
@@ -6460,7 +6465,7 @@
           <p:cNvPr id="6" name="">
             <a:extLst xmlns:a="http://schemas.openxmlformats.org/drawingml/2006/main">
               <a:ext uri="{FF2B5EF4-FFF2-40B4-BE49-F238E27FC236}">
-                <a16:creationId xmlns:a16="http://schemas.microsoft.com/office/drawing/2014/main" id="{7FC4DB9D-DADD-4ACA-9702-D3B2C4B02164}"/>
+                <a16:creationId xmlns:a16="http://schemas.microsoft.com/office/drawing/2014/main" id="{82F1D40A-486A-4831-BD03-5C1E40019AE5}"/>
               </a:ext>
             </a:extLst>
           </p:cNvPr>
@@ -6510,7 +6515,7 @@
           <p:cNvPr id="7" name="">
             <a:extLst xmlns:a="http://schemas.openxmlformats.org/drawingml/2006/main">
               <a:ext uri="{FF2B5EF4-FFF2-40B4-BE49-F238E27FC236}">
-                <a16:creationId xmlns:a16="http://schemas.microsoft.com/office/drawing/2014/main" id="{7EA54725-F700-4A3D-A474-5AA37F53A9D6}"/>
+                <a16:creationId xmlns:a16="http://schemas.microsoft.com/office/drawing/2014/main" id="{204F010B-26BF-4B4C-AFEC-47537C774B5D}"/>
               </a:ext>
             </a:extLst>
           </p:cNvPr>
@@ -6560,7 +6565,7 @@
           <p:cNvPr id="8" name="">
             <a:extLst xmlns:a="http://schemas.openxmlformats.org/drawingml/2006/main">
               <a:ext uri="{FF2B5EF4-FFF2-40B4-BE49-F238E27FC236}">
-                <a16:creationId xmlns:a16="http://schemas.microsoft.com/office/drawing/2014/main" id="{2D24B02A-0EE4-4A7E-8332-E52C4EAD6805}"/>
+                <a16:creationId xmlns:a16="http://schemas.microsoft.com/office/drawing/2014/main" id="{1D656082-9A85-4606-ACBA-9A1EF0DC7BD7}"/>
               </a:ext>
             </a:extLst>
           </p:cNvPr>
@@ -6593,7 +6598,7 @@
           <p:cNvPr id="9" name="">
             <a:extLst xmlns:a="http://schemas.openxmlformats.org/drawingml/2006/main">
               <a:ext uri="{FF2B5EF4-FFF2-40B4-BE49-F238E27FC236}">
-                <a16:creationId xmlns:a16="http://schemas.microsoft.com/office/drawing/2014/main" id="{CAE0F264-7255-487E-8132-5A67AEEE2B9A}"/>
+                <a16:creationId xmlns:a16="http://schemas.microsoft.com/office/drawing/2014/main" id="{D5B9D605-23E8-4006-BA13-A42461065EB8}"/>
               </a:ext>
             </a:extLst>
           </p:cNvPr>
@@ -6643,7 +6648,7 @@
           <p:cNvPr id="10" name="">
             <a:extLst xmlns:a="http://schemas.openxmlformats.org/drawingml/2006/main">
               <a:ext uri="{FF2B5EF4-FFF2-40B4-BE49-F238E27FC236}">
-                <a16:creationId xmlns:a16="http://schemas.microsoft.com/office/drawing/2014/main" id="{823D8745-C2C1-4346-8981-CEEC5EDCC464}"/>
+                <a16:creationId xmlns:a16="http://schemas.microsoft.com/office/drawing/2014/main" id="{3D1D1691-98B1-4D48-B3DD-C9AA0C8ABAD2}"/>
               </a:ext>
             </a:extLst>
           </p:cNvPr>
@@ -6683,7 +6688,7 @@
                   <a:srgbClr val="16312E"/>
                 </a:solidFill>
               </a:rPr>
-              <a:t>a simple GLM for the live workshop</a:t>
+              <a:t>GLM, GBM, and RF examples</a:t>
             </a:r>
           </a:p>
         </p:txBody>
@@ -6693,7 +6698,7 @@
           <p:cNvPr id="11" name="">
             <a:extLst xmlns:a="http://schemas.openxmlformats.org/drawingml/2006/main">
               <a:ext uri="{FF2B5EF4-FFF2-40B4-BE49-F238E27FC236}">
-                <a16:creationId xmlns:a16="http://schemas.microsoft.com/office/drawing/2014/main" id="{50C801FB-35F1-4DB1-AF25-5BDB64CF2DCC}"/>
+                <a16:creationId xmlns:a16="http://schemas.microsoft.com/office/drawing/2014/main" id="{CBAEF079-61F4-42CD-A041-AAA32EDD9F63}"/>
               </a:ext>
             </a:extLst>
           </p:cNvPr>
@@ -6726,7 +6731,7 @@
           <p:cNvPr id="12" name="">
             <a:extLst xmlns:a="http://schemas.openxmlformats.org/drawingml/2006/main">
               <a:ext uri="{FF2B5EF4-FFF2-40B4-BE49-F238E27FC236}">
-                <a16:creationId xmlns:a16="http://schemas.microsoft.com/office/drawing/2014/main" id="{689FB733-80D5-4B7D-BF9E-8A9664EFE4D2}"/>
+                <a16:creationId xmlns:a16="http://schemas.microsoft.com/office/drawing/2014/main" id="{B825CB74-24B6-49AB-80DD-DA62B2D0A361}"/>
               </a:ext>
             </a:extLst>
           </p:cNvPr>
@@ -6776,7 +6781,7 @@
           <p:cNvPr id="13" name="">
             <a:extLst xmlns:a="http://schemas.openxmlformats.org/drawingml/2006/main">
               <a:ext uri="{FF2B5EF4-FFF2-40B4-BE49-F238E27FC236}">
-                <a16:creationId xmlns:a16="http://schemas.microsoft.com/office/drawing/2014/main" id="{A61358CB-EC7B-45E1-A89E-7EF045D23930}"/>
+                <a16:creationId xmlns:a16="http://schemas.microsoft.com/office/drawing/2014/main" id="{9924F9C2-43F9-4D5C-A561-7F89063094B8}"/>
               </a:ext>
             </a:extLst>
           </p:cNvPr>
@@ -6826,7 +6831,7 @@
           <p:cNvPr id="14" name="">
             <a:extLst xmlns:a="http://schemas.openxmlformats.org/drawingml/2006/main">
               <a:ext uri="{FF2B5EF4-FFF2-40B4-BE49-F238E27FC236}">
-                <a16:creationId xmlns:a16="http://schemas.microsoft.com/office/drawing/2014/main" id="{A1D17109-89CE-4941-AD80-412C4CD4AF76}"/>
+                <a16:creationId xmlns:a16="http://schemas.microsoft.com/office/drawing/2014/main" id="{4EBEDFB0-F679-4496-B78D-20440C3376F6}"/>
               </a:ext>
             </a:extLst>
           </p:cNvPr>
@@ -6859,7 +6864,7 @@
           <p:cNvPr id="15" name="">
             <a:extLst xmlns:a="http://schemas.openxmlformats.org/drawingml/2006/main">
               <a:ext uri="{FF2B5EF4-FFF2-40B4-BE49-F238E27FC236}">
-                <a16:creationId xmlns:a16="http://schemas.microsoft.com/office/drawing/2014/main" id="{BB8EF3C9-F306-41B7-9743-76A0D57A7060}"/>
+                <a16:creationId xmlns:a16="http://schemas.microsoft.com/office/drawing/2014/main" id="{EB42627B-C418-4D23-AE6B-EDF651F3B885}"/>
               </a:ext>
             </a:extLst>
           </p:cNvPr>
@@ -6909,7 +6914,7 @@
           <p:cNvPr id="16" name="">
             <a:extLst xmlns:a="http://schemas.openxmlformats.org/drawingml/2006/main">
               <a:ext uri="{FF2B5EF4-FFF2-40B4-BE49-F238E27FC236}">
-                <a16:creationId xmlns:a16="http://schemas.microsoft.com/office/drawing/2014/main" id="{6B5C4745-1DF8-47AE-B3F8-356F34DB917B}"/>
+                <a16:creationId xmlns:a16="http://schemas.microsoft.com/office/drawing/2014/main" id="{E708DC5E-A020-4303-B973-16321C5F9981}"/>
               </a:ext>
             </a:extLst>
           </p:cNvPr>
@@ -6959,7 +6964,7 @@
           <p:cNvPr id="17" name="">
             <a:extLst xmlns:a="http://schemas.openxmlformats.org/drawingml/2006/main">
               <a:ext uri="{FF2B5EF4-FFF2-40B4-BE49-F238E27FC236}">
-                <a16:creationId xmlns:a16="http://schemas.microsoft.com/office/drawing/2014/main" id="{92F43657-AC6C-4B7A-91E9-D18668B11DAD}"/>
+                <a16:creationId xmlns:a16="http://schemas.microsoft.com/office/drawing/2014/main" id="{09B123C8-F78F-4EEA-9391-461B258D5098}"/>
               </a:ext>
             </a:extLst>
           </p:cNvPr>
@@ -6992,23 +6997,23 @@
           <p:cNvPr id="18" name="">
             <a:extLst xmlns:a="http://schemas.openxmlformats.org/drawingml/2006/main">
               <a:ext uri="{FF2B5EF4-FFF2-40B4-BE49-F238E27FC236}">
-                <a16:creationId xmlns:a16="http://schemas.microsoft.com/office/drawing/2014/main" id="{2941A3AA-AE68-44D1-9524-FBBD328802DF}"/>
-              </a:ext>
-            </a:extLst>
-          </p:cNvPr>
-          <p:cNvSpPr>
-            <a:spLocks xmlns:a="http://schemas.openxmlformats.org/drawingml/2006/main" noGrp="1"/>
-          </p:cNvSpPr>
-          <p:nvPr/>
-        </p:nvSpPr>
-        <p:spPr>
-          <a:xfrm xmlns:a="http://schemas.openxmlformats.org/drawingml/2006/main">
-            <a:off x="8905875" y="1752600"/>
-            <a:ext cx="1828800" cy="2476500"/>
+                <a16:creationId xmlns:a16="http://schemas.microsoft.com/office/drawing/2014/main" id="{3459B4AF-1EEC-409A-8031-74DB2A36B639}"/>
+              </a:ext>
+            </a:extLst>
+          </p:cNvPr>
+          <p:cNvSpPr>
+            <a:spLocks xmlns:a="http://schemas.openxmlformats.org/drawingml/2006/main" noGrp="1"/>
+          </p:cNvSpPr>
+          <p:nvPr/>
+        </p:nvSpPr>
+        <p:spPr>
+          <a:xfrm xmlns:a="http://schemas.openxmlformats.org/drawingml/2006/main">
+            <a:off x="8763000" y="1447800"/>
+            <a:ext cx="2190750" cy="3143250"/>
           </a:xfrm>
           <a:prstGeom xmlns:a="http://schemas.openxmlformats.org/drawingml/2006/main" prst="roundRect">
             <a:avLst>
-              <a:gd name="adj" fmla="val 4167"/>
+              <a:gd name="adj" fmla="val 3478"/>
             </a:avLst>
           </a:prstGeom>
           <a:solidFill xmlns:a="http://schemas.openxmlformats.org/drawingml/2006/main">
@@ -7027,19 +7032,19 @@
           <p:cNvPr id="19" name="">
             <a:extLst xmlns:a="http://schemas.openxmlformats.org/drawingml/2006/main">
               <a:ext uri="{FF2B5EF4-FFF2-40B4-BE49-F238E27FC236}">
-                <a16:creationId xmlns:a16="http://schemas.microsoft.com/office/drawing/2014/main" id="{BDDA065A-3EB3-4476-A8D4-215F8139C904}"/>
-              </a:ext>
-            </a:extLst>
-          </p:cNvPr>
-          <p:cNvSpPr>
-            <a:spLocks xmlns:a="http://schemas.openxmlformats.org/drawingml/2006/main" noGrp="1"/>
-          </p:cNvSpPr>
-          <p:nvPr/>
-        </p:nvSpPr>
-        <p:spPr>
-          <a:xfrm xmlns:a="http://schemas.openxmlformats.org/drawingml/2006/main">
-            <a:off x="9182100" y="2057400"/>
-            <a:ext cx="1333500" cy="304800"/>
+                <a16:creationId xmlns:a16="http://schemas.microsoft.com/office/drawing/2014/main" id="{38088C81-C046-44FE-A48C-B55ECEEFB7EA}"/>
+              </a:ext>
+            </a:extLst>
+          </p:cNvPr>
+          <p:cNvSpPr>
+            <a:spLocks xmlns:a="http://schemas.openxmlformats.org/drawingml/2006/main" noGrp="1"/>
+          </p:cNvSpPr>
+          <p:nvPr/>
+        </p:nvSpPr>
+        <p:spPr>
+          <a:xfrm xmlns:a="http://schemas.openxmlformats.org/drawingml/2006/main">
+            <a:off x="9105900" y="1752600"/>
+            <a:ext cx="1504950" cy="304800"/>
           </a:xfrm>
           <a:prstGeom xmlns:a="http://schemas.openxmlformats.org/drawingml/2006/main" prst="rect">
             <a:avLst/>
@@ -7067,7 +7072,7 @@
                   <a:srgbClr val="0B3D3A"/>
                 </a:solidFill>
               </a:rPr>
-              <a:t>Live model</a:t>
+              <a:t>Live models</a:t>
             </a:r>
           </a:p>
         </p:txBody>
@@ -7077,19 +7082,19 @@
           <p:cNvPr id="20" name="">
             <a:extLst xmlns:a="http://schemas.openxmlformats.org/drawingml/2006/main">
               <a:ext uri="{FF2B5EF4-FFF2-40B4-BE49-F238E27FC236}">
-                <a16:creationId xmlns:a16="http://schemas.microsoft.com/office/drawing/2014/main" id="{75C3A34F-EC2B-4E3E-8C4B-C40B38A524A6}"/>
-              </a:ext>
-            </a:extLst>
-          </p:cNvPr>
-          <p:cNvSpPr>
-            <a:spLocks xmlns:a="http://schemas.openxmlformats.org/drawingml/2006/main" noGrp="1"/>
-          </p:cNvSpPr>
-          <p:nvPr/>
-        </p:nvSpPr>
-        <p:spPr>
-          <a:xfrm xmlns:a="http://schemas.openxmlformats.org/drawingml/2006/main">
-            <a:off x="9144000" y="2647950"/>
-            <a:ext cx="1371600" cy="590550"/>
+                <a16:creationId xmlns:a16="http://schemas.microsoft.com/office/drawing/2014/main" id="{612E277A-D17F-445E-931D-593843F9A6A7}"/>
+              </a:ext>
+            </a:extLst>
+          </p:cNvPr>
+          <p:cNvSpPr>
+            <a:spLocks xmlns:a="http://schemas.openxmlformats.org/drawingml/2006/main" noGrp="1"/>
+          </p:cNvSpPr>
+          <p:nvPr/>
+        </p:nvSpPr>
+        <p:spPr>
+          <a:xfrm xmlns:a="http://schemas.openxmlformats.org/drawingml/2006/main">
+            <a:off x="9182100" y="2324100"/>
+            <a:ext cx="1333500" cy="361950"/>
           </a:xfrm>
           <a:prstGeom xmlns:a="http://schemas.openxmlformats.org/drawingml/2006/main" prst="rect">
             <a:avLst/>
@@ -7105,14 +7110,14 @@
           <a:lstStyle xmlns:a="http://schemas.openxmlformats.org/drawingml/2006/main"/>
           <a:p xmlns:a="http://schemas.openxmlformats.org/drawingml/2006/main">
             <a:pPr algn="ctr">
-              <a:defRPr sz="3900" b="1">
+              <a:defRPr sz="2550" b="1">
                 <a:solidFill>
                   <a:srgbClr val="1B7F72"/>
                 </a:solidFill>
               </a:defRPr>
             </a:pPr>
             <a:r>
-              <a:rPr sz="3900" b="1">
+              <a:rPr sz="2550" b="1">
                 <a:solidFill>
                   <a:srgbClr val="1B7F72"/>
                 </a:solidFill>
@@ -7127,19 +7132,19 @@
           <p:cNvPr id="21" name="">
             <a:extLst xmlns:a="http://schemas.openxmlformats.org/drawingml/2006/main">
               <a:ext uri="{FF2B5EF4-FFF2-40B4-BE49-F238E27FC236}">
-                <a16:creationId xmlns:a16="http://schemas.microsoft.com/office/drawing/2014/main" id="{32278608-3343-4551-8B5D-3F11375F51B9}"/>
-              </a:ext>
-            </a:extLst>
-          </p:cNvPr>
-          <p:cNvSpPr>
-            <a:spLocks xmlns:a="http://schemas.openxmlformats.org/drawingml/2006/main" noGrp="1"/>
-          </p:cNvSpPr>
-          <p:nvPr/>
-        </p:nvSpPr>
-        <p:spPr>
-          <a:xfrm xmlns:a="http://schemas.openxmlformats.org/drawingml/2006/main">
-            <a:off x="9182100" y="3429000"/>
-            <a:ext cx="1333500" cy="514350"/>
+                <a16:creationId xmlns:a16="http://schemas.microsoft.com/office/drawing/2014/main" id="{60BC3D7C-63B2-48A7-ACED-72944B70964B}"/>
+              </a:ext>
+            </a:extLst>
+          </p:cNvPr>
+          <p:cNvSpPr>
+            <a:spLocks xmlns:a="http://schemas.openxmlformats.org/drawingml/2006/main" noGrp="1"/>
+          </p:cNvSpPr>
+          <p:nvPr/>
+        </p:nvSpPr>
+        <p:spPr>
+          <a:xfrm xmlns:a="http://schemas.openxmlformats.org/drawingml/2006/main">
+            <a:off x="9182100" y="2895600"/>
+            <a:ext cx="1333500" cy="361950"/>
           </a:xfrm>
           <a:prstGeom xmlns:a="http://schemas.openxmlformats.org/drawingml/2006/main" prst="rect">
             <a:avLst/>
@@ -7155,19 +7160,19 @@
           <a:lstStyle xmlns:a="http://schemas.openxmlformats.org/drawingml/2006/main"/>
           <a:p xmlns:a="http://schemas.openxmlformats.org/drawingml/2006/main">
             <a:pPr algn="ctr">
-              <a:defRPr sz="1350" b="0">
-                <a:solidFill>
-                  <a:srgbClr val="5F6F6A"/>
-                </a:solidFill>
-              </a:defRPr>
-            </a:pPr>
-            <a:r>
-              <a:rPr sz="1350" b="0">
-                <a:solidFill>
-                  <a:srgbClr val="5F6F6A"/>
-                </a:solidFill>
-              </a:rPr>
-              <a:t>Fast enough for beginner laptops</a:t>
+              <a:defRPr sz="2550" b="1">
+                <a:solidFill>
+                  <a:srgbClr val="1B7F72"/>
+                </a:solidFill>
+              </a:defRPr>
+            </a:pPr>
+            <a:r>
+              <a:rPr sz="2550" b="1">
+                <a:solidFill>
+                  <a:srgbClr val="1B7F72"/>
+                </a:solidFill>
+              </a:rPr>
+              <a:t>GBM</a:t>
             </a:r>
           </a:p>
         </p:txBody>
@@ -7177,7 +7182,107 @@
           <p:cNvPr id="22" name="">
             <a:extLst xmlns:a="http://schemas.openxmlformats.org/drawingml/2006/main">
               <a:ext uri="{FF2B5EF4-FFF2-40B4-BE49-F238E27FC236}">
-                <a16:creationId xmlns:a16="http://schemas.microsoft.com/office/drawing/2014/main" id="{4FC2E58A-7A6A-42BF-BC29-D8B8B6B8A764}"/>
+                <a16:creationId xmlns:a16="http://schemas.microsoft.com/office/drawing/2014/main" id="{4B593A61-F2E9-446E-85D7-0A57C6F674E4}"/>
+              </a:ext>
+            </a:extLst>
+          </p:cNvPr>
+          <p:cNvSpPr>
+            <a:spLocks xmlns:a="http://schemas.openxmlformats.org/drawingml/2006/main" noGrp="1"/>
+          </p:cNvSpPr>
+          <p:nvPr/>
+        </p:nvSpPr>
+        <p:spPr>
+          <a:xfrm xmlns:a="http://schemas.openxmlformats.org/drawingml/2006/main">
+            <a:off x="9182100" y="3467100"/>
+            <a:ext cx="1333500" cy="361950"/>
+          </a:xfrm>
+          <a:prstGeom xmlns:a="http://schemas.openxmlformats.org/drawingml/2006/main" prst="rect">
+            <a:avLst/>
+          </a:prstGeom>
+          <a:noFill xmlns:a="http://schemas.openxmlformats.org/drawingml/2006/main"/>
+          <a:ln xmlns:a="http://schemas.openxmlformats.org/drawingml/2006/main" w="0">
+            <a:noFill/>
+            <a:prstDash val="solid"/>
+          </a:ln>
+        </p:spPr>
+        <p:txBody>
+          <a:bodyPr xmlns:a="http://schemas.openxmlformats.org/drawingml/2006/main"/>
+          <a:lstStyle xmlns:a="http://schemas.openxmlformats.org/drawingml/2006/main"/>
+          <a:p xmlns:a="http://schemas.openxmlformats.org/drawingml/2006/main">
+            <a:pPr algn="ctr">
+              <a:defRPr sz="2550" b="1">
+                <a:solidFill>
+                  <a:srgbClr val="1B7F72"/>
+                </a:solidFill>
+              </a:defRPr>
+            </a:pPr>
+            <a:r>
+              <a:rPr sz="2550" b="1">
+                <a:solidFill>
+                  <a:srgbClr val="1B7F72"/>
+                </a:solidFill>
+              </a:rPr>
+              <a:t>RF</a:t>
+            </a:r>
+          </a:p>
+        </p:txBody>
+      </p:sp>
+      <p:sp>
+        <p:nvSpPr>
+          <p:cNvPr id="23" name="">
+            <a:extLst xmlns:a="http://schemas.openxmlformats.org/drawingml/2006/main">
+              <a:ext uri="{FF2B5EF4-FFF2-40B4-BE49-F238E27FC236}">
+                <a16:creationId xmlns:a16="http://schemas.microsoft.com/office/drawing/2014/main" id="{A636FA0A-4A6B-4741-8287-5C42078D8DBB}"/>
+              </a:ext>
+            </a:extLst>
+          </p:cNvPr>
+          <p:cNvSpPr>
+            <a:spLocks xmlns:a="http://schemas.openxmlformats.org/drawingml/2006/main" noGrp="1"/>
+          </p:cNvSpPr>
+          <p:nvPr/>
+        </p:nvSpPr>
+        <p:spPr>
+          <a:xfrm xmlns:a="http://schemas.openxmlformats.org/drawingml/2006/main">
+            <a:off x="9182100" y="4038600"/>
+            <a:ext cx="1333500" cy="323850"/>
+          </a:xfrm>
+          <a:prstGeom xmlns:a="http://schemas.openxmlformats.org/drawingml/2006/main" prst="rect">
+            <a:avLst/>
+          </a:prstGeom>
+          <a:noFill xmlns:a="http://schemas.openxmlformats.org/drawingml/2006/main"/>
+          <a:ln xmlns:a="http://schemas.openxmlformats.org/drawingml/2006/main" w="0">
+            <a:noFill/>
+            <a:prstDash val="solid"/>
+          </a:ln>
+        </p:spPr>
+        <p:txBody>
+          <a:bodyPr xmlns:a="http://schemas.openxmlformats.org/drawingml/2006/main"/>
+          <a:lstStyle xmlns:a="http://schemas.openxmlformats.org/drawingml/2006/main"/>
+          <a:p xmlns:a="http://schemas.openxmlformats.org/drawingml/2006/main">
+            <a:pPr algn="ctr">
+              <a:defRPr sz="1725" b="1">
+                <a:solidFill>
+                  <a:srgbClr val="D1495B"/>
+                </a:solidFill>
+              </a:defRPr>
+            </a:pPr>
+            <a:r>
+              <a:rPr sz="1725" b="1">
+                <a:solidFill>
+                  <a:srgbClr val="D1495B"/>
+                </a:solidFill>
+              </a:rPr>
+              <a:t>+ ensemble</a:t>
+            </a:r>
+          </a:p>
+        </p:txBody>
+      </p:sp>
+      <p:sp>
+        <p:nvSpPr>
+          <p:cNvPr id="24" name="">
+            <a:extLst xmlns:a="http://schemas.openxmlformats.org/drawingml/2006/main">
+              <a:ext uri="{FF2B5EF4-FFF2-40B4-BE49-F238E27FC236}">
+                <a16:creationId xmlns:a16="http://schemas.microsoft.com/office/drawing/2014/main" id="{5C85783A-1478-429C-A864-D1C8BE31CC3A}"/>
               </a:ext>
             </a:extLst>
           </p:cNvPr>
@@ -7224,10 +7329,10 @@
       </p:sp>
       <p:sp>
         <p:nvSpPr>
-          <p:cNvPr id="23" name="">
-            <a:extLst xmlns:a="http://schemas.openxmlformats.org/drawingml/2006/main">
-              <a:ext uri="{FF2B5EF4-FFF2-40B4-BE49-F238E27FC236}">
-                <a16:creationId xmlns:a16="http://schemas.microsoft.com/office/drawing/2014/main" id="{BFA20771-406C-40F2-8431-C2EA161E47E4}"/>
+          <p:cNvPr id="25" name="">
+            <a:extLst xmlns:a="http://schemas.openxmlformats.org/drawingml/2006/main">
+              <a:ext uri="{FF2B5EF4-FFF2-40B4-BE49-F238E27FC236}">
+                <a16:creationId xmlns:a16="http://schemas.microsoft.com/office/drawing/2014/main" id="{FF8E0AA6-2562-4F4C-A25E-A4321A969339}"/>
               </a:ext>
             </a:extLst>
           </p:cNvPr>
@@ -7275,7 +7380,7 @@
     </p:spTree>
     <p:extLst>
       <p:ext uri="{BB962C8B-B14F-4D97-AF65-F5344CB8AC3E}">
-        <p14:creationId xmlns:p14="http://schemas.microsoft.com/office/powerpoint/2010/main" val="1404773462"/>
+        <p14:creationId xmlns:p14="http://schemas.microsoft.com/office/powerpoint/2010/main" val="817386683"/>
       </p:ext>
     </p:extLst>
   </p:cSld>
@@ -7306,7 +7411,7 @@
           <p:cNvPr id="1" name="">
             <a:extLst xmlns:a="http://schemas.openxmlformats.org/drawingml/2006/main">
               <a:ext uri="{FF2B5EF4-FFF2-40B4-BE49-F238E27FC236}">
-                <a16:creationId xmlns:a16="http://schemas.microsoft.com/office/drawing/2014/main" id="{5E211F02-D19C-4F9B-A6C7-DF44C1062879}"/>
+                <a16:creationId xmlns:a16="http://schemas.microsoft.com/office/drawing/2014/main" id="{A07B58CE-F0F0-42CF-853E-B3BB2E0CBC8D}"/>
               </a:ext>
             </a:extLst>
           </p:cNvPr>
@@ -7356,7 +7461,7 @@
           <p:cNvPr id="2" name="">
             <a:extLst xmlns:a="http://schemas.openxmlformats.org/drawingml/2006/main">
               <a:ext uri="{FF2B5EF4-FFF2-40B4-BE49-F238E27FC236}">
-                <a16:creationId xmlns:a16="http://schemas.microsoft.com/office/drawing/2014/main" id="{9491D1BA-844F-4325-8721-CBC630933FED}"/>
+                <a16:creationId xmlns:a16="http://schemas.microsoft.com/office/drawing/2014/main" id="{A5741DFF-5E77-49F5-ABF5-9BEC85F61418}"/>
               </a:ext>
             </a:extLst>
           </p:cNvPr>
@@ -7406,7 +7511,7 @@
           <p:cNvPr id="3" name="">
             <a:extLst xmlns:a="http://schemas.openxmlformats.org/drawingml/2006/main">
               <a:ext uri="{FF2B5EF4-FFF2-40B4-BE49-F238E27FC236}">
-                <a16:creationId xmlns:a16="http://schemas.microsoft.com/office/drawing/2014/main" id="{E8F8913D-8912-4900-B1F1-314206F471C6}"/>
+                <a16:creationId xmlns:a16="http://schemas.microsoft.com/office/drawing/2014/main" id="{2AD228FB-D050-4E20-9FFB-6170F6A6C8FB}"/>
               </a:ext>
             </a:extLst>
           </p:cNvPr>
@@ -7441,7 +7546,7 @@
           <p:cNvPr id="4" name="">
             <a:extLst xmlns:a="http://schemas.openxmlformats.org/drawingml/2006/main">
               <a:ext uri="{FF2B5EF4-FFF2-40B4-BE49-F238E27FC236}">
-                <a16:creationId xmlns:a16="http://schemas.microsoft.com/office/drawing/2014/main" id="{218E4200-4855-4590-B303-00C7BAE758ED}"/>
+                <a16:creationId xmlns:a16="http://schemas.microsoft.com/office/drawing/2014/main" id="{29A73BC9-822B-40F6-B452-EBB91A29FBEE}"/>
               </a:ext>
             </a:extLst>
           </p:cNvPr>
@@ -7491,7 +7596,7 @@
           <p:cNvPr id="5" name="">
             <a:extLst xmlns:a="http://schemas.openxmlformats.org/drawingml/2006/main">
               <a:ext uri="{FF2B5EF4-FFF2-40B4-BE49-F238E27FC236}">
-                <a16:creationId xmlns:a16="http://schemas.microsoft.com/office/drawing/2014/main" id="{7792088D-ACEB-4FDD-B90E-EAA7E3D5500D}"/>
+                <a16:creationId xmlns:a16="http://schemas.microsoft.com/office/drawing/2014/main" id="{D6A287D9-B548-4034-9888-3F2C75A9C967}"/>
               </a:ext>
             </a:extLst>
           </p:cNvPr>
@@ -7541,7 +7646,7 @@
           <p:cNvPr id="6" name="">
             <a:extLst xmlns:a="http://schemas.openxmlformats.org/drawingml/2006/main">
               <a:ext uri="{FF2B5EF4-FFF2-40B4-BE49-F238E27FC236}">
-                <a16:creationId xmlns:a16="http://schemas.microsoft.com/office/drawing/2014/main" id="{07F7C086-A884-4627-8C52-57F517CFD9F6}"/>
+                <a16:creationId xmlns:a16="http://schemas.microsoft.com/office/drawing/2014/main" id="{EB1D3EB1-60E8-4C99-9DE1-301C2C238B58}"/>
               </a:ext>
             </a:extLst>
           </p:cNvPr>
@@ -7591,7 +7696,7 @@
           <p:cNvPr id="7" name="">
             <a:extLst xmlns:a="http://schemas.openxmlformats.org/drawingml/2006/main">
               <a:ext uri="{FF2B5EF4-FFF2-40B4-BE49-F238E27FC236}">
-                <a16:creationId xmlns:a16="http://schemas.microsoft.com/office/drawing/2014/main" id="{069FBA4C-CBB4-4B69-830B-BE23000C14B2}"/>
+                <a16:creationId xmlns:a16="http://schemas.microsoft.com/office/drawing/2014/main" id="{9A0F7895-7E08-4571-B547-99AD2E99D3F7}"/>
               </a:ext>
             </a:extLst>
           </p:cNvPr>
@@ -7626,7 +7731,7 @@
           <p:cNvPr id="8" name="">
             <a:extLst xmlns:a="http://schemas.openxmlformats.org/drawingml/2006/main">
               <a:ext uri="{FF2B5EF4-FFF2-40B4-BE49-F238E27FC236}">
-                <a16:creationId xmlns:a16="http://schemas.microsoft.com/office/drawing/2014/main" id="{049C73D7-2C29-40D6-BE7B-50B29BA51404}"/>
+                <a16:creationId xmlns:a16="http://schemas.microsoft.com/office/drawing/2014/main" id="{DDFDBB1C-CA0F-417A-B321-98B9727647F0}"/>
               </a:ext>
             </a:extLst>
           </p:cNvPr>
@@ -7676,7 +7781,7 @@
           <p:cNvPr id="9" name="">
             <a:extLst xmlns:a="http://schemas.openxmlformats.org/drawingml/2006/main">
               <a:ext uri="{FF2B5EF4-FFF2-40B4-BE49-F238E27FC236}">
-                <a16:creationId xmlns:a16="http://schemas.microsoft.com/office/drawing/2014/main" id="{A95085D4-9E4E-45A9-80E9-B2B0D46299C1}"/>
+                <a16:creationId xmlns:a16="http://schemas.microsoft.com/office/drawing/2014/main" id="{ABC5CEE7-CA39-4A7C-AF84-8E39BA3D699F}"/>
               </a:ext>
             </a:extLst>
           </p:cNvPr>
@@ -7726,7 +7831,7 @@
           <p:cNvPr id="10" name="">
             <a:extLst xmlns:a="http://schemas.openxmlformats.org/drawingml/2006/main">
               <a:ext uri="{FF2B5EF4-FFF2-40B4-BE49-F238E27FC236}">
-                <a16:creationId xmlns:a16="http://schemas.microsoft.com/office/drawing/2014/main" id="{AD82E1AB-4A66-425C-AD9B-19EE61110484}"/>
+                <a16:creationId xmlns:a16="http://schemas.microsoft.com/office/drawing/2014/main" id="{5D97DAA1-DA7D-4E55-864D-EAECCF71A3BB}"/>
               </a:ext>
             </a:extLst>
           </p:cNvPr>
@@ -7776,7 +7881,7 @@
           <p:cNvPr id="11" name="">
             <a:extLst xmlns:a="http://schemas.openxmlformats.org/drawingml/2006/main">
               <a:ext uri="{FF2B5EF4-FFF2-40B4-BE49-F238E27FC236}">
-                <a16:creationId xmlns:a16="http://schemas.microsoft.com/office/drawing/2014/main" id="{754DFBD8-0403-4166-8A05-ED6D02895E0A}"/>
+                <a16:creationId xmlns:a16="http://schemas.microsoft.com/office/drawing/2014/main" id="{24ED8205-B69B-4465-8CC6-8D70DB60E3FE}"/>
               </a:ext>
             </a:extLst>
           </p:cNvPr>
@@ -7826,7 +7931,7 @@
           <p:cNvPr id="12" name="">
             <a:extLst xmlns:a="http://schemas.openxmlformats.org/drawingml/2006/main">
               <a:ext uri="{FF2B5EF4-FFF2-40B4-BE49-F238E27FC236}">
-                <a16:creationId xmlns:a16="http://schemas.microsoft.com/office/drawing/2014/main" id="{590B50FD-A031-403E-BC78-693ACC2EF95A}"/>
+                <a16:creationId xmlns:a16="http://schemas.microsoft.com/office/drawing/2014/main" id="{EB281370-BE22-4602-89F4-4FBB8E1D1A5E}"/>
               </a:ext>
             </a:extLst>
           </p:cNvPr>
@@ -7876,7 +7981,7 @@
           <p:cNvPr id="13" name="">
             <a:extLst xmlns:a="http://schemas.openxmlformats.org/drawingml/2006/main">
               <a:ext uri="{FF2B5EF4-FFF2-40B4-BE49-F238E27FC236}">
-                <a16:creationId xmlns:a16="http://schemas.microsoft.com/office/drawing/2014/main" id="{5D598B0D-3840-42A0-B6F2-6791422F6A7F}"/>
+                <a16:creationId xmlns:a16="http://schemas.microsoft.com/office/drawing/2014/main" id="{BC168361-395F-4DF9-BE09-0A56B2B5F63A}"/>
               </a:ext>
             </a:extLst>
           </p:cNvPr>
@@ -7924,7 +8029,7 @@
     </p:spTree>
     <p:extLst>
       <p:ext uri="{BB962C8B-B14F-4D97-AF65-F5344CB8AC3E}">
-        <p14:creationId xmlns:p14="http://schemas.microsoft.com/office/powerpoint/2010/main" val="1194983175"/>
+        <p14:creationId xmlns:p14="http://schemas.microsoft.com/office/powerpoint/2010/main" val="1171658916"/>
       </p:ext>
     </p:extLst>
   </p:cSld>
@@ -7955,7 +8060,7 @@
           <p:cNvPr id="1" name="">
             <a:extLst xmlns:a="http://schemas.openxmlformats.org/drawingml/2006/main">
               <a:ext uri="{FF2B5EF4-FFF2-40B4-BE49-F238E27FC236}">
-                <a16:creationId xmlns:a16="http://schemas.microsoft.com/office/drawing/2014/main" id="{86B61E03-5134-4892-82BA-BE6829249CD2}"/>
+                <a16:creationId xmlns:a16="http://schemas.microsoft.com/office/drawing/2014/main" id="{EF9353A1-AFCA-43EB-B95C-2BA278444F69}"/>
               </a:ext>
             </a:extLst>
           </p:cNvPr>
@@ -8005,7 +8110,7 @@
           <p:cNvPr id="2" name="">
             <a:extLst xmlns:a="http://schemas.openxmlformats.org/drawingml/2006/main">
               <a:ext uri="{FF2B5EF4-FFF2-40B4-BE49-F238E27FC236}">
-                <a16:creationId xmlns:a16="http://schemas.microsoft.com/office/drawing/2014/main" id="{2E330FC7-3F5F-41AE-A172-E486D00B6751}"/>
+                <a16:creationId xmlns:a16="http://schemas.microsoft.com/office/drawing/2014/main" id="{B793D2A2-33C7-48C4-B3EE-8A4143BCDFDC}"/>
               </a:ext>
             </a:extLst>
           </p:cNvPr>
@@ -8059,7 +8164,7 @@
           <p:nvPr/>
         </p:nvPicPr>
         <p:blipFill>
-          <a:blip xmlns:r="http://schemas.openxmlformats.org/officeDocument/2006/relationships" xmlns:a="http://schemas.openxmlformats.org/drawingml/2006/main" r:embed="Rfac4820e363248e6"/>
+          <a:blip xmlns:r="http://schemas.openxmlformats.org/officeDocument/2006/relationships" xmlns:a="http://schemas.openxmlformats.org/drawingml/2006/main" r:embed="R7b97f0fb7a614341"/>
           <a:stretch xmlns:a="http://schemas.openxmlformats.org/drawingml/2006/main"/>
         </p:blipFill>
         <p:spPr>
@@ -8077,7 +8182,7 @@
           <p:cNvPr id="4" name="">
             <a:extLst xmlns:a="http://schemas.openxmlformats.org/drawingml/2006/main">
               <a:ext uri="{FF2B5EF4-FFF2-40B4-BE49-F238E27FC236}">
-                <a16:creationId xmlns:a16="http://schemas.microsoft.com/office/drawing/2014/main" id="{2F66167D-A125-4B34-9CF3-0925A387CAD5}"/>
+                <a16:creationId xmlns:a16="http://schemas.microsoft.com/office/drawing/2014/main" id="{12D5E25D-992E-4A74-AEFF-15AFED6C0322}"/>
               </a:ext>
             </a:extLst>
           </p:cNvPr>
@@ -8110,7 +8215,7 @@
           <p:cNvPr id="5" name="">
             <a:extLst xmlns:a="http://schemas.openxmlformats.org/drawingml/2006/main">
               <a:ext uri="{FF2B5EF4-FFF2-40B4-BE49-F238E27FC236}">
-                <a16:creationId xmlns:a16="http://schemas.microsoft.com/office/drawing/2014/main" id="{07AF2520-0D9F-4B90-ABB7-3D09B5BF93BF}"/>
+                <a16:creationId xmlns:a16="http://schemas.microsoft.com/office/drawing/2014/main" id="{028F7841-4616-4600-85EA-6611E76E63DE}"/>
               </a:ext>
             </a:extLst>
           </p:cNvPr>
@@ -8160,7 +8265,7 @@
           <p:cNvPr id="6" name="">
             <a:extLst xmlns:a="http://schemas.openxmlformats.org/drawingml/2006/main">
               <a:ext uri="{FF2B5EF4-FFF2-40B4-BE49-F238E27FC236}">
-                <a16:creationId xmlns:a16="http://schemas.microsoft.com/office/drawing/2014/main" id="{737A2B87-E10D-4CE3-A0DC-1ED9D6B542A9}"/>
+                <a16:creationId xmlns:a16="http://schemas.microsoft.com/office/drawing/2014/main" id="{A1BE1DD7-92FF-42B6-8BB4-8D84317529B1}"/>
               </a:ext>
             </a:extLst>
           </p:cNvPr>
@@ -8193,7 +8298,7 @@
           <p:cNvPr id="7" name="">
             <a:extLst xmlns:a="http://schemas.openxmlformats.org/drawingml/2006/main">
               <a:ext uri="{FF2B5EF4-FFF2-40B4-BE49-F238E27FC236}">
-                <a16:creationId xmlns:a16="http://schemas.microsoft.com/office/drawing/2014/main" id="{01C9BE94-BC90-46AB-9D92-E88439EA5321}"/>
+                <a16:creationId xmlns:a16="http://schemas.microsoft.com/office/drawing/2014/main" id="{126358D7-5E46-4AF8-9DA7-C9B7E8E9E6DA}"/>
               </a:ext>
             </a:extLst>
           </p:cNvPr>
@@ -8243,7 +8348,7 @@
           <p:cNvPr id="8" name="">
             <a:extLst xmlns:a="http://schemas.openxmlformats.org/drawingml/2006/main">
               <a:ext uri="{FF2B5EF4-FFF2-40B4-BE49-F238E27FC236}">
-                <a16:creationId xmlns:a16="http://schemas.microsoft.com/office/drawing/2014/main" id="{4CA58A11-6905-43B2-B3BC-77F4E913DEBE}"/>
+                <a16:creationId xmlns:a16="http://schemas.microsoft.com/office/drawing/2014/main" id="{74E1EEC9-5217-4B29-976F-F6E5C1768903}"/>
               </a:ext>
             </a:extLst>
           </p:cNvPr>
@@ -8276,7 +8381,7 @@
           <p:cNvPr id="9" name="">
             <a:extLst xmlns:a="http://schemas.openxmlformats.org/drawingml/2006/main">
               <a:ext uri="{FF2B5EF4-FFF2-40B4-BE49-F238E27FC236}">
-                <a16:creationId xmlns:a16="http://schemas.microsoft.com/office/drawing/2014/main" id="{D374833B-3B69-4815-871B-9E7756DBF735}"/>
+                <a16:creationId xmlns:a16="http://schemas.microsoft.com/office/drawing/2014/main" id="{44529AE3-424C-4107-A4C1-693C2F765DC9}"/>
               </a:ext>
             </a:extLst>
           </p:cNvPr>
@@ -8326,7 +8431,7 @@
           <p:cNvPr id="10" name="">
             <a:extLst xmlns:a="http://schemas.openxmlformats.org/drawingml/2006/main">
               <a:ext uri="{FF2B5EF4-FFF2-40B4-BE49-F238E27FC236}">
-                <a16:creationId xmlns:a16="http://schemas.microsoft.com/office/drawing/2014/main" id="{51031FDA-34FD-413B-9F82-CD817C245002}"/>
+                <a16:creationId xmlns:a16="http://schemas.microsoft.com/office/drawing/2014/main" id="{2A696230-961E-4671-A03E-2D2C0078DE1A}"/>
               </a:ext>
             </a:extLst>
           </p:cNvPr>
@@ -8359,7 +8464,7 @@
           <p:cNvPr id="11" name="">
             <a:extLst xmlns:a="http://schemas.openxmlformats.org/drawingml/2006/main">
               <a:ext uri="{FF2B5EF4-FFF2-40B4-BE49-F238E27FC236}">
-                <a16:creationId xmlns:a16="http://schemas.microsoft.com/office/drawing/2014/main" id="{AA5804AA-EE9E-4A08-A7BE-A60C26EE9A3A}"/>
+                <a16:creationId xmlns:a16="http://schemas.microsoft.com/office/drawing/2014/main" id="{BBC131BD-10E4-4A06-9247-38678FD85A42}"/>
               </a:ext>
             </a:extLst>
           </p:cNvPr>
@@ -8409,7 +8514,7 @@
           <p:cNvPr id="12" name="">
             <a:extLst xmlns:a="http://schemas.openxmlformats.org/drawingml/2006/main">
               <a:ext uri="{FF2B5EF4-FFF2-40B4-BE49-F238E27FC236}">
-                <a16:creationId xmlns:a16="http://schemas.microsoft.com/office/drawing/2014/main" id="{3957EFD7-91DC-44D4-89C4-CB3C61277C1C}"/>
+                <a16:creationId xmlns:a16="http://schemas.microsoft.com/office/drawing/2014/main" id="{2B9FF2E5-FA59-452B-A95F-980A1F63883F}"/>
               </a:ext>
             </a:extLst>
           </p:cNvPr>
@@ -8459,7 +8564,7 @@
           <p:cNvPr id="13" name="">
             <a:extLst xmlns:a="http://schemas.openxmlformats.org/drawingml/2006/main">
               <a:ext uri="{FF2B5EF4-FFF2-40B4-BE49-F238E27FC236}">
-                <a16:creationId xmlns:a16="http://schemas.microsoft.com/office/drawing/2014/main" id="{4F0F4FC5-FC2F-4D12-8DEA-9E38FE2AF43C}"/>
+                <a16:creationId xmlns:a16="http://schemas.microsoft.com/office/drawing/2014/main" id="{ED1D58AD-0296-4075-BA1D-76E4F6C62E81}"/>
               </a:ext>
             </a:extLst>
           </p:cNvPr>
@@ -8509,7 +8614,7 @@
           <p:cNvPr id="14" name="">
             <a:extLst xmlns:a="http://schemas.openxmlformats.org/drawingml/2006/main">
               <a:ext uri="{FF2B5EF4-FFF2-40B4-BE49-F238E27FC236}">
-                <a16:creationId xmlns:a16="http://schemas.microsoft.com/office/drawing/2014/main" id="{5E783663-B3D7-49EA-BE58-C53DF91E576A}"/>
+                <a16:creationId xmlns:a16="http://schemas.microsoft.com/office/drawing/2014/main" id="{E22D9503-7BF2-458A-A394-D599452362DD}"/>
               </a:ext>
             </a:extLst>
           </p:cNvPr>
@@ -8557,7 +8662,7 @@
     </p:spTree>
     <p:extLst>
       <p:ext uri="{BB962C8B-B14F-4D97-AF65-F5344CB8AC3E}">
-        <p14:creationId xmlns:p14="http://schemas.microsoft.com/office/powerpoint/2010/main" val="278412296"/>
+        <p14:creationId xmlns:p14="http://schemas.microsoft.com/office/powerpoint/2010/main" val="1560041298"/>
       </p:ext>
     </p:extLst>
   </p:cSld>
@@ -8588,7 +8693,7 @@
           <p:cNvPr id="1" name="">
             <a:extLst xmlns:a="http://schemas.openxmlformats.org/drawingml/2006/main">
               <a:ext uri="{FF2B5EF4-FFF2-40B4-BE49-F238E27FC236}">
-                <a16:creationId xmlns:a16="http://schemas.microsoft.com/office/drawing/2014/main" id="{6A45A341-C303-45B0-AC96-25FF5BD9636B}"/>
+                <a16:creationId xmlns:a16="http://schemas.microsoft.com/office/drawing/2014/main" id="{0D8A8E78-AF5E-4B04-9C08-52AABA88D07E}"/>
               </a:ext>
             </a:extLst>
           </p:cNvPr>
@@ -8638,7 +8743,7 @@
           <p:cNvPr id="2" name="">
             <a:extLst xmlns:a="http://schemas.openxmlformats.org/drawingml/2006/main">
               <a:ext uri="{FF2B5EF4-FFF2-40B4-BE49-F238E27FC236}">
-                <a16:creationId xmlns:a16="http://schemas.microsoft.com/office/drawing/2014/main" id="{4C329D8C-73E4-47B6-997D-8016F7983348}"/>
+                <a16:creationId xmlns:a16="http://schemas.microsoft.com/office/drawing/2014/main" id="{B28A1450-387C-49A0-B50D-4E8BB6D6F1AC}"/>
               </a:ext>
             </a:extLst>
           </p:cNvPr>
@@ -8688,7 +8793,7 @@
           <p:cNvPr id="3" name="">
             <a:extLst xmlns:a="http://schemas.openxmlformats.org/drawingml/2006/main">
               <a:ext uri="{FF2B5EF4-FFF2-40B4-BE49-F238E27FC236}">
-                <a16:creationId xmlns:a16="http://schemas.microsoft.com/office/drawing/2014/main" id="{698CEF86-F0DE-4C7F-8E7F-96B94BA4D56A}"/>
+                <a16:creationId xmlns:a16="http://schemas.microsoft.com/office/drawing/2014/main" id="{1762CA5C-2FA7-4789-A999-AC39752DD3E8}"/>
               </a:ext>
             </a:extLst>
           </p:cNvPr>
@@ -8723,7 +8828,7 @@
           <p:cNvPr id="4" name="">
             <a:extLst xmlns:a="http://schemas.openxmlformats.org/drawingml/2006/main">
               <a:ext uri="{FF2B5EF4-FFF2-40B4-BE49-F238E27FC236}">
-                <a16:creationId xmlns:a16="http://schemas.microsoft.com/office/drawing/2014/main" id="{90BBFB4E-150E-4A4E-BC63-A78E7A88737A}"/>
+                <a16:creationId xmlns:a16="http://schemas.microsoft.com/office/drawing/2014/main" id="{90F67B5D-EEDA-49C3-860F-56B46C43C55E}"/>
               </a:ext>
             </a:extLst>
           </p:cNvPr>
@@ -8773,7 +8878,7 @@
           <p:cNvPr id="5" name="">
             <a:extLst xmlns:a="http://schemas.openxmlformats.org/drawingml/2006/main">
               <a:ext uri="{FF2B5EF4-FFF2-40B4-BE49-F238E27FC236}">
-                <a16:creationId xmlns:a16="http://schemas.microsoft.com/office/drawing/2014/main" id="{BEA187AA-73BA-4706-B30C-A243F48A1BE3}"/>
+                <a16:creationId xmlns:a16="http://schemas.microsoft.com/office/drawing/2014/main" id="{41C35573-A274-427A-A271-9E42C3B4253A}"/>
               </a:ext>
             </a:extLst>
           </p:cNvPr>
@@ -8806,7 +8911,7 @@
           <p:cNvPr id="6" name="">
             <a:extLst xmlns:a="http://schemas.openxmlformats.org/drawingml/2006/main">
               <a:ext uri="{FF2B5EF4-FFF2-40B4-BE49-F238E27FC236}">
-                <a16:creationId xmlns:a16="http://schemas.microsoft.com/office/drawing/2014/main" id="{830BBE38-3979-4048-9E88-C1E76333A35C}"/>
+                <a16:creationId xmlns:a16="http://schemas.microsoft.com/office/drawing/2014/main" id="{00A9531A-A346-4EBE-A024-AE52E3B7AF11}"/>
               </a:ext>
             </a:extLst>
           </p:cNvPr>
@@ -8856,7 +8961,7 @@
           <p:cNvPr id="7" name="">
             <a:extLst xmlns:a="http://schemas.openxmlformats.org/drawingml/2006/main">
               <a:ext uri="{FF2B5EF4-FFF2-40B4-BE49-F238E27FC236}">
-                <a16:creationId xmlns:a16="http://schemas.microsoft.com/office/drawing/2014/main" id="{DE061EE7-C759-435D-A264-21E1D317748C}"/>
+                <a16:creationId xmlns:a16="http://schemas.microsoft.com/office/drawing/2014/main" id="{74EA2603-D532-4BD4-AD75-B34C209A37FA}"/>
               </a:ext>
             </a:extLst>
           </p:cNvPr>
@@ -8889,7 +8994,7 @@
           <p:cNvPr id="8" name="">
             <a:extLst xmlns:a="http://schemas.openxmlformats.org/drawingml/2006/main">
               <a:ext uri="{FF2B5EF4-FFF2-40B4-BE49-F238E27FC236}">
-                <a16:creationId xmlns:a16="http://schemas.microsoft.com/office/drawing/2014/main" id="{EB4D4258-FD14-456C-A1C9-9B94051B71B5}"/>
+                <a16:creationId xmlns:a16="http://schemas.microsoft.com/office/drawing/2014/main" id="{CEE726EF-D0E0-4B3E-867D-D6A28BECBB14}"/>
               </a:ext>
             </a:extLst>
           </p:cNvPr>
@@ -8939,7 +9044,7 @@
           <p:cNvPr id="9" name="">
             <a:extLst xmlns:a="http://schemas.openxmlformats.org/drawingml/2006/main">
               <a:ext uri="{FF2B5EF4-FFF2-40B4-BE49-F238E27FC236}">
-                <a16:creationId xmlns:a16="http://schemas.microsoft.com/office/drawing/2014/main" id="{3D5C555D-4379-4953-93E4-EB9670E1CA4D}"/>
+                <a16:creationId xmlns:a16="http://schemas.microsoft.com/office/drawing/2014/main" id="{7B1D7D3F-58B0-4B6F-B8C4-EDB9A48989A4}"/>
               </a:ext>
             </a:extLst>
           </p:cNvPr>
@@ -8972,7 +9077,7 @@
           <p:cNvPr id="10" name="">
             <a:extLst xmlns:a="http://schemas.openxmlformats.org/drawingml/2006/main">
               <a:ext uri="{FF2B5EF4-FFF2-40B4-BE49-F238E27FC236}">
-                <a16:creationId xmlns:a16="http://schemas.microsoft.com/office/drawing/2014/main" id="{61D47162-81C4-4C92-B9DB-164025963B24}"/>
+                <a16:creationId xmlns:a16="http://schemas.microsoft.com/office/drawing/2014/main" id="{6993D682-9C60-4F13-A407-3A1EA730AD8C}"/>
               </a:ext>
             </a:extLst>
           </p:cNvPr>
@@ -9022,7 +9127,7 @@
           <p:cNvPr id="11" name="">
             <a:extLst xmlns:a="http://schemas.openxmlformats.org/drawingml/2006/main">
               <a:ext uri="{FF2B5EF4-FFF2-40B4-BE49-F238E27FC236}">
-                <a16:creationId xmlns:a16="http://schemas.microsoft.com/office/drawing/2014/main" id="{647C99FE-F663-49D1-807B-88606D643A8B}"/>
+                <a16:creationId xmlns:a16="http://schemas.microsoft.com/office/drawing/2014/main" id="{6714DA8F-7A42-4832-A5E2-8E969CBB3127}"/>
               </a:ext>
             </a:extLst>
           </p:cNvPr>
@@ -9055,7 +9160,7 @@
           <p:cNvPr id="12" name="">
             <a:extLst xmlns:a="http://schemas.openxmlformats.org/drawingml/2006/main">
               <a:ext uri="{FF2B5EF4-FFF2-40B4-BE49-F238E27FC236}">
-                <a16:creationId xmlns:a16="http://schemas.microsoft.com/office/drawing/2014/main" id="{7045AF22-7479-4E7A-96A4-F7B6FD04CAD2}"/>
+                <a16:creationId xmlns:a16="http://schemas.microsoft.com/office/drawing/2014/main" id="{78FBA8D2-1529-4F53-B916-BE4884485607}"/>
               </a:ext>
             </a:extLst>
           </p:cNvPr>
@@ -9105,7 +9210,7 @@
           <p:cNvPr id="13" name="">
             <a:extLst xmlns:a="http://schemas.openxmlformats.org/drawingml/2006/main">
               <a:ext uri="{FF2B5EF4-FFF2-40B4-BE49-F238E27FC236}">
-                <a16:creationId xmlns:a16="http://schemas.microsoft.com/office/drawing/2014/main" id="{4937515E-FE26-4AA0-99AB-244277412465}"/>
+                <a16:creationId xmlns:a16="http://schemas.microsoft.com/office/drawing/2014/main" id="{8D5332B1-9C42-4CE7-8AF4-2D98466B1721}"/>
               </a:ext>
             </a:extLst>
           </p:cNvPr>
@@ -9140,7 +9245,7 @@
           <p:cNvPr id="14" name="">
             <a:extLst xmlns:a="http://schemas.openxmlformats.org/drawingml/2006/main">
               <a:ext uri="{FF2B5EF4-FFF2-40B4-BE49-F238E27FC236}">
-                <a16:creationId xmlns:a16="http://schemas.microsoft.com/office/drawing/2014/main" id="{98A131A3-2DB4-436B-842E-42F7E537686C}"/>
+                <a16:creationId xmlns:a16="http://schemas.microsoft.com/office/drawing/2014/main" id="{7F848198-6ECB-432E-8F68-42BDF6838D5C}"/>
               </a:ext>
             </a:extLst>
           </p:cNvPr>
@@ -9190,7 +9295,7 @@
           <p:cNvPr id="15" name="">
             <a:extLst xmlns:a="http://schemas.openxmlformats.org/drawingml/2006/main">
               <a:ext uri="{FF2B5EF4-FFF2-40B4-BE49-F238E27FC236}">
-                <a16:creationId xmlns:a16="http://schemas.microsoft.com/office/drawing/2014/main" id="{73A18925-DF30-4EDF-9B7E-D97B94C25638}"/>
+                <a16:creationId xmlns:a16="http://schemas.microsoft.com/office/drawing/2014/main" id="{C23BD3BF-1D6B-4FF9-894A-B7AFB15C213A}"/>
               </a:ext>
             </a:extLst>
           </p:cNvPr>
@@ -9223,7 +9328,7 @@
           <p:cNvPr id="16" name="">
             <a:extLst xmlns:a="http://schemas.openxmlformats.org/drawingml/2006/main">
               <a:ext uri="{FF2B5EF4-FFF2-40B4-BE49-F238E27FC236}">
-                <a16:creationId xmlns:a16="http://schemas.microsoft.com/office/drawing/2014/main" id="{71FE952F-C5B7-4948-90F6-C1DE86149C89}"/>
+                <a16:creationId xmlns:a16="http://schemas.microsoft.com/office/drawing/2014/main" id="{00F7222F-C3B3-4A43-A8DC-09D5C7DCF5AA}"/>
               </a:ext>
             </a:extLst>
           </p:cNvPr>
@@ -9273,7 +9378,7 @@
           <p:cNvPr id="17" name="">
             <a:extLst xmlns:a="http://schemas.openxmlformats.org/drawingml/2006/main">
               <a:ext uri="{FF2B5EF4-FFF2-40B4-BE49-F238E27FC236}">
-                <a16:creationId xmlns:a16="http://schemas.microsoft.com/office/drawing/2014/main" id="{C542F60C-6CA4-4378-A176-CB78111CB024}"/>
+                <a16:creationId xmlns:a16="http://schemas.microsoft.com/office/drawing/2014/main" id="{9AC1CC19-986D-466C-8D53-8EF4B585CD2B}"/>
               </a:ext>
             </a:extLst>
           </p:cNvPr>
@@ -9306,7 +9411,7 @@
           <p:cNvPr id="18" name="">
             <a:extLst xmlns:a="http://schemas.openxmlformats.org/drawingml/2006/main">
               <a:ext uri="{FF2B5EF4-FFF2-40B4-BE49-F238E27FC236}">
-                <a16:creationId xmlns:a16="http://schemas.microsoft.com/office/drawing/2014/main" id="{ABA4FE26-6A8A-46C3-955F-8D15ECC325D1}"/>
+                <a16:creationId xmlns:a16="http://schemas.microsoft.com/office/drawing/2014/main" id="{ECDC8743-39ED-429F-9C0C-218311D089B8}"/>
               </a:ext>
             </a:extLst>
           </p:cNvPr>
@@ -9356,7 +9461,7 @@
           <p:cNvPr id="19" name="">
             <a:extLst xmlns:a="http://schemas.openxmlformats.org/drawingml/2006/main">
               <a:ext uri="{FF2B5EF4-FFF2-40B4-BE49-F238E27FC236}">
-                <a16:creationId xmlns:a16="http://schemas.microsoft.com/office/drawing/2014/main" id="{CEB270D4-0101-4642-976D-9674BE843D52}"/>
+                <a16:creationId xmlns:a16="http://schemas.microsoft.com/office/drawing/2014/main" id="{C3B80951-958A-4639-A35E-325D83243768}"/>
               </a:ext>
             </a:extLst>
           </p:cNvPr>
@@ -9389,7 +9494,7 @@
           <p:cNvPr id="20" name="">
             <a:extLst xmlns:a="http://schemas.openxmlformats.org/drawingml/2006/main">
               <a:ext uri="{FF2B5EF4-FFF2-40B4-BE49-F238E27FC236}">
-                <a16:creationId xmlns:a16="http://schemas.microsoft.com/office/drawing/2014/main" id="{DE549D90-99D4-400F-AAF5-433807FD11BF}"/>
+                <a16:creationId xmlns:a16="http://schemas.microsoft.com/office/drawing/2014/main" id="{D8E62999-B142-487A-AE48-8E2DD15C90DF}"/>
               </a:ext>
             </a:extLst>
           </p:cNvPr>
@@ -9439,7 +9544,7 @@
           <p:cNvPr id="21" name="">
             <a:extLst xmlns:a="http://schemas.openxmlformats.org/drawingml/2006/main">
               <a:ext uri="{FF2B5EF4-FFF2-40B4-BE49-F238E27FC236}">
-                <a16:creationId xmlns:a16="http://schemas.microsoft.com/office/drawing/2014/main" id="{888CFD41-9410-4034-8CBC-01C8E1971C2F}"/>
+                <a16:creationId xmlns:a16="http://schemas.microsoft.com/office/drawing/2014/main" id="{36B8756C-BF3F-4678-BA97-FEFBDAB1019B}"/>
               </a:ext>
             </a:extLst>
           </p:cNvPr>
@@ -9472,7 +9577,7 @@
           <p:cNvPr id="22" name="">
             <a:extLst xmlns:a="http://schemas.openxmlformats.org/drawingml/2006/main">
               <a:ext uri="{FF2B5EF4-FFF2-40B4-BE49-F238E27FC236}">
-                <a16:creationId xmlns:a16="http://schemas.microsoft.com/office/drawing/2014/main" id="{D7D75148-89FC-4FDF-B88C-45885EF4AE6B}"/>
+                <a16:creationId xmlns:a16="http://schemas.microsoft.com/office/drawing/2014/main" id="{C8631100-E273-42E9-9DB4-C8C3F561444B}"/>
               </a:ext>
             </a:extLst>
           </p:cNvPr>
@@ -9522,7 +9627,7 @@
           <p:cNvPr id="23" name="">
             <a:extLst xmlns:a="http://schemas.openxmlformats.org/drawingml/2006/main">
               <a:ext uri="{FF2B5EF4-FFF2-40B4-BE49-F238E27FC236}">
-                <a16:creationId xmlns:a16="http://schemas.microsoft.com/office/drawing/2014/main" id="{996BE055-D298-49B3-B601-A2EAC1210676}"/>
+                <a16:creationId xmlns:a16="http://schemas.microsoft.com/office/drawing/2014/main" id="{6ADBA49C-24E1-4E41-B798-E8CDAD08FA05}"/>
               </a:ext>
             </a:extLst>
           </p:cNvPr>
@@ -9572,7 +9677,7 @@
           <p:cNvPr id="24" name="">
             <a:extLst xmlns:a="http://schemas.openxmlformats.org/drawingml/2006/main">
               <a:ext uri="{FF2B5EF4-FFF2-40B4-BE49-F238E27FC236}">
-                <a16:creationId xmlns:a16="http://schemas.microsoft.com/office/drawing/2014/main" id="{7F1E75BB-1C11-4584-8DEB-A5286948A219}"/>
+                <a16:creationId xmlns:a16="http://schemas.microsoft.com/office/drawing/2014/main" id="{FB109199-0D1B-4183-8141-A7AB27D9AC07}"/>
               </a:ext>
             </a:extLst>
           </p:cNvPr>
@@ -9620,7 +9725,7 @@
     </p:spTree>
     <p:extLst>
       <p:ext uri="{BB962C8B-B14F-4D97-AF65-F5344CB8AC3E}">
-        <p14:creationId xmlns:p14="http://schemas.microsoft.com/office/powerpoint/2010/main" val="237116594"/>
+        <p14:creationId xmlns:p14="http://schemas.microsoft.com/office/powerpoint/2010/main" val="1917084629"/>
       </p:ext>
     </p:extLst>
   </p:cSld>

</xml_diff>

<commit_message>
Start slides with SDM foundations
</commit_message>
<xml_diff>
--- a/slides/intro_sdm_dengue_brazil.pptx
+++ b/slides/intro_sdm_dengue_brazil.pptx
@@ -2,24 +2,24 @@
 <file path=ppt/presentation.xml><?xml version="1.0" encoding="utf-8"?>
 <p:presentation xmlns:p="http://schemas.openxmlformats.org/presentationml/2006/main">
   <p:sldMasterIdLst>
-    <p:sldMasterId xmlns:r="http://schemas.openxmlformats.org/officeDocument/2006/relationships" id="2147483648" r:id="Rcf8161e451844c5f"/>
+    <p:sldMasterId xmlns:r="http://schemas.openxmlformats.org/officeDocument/2006/relationships" id="2147483648" r:id="R971a843fa16f4dd7"/>
   </p:sldMasterIdLst>
   <p:notesMasterIdLst>
-    <p:notesMasterId xmlns:r="http://schemas.openxmlformats.org/officeDocument/2006/relationships" r:id="Rb115892b809143ac"/>
+    <p:notesMasterId xmlns:r="http://schemas.openxmlformats.org/officeDocument/2006/relationships" r:id="Rc7599ac579a14ba5"/>
   </p:notesMasterIdLst>
   <p:sldIdLst>
-    <p:sldId xmlns:r="http://schemas.openxmlformats.org/officeDocument/2006/relationships" id="256" r:id="Re0319f4d8ac4409c"/>
-    <p:sldId xmlns:r="http://schemas.openxmlformats.org/officeDocument/2006/relationships" id="257" r:id="Rd9d4504eb5874078"/>
-    <p:sldId xmlns:r="http://schemas.openxmlformats.org/officeDocument/2006/relationships" id="258" r:id="R3481b8ed67f34afb"/>
-    <p:sldId xmlns:r="http://schemas.openxmlformats.org/officeDocument/2006/relationships" id="259" r:id="R41bf856b99174004"/>
-    <p:sldId xmlns:r="http://schemas.openxmlformats.org/officeDocument/2006/relationships" id="260" r:id="R30bd3f3aec7249ca"/>
-    <p:sldId xmlns:r="http://schemas.openxmlformats.org/officeDocument/2006/relationships" id="261" r:id="R963a4c172dfa4bb8"/>
-    <p:sldId xmlns:r="http://schemas.openxmlformats.org/officeDocument/2006/relationships" id="262" r:id="R8034f53d6bb942fb"/>
-    <p:sldId xmlns:r="http://schemas.openxmlformats.org/officeDocument/2006/relationships" id="263" r:id="R1b0d8aba24854589"/>
-    <p:sldId xmlns:r="http://schemas.openxmlformats.org/officeDocument/2006/relationships" id="264" r:id="Re2a93b2d01ba4501"/>
-    <p:sldId xmlns:r="http://schemas.openxmlformats.org/officeDocument/2006/relationships" id="265" r:id="R01f8dc5af56c4e35"/>
-    <p:sldId xmlns:r="http://schemas.openxmlformats.org/officeDocument/2006/relationships" id="266" r:id="Rc654ee032b6c4e41"/>
-    <p:sldId xmlns:r="http://schemas.openxmlformats.org/officeDocument/2006/relationships" id="267" r:id="Raf31625111d4461e"/>
+    <p:sldId xmlns:r="http://schemas.openxmlformats.org/officeDocument/2006/relationships" id="256" r:id="Rb5afbde976de4a3d"/>
+    <p:sldId xmlns:r="http://schemas.openxmlformats.org/officeDocument/2006/relationships" id="257" r:id="R57824d8e407e4ee4"/>
+    <p:sldId xmlns:r="http://schemas.openxmlformats.org/officeDocument/2006/relationships" id="258" r:id="R7699c39123a9432b"/>
+    <p:sldId xmlns:r="http://schemas.openxmlformats.org/officeDocument/2006/relationships" id="259" r:id="R37d257c6d0bb46ea"/>
+    <p:sldId xmlns:r="http://schemas.openxmlformats.org/officeDocument/2006/relationships" id="260" r:id="R09ccfb7eed1e45f1"/>
+    <p:sldId xmlns:r="http://schemas.openxmlformats.org/officeDocument/2006/relationships" id="261" r:id="R37eac961230243f8"/>
+    <p:sldId xmlns:r="http://schemas.openxmlformats.org/officeDocument/2006/relationships" id="262" r:id="R6b07d70fad7d45be"/>
+    <p:sldId xmlns:r="http://schemas.openxmlformats.org/officeDocument/2006/relationships" id="263" r:id="R6b83799b7baa417e"/>
+    <p:sldId xmlns:r="http://schemas.openxmlformats.org/officeDocument/2006/relationships" id="264" r:id="R0c261b54a0184c5a"/>
+    <p:sldId xmlns:r="http://schemas.openxmlformats.org/officeDocument/2006/relationships" id="265" r:id="Rda2b5ae8d0b64a11"/>
+    <p:sldId xmlns:r="http://schemas.openxmlformats.org/officeDocument/2006/relationships" id="266" r:id="R98d0ef0bf184448c"/>
+    <p:sldId xmlns:r="http://schemas.openxmlformats.org/officeDocument/2006/relationships" id="267" r:id="R6f33da91cf014dfe"/>
   </p:sldIdLst>
   <p:sldSz cx="12192000" cy="6858000"/>
   <p:notesSz cx="6858000" cy="9144000"/>
@@ -453,7 +453,7 @@
           <a:lstStyle xmlns:a="http://schemas.openxmlformats.org/drawingml/2006/main"/>
           <a:p xmlns:a="http://schemas.openxmlformats.org/drawingml/2006/main">
             <a:r>
-              <a:t>Open by positioning the session as applied modelling, not a general SDM survey.</a:t>
+              <a:t>Open with SDM as the method, then signal that Aedes aegypti in Brazil is the practical case study.</a:t>
             </a:r>
           </a:p>
           <a:p xmlns:a="http://schemas.openxmlformats.org/drawingml/2006/main">
@@ -753,12 +753,12 @@
           <a:lstStyle xmlns:a="http://schemas.openxmlformats.org/drawingml/2006/main"/>
           <a:p xmlns:a="http://schemas.openxmlformats.org/drawingml/2006/main">
             <a:r>
-              <a:t>Use this slide to prevent overclaiming before any map appears.</a:t>
-            </a:r>
-          </a:p>
-          <a:p xmlns:a="http://schemas.openxmlformats.org/drawingml/2006/main">
-            <a:r>
-              <a:t>[Sources] Workshop scope; infectious disease interpretation framed by vector SDM use.</a:t>
+              <a:t>Define SDM at the foundation level before naming dengue or Aedes aegypti.</a:t>
+            </a:r>
+          </a:p>
+          <a:p xmlns:a="http://schemas.openxmlformats.org/drawingml/2006/main">
+            <a:r>
+              <a:t>[Sources] Core SDM framing adapted from Lecture1_12Juin17.pdf pages 3 and 57-58.</a:t>
             </a:r>
           </a:p>
         </p:txBody>
@@ -828,12 +828,12 @@
           <a:lstStyle xmlns:a="http://schemas.openxmlformats.org/drawingml/2006/main"/>
           <a:p xmlns:a="http://schemas.openxmlformats.org/drawingml/2006/main">
             <a:r>
-              <a:t>Teaching bridge from old lecture's geography/environmental-space framing to the live code.</a:t>
-            </a:r>
-          </a:p>
-          <a:p xmlns:a="http://schemas.openxmlformats.org/drawingml/2006/main">
-            <a:r>
-              <a:t>[Sources] Concept adapted from Lecture1_12Juin17.pdf pages 57-58; workshop maps.</a:t>
+              <a:t>Make the difference between suitability and observed distribution explicit.</a:t>
+            </a:r>
+          </a:p>
+          <a:p xmlns:a="http://schemas.openxmlformats.org/drawingml/2006/main">
+            <a:r>
+              <a:t>[Sources] Concept adapted from Lecture1_12Juin17.pdf pages 7, 13, and 57-58; workshop maps.</a:t>
             </a:r>
           </a:p>
         </p:txBody>
@@ -903,12 +903,12 @@
           <a:lstStyle xmlns:a="http://schemas.openxmlformats.org/drawingml/2006/main"/>
           <a:p xmlns:a="http://schemas.openxmlformats.org/drawingml/2006/main">
             <a:r>
-              <a:t>Make the data caveat feel professional rather than apologetic.</a:t>
-            </a:r>
-          </a:p>
-          <a:p xmlns:a="http://schemas.openxmlformats.org/drawingml/2006/main">
-            <a:r>
-              <a:t>[Sources] Workshop GBIF data and cleaned occurrence map.</a:t>
+              <a:t>Introduce the applied infectious disease example after the SDM foundation.</a:t>
+            </a:r>
+          </a:p>
+          <a:p xmlns:a="http://schemas.openxmlformats.org/drawingml/2006/main">
+            <a:r>
+              <a:t>[Sources] Workshop scope and GBIF-based occurrence map.</a:t>
             </a:r>
           </a:p>
         </p:txBody>
@@ -1351,7 +1351,7 @@
   </p:cSld>
   <p:clrMap bg1="lt1" tx1="dk1" bg2="lt2" tx2="dk2" accent1="accent1" accent2="accent2" accent3="accent3" accent4="accent4" accent5="accent5" accent6="accent6" hlink="hlink" folHlink="folHlink"/>
   <p:sldLayoutIdLst>
-    <p:sldLayoutId xmlns:r="http://schemas.openxmlformats.org/officeDocument/2006/relationships" id="2147483649" r:id="Rf1c673feca384454"/>
+    <p:sldLayoutId xmlns:r="http://schemas.openxmlformats.org/officeDocument/2006/relationships" id="2147483649" r:id="Rd5eb5facd1964ddd"/>
   </p:sldLayoutIdLst>
   <p:txStyles>
     <p:titleStyle>
@@ -1906,7 +1906,7 @@
           <p:nvPr/>
         </p:nvPicPr>
         <p:blipFill>
-          <a:blip xmlns:r="http://schemas.openxmlformats.org/officeDocument/2006/relationships" xmlns:a="http://schemas.openxmlformats.org/drawingml/2006/main" r:embed="R751ef501880846ea"/>
+          <a:blip xmlns:r="http://schemas.openxmlformats.org/officeDocument/2006/relationships" xmlns:a="http://schemas.openxmlformats.org/drawingml/2006/main" r:embed="R451d0b3f15614183"/>
           <a:stretch xmlns:a="http://schemas.openxmlformats.org/drawingml/2006/main"/>
         </p:blipFill>
         <p:spPr>
@@ -1924,7 +1924,7 @@
           <p:cNvPr id="2" name="">
             <a:extLst xmlns:a="http://schemas.openxmlformats.org/drawingml/2006/main">
               <a:ext uri="{FF2B5EF4-FFF2-40B4-BE49-F238E27FC236}">
-                <a16:creationId xmlns:a16="http://schemas.microsoft.com/office/drawing/2014/main" id="{223AE12B-B563-476D-851A-C2D48049157D}"/>
+                <a16:creationId xmlns:a16="http://schemas.microsoft.com/office/drawing/2014/main" id="{6E0ADF48-153C-41FC-BA89-F648788E3D11}"/>
               </a:ext>
             </a:extLst>
           </p:cNvPr>
@@ -1955,7 +1955,7 @@
           <p:cNvPr id="3" name="">
             <a:extLst xmlns:a="http://schemas.openxmlformats.org/drawingml/2006/main">
               <a:ext uri="{FF2B5EF4-FFF2-40B4-BE49-F238E27FC236}">
-                <a16:creationId xmlns:a16="http://schemas.microsoft.com/office/drawing/2014/main" id="{FBFFFAFC-C027-4C29-AC47-442FA434E197}"/>
+                <a16:creationId xmlns:a16="http://schemas.microsoft.com/office/drawing/2014/main" id="{7116443A-3E13-4CF3-8ABB-5DECDC0A8EE1}"/>
               </a:ext>
             </a:extLst>
           </p:cNvPr>
@@ -1983,53 +1983,53 @@
           <a:lstStyle xmlns:a="http://schemas.openxmlformats.org/drawingml/2006/main"/>
           <a:p xmlns:a="http://schemas.openxmlformats.org/drawingml/2006/main">
             <a:pPr algn="l">
-              <a:defRPr sz="3750" b="1" i="0">
+              <a:defRPr sz="4050" b="1" i="0">
                 <a:solidFill>
                   <a:srgbClr val="FFFFFF"/>
                 </a:solidFill>
               </a:defRPr>
             </a:pPr>
             <a:r>
-              <a:rPr sz="3750" b="1" i="0">
+              <a:rPr sz="4050" b="1" i="0">
                 <a:solidFill>
                   <a:srgbClr val="FFFFFF"/>
                 </a:solidFill>
               </a:rPr>
-              <a:t>Aedes aegypti</a:t>
+              <a:t>Species</a:t>
             </a:r>
           </a:p>
           <a:p xmlns:a="http://schemas.openxmlformats.org/drawingml/2006/main">
             <a:pPr algn="l">
-              <a:defRPr sz="3750" b="1" i="0">
+              <a:defRPr sz="4050" b="1" i="0">
                 <a:solidFill>
                   <a:srgbClr val="FFFFFF"/>
                 </a:solidFill>
               </a:defRPr>
             </a:pPr>
             <a:r>
-              <a:rPr sz="3750" b="1" i="0">
+              <a:rPr sz="4050" b="1" i="0">
                 <a:solidFill>
                   <a:srgbClr val="FFFFFF"/>
                 </a:solidFill>
               </a:rPr>
-              <a:t>suitability</a:t>
+              <a:t>distribution</a:t>
             </a:r>
           </a:p>
           <a:p xmlns:a="http://schemas.openxmlformats.org/drawingml/2006/main">
             <a:pPr algn="l">
-              <a:defRPr sz="3750" b="1" i="0">
+              <a:defRPr sz="4050" b="1" i="0">
                 <a:solidFill>
                   <a:srgbClr val="FFFFFF"/>
                 </a:solidFill>
               </a:defRPr>
             </a:pPr>
             <a:r>
-              <a:rPr sz="3750" b="1" i="0">
+              <a:rPr sz="4050" b="1" i="0">
                 <a:solidFill>
                   <a:srgbClr val="FFFFFF"/>
                 </a:solidFill>
               </a:rPr>
-              <a:t>modelling</a:t>
+              <a:t>models</a:t>
             </a:r>
           </a:p>
         </p:txBody>
@@ -2039,7 +2039,7 @@
           <p:cNvPr id="4" name="">
             <a:extLst xmlns:a="http://schemas.openxmlformats.org/drawingml/2006/main">
               <a:ext uri="{FF2B5EF4-FFF2-40B4-BE49-F238E27FC236}">
-                <a16:creationId xmlns:a16="http://schemas.microsoft.com/office/drawing/2014/main" id="{6D7FDC1A-8DA9-493C-B323-ED9A3AA04A72}"/>
+                <a16:creationId xmlns:a16="http://schemas.microsoft.com/office/drawing/2014/main" id="{319A5084-422D-4DF5-8805-C70563120D15}"/>
               </a:ext>
             </a:extLst>
           </p:cNvPr>
@@ -2079,7 +2079,7 @@
                   <a:srgbClr val="D7E9E4"/>
                 </a:solidFill>
               </a:rPr>
-              <a:t>A compact R workshop for infectious disease researchers: from GBIF records to biomod2 ensembles.</a:t>
+              <a:t>Foundations first, then a worked R example using Aedes aegypti suitability in Brazil.</a:t>
             </a:r>
           </a:p>
         </p:txBody>
@@ -2089,7 +2089,7 @@
           <p:cNvPr id="5" name="">
             <a:extLst xmlns:a="http://schemas.openxmlformats.org/drawingml/2006/main">
               <a:ext uri="{FF2B5EF4-FFF2-40B4-BE49-F238E27FC236}">
-                <a16:creationId xmlns:a16="http://schemas.microsoft.com/office/drawing/2014/main" id="{79F76DB2-5E91-4FEE-A263-CB5BADEBC30E}"/>
+                <a16:creationId xmlns:a16="http://schemas.microsoft.com/office/drawing/2014/main" id="{44F09332-934C-4E15-92D3-A71CA7A2A177}"/>
               </a:ext>
             </a:extLst>
           </p:cNvPr>
@@ -2120,7 +2120,7 @@
           <p:cNvPr id="6" name="">
             <a:extLst xmlns:a="http://schemas.openxmlformats.org/drawingml/2006/main">
               <a:ext uri="{FF2B5EF4-FFF2-40B4-BE49-F238E27FC236}">
-                <a16:creationId xmlns:a16="http://schemas.microsoft.com/office/drawing/2014/main" id="{F019256D-D209-42E0-924B-05763F44F683}"/>
+                <a16:creationId xmlns:a16="http://schemas.microsoft.com/office/drawing/2014/main" id="{E90CC5AC-4B7E-471D-810D-1247D99FDC88}"/>
               </a:ext>
             </a:extLst>
           </p:cNvPr>
@@ -2160,7 +2160,7 @@
                   <a:srgbClr val="F3D2B3"/>
                 </a:solidFill>
               </a:rPr>
-              <a:t>Brazil | GBIF | WorldClim | GLM, GBM, RF</a:t>
+              <a:t>niche | occurrence data | predictors | projection</a:t>
             </a:r>
           </a:p>
         </p:txBody>
@@ -2168,7 +2168,7 @@
     </p:spTree>
     <p:extLst>
       <p:ext uri="{BB962C8B-B14F-4D97-AF65-F5344CB8AC3E}">
-        <p14:creationId xmlns:p14="http://schemas.microsoft.com/office/powerpoint/2010/main" val="136328300"/>
+        <p14:creationId xmlns:p14="http://schemas.microsoft.com/office/powerpoint/2010/main" val="435423562"/>
       </p:ext>
     </p:extLst>
   </p:cSld>
@@ -2199,7 +2199,7 @@
           <p:cNvPr id="15" name="">
             <a:extLst xmlns:a="http://schemas.openxmlformats.org/drawingml/2006/main">
               <a:ext uri="{FF2B5EF4-FFF2-40B4-BE49-F238E27FC236}">
-                <a16:creationId xmlns:a16="http://schemas.microsoft.com/office/drawing/2014/main" id="{21B2177D-56F3-4473-AB27-E9960BC81CDC}"/>
+                <a16:creationId xmlns:a16="http://schemas.microsoft.com/office/drawing/2014/main" id="{DFFF9DE7-9E88-499A-8693-EF2D8B0B1F89}"/>
               </a:ext>
             </a:extLst>
           </p:cNvPr>
@@ -2249,7 +2249,7 @@
           <p:cNvPr id="2" name="">
             <a:extLst xmlns:a="http://schemas.openxmlformats.org/drawingml/2006/main">
               <a:ext uri="{FF2B5EF4-FFF2-40B4-BE49-F238E27FC236}">
-                <a16:creationId xmlns:a16="http://schemas.microsoft.com/office/drawing/2014/main" id="{54123652-B675-4A15-A60A-D269891C353B}"/>
+                <a16:creationId xmlns:a16="http://schemas.microsoft.com/office/drawing/2014/main" id="{FE7D7710-AB34-40E5-B2CA-CAEB544B9BDF}"/>
               </a:ext>
             </a:extLst>
           </p:cNvPr>
@@ -2280,7 +2280,7 @@
           <p:cNvPr id="3" name="">
             <a:extLst xmlns:a="http://schemas.openxmlformats.org/drawingml/2006/main">
               <a:ext uri="{FF2B5EF4-FFF2-40B4-BE49-F238E27FC236}">
-                <a16:creationId xmlns:a16="http://schemas.microsoft.com/office/drawing/2014/main" id="{0C898568-CC69-464E-A7D8-4C0179819FA5}"/>
+                <a16:creationId xmlns:a16="http://schemas.microsoft.com/office/drawing/2014/main" id="{F7FCD8D5-81B4-4162-98CE-491941A257C4}"/>
               </a:ext>
             </a:extLst>
           </p:cNvPr>
@@ -2330,7 +2330,7 @@
           <p:cNvPr id="4" name="">
             <a:extLst xmlns:a="http://schemas.openxmlformats.org/drawingml/2006/main">
               <a:ext uri="{FF2B5EF4-FFF2-40B4-BE49-F238E27FC236}">
-                <a16:creationId xmlns:a16="http://schemas.microsoft.com/office/drawing/2014/main" id="{927EE055-EBBE-4AF6-B89F-71F6DA176184}"/>
+                <a16:creationId xmlns:a16="http://schemas.microsoft.com/office/drawing/2014/main" id="{C1D73C20-2D0B-4C93-99EE-D9ED2697DA27}"/>
               </a:ext>
             </a:extLst>
           </p:cNvPr>
@@ -2380,7 +2380,7 @@
           <p:cNvPr id="5" name="">
             <a:extLst xmlns:a="http://schemas.openxmlformats.org/drawingml/2006/main">
               <a:ext uri="{FF2B5EF4-FFF2-40B4-BE49-F238E27FC236}">
-                <a16:creationId xmlns:a16="http://schemas.microsoft.com/office/drawing/2014/main" id="{B67E599D-645C-4250-A4BA-D618CE12F4C6}"/>
+                <a16:creationId xmlns:a16="http://schemas.microsoft.com/office/drawing/2014/main" id="{59F96B9A-E2F9-4CF5-8CA1-1DB3FCB68E9D}"/>
               </a:ext>
             </a:extLst>
           </p:cNvPr>
@@ -2430,7 +2430,7 @@
           <p:cNvPr id="6" name="">
             <a:extLst xmlns:a="http://schemas.openxmlformats.org/drawingml/2006/main">
               <a:ext uri="{FF2B5EF4-FFF2-40B4-BE49-F238E27FC236}">
-                <a16:creationId xmlns:a16="http://schemas.microsoft.com/office/drawing/2014/main" id="{67BE35A1-C049-46FA-B79B-FD14C616F45D}"/>
+                <a16:creationId xmlns:a16="http://schemas.microsoft.com/office/drawing/2014/main" id="{E5A577D2-76C0-4793-A9E2-C7926E0A2334}"/>
               </a:ext>
             </a:extLst>
           </p:cNvPr>
@@ -2480,7 +2480,7 @@
           <p:cNvPr id="7" name="">
             <a:extLst xmlns:a="http://schemas.openxmlformats.org/drawingml/2006/main">
               <a:ext uri="{FF2B5EF4-FFF2-40B4-BE49-F238E27FC236}">
-                <a16:creationId xmlns:a16="http://schemas.microsoft.com/office/drawing/2014/main" id="{63460CE4-111D-4321-B8A2-07499660A41A}"/>
+                <a16:creationId xmlns:a16="http://schemas.microsoft.com/office/drawing/2014/main" id="{AA635E19-2CF7-4BE9-AC82-7D6144DE929E}"/>
               </a:ext>
             </a:extLst>
           </p:cNvPr>
@@ -2530,7 +2530,7 @@
           <p:cNvPr id="8" name="">
             <a:extLst xmlns:a="http://schemas.openxmlformats.org/drawingml/2006/main">
               <a:ext uri="{FF2B5EF4-FFF2-40B4-BE49-F238E27FC236}">
-                <a16:creationId xmlns:a16="http://schemas.microsoft.com/office/drawing/2014/main" id="{13B64EBF-9638-43F9-B5D2-4602526CC98E}"/>
+                <a16:creationId xmlns:a16="http://schemas.microsoft.com/office/drawing/2014/main" id="{B2D287F7-17A4-4311-9410-65C4194B9BDA}"/>
               </a:ext>
             </a:extLst>
           </p:cNvPr>
@@ -2580,7 +2580,7 @@
           <p:cNvPr id="9" name="">
             <a:extLst xmlns:a="http://schemas.openxmlformats.org/drawingml/2006/main">
               <a:ext uri="{FF2B5EF4-FFF2-40B4-BE49-F238E27FC236}">
-                <a16:creationId xmlns:a16="http://schemas.microsoft.com/office/drawing/2014/main" id="{ABC62E13-9894-45EC-A5D6-CFEBC010A22C}"/>
+                <a16:creationId xmlns:a16="http://schemas.microsoft.com/office/drawing/2014/main" id="{56EAEB22-B8D2-45CE-B723-7EC726D64EAB}"/>
               </a:ext>
             </a:extLst>
           </p:cNvPr>
@@ -2611,7 +2611,7 @@
           <p:cNvPr id="10" name="">
             <a:extLst xmlns:a="http://schemas.openxmlformats.org/drawingml/2006/main">
               <a:ext uri="{FF2B5EF4-FFF2-40B4-BE49-F238E27FC236}">
-                <a16:creationId xmlns:a16="http://schemas.microsoft.com/office/drawing/2014/main" id="{4F325772-1350-4ED7-BE14-2F01A7B49A7A}"/>
+                <a16:creationId xmlns:a16="http://schemas.microsoft.com/office/drawing/2014/main" id="{04870CA6-5A56-428A-9BD8-A99624B0AB3A}"/>
               </a:ext>
             </a:extLst>
           </p:cNvPr>
@@ -2661,7 +2661,7 @@
           <p:cNvPr id="11" name="">
             <a:extLst xmlns:a="http://schemas.openxmlformats.org/drawingml/2006/main">
               <a:ext uri="{FF2B5EF4-FFF2-40B4-BE49-F238E27FC236}">
-                <a16:creationId xmlns:a16="http://schemas.microsoft.com/office/drawing/2014/main" id="{E39F7696-057F-403B-A4E1-1461D2AD59A6}"/>
+                <a16:creationId xmlns:a16="http://schemas.microsoft.com/office/drawing/2014/main" id="{C7BF3522-1FCB-484E-A2C0-C293B2529C8E}"/>
               </a:ext>
             </a:extLst>
           </p:cNvPr>
@@ -2711,7 +2711,7 @@
           <p:cNvPr id="12" name="">
             <a:extLst xmlns:a="http://schemas.openxmlformats.org/drawingml/2006/main">
               <a:ext uri="{FF2B5EF4-FFF2-40B4-BE49-F238E27FC236}">
-                <a16:creationId xmlns:a16="http://schemas.microsoft.com/office/drawing/2014/main" id="{929E317E-3323-4ED0-87A2-15B5786FA0B1}"/>
+                <a16:creationId xmlns:a16="http://schemas.microsoft.com/office/drawing/2014/main" id="{4FBE4279-CB46-4EDF-865F-5D2ECCF3D530}"/>
               </a:ext>
             </a:extLst>
           </p:cNvPr>
@@ -2761,7 +2761,7 @@
           <p:cNvPr id="13" name="">
             <a:extLst xmlns:a="http://schemas.openxmlformats.org/drawingml/2006/main">
               <a:ext uri="{FF2B5EF4-FFF2-40B4-BE49-F238E27FC236}">
-                <a16:creationId xmlns:a16="http://schemas.microsoft.com/office/drawing/2014/main" id="{1D158082-408A-426F-8BA7-93CC519D802B}"/>
+                <a16:creationId xmlns:a16="http://schemas.microsoft.com/office/drawing/2014/main" id="{31731FF2-B6B8-4C3F-8398-A1BF48290428}"/>
               </a:ext>
             </a:extLst>
           </p:cNvPr>
@@ -2811,7 +2811,7 @@
           <p:cNvPr id="14" name="">
             <a:extLst xmlns:a="http://schemas.openxmlformats.org/drawingml/2006/main">
               <a:ext uri="{FF2B5EF4-FFF2-40B4-BE49-F238E27FC236}">
-                <a16:creationId xmlns:a16="http://schemas.microsoft.com/office/drawing/2014/main" id="{46ED8475-EC58-4319-8FED-80096B8E3690}"/>
+                <a16:creationId xmlns:a16="http://schemas.microsoft.com/office/drawing/2014/main" id="{37DDED26-513A-4DA4-84F4-23339250C455}"/>
               </a:ext>
             </a:extLst>
           </p:cNvPr>
@@ -2823,7 +2823,7 @@
         <p:spPr>
           <a:xfrm xmlns:a="http://schemas.openxmlformats.org/drawingml/2006/main">
             <a:off x="685800" y="6419850"/>
-            <a:ext cx="4000500" cy="171450"/>
+            <a:ext cx="3048000" cy="171450"/>
           </a:xfrm>
           <a:prstGeom xmlns:a="http://schemas.openxmlformats.org/drawingml/2006/main" prst="rect">
             <a:avLst/>
@@ -2851,7 +2851,7 @@
                   <a:srgbClr val="87AAA5"/>
                 </a:solidFill>
               </a:rPr>
-              <a:t>Species distribution modelling for dengue vector mapping</a:t>
+              <a:t>Species distribution modelling workshop</a:t>
             </a:r>
           </a:p>
         </p:txBody>
@@ -2859,7 +2859,7 @@
     </p:spTree>
     <p:extLst>
       <p:ext uri="{BB962C8B-B14F-4D97-AF65-F5344CB8AC3E}">
-        <p14:creationId xmlns:p14="http://schemas.microsoft.com/office/powerpoint/2010/main" val="1296354279"/>
+        <p14:creationId xmlns:p14="http://schemas.microsoft.com/office/powerpoint/2010/main" val="511151755"/>
       </p:ext>
     </p:extLst>
   </p:cSld>
@@ -2890,7 +2890,7 @@
           <p:cNvPr id="10" name="">
             <a:extLst xmlns:a="http://schemas.openxmlformats.org/drawingml/2006/main">
               <a:ext uri="{FF2B5EF4-FFF2-40B4-BE49-F238E27FC236}">
-                <a16:creationId xmlns:a16="http://schemas.microsoft.com/office/drawing/2014/main" id="{C6988BDD-723F-49E5-975F-6876ADD1D144}"/>
+                <a16:creationId xmlns:a16="http://schemas.microsoft.com/office/drawing/2014/main" id="{40834FC8-0AA0-4FBB-AFC5-49E3A0F45CAB}"/>
               </a:ext>
             </a:extLst>
           </p:cNvPr>
@@ -2940,7 +2940,7 @@
           <p:cNvPr id="2" name="">
             <a:extLst xmlns:a="http://schemas.openxmlformats.org/drawingml/2006/main">
               <a:ext uri="{FF2B5EF4-FFF2-40B4-BE49-F238E27FC236}">
-                <a16:creationId xmlns:a16="http://schemas.microsoft.com/office/drawing/2014/main" id="{D5166DB7-9A35-497D-AB92-7187D62E9597}"/>
+                <a16:creationId xmlns:a16="http://schemas.microsoft.com/office/drawing/2014/main" id="{1E152504-347B-4248-A23D-26202885AD40}"/>
               </a:ext>
             </a:extLst>
           </p:cNvPr>
@@ -2971,7 +2971,7 @@
           <p:cNvPr id="3" name="">
             <a:extLst xmlns:a="http://schemas.openxmlformats.org/drawingml/2006/main">
               <a:ext uri="{FF2B5EF4-FFF2-40B4-BE49-F238E27FC236}">
-                <a16:creationId xmlns:a16="http://schemas.microsoft.com/office/drawing/2014/main" id="{EA686DE1-C72E-44AF-8419-7702074CBEFD}"/>
+                <a16:creationId xmlns:a16="http://schemas.microsoft.com/office/drawing/2014/main" id="{7B11EB6A-11A8-40A6-83DC-AEF661774276}"/>
               </a:ext>
             </a:extLst>
           </p:cNvPr>
@@ -3021,7 +3021,7 @@
           <p:cNvPr id="4" name="">
             <a:extLst xmlns:a="http://schemas.openxmlformats.org/drawingml/2006/main">
               <a:ext uri="{FF2B5EF4-FFF2-40B4-BE49-F238E27FC236}">
-                <a16:creationId xmlns:a16="http://schemas.microsoft.com/office/drawing/2014/main" id="{0239E995-0850-4085-BD1A-94CF0382EA4C}"/>
+                <a16:creationId xmlns:a16="http://schemas.microsoft.com/office/drawing/2014/main" id="{5B29D40F-575F-451C-8B1D-59936549025D}"/>
               </a:ext>
             </a:extLst>
           </p:cNvPr>
@@ -3075,7 +3075,7 @@
           <p:nvPr/>
         </p:nvPicPr>
         <p:blipFill>
-          <a:blip xmlns:r="http://schemas.openxmlformats.org/officeDocument/2006/relationships" xmlns:a="http://schemas.openxmlformats.org/drawingml/2006/main" r:embed="R2d01fca2ce854862"/>
+          <a:blip xmlns:r="http://schemas.openxmlformats.org/officeDocument/2006/relationships" xmlns:a="http://schemas.openxmlformats.org/drawingml/2006/main" r:embed="Ra68b0cf7c9ee4229"/>
           <a:stretch xmlns:a="http://schemas.openxmlformats.org/drawingml/2006/main"/>
         </p:blipFill>
         <p:spPr>
@@ -3097,7 +3097,7 @@
           <p:nvPr/>
         </p:nvPicPr>
         <p:blipFill>
-          <a:blip xmlns:r="http://schemas.openxmlformats.org/officeDocument/2006/relationships" xmlns:a="http://schemas.openxmlformats.org/drawingml/2006/main" r:embed="Re43900270f1b4a19"/>
+          <a:blip xmlns:r="http://schemas.openxmlformats.org/officeDocument/2006/relationships" xmlns:a="http://schemas.openxmlformats.org/drawingml/2006/main" r:embed="R2f9c7d16f25544a0"/>
           <a:stretch xmlns:a="http://schemas.openxmlformats.org/drawingml/2006/main"/>
         </p:blipFill>
         <p:spPr>
@@ -3115,7 +3115,7 @@
           <p:cNvPr id="7" name="">
             <a:extLst xmlns:a="http://schemas.openxmlformats.org/drawingml/2006/main">
               <a:ext uri="{FF2B5EF4-FFF2-40B4-BE49-F238E27FC236}">
-                <a16:creationId xmlns:a16="http://schemas.microsoft.com/office/drawing/2014/main" id="{109E5E01-CABC-4991-BE13-64C16F232BBF}"/>
+                <a16:creationId xmlns:a16="http://schemas.microsoft.com/office/drawing/2014/main" id="{490DA823-8CE4-49FF-BCBA-A2FE81BFD0A4}"/>
               </a:ext>
             </a:extLst>
           </p:cNvPr>
@@ -3165,7 +3165,7 @@
           <p:cNvPr id="8" name="">
             <a:extLst xmlns:a="http://schemas.openxmlformats.org/drawingml/2006/main">
               <a:ext uri="{FF2B5EF4-FFF2-40B4-BE49-F238E27FC236}">
-                <a16:creationId xmlns:a16="http://schemas.microsoft.com/office/drawing/2014/main" id="{255A756C-67F4-439E-BCAF-7B5B099F258E}"/>
+                <a16:creationId xmlns:a16="http://schemas.microsoft.com/office/drawing/2014/main" id="{0D97F975-CF5F-4750-8723-16E16F57C720}"/>
               </a:ext>
             </a:extLst>
           </p:cNvPr>
@@ -3215,7 +3215,7 @@
           <p:cNvPr id="9" name="">
             <a:extLst xmlns:a="http://schemas.openxmlformats.org/drawingml/2006/main">
               <a:ext uri="{FF2B5EF4-FFF2-40B4-BE49-F238E27FC236}">
-                <a16:creationId xmlns:a16="http://schemas.microsoft.com/office/drawing/2014/main" id="{893D1848-EF15-4BCB-B524-ACEC8071FAD4}"/>
+                <a16:creationId xmlns:a16="http://schemas.microsoft.com/office/drawing/2014/main" id="{DA1B7BE6-5932-4CD4-BEA4-DDE7B50FA9CA}"/>
               </a:ext>
             </a:extLst>
           </p:cNvPr>
@@ -3227,7 +3227,7 @@
         <p:spPr>
           <a:xfrm xmlns:a="http://schemas.openxmlformats.org/drawingml/2006/main">
             <a:off x="685800" y="6419850"/>
-            <a:ext cx="4000500" cy="171450"/>
+            <a:ext cx="3048000" cy="171450"/>
           </a:xfrm>
           <a:prstGeom xmlns:a="http://schemas.openxmlformats.org/drawingml/2006/main" prst="rect">
             <a:avLst/>
@@ -3255,7 +3255,7 @@
                   <a:srgbClr val="9A948B"/>
                 </a:solidFill>
               </a:rPr>
-              <a:t>Species distribution modelling for dengue vector mapping</a:t>
+              <a:t>Species distribution modelling workshop</a:t>
             </a:r>
           </a:p>
         </p:txBody>
@@ -3263,7 +3263,7 @@
     </p:spTree>
     <p:extLst>
       <p:ext uri="{BB962C8B-B14F-4D97-AF65-F5344CB8AC3E}">
-        <p14:creationId xmlns:p14="http://schemas.microsoft.com/office/powerpoint/2010/main" val="1042762770"/>
+        <p14:creationId xmlns:p14="http://schemas.microsoft.com/office/powerpoint/2010/main" val="1771123614"/>
       </p:ext>
     </p:extLst>
   </p:cSld>
@@ -3294,7 +3294,7 @@
           <p:cNvPr id="19" name="">
             <a:extLst xmlns:a="http://schemas.openxmlformats.org/drawingml/2006/main">
               <a:ext uri="{FF2B5EF4-FFF2-40B4-BE49-F238E27FC236}">
-                <a16:creationId xmlns:a16="http://schemas.microsoft.com/office/drawing/2014/main" id="{A112D1D4-5BC5-4E5D-8E9E-D6543A1817FE}"/>
+                <a16:creationId xmlns:a16="http://schemas.microsoft.com/office/drawing/2014/main" id="{D6CE4726-D56C-4C3C-8DD7-6CB789A497EC}"/>
               </a:ext>
             </a:extLst>
           </p:cNvPr>
@@ -3344,7 +3344,7 @@
           <p:cNvPr id="2" name="">
             <a:extLst xmlns:a="http://schemas.openxmlformats.org/drawingml/2006/main">
               <a:ext uri="{FF2B5EF4-FFF2-40B4-BE49-F238E27FC236}">
-                <a16:creationId xmlns:a16="http://schemas.microsoft.com/office/drawing/2014/main" id="{63112284-2504-4816-9946-A4EE275886CE}"/>
+                <a16:creationId xmlns:a16="http://schemas.microsoft.com/office/drawing/2014/main" id="{95E99CA0-5717-4638-B085-CC0DFDCF7CDE}"/>
               </a:ext>
             </a:extLst>
           </p:cNvPr>
@@ -3375,7 +3375,7 @@
           <p:cNvPr id="3" name="">
             <a:extLst xmlns:a="http://schemas.openxmlformats.org/drawingml/2006/main">
               <a:ext uri="{FF2B5EF4-FFF2-40B4-BE49-F238E27FC236}">
-                <a16:creationId xmlns:a16="http://schemas.microsoft.com/office/drawing/2014/main" id="{D1518B3E-6524-45E5-B979-52D318227CD0}"/>
+                <a16:creationId xmlns:a16="http://schemas.microsoft.com/office/drawing/2014/main" id="{86E9DC0A-993B-4DD5-A31C-04502B4F5EB7}"/>
               </a:ext>
             </a:extLst>
           </p:cNvPr>
@@ -3425,7 +3425,7 @@
           <p:cNvPr id="4" name="">
             <a:extLst xmlns:a="http://schemas.openxmlformats.org/drawingml/2006/main">
               <a:ext uri="{FF2B5EF4-FFF2-40B4-BE49-F238E27FC236}">
-                <a16:creationId xmlns:a16="http://schemas.microsoft.com/office/drawing/2014/main" id="{DB63F016-DB62-4D40-9F53-2E55FB0C8FC0}"/>
+                <a16:creationId xmlns:a16="http://schemas.microsoft.com/office/drawing/2014/main" id="{3E4F24EC-09D3-43D4-8B44-2B324E8E8E46}"/>
               </a:ext>
             </a:extLst>
           </p:cNvPr>
@@ -3479,7 +3479,7 @@
           <p:nvPr/>
         </p:nvPicPr>
         <p:blipFill>
-          <a:blip xmlns:r="http://schemas.openxmlformats.org/officeDocument/2006/relationships" xmlns:a="http://schemas.openxmlformats.org/drawingml/2006/main" r:embed="Rd3c9f8f68e1d40e8"/>
+          <a:blip xmlns:r="http://schemas.openxmlformats.org/officeDocument/2006/relationships" xmlns:a="http://schemas.openxmlformats.org/drawingml/2006/main" r:embed="R7379a4409fe44f6d"/>
           <a:stretch xmlns:a="http://schemas.openxmlformats.org/drawingml/2006/main"/>
         </p:blipFill>
         <p:spPr>
@@ -3497,7 +3497,7 @@
           <p:cNvPr id="6" name="">
             <a:extLst xmlns:a="http://schemas.openxmlformats.org/drawingml/2006/main">
               <a:ext uri="{FF2B5EF4-FFF2-40B4-BE49-F238E27FC236}">
-                <a16:creationId xmlns:a16="http://schemas.microsoft.com/office/drawing/2014/main" id="{BCBFCF0D-1035-430D-B36E-6E316D64F972}"/>
+                <a16:creationId xmlns:a16="http://schemas.microsoft.com/office/drawing/2014/main" id="{1B935A9D-AED3-488A-9CE0-28452E96667B}"/>
               </a:ext>
             </a:extLst>
           </p:cNvPr>
@@ -3547,7 +3547,7 @@
           <p:cNvPr id="7" name="">
             <a:extLst xmlns:a="http://schemas.openxmlformats.org/drawingml/2006/main">
               <a:ext uri="{FF2B5EF4-FFF2-40B4-BE49-F238E27FC236}">
-                <a16:creationId xmlns:a16="http://schemas.microsoft.com/office/drawing/2014/main" id="{2F57DC32-51C0-4144-9338-C7954FE81B55}"/>
+                <a16:creationId xmlns:a16="http://schemas.microsoft.com/office/drawing/2014/main" id="{6C26EF74-34AE-4E34-AC9B-17153BC617EA}"/>
               </a:ext>
             </a:extLst>
           </p:cNvPr>
@@ -3578,7 +3578,7 @@
           <p:cNvPr id="8" name="">
             <a:extLst xmlns:a="http://schemas.openxmlformats.org/drawingml/2006/main">
               <a:ext uri="{FF2B5EF4-FFF2-40B4-BE49-F238E27FC236}">
-                <a16:creationId xmlns:a16="http://schemas.microsoft.com/office/drawing/2014/main" id="{24E6EFC1-FF99-483B-8803-D44FE8AB1CD6}"/>
+                <a16:creationId xmlns:a16="http://schemas.microsoft.com/office/drawing/2014/main" id="{8E7DA1EA-2227-485A-92BE-83FBA20D61A0}"/>
               </a:ext>
             </a:extLst>
           </p:cNvPr>
@@ -3628,7 +3628,7 @@
           <p:cNvPr id="9" name="">
             <a:extLst xmlns:a="http://schemas.openxmlformats.org/drawingml/2006/main">
               <a:ext uri="{FF2B5EF4-FFF2-40B4-BE49-F238E27FC236}">
-                <a16:creationId xmlns:a16="http://schemas.microsoft.com/office/drawing/2014/main" id="{2D8CA101-AFE4-411E-B2BF-3A58C11E6892}"/>
+                <a16:creationId xmlns:a16="http://schemas.microsoft.com/office/drawing/2014/main" id="{710AD975-71D5-4D18-B498-9FF646132635}"/>
               </a:ext>
             </a:extLst>
           </p:cNvPr>
@@ -3659,7 +3659,7 @@
           <p:cNvPr id="10" name="">
             <a:extLst xmlns:a="http://schemas.openxmlformats.org/drawingml/2006/main">
               <a:ext uri="{FF2B5EF4-FFF2-40B4-BE49-F238E27FC236}">
-                <a16:creationId xmlns:a16="http://schemas.microsoft.com/office/drawing/2014/main" id="{EA30806C-3AAF-4317-B9AB-76D75778C0A8}"/>
+                <a16:creationId xmlns:a16="http://schemas.microsoft.com/office/drawing/2014/main" id="{ACD06CAA-576D-4DEA-8560-F5AAC0788B6A}"/>
               </a:ext>
             </a:extLst>
           </p:cNvPr>
@@ -3709,7 +3709,7 @@
           <p:cNvPr id="11" name="">
             <a:extLst xmlns:a="http://schemas.openxmlformats.org/drawingml/2006/main">
               <a:ext uri="{FF2B5EF4-FFF2-40B4-BE49-F238E27FC236}">
-                <a16:creationId xmlns:a16="http://schemas.microsoft.com/office/drawing/2014/main" id="{E5D02FD7-9D17-44EE-8837-8C6C828A6964}"/>
+                <a16:creationId xmlns:a16="http://schemas.microsoft.com/office/drawing/2014/main" id="{027AAD51-C16A-48BF-A5B9-BD4891B1BDA7}"/>
               </a:ext>
             </a:extLst>
           </p:cNvPr>
@@ -3740,7 +3740,7 @@
           <p:cNvPr id="12" name="">
             <a:extLst xmlns:a="http://schemas.openxmlformats.org/drawingml/2006/main">
               <a:ext uri="{FF2B5EF4-FFF2-40B4-BE49-F238E27FC236}">
-                <a16:creationId xmlns:a16="http://schemas.microsoft.com/office/drawing/2014/main" id="{752F2783-89B1-4D2D-B5B0-AFD51F292B35}"/>
+                <a16:creationId xmlns:a16="http://schemas.microsoft.com/office/drawing/2014/main" id="{0A3826DA-B1C7-443D-817A-6A9279B08A5B}"/>
               </a:ext>
             </a:extLst>
           </p:cNvPr>
@@ -3790,7 +3790,7 @@
           <p:cNvPr id="13" name="">
             <a:extLst xmlns:a="http://schemas.openxmlformats.org/drawingml/2006/main">
               <a:ext uri="{FF2B5EF4-FFF2-40B4-BE49-F238E27FC236}">
-                <a16:creationId xmlns:a16="http://schemas.microsoft.com/office/drawing/2014/main" id="{DC59F809-23FE-45B2-9C30-5D627B77BFE6}"/>
+                <a16:creationId xmlns:a16="http://schemas.microsoft.com/office/drawing/2014/main" id="{1DDD6E79-1170-46E8-B477-EFE6DED70231}"/>
               </a:ext>
             </a:extLst>
           </p:cNvPr>
@@ -3821,7 +3821,7 @@
           <p:cNvPr id="14" name="">
             <a:extLst xmlns:a="http://schemas.openxmlformats.org/drawingml/2006/main">
               <a:ext uri="{FF2B5EF4-FFF2-40B4-BE49-F238E27FC236}">
-                <a16:creationId xmlns:a16="http://schemas.microsoft.com/office/drawing/2014/main" id="{75FE52C0-C524-4076-90B1-60FA7939112E}"/>
+                <a16:creationId xmlns:a16="http://schemas.microsoft.com/office/drawing/2014/main" id="{1F795CC1-6384-47CA-83FA-359A38A323CA}"/>
               </a:ext>
             </a:extLst>
           </p:cNvPr>
@@ -3871,7 +3871,7 @@
           <p:cNvPr id="15" name="">
             <a:extLst xmlns:a="http://schemas.openxmlformats.org/drawingml/2006/main">
               <a:ext uri="{FF2B5EF4-FFF2-40B4-BE49-F238E27FC236}">
-                <a16:creationId xmlns:a16="http://schemas.microsoft.com/office/drawing/2014/main" id="{392444B5-D3BE-4F22-8A00-CC7CD4145A16}"/>
+                <a16:creationId xmlns:a16="http://schemas.microsoft.com/office/drawing/2014/main" id="{BCCE5511-0BD7-4380-82EC-25734CD91DEA}"/>
               </a:ext>
             </a:extLst>
           </p:cNvPr>
@@ -3902,7 +3902,7 @@
           <p:cNvPr id="16" name="">
             <a:extLst xmlns:a="http://schemas.openxmlformats.org/drawingml/2006/main">
               <a:ext uri="{FF2B5EF4-FFF2-40B4-BE49-F238E27FC236}">
-                <a16:creationId xmlns:a16="http://schemas.microsoft.com/office/drawing/2014/main" id="{115791C7-0995-40E0-ACB8-EE7882F628C5}"/>
+                <a16:creationId xmlns:a16="http://schemas.microsoft.com/office/drawing/2014/main" id="{C1E27940-4F78-44D4-8C37-00D06356CC8E}"/>
               </a:ext>
             </a:extLst>
           </p:cNvPr>
@@ -3952,7 +3952,7 @@
           <p:cNvPr id="17" name="">
             <a:extLst xmlns:a="http://schemas.openxmlformats.org/drawingml/2006/main">
               <a:ext uri="{FF2B5EF4-FFF2-40B4-BE49-F238E27FC236}">
-                <a16:creationId xmlns:a16="http://schemas.microsoft.com/office/drawing/2014/main" id="{69CB517D-F926-410E-A09B-D3185402160B}"/>
+                <a16:creationId xmlns:a16="http://schemas.microsoft.com/office/drawing/2014/main" id="{CEB3D8B3-FB67-4632-AF88-DC7AC337A48A}"/>
               </a:ext>
             </a:extLst>
           </p:cNvPr>
@@ -4002,7 +4002,7 @@
           <p:cNvPr id="18" name="">
             <a:extLst xmlns:a="http://schemas.openxmlformats.org/drawingml/2006/main">
               <a:ext uri="{FF2B5EF4-FFF2-40B4-BE49-F238E27FC236}">
-                <a16:creationId xmlns:a16="http://schemas.microsoft.com/office/drawing/2014/main" id="{036B8A91-11E2-4349-853E-966869894B42}"/>
+                <a16:creationId xmlns:a16="http://schemas.microsoft.com/office/drawing/2014/main" id="{55AD30D0-4B87-4808-BBA3-284572417892}"/>
               </a:ext>
             </a:extLst>
           </p:cNvPr>
@@ -4014,7 +4014,7 @@
         <p:spPr>
           <a:xfrm xmlns:a="http://schemas.openxmlformats.org/drawingml/2006/main">
             <a:off x="685800" y="6419850"/>
-            <a:ext cx="4000500" cy="171450"/>
+            <a:ext cx="3048000" cy="171450"/>
           </a:xfrm>
           <a:prstGeom xmlns:a="http://schemas.openxmlformats.org/drawingml/2006/main" prst="rect">
             <a:avLst/>
@@ -4042,7 +4042,7 @@
                   <a:srgbClr val="9A948B"/>
                 </a:solidFill>
               </a:rPr>
-              <a:t>Species distribution modelling for dengue vector mapping</a:t>
+              <a:t>Species distribution modelling workshop</a:t>
             </a:r>
           </a:p>
         </p:txBody>
@@ -4050,7 +4050,7 @@
     </p:spTree>
     <p:extLst>
       <p:ext uri="{BB962C8B-B14F-4D97-AF65-F5344CB8AC3E}">
-        <p14:creationId xmlns:p14="http://schemas.microsoft.com/office/powerpoint/2010/main" val="868741248"/>
+        <p14:creationId xmlns:p14="http://schemas.microsoft.com/office/powerpoint/2010/main" val="882581382"/>
       </p:ext>
     </p:extLst>
   </p:cSld>
@@ -4078,10 +4078,10 @@
       </p:grpSpPr>
       <p:sp>
         <p:nvSpPr>
-          <p:cNvPr id="13" name="">
-            <a:extLst xmlns:a="http://schemas.openxmlformats.org/drawingml/2006/main">
-              <a:ext uri="{FF2B5EF4-FFF2-40B4-BE49-F238E27FC236}">
-                <a16:creationId xmlns:a16="http://schemas.microsoft.com/office/drawing/2014/main" id="{00F5BAA1-C2EA-4215-A59F-42D20FE74A6B}"/>
+          <p:cNvPr id="16" name="">
+            <a:extLst xmlns:a="http://schemas.openxmlformats.org/drawingml/2006/main">
+              <a:ext uri="{FF2B5EF4-FFF2-40B4-BE49-F238E27FC236}">
+                <a16:creationId xmlns:a16="http://schemas.microsoft.com/office/drawing/2014/main" id="{F7A24E57-C78B-44C5-8E69-35CFAAE2C1BC}"/>
               </a:ext>
             </a:extLst>
           </p:cNvPr>
@@ -4121,7 +4121,7 @@
                   <a:srgbClr val="0E6E73"/>
                 </a:solidFill>
               </a:rPr>
-              <a:t>FRAMING</a:t>
+              <a:t>FOUNDATION</a:t>
             </a:r>
           </a:p>
         </p:txBody>
@@ -4131,7 +4131,7 @@
           <p:cNvPr id="2" name="">
             <a:extLst xmlns:a="http://schemas.openxmlformats.org/drawingml/2006/main">
               <a:ext uri="{FF2B5EF4-FFF2-40B4-BE49-F238E27FC236}">
-                <a16:creationId xmlns:a16="http://schemas.microsoft.com/office/drawing/2014/main" id="{5DF62C75-C44E-4FCA-B3A0-49FD8ACB109F}"/>
+                <a16:creationId xmlns:a16="http://schemas.microsoft.com/office/drawing/2014/main" id="{DE8CBAAD-ECF3-4302-AE28-BE522632D357}"/>
               </a:ext>
             </a:extLst>
           </p:cNvPr>
@@ -4162,7 +4162,7 @@
           <p:cNvPr id="3" name="">
             <a:extLst xmlns:a="http://schemas.openxmlformats.org/drawingml/2006/main">
               <a:ext uri="{FF2B5EF4-FFF2-40B4-BE49-F238E27FC236}">
-                <a16:creationId xmlns:a16="http://schemas.microsoft.com/office/drawing/2014/main" id="{B2D09BEF-24D1-4AE1-AD2B-371C75D51056}"/>
+                <a16:creationId xmlns:a16="http://schemas.microsoft.com/office/drawing/2014/main" id="{0B55FDD5-E1CD-4975-9F11-232921CFAEC6}"/>
               </a:ext>
             </a:extLst>
           </p:cNvPr>
@@ -4212,7 +4212,7 @@
           <p:cNvPr id="4" name="">
             <a:extLst xmlns:a="http://schemas.openxmlformats.org/drawingml/2006/main">
               <a:ext uri="{FF2B5EF4-FFF2-40B4-BE49-F238E27FC236}">
-                <a16:creationId xmlns:a16="http://schemas.microsoft.com/office/drawing/2014/main" id="{04D42D97-7BBD-4764-973E-DD50B0236E7D}"/>
+                <a16:creationId xmlns:a16="http://schemas.microsoft.com/office/drawing/2014/main" id="{8E16F4AC-B39B-4A75-B8BE-154A1C161471}"/>
               </a:ext>
             </a:extLst>
           </p:cNvPr>
@@ -4224,7 +4224,7 @@
         <p:spPr>
           <a:xfrm xmlns:a="http://schemas.openxmlformats.org/drawingml/2006/main">
             <a:off x="685800" y="914400"/>
-            <a:ext cx="7239000" cy="1000125"/>
+            <a:ext cx="8763000" cy="1000125"/>
           </a:xfrm>
           <a:prstGeom xmlns:a="http://schemas.openxmlformats.org/drawingml/2006/main" prst="rect">
             <a:avLst/>
@@ -4252,7 +4252,7 @@
                   <a:srgbClr val="10231F"/>
                 </a:solidFill>
               </a:rPr>
-              <a:t>The model answers a narrower question than dengue risk</a:t>
+              <a:t>An SDM links where a species is observed to the environments it occupies</a:t>
             </a:r>
           </a:p>
         </p:txBody>
@@ -4262,19 +4262,19 @@
           <p:cNvPr id="5" name="">
             <a:extLst xmlns:a="http://schemas.openxmlformats.org/drawingml/2006/main">
               <a:ext uri="{FF2B5EF4-FFF2-40B4-BE49-F238E27FC236}">
-                <a16:creationId xmlns:a16="http://schemas.microsoft.com/office/drawing/2014/main" id="{4438A7DC-2ED1-4A8E-B143-EC6575363263}"/>
-              </a:ext>
-            </a:extLst>
-          </p:cNvPr>
-          <p:cNvSpPr>
-            <a:spLocks xmlns:a="http://schemas.openxmlformats.org/drawingml/2006/main" noGrp="1"/>
-          </p:cNvSpPr>
-          <p:nvPr/>
-        </p:nvSpPr>
-        <p:spPr>
-          <a:xfrm xmlns:a="http://schemas.openxmlformats.org/drawingml/2006/main">
-            <a:off x="704850" y="1962150"/>
-            <a:ext cx="5905500" cy="609600"/>
+                <a16:creationId xmlns:a16="http://schemas.microsoft.com/office/drawing/2014/main" id="{0AD8B84E-F59A-498D-9E4A-77B1B4E2F0B2}"/>
+              </a:ext>
+            </a:extLst>
+          </p:cNvPr>
+          <p:cNvSpPr>
+            <a:spLocks xmlns:a="http://schemas.openxmlformats.org/drawingml/2006/main" noGrp="1"/>
+          </p:cNvSpPr>
+          <p:nvPr/>
+        </p:nvSpPr>
+        <p:spPr>
+          <a:xfrm xmlns:a="http://schemas.openxmlformats.org/drawingml/2006/main">
+            <a:off x="704850" y="2095500"/>
+            <a:ext cx="7429500" cy="609600"/>
           </a:xfrm>
           <a:prstGeom xmlns:a="http://schemas.openxmlformats.org/drawingml/2006/main" prst="rect">
             <a:avLst/>
@@ -4302,7 +4302,7 @@
                   <a:srgbClr val="60706B"/>
                 </a:solidFill>
               </a:rPr>
-              <a:t>For the workshop, we estimate where climate conditions are consistent with recorded Aedes aegypti occurrence.</a:t>
+              <a:t>The basic move is simple: compare occurrence locations with environmental predictors, then project that fitted relationship across space.</a:t>
             </a:r>
           </a:p>
         </p:txBody>
@@ -4312,18 +4312,18 @@
           <p:cNvPr id="6" name="">
             <a:extLst xmlns:a="http://schemas.openxmlformats.org/drawingml/2006/main">
               <a:ext uri="{FF2B5EF4-FFF2-40B4-BE49-F238E27FC236}">
-                <a16:creationId xmlns:a16="http://schemas.microsoft.com/office/drawing/2014/main" id="{53FAEF45-AB95-4858-AB23-8A1F9BA6B967}"/>
-              </a:ext>
-            </a:extLst>
-          </p:cNvPr>
-          <p:cNvSpPr>
-            <a:spLocks xmlns:a="http://schemas.openxmlformats.org/drawingml/2006/main" noGrp="1"/>
-          </p:cNvSpPr>
-          <p:nvPr/>
-        </p:nvSpPr>
-        <p:spPr>
-          <a:xfrm xmlns:a="http://schemas.openxmlformats.org/drawingml/2006/main">
-            <a:off x="704850" y="2990850"/>
+                <a16:creationId xmlns:a16="http://schemas.microsoft.com/office/drawing/2014/main" id="{84B52A18-4DB4-467E-805A-2C84E9B77CAB}"/>
+              </a:ext>
+            </a:extLst>
+          </p:cNvPr>
+          <p:cNvSpPr>
+            <a:spLocks xmlns:a="http://schemas.openxmlformats.org/drawingml/2006/main" noGrp="1"/>
+          </p:cNvSpPr>
+          <p:nvPr/>
+        </p:nvSpPr>
+        <p:spPr>
+          <a:xfrm xmlns:a="http://schemas.openxmlformats.org/drawingml/2006/main">
+            <a:off x="704850" y="3124200"/>
             <a:ext cx="4476750" cy="0"/>
           </a:xfrm>
           <a:prstGeom xmlns:a="http://schemas.openxmlformats.org/drawingml/2006/main" prst="line">
@@ -4343,19 +4343,19 @@
           <p:cNvPr id="7" name="">
             <a:extLst xmlns:a="http://schemas.openxmlformats.org/drawingml/2006/main">
               <a:ext uri="{FF2B5EF4-FFF2-40B4-BE49-F238E27FC236}">
-                <a16:creationId xmlns:a16="http://schemas.microsoft.com/office/drawing/2014/main" id="{6945C0F6-51F5-4C21-AE5F-46AE6E0FFFA7}"/>
-              </a:ext>
-            </a:extLst>
-          </p:cNvPr>
-          <p:cNvSpPr>
-            <a:spLocks xmlns:a="http://schemas.openxmlformats.org/drawingml/2006/main" noGrp="1"/>
-          </p:cNvSpPr>
-          <p:nvPr/>
-        </p:nvSpPr>
-        <p:spPr>
-          <a:xfrm xmlns:a="http://schemas.openxmlformats.org/drawingml/2006/main">
-            <a:off x="1047750" y="3524250"/>
-            <a:ext cx="2667000" cy="323850"/>
+                <a16:creationId xmlns:a16="http://schemas.microsoft.com/office/drawing/2014/main" id="{CF0A303C-B747-4098-81DD-BC4C8953D02B}"/>
+              </a:ext>
+            </a:extLst>
+          </p:cNvPr>
+          <p:cNvSpPr>
+            <a:spLocks xmlns:a="http://schemas.openxmlformats.org/drawingml/2006/main" noGrp="1"/>
+          </p:cNvSpPr>
+          <p:nvPr/>
+        </p:nvSpPr>
+        <p:spPr>
+          <a:xfrm xmlns:a="http://schemas.openxmlformats.org/drawingml/2006/main">
+            <a:off x="1047750" y="3638550"/>
+            <a:ext cx="2095500" cy="323850"/>
           </a:xfrm>
           <a:prstGeom xmlns:a="http://schemas.openxmlformats.org/drawingml/2006/main" prst="rect">
             <a:avLst/>
@@ -4383,7 +4383,7 @@
                   <a:srgbClr val="0E6E73"/>
                 </a:solidFill>
               </a:rPr>
-              <a:t>Vector suitability</a:t>
+              <a:t>Records</a:t>
             </a:r>
           </a:p>
         </p:txBody>
@@ -4393,19 +4393,19 @@
           <p:cNvPr id="8" name="">
             <a:extLst xmlns:a="http://schemas.openxmlformats.org/drawingml/2006/main">
               <a:ext uri="{FF2B5EF4-FFF2-40B4-BE49-F238E27FC236}">
-                <a16:creationId xmlns:a16="http://schemas.microsoft.com/office/drawing/2014/main" id="{F85BE917-C054-4238-836E-D8E6439D8845}"/>
-              </a:ext>
-            </a:extLst>
-          </p:cNvPr>
-          <p:cNvSpPr>
-            <a:spLocks xmlns:a="http://schemas.openxmlformats.org/drawingml/2006/main" noGrp="1"/>
-          </p:cNvSpPr>
-          <p:nvPr/>
-        </p:nvSpPr>
-        <p:spPr>
-          <a:xfrm xmlns:a="http://schemas.openxmlformats.org/drawingml/2006/main">
-            <a:off x="1047750" y="3943350"/>
-            <a:ext cx="3333750" cy="552450"/>
+                <a16:creationId xmlns:a16="http://schemas.microsoft.com/office/drawing/2014/main" id="{534396E3-8DEF-4803-9960-6E5DC1E72D74}"/>
+              </a:ext>
+            </a:extLst>
+          </p:cNvPr>
+          <p:cNvSpPr>
+            <a:spLocks xmlns:a="http://schemas.openxmlformats.org/drawingml/2006/main" noGrp="1"/>
+          </p:cNvSpPr>
+          <p:nvPr/>
+        </p:nvSpPr>
+        <p:spPr>
+          <a:xfrm xmlns:a="http://schemas.openxmlformats.org/drawingml/2006/main">
+            <a:off x="1047750" y="4057650"/>
+            <a:ext cx="2476500" cy="457200"/>
           </a:xfrm>
           <a:prstGeom xmlns:a="http://schemas.openxmlformats.org/drawingml/2006/main" prst="rect">
             <a:avLst/>
@@ -4433,7 +4433,7 @@
                   <a:srgbClr val="60706B"/>
                 </a:solidFill>
               </a:rPr>
-              <a:t>Environmental conditions that could support the mosquito.</a:t>
+              <a:t>locations in geographic space</a:t>
             </a:r>
           </a:p>
         </p:txBody>
@@ -4443,19 +4443,19 @@
           <p:cNvPr id="9" name="">
             <a:extLst xmlns:a="http://schemas.openxmlformats.org/drawingml/2006/main">
               <a:ext uri="{FF2B5EF4-FFF2-40B4-BE49-F238E27FC236}">
-                <a16:creationId xmlns:a16="http://schemas.microsoft.com/office/drawing/2014/main" id="{2564FF1C-2082-4737-A5DE-9B68C3726A91}"/>
-              </a:ext>
-            </a:extLst>
-          </p:cNvPr>
-          <p:cNvSpPr>
-            <a:spLocks xmlns:a="http://schemas.openxmlformats.org/drawingml/2006/main" noGrp="1"/>
-          </p:cNvSpPr>
-          <p:nvPr/>
-        </p:nvSpPr>
-        <p:spPr>
-          <a:xfrm xmlns:a="http://schemas.openxmlformats.org/drawingml/2006/main">
-            <a:off x="4876800" y="3829050"/>
-            <a:ext cx="819150" cy="266700"/>
+                <a16:creationId xmlns:a16="http://schemas.microsoft.com/office/drawing/2014/main" id="{EE06C655-24F6-4B90-831F-AFB43A17D014}"/>
+              </a:ext>
+            </a:extLst>
+          </p:cNvPr>
+          <p:cNvSpPr>
+            <a:spLocks xmlns:a="http://schemas.openxmlformats.org/drawingml/2006/main" noGrp="1"/>
+          </p:cNvSpPr>
+          <p:nvPr/>
+        </p:nvSpPr>
+        <p:spPr>
+          <a:xfrm xmlns:a="http://schemas.openxmlformats.org/drawingml/2006/main">
+            <a:off x="3790950" y="3905250"/>
+            <a:ext cx="781050" cy="266700"/>
           </a:xfrm>
           <a:prstGeom xmlns:a="http://schemas.openxmlformats.org/drawingml/2006/main" prst="rightArrow">
             <a:avLst/>
@@ -4474,19 +4474,19 @@
           <p:cNvPr id="10" name="">
             <a:extLst xmlns:a="http://schemas.openxmlformats.org/drawingml/2006/main">
               <a:ext uri="{FF2B5EF4-FFF2-40B4-BE49-F238E27FC236}">
-                <a16:creationId xmlns:a16="http://schemas.microsoft.com/office/drawing/2014/main" id="{5E580188-C5CD-4CFA-AC65-ED0972612093}"/>
-              </a:ext>
-            </a:extLst>
-          </p:cNvPr>
-          <p:cNvSpPr>
-            <a:spLocks xmlns:a="http://schemas.openxmlformats.org/drawingml/2006/main" noGrp="1"/>
-          </p:cNvSpPr>
-          <p:nvPr/>
-        </p:nvSpPr>
-        <p:spPr>
-          <a:xfrm xmlns:a="http://schemas.openxmlformats.org/drawingml/2006/main">
-            <a:off x="6191250" y="3524250"/>
-            <a:ext cx="2286000" cy="323850"/>
+                <a16:creationId xmlns:a16="http://schemas.microsoft.com/office/drawing/2014/main" id="{F598FA97-80BC-4D38-96D4-9FB69F2E594A}"/>
+              </a:ext>
+            </a:extLst>
+          </p:cNvPr>
+          <p:cNvSpPr>
+            <a:spLocks xmlns:a="http://schemas.openxmlformats.org/drawingml/2006/main" noGrp="1"/>
+          </p:cNvSpPr>
+          <p:nvPr/>
+        </p:nvSpPr>
+        <p:spPr>
+          <a:xfrm xmlns:a="http://schemas.openxmlformats.org/drawingml/2006/main">
+            <a:off x="5048250" y="3486150"/>
+            <a:ext cx="2952750" cy="666750"/>
           </a:xfrm>
           <a:prstGeom xmlns:a="http://schemas.openxmlformats.org/drawingml/2006/main" prst="rect">
             <a:avLst/>
@@ -4514,7 +4514,24 @@
                   <a:srgbClr val="D96445"/>
                 </a:solidFill>
               </a:rPr>
-              <a:t>Dengue risk</a:t>
+              <a:t>Environmental</a:t>
+            </a:r>
+          </a:p>
+          <a:p xmlns:a="http://schemas.openxmlformats.org/drawingml/2006/main">
+            <a:pPr algn="l">
+              <a:defRPr sz="2100" b="1" i="0">
+                <a:solidFill>
+                  <a:srgbClr val="D96445"/>
+                </a:solidFill>
+              </a:defRPr>
+            </a:pPr>
+            <a:r>
+              <a:rPr sz="2100" b="1" i="0">
+                <a:solidFill>
+                  <a:srgbClr val="D96445"/>
+                </a:solidFill>
+              </a:rPr>
+              <a:t>relationship</a:t>
             </a:r>
           </a:p>
         </p:txBody>
@@ -4524,19 +4541,19 @@
           <p:cNvPr id="11" name="">
             <a:extLst xmlns:a="http://schemas.openxmlformats.org/drawingml/2006/main">
               <a:ext uri="{FF2B5EF4-FFF2-40B4-BE49-F238E27FC236}">
-                <a16:creationId xmlns:a16="http://schemas.microsoft.com/office/drawing/2014/main" id="{099E12D9-E73C-42DD-8B9F-80D83AF92290}"/>
-              </a:ext>
-            </a:extLst>
-          </p:cNvPr>
-          <p:cNvSpPr>
-            <a:spLocks xmlns:a="http://schemas.openxmlformats.org/drawingml/2006/main" noGrp="1"/>
-          </p:cNvSpPr>
-          <p:nvPr/>
-        </p:nvSpPr>
-        <p:spPr>
-          <a:xfrm xmlns:a="http://schemas.openxmlformats.org/drawingml/2006/main">
-            <a:off x="6191250" y="3943350"/>
-            <a:ext cx="3810000" cy="800100"/>
+                <a16:creationId xmlns:a16="http://schemas.microsoft.com/office/drawing/2014/main" id="{07879CCB-D9F7-4570-B06A-82B5EB7CFA0D}"/>
+              </a:ext>
+            </a:extLst>
+          </p:cNvPr>
+          <p:cNvSpPr>
+            <a:spLocks xmlns:a="http://schemas.openxmlformats.org/drawingml/2006/main" noGrp="1"/>
+          </p:cNvSpPr>
+          <p:nvPr/>
+        </p:nvSpPr>
+        <p:spPr>
+          <a:xfrm xmlns:a="http://schemas.openxmlformats.org/drawingml/2006/main">
+            <a:off x="5048250" y="4267200"/>
+            <a:ext cx="2952750" cy="381000"/>
           </a:xfrm>
           <a:prstGeom xmlns:a="http://schemas.openxmlformats.org/drawingml/2006/main" prst="rect">
             <a:avLst/>
@@ -4564,7 +4581,7 @@
                   <a:srgbClr val="60706B"/>
                 </a:solidFill>
               </a:rPr>
-              <a:t>Also depends on people, virus circulation, immunity, housing, surveillance, and interventions.</a:t>
+              <a:t>association learned by the model</a:t>
             </a:r>
           </a:p>
         </p:txBody>
@@ -4574,7 +4591,138 @@
           <p:cNvPr id="12" name="">
             <a:extLst xmlns:a="http://schemas.openxmlformats.org/drawingml/2006/main">
               <a:ext uri="{FF2B5EF4-FFF2-40B4-BE49-F238E27FC236}">
-                <a16:creationId xmlns:a16="http://schemas.microsoft.com/office/drawing/2014/main" id="{FC545515-AAEC-4A57-B603-E21DE218FFFA}"/>
+                <a16:creationId xmlns:a16="http://schemas.microsoft.com/office/drawing/2014/main" id="{AED3141B-135F-4048-A686-ADDFDD314910}"/>
+              </a:ext>
+            </a:extLst>
+          </p:cNvPr>
+          <p:cNvSpPr>
+            <a:spLocks xmlns:a="http://schemas.openxmlformats.org/drawingml/2006/main" noGrp="1"/>
+          </p:cNvSpPr>
+          <p:nvPr/>
+        </p:nvSpPr>
+        <p:spPr>
+          <a:xfrm xmlns:a="http://schemas.openxmlformats.org/drawingml/2006/main">
+            <a:off x="8248650" y="3905250"/>
+            <a:ext cx="781050" cy="266700"/>
+          </a:xfrm>
+          <a:prstGeom xmlns:a="http://schemas.openxmlformats.org/drawingml/2006/main" prst="rightArrow">
+            <a:avLst/>
+          </a:prstGeom>
+          <a:solidFill xmlns:a="http://schemas.openxmlformats.org/drawingml/2006/main">
+            <a:srgbClr val="D96445"/>
+          </a:solidFill>
+          <a:ln xmlns:a="http://schemas.openxmlformats.org/drawingml/2006/main" w="0">
+            <a:noFill/>
+            <a:prstDash val="solid"/>
+          </a:ln>
+        </p:spPr>
+      </p:sp>
+      <p:sp>
+        <p:nvSpPr>
+          <p:cNvPr id="13" name="">
+            <a:extLst xmlns:a="http://schemas.openxmlformats.org/drawingml/2006/main">
+              <a:ext uri="{FF2B5EF4-FFF2-40B4-BE49-F238E27FC236}">
+                <a16:creationId xmlns:a16="http://schemas.microsoft.com/office/drawing/2014/main" id="{B1096973-D5A4-4116-AD15-D0FA2C4077AB}"/>
+              </a:ext>
+            </a:extLst>
+          </p:cNvPr>
+          <p:cNvSpPr>
+            <a:spLocks xmlns:a="http://schemas.openxmlformats.org/drawingml/2006/main" noGrp="1"/>
+          </p:cNvSpPr>
+          <p:nvPr/>
+        </p:nvSpPr>
+        <p:spPr>
+          <a:xfrm xmlns:a="http://schemas.openxmlformats.org/drawingml/2006/main">
+            <a:off x="9429750" y="3638550"/>
+            <a:ext cx="1809750" cy="323850"/>
+          </a:xfrm>
+          <a:prstGeom xmlns:a="http://schemas.openxmlformats.org/drawingml/2006/main" prst="rect">
+            <a:avLst/>
+          </a:prstGeom>
+          <a:noFill xmlns:a="http://schemas.openxmlformats.org/drawingml/2006/main"/>
+          <a:ln xmlns:a="http://schemas.openxmlformats.org/drawingml/2006/main" w="0">
+            <a:noFill/>
+            <a:prstDash val="solid"/>
+          </a:ln>
+        </p:spPr>
+        <p:txBody>
+          <a:bodyPr xmlns:a="http://schemas.openxmlformats.org/drawingml/2006/main"/>
+          <a:lstStyle xmlns:a="http://schemas.openxmlformats.org/drawingml/2006/main"/>
+          <a:p xmlns:a="http://schemas.openxmlformats.org/drawingml/2006/main">
+            <a:pPr algn="l">
+              <a:defRPr sz="2100" b="1" i="0">
+                <a:solidFill>
+                  <a:srgbClr val="0E6E73"/>
+                </a:solidFill>
+              </a:defRPr>
+            </a:pPr>
+            <a:r>
+              <a:rPr sz="2100" b="1" i="0">
+                <a:solidFill>
+                  <a:srgbClr val="0E6E73"/>
+                </a:solidFill>
+              </a:rPr>
+              <a:t>Projection</a:t>
+            </a:r>
+          </a:p>
+        </p:txBody>
+      </p:sp>
+      <p:sp>
+        <p:nvSpPr>
+          <p:cNvPr id="14" name="">
+            <a:extLst xmlns:a="http://schemas.openxmlformats.org/drawingml/2006/main">
+              <a:ext uri="{FF2B5EF4-FFF2-40B4-BE49-F238E27FC236}">
+                <a16:creationId xmlns:a16="http://schemas.microsoft.com/office/drawing/2014/main" id="{B2051DC1-56EB-47C8-9FE9-F9ECEA2CB65F}"/>
+              </a:ext>
+            </a:extLst>
+          </p:cNvPr>
+          <p:cNvSpPr>
+            <a:spLocks xmlns:a="http://schemas.openxmlformats.org/drawingml/2006/main" noGrp="1"/>
+          </p:cNvSpPr>
+          <p:nvPr/>
+        </p:nvSpPr>
+        <p:spPr>
+          <a:xfrm xmlns:a="http://schemas.openxmlformats.org/drawingml/2006/main">
+            <a:off x="9429750" y="4057650"/>
+            <a:ext cx="1809750" cy="381000"/>
+          </a:xfrm>
+          <a:prstGeom xmlns:a="http://schemas.openxmlformats.org/drawingml/2006/main" prst="rect">
+            <a:avLst/>
+          </a:prstGeom>
+          <a:noFill xmlns:a="http://schemas.openxmlformats.org/drawingml/2006/main"/>
+          <a:ln xmlns:a="http://schemas.openxmlformats.org/drawingml/2006/main" w="0">
+            <a:noFill/>
+            <a:prstDash val="solid"/>
+          </a:ln>
+        </p:spPr>
+        <p:txBody>
+          <a:bodyPr xmlns:a="http://schemas.openxmlformats.org/drawingml/2006/main"/>
+          <a:lstStyle xmlns:a="http://schemas.openxmlformats.org/drawingml/2006/main"/>
+          <a:p xmlns:a="http://schemas.openxmlformats.org/drawingml/2006/main">
+            <a:pPr algn="l">
+              <a:defRPr sz="1575" b="0" i="0">
+                <a:solidFill>
+                  <a:srgbClr val="60706B"/>
+                </a:solidFill>
+              </a:defRPr>
+            </a:pPr>
+            <a:r>
+              <a:rPr sz="1575" b="0" i="0">
+                <a:solidFill>
+                  <a:srgbClr val="60706B"/>
+                </a:solidFill>
+              </a:rPr>
+              <a:t>a suitability surface</a:t>
+            </a:r>
+          </a:p>
+        </p:txBody>
+      </p:sp>
+      <p:sp>
+        <p:nvSpPr>
+          <p:cNvPr id="15" name="">
+            <a:extLst xmlns:a="http://schemas.openxmlformats.org/drawingml/2006/main">
+              <a:ext uri="{FF2B5EF4-FFF2-40B4-BE49-F238E27FC236}">
+                <a16:creationId xmlns:a16="http://schemas.microsoft.com/office/drawing/2014/main" id="{38FC8857-2842-4924-93DC-3848BA839CC5}"/>
               </a:ext>
             </a:extLst>
           </p:cNvPr>
@@ -4586,7 +4734,7 @@
         <p:spPr>
           <a:xfrm xmlns:a="http://schemas.openxmlformats.org/drawingml/2006/main">
             <a:off x="685800" y="6419850"/>
-            <a:ext cx="4000500" cy="171450"/>
+            <a:ext cx="3048000" cy="171450"/>
           </a:xfrm>
           <a:prstGeom xmlns:a="http://schemas.openxmlformats.org/drawingml/2006/main" prst="rect">
             <a:avLst/>
@@ -4614,7 +4762,7 @@
                   <a:srgbClr val="9A948B"/>
                 </a:solidFill>
               </a:rPr>
-              <a:t>Species distribution modelling for dengue vector mapping</a:t>
+              <a:t>Species distribution modelling workshop</a:t>
             </a:r>
           </a:p>
         </p:txBody>
@@ -4622,7 +4770,7 @@
     </p:spTree>
     <p:extLst>
       <p:ext uri="{BB962C8B-B14F-4D97-AF65-F5344CB8AC3E}">
-        <p14:creationId xmlns:p14="http://schemas.microsoft.com/office/powerpoint/2010/main" val="754856097"/>
+        <p14:creationId xmlns:p14="http://schemas.microsoft.com/office/powerpoint/2010/main" val="48692560"/>
       </p:ext>
     </p:extLst>
   </p:cSld>
@@ -4653,7 +4801,7 @@
           <p:cNvPr id="16" name="">
             <a:extLst xmlns:a="http://schemas.openxmlformats.org/drawingml/2006/main">
               <a:ext uri="{FF2B5EF4-FFF2-40B4-BE49-F238E27FC236}">
-                <a16:creationId xmlns:a16="http://schemas.microsoft.com/office/drawing/2014/main" id="{E3E1ED76-1E3F-473D-A052-F0196A4CF99D}"/>
+                <a16:creationId xmlns:a16="http://schemas.microsoft.com/office/drawing/2014/main" id="{03D5E9A9-2B6C-4E69-B936-37D4AD2CC52D}"/>
               </a:ext>
             </a:extLst>
           </p:cNvPr>
@@ -4693,7 +4841,7 @@
                   <a:srgbClr val="0E6E73"/>
                 </a:solidFill>
               </a:rPr>
-              <a:t>CONCEPT</a:t>
+              <a:t>FOUNDATION</a:t>
             </a:r>
           </a:p>
         </p:txBody>
@@ -4703,7 +4851,7 @@
           <p:cNvPr id="2" name="">
             <a:extLst xmlns:a="http://schemas.openxmlformats.org/drawingml/2006/main">
               <a:ext uri="{FF2B5EF4-FFF2-40B4-BE49-F238E27FC236}">
-                <a16:creationId xmlns:a16="http://schemas.microsoft.com/office/drawing/2014/main" id="{0CDD787D-F872-45C9-B15B-CABADB1AE545}"/>
+                <a16:creationId xmlns:a16="http://schemas.microsoft.com/office/drawing/2014/main" id="{02E87CB0-0A8E-4D33-9B98-E07CA829FA0C}"/>
               </a:ext>
             </a:extLst>
           </p:cNvPr>
@@ -4734,7 +4882,7 @@
           <p:cNvPr id="3" name="">
             <a:extLst xmlns:a="http://schemas.openxmlformats.org/drawingml/2006/main">
               <a:ext uri="{FF2B5EF4-FFF2-40B4-BE49-F238E27FC236}">
-                <a16:creationId xmlns:a16="http://schemas.microsoft.com/office/drawing/2014/main" id="{5BE6EBC0-2A70-4658-8F8A-6C87AA263AAE}"/>
+                <a16:creationId xmlns:a16="http://schemas.microsoft.com/office/drawing/2014/main" id="{82781BDF-F999-476D-83FC-B726F2D04A6F}"/>
               </a:ext>
             </a:extLst>
           </p:cNvPr>
@@ -4784,7 +4932,7 @@
           <p:cNvPr id="4" name="">
             <a:extLst xmlns:a="http://schemas.openxmlformats.org/drawingml/2006/main">
               <a:ext uri="{FF2B5EF4-FFF2-40B4-BE49-F238E27FC236}">
-                <a16:creationId xmlns:a16="http://schemas.microsoft.com/office/drawing/2014/main" id="{93ACE64F-30A5-4A7D-8A01-6E5C6CE4F2ED}"/>
+                <a16:creationId xmlns:a16="http://schemas.microsoft.com/office/drawing/2014/main" id="{A71D45B2-1A4E-4345-90F8-0B8C3EE28444}"/>
               </a:ext>
             </a:extLst>
           </p:cNvPr>
@@ -4796,7 +4944,7 @@
         <p:spPr>
           <a:xfrm xmlns:a="http://schemas.openxmlformats.org/drawingml/2006/main">
             <a:off x="685800" y="914400"/>
-            <a:ext cx="7239000" cy="1000125"/>
+            <a:ext cx="7810500" cy="819150"/>
           </a:xfrm>
           <a:prstGeom xmlns:a="http://schemas.openxmlformats.org/drawingml/2006/main" prst="rect">
             <a:avLst/>
@@ -4824,7 +4972,7 @@
                   <a:srgbClr val="10231F"/>
                 </a:solidFill>
               </a:rPr>
-              <a:t>SDMs translate a geographic pattern into environmental space</a:t>
+              <a:t>The output is suitability, not proof of presence</a:t>
             </a:r>
           </a:p>
         </p:txBody>
@@ -4834,7 +4982,7 @@
           <p:cNvPr id="5" name="">
             <a:extLst xmlns:a="http://schemas.openxmlformats.org/drawingml/2006/main">
               <a:ext uri="{FF2B5EF4-FFF2-40B4-BE49-F238E27FC236}">
-                <a16:creationId xmlns:a16="http://schemas.microsoft.com/office/drawing/2014/main" id="{C7BCDE70-2448-4F23-8FB4-96A73250BCAE}"/>
+                <a16:creationId xmlns:a16="http://schemas.microsoft.com/office/drawing/2014/main" id="{F4BE772E-21E3-4FEB-8D90-7CAA55246D51}"/>
               </a:ext>
             </a:extLst>
           </p:cNvPr>
@@ -4846,7 +4994,7 @@
         <p:spPr>
           <a:xfrm xmlns:a="http://schemas.openxmlformats.org/drawingml/2006/main">
             <a:off x="704850" y="1905000"/>
-            <a:ext cx="6858000" cy="571500"/>
+            <a:ext cx="7429500" cy="647700"/>
           </a:xfrm>
           <a:prstGeom xmlns:a="http://schemas.openxmlformats.org/drawingml/2006/main" prst="rect">
             <a:avLst/>
@@ -4874,7 +5022,7 @@
                   <a:srgbClr val="60706B"/>
                 </a:solidFill>
               </a:rPr>
-              <a:t>The algorithm does not know the biology. It sees locations, predictor values, and a modelling design.</a:t>
+              <a:t>Most SDMs estimate where environments resemble those associated with known records. Biology, dispersal, interactions, and sampling still matter.</a:t>
             </a:r>
           </a:p>
         </p:txBody>
@@ -4888,7 +5036,7 @@
           <p:nvPr/>
         </p:nvPicPr>
         <p:blipFill>
-          <a:blip xmlns:r="http://schemas.openxmlformats.org/officeDocument/2006/relationships" xmlns:a="http://schemas.openxmlformats.org/drawingml/2006/main" r:embed="R86fd627a04c94dcc"/>
+          <a:blip xmlns:r="http://schemas.openxmlformats.org/officeDocument/2006/relationships" xmlns:a="http://schemas.openxmlformats.org/drawingml/2006/main" r:embed="R0b24e68b8fb64687"/>
           <a:stretch xmlns:a="http://schemas.openxmlformats.org/drawingml/2006/main"/>
         </p:blipFill>
         <p:spPr>
@@ -4906,7 +5054,7 @@
           <p:cNvPr id="7" name="">
             <a:extLst xmlns:a="http://schemas.openxmlformats.org/drawingml/2006/main">
               <a:ext uri="{FF2B5EF4-FFF2-40B4-BE49-F238E27FC236}">
-                <a16:creationId xmlns:a16="http://schemas.microsoft.com/office/drawing/2014/main" id="{CF1FE18E-01D4-4062-AE23-A9F4E0A88932}"/>
+                <a16:creationId xmlns:a16="http://schemas.microsoft.com/office/drawing/2014/main" id="{932E90B6-D0AB-4DF6-8387-2E915DFE94F5}"/>
               </a:ext>
             </a:extLst>
           </p:cNvPr>
@@ -4956,7 +5104,7 @@
           <p:cNvPr id="8" name="">
             <a:extLst xmlns:a="http://schemas.openxmlformats.org/drawingml/2006/main">
               <a:ext uri="{FF2B5EF4-FFF2-40B4-BE49-F238E27FC236}">
-                <a16:creationId xmlns:a16="http://schemas.microsoft.com/office/drawing/2014/main" id="{3A947C06-55A4-446D-B2CB-66126F1960AA}"/>
+                <a16:creationId xmlns:a16="http://schemas.microsoft.com/office/drawing/2014/main" id="{9AB6D428-BD26-4493-BEB8-F9CFA8ECAFEC}"/>
               </a:ext>
             </a:extLst>
           </p:cNvPr>
@@ -4987,7 +5135,7 @@
           <p:cNvPr id="9" name="">
             <a:extLst xmlns:a="http://schemas.openxmlformats.org/drawingml/2006/main">
               <a:ext uri="{FF2B5EF4-FFF2-40B4-BE49-F238E27FC236}">
-                <a16:creationId xmlns:a16="http://schemas.microsoft.com/office/drawing/2014/main" id="{9EA089DC-FE8E-4F63-A531-507EE95B4108}"/>
+                <a16:creationId xmlns:a16="http://schemas.microsoft.com/office/drawing/2014/main" id="{2CBC77FF-F579-47E9-B161-6230FCF48963}"/>
               </a:ext>
             </a:extLst>
           </p:cNvPr>
@@ -5020,7 +5168,7 @@
           <p:cNvPr id="10" name="">
             <a:extLst xmlns:a="http://schemas.openxmlformats.org/drawingml/2006/main">
               <a:ext uri="{FF2B5EF4-FFF2-40B4-BE49-F238E27FC236}">
-                <a16:creationId xmlns:a16="http://schemas.microsoft.com/office/drawing/2014/main" id="{DF50A69C-97D1-4ADC-90B5-977E4494B692}"/>
+                <a16:creationId xmlns:a16="http://schemas.microsoft.com/office/drawing/2014/main" id="{F97FF2B0-F590-4D4F-857D-0A35C4A25CC3}"/>
               </a:ext>
             </a:extLst>
           </p:cNvPr>
@@ -5070,7 +5218,7 @@
           <p:cNvPr id="11" name="">
             <a:extLst xmlns:a="http://schemas.openxmlformats.org/drawingml/2006/main">
               <a:ext uri="{FF2B5EF4-FFF2-40B4-BE49-F238E27FC236}">
-                <a16:creationId xmlns:a16="http://schemas.microsoft.com/office/drawing/2014/main" id="{DDE19755-851B-4A41-8EE3-1D73536DD346}"/>
+                <a16:creationId xmlns:a16="http://schemas.microsoft.com/office/drawing/2014/main" id="{834E973B-E72C-4C17-BECE-49E5C5D30FBA}"/>
               </a:ext>
             </a:extLst>
           </p:cNvPr>
@@ -5154,7 +5302,7 @@
           <p:cNvPr id="12" name="">
             <a:extLst xmlns:a="http://schemas.openxmlformats.org/drawingml/2006/main">
               <a:ext uri="{FF2B5EF4-FFF2-40B4-BE49-F238E27FC236}">
-                <a16:creationId xmlns:a16="http://schemas.microsoft.com/office/drawing/2014/main" id="{7FE2978D-2BFF-447D-AA23-30CEC73F3057}"/>
+                <a16:creationId xmlns:a16="http://schemas.microsoft.com/office/drawing/2014/main" id="{CD735E6A-2227-4954-AFD5-5F379EF84C0D}"/>
               </a:ext>
             </a:extLst>
           </p:cNvPr>
@@ -5189,7 +5337,7 @@
           <p:nvPr/>
         </p:nvPicPr>
         <p:blipFill>
-          <a:blip xmlns:r="http://schemas.openxmlformats.org/officeDocument/2006/relationships" xmlns:a="http://schemas.openxmlformats.org/drawingml/2006/main" r:embed="R0c67829a73e0495e"/>
+          <a:blip xmlns:r="http://schemas.openxmlformats.org/officeDocument/2006/relationships" xmlns:a="http://schemas.openxmlformats.org/drawingml/2006/main" r:embed="R14d29cadd371481c"/>
           <a:stretch xmlns:a="http://schemas.openxmlformats.org/drawingml/2006/main"/>
         </p:blipFill>
         <p:spPr>
@@ -5207,7 +5355,7 @@
           <p:cNvPr id="14" name="">
             <a:extLst xmlns:a="http://schemas.openxmlformats.org/drawingml/2006/main">
               <a:ext uri="{FF2B5EF4-FFF2-40B4-BE49-F238E27FC236}">
-                <a16:creationId xmlns:a16="http://schemas.microsoft.com/office/drawing/2014/main" id="{0469F9E9-86C5-4205-9900-CB183B0C6939}"/>
+                <a16:creationId xmlns:a16="http://schemas.microsoft.com/office/drawing/2014/main" id="{C4B3E2C9-5DC5-4C97-A229-9DBC6898EC11}"/>
               </a:ext>
             </a:extLst>
           </p:cNvPr>
@@ -5257,7 +5405,7 @@
           <p:cNvPr id="15" name="">
             <a:extLst xmlns:a="http://schemas.openxmlformats.org/drawingml/2006/main">
               <a:ext uri="{FF2B5EF4-FFF2-40B4-BE49-F238E27FC236}">
-                <a16:creationId xmlns:a16="http://schemas.microsoft.com/office/drawing/2014/main" id="{0965D6C9-DDA1-4BCE-92B2-03BDD6C4D9CB}"/>
+                <a16:creationId xmlns:a16="http://schemas.microsoft.com/office/drawing/2014/main" id="{02BF1AD2-92EE-4F8C-952E-981EE41EBF2C}"/>
               </a:ext>
             </a:extLst>
           </p:cNvPr>
@@ -5269,7 +5417,7 @@
         <p:spPr>
           <a:xfrm xmlns:a="http://schemas.openxmlformats.org/drawingml/2006/main">
             <a:off x="685800" y="6419850"/>
-            <a:ext cx="4000500" cy="171450"/>
+            <a:ext cx="3048000" cy="171450"/>
           </a:xfrm>
           <a:prstGeom xmlns:a="http://schemas.openxmlformats.org/drawingml/2006/main" prst="rect">
             <a:avLst/>
@@ -5297,7 +5445,7 @@
                   <a:srgbClr val="9A948B"/>
                 </a:solidFill>
               </a:rPr>
-              <a:t>Species distribution modelling for dengue vector mapping</a:t>
+              <a:t>Species distribution modelling workshop</a:t>
             </a:r>
           </a:p>
         </p:txBody>
@@ -5305,7 +5453,7 @@
     </p:spTree>
     <p:extLst>
       <p:ext uri="{BB962C8B-B14F-4D97-AF65-F5344CB8AC3E}">
-        <p14:creationId xmlns:p14="http://schemas.microsoft.com/office/powerpoint/2010/main" val="2008564901"/>
+        <p14:creationId xmlns:p14="http://schemas.microsoft.com/office/powerpoint/2010/main" val="2010317528"/>
       </p:ext>
     </p:extLst>
   </p:cSld>
@@ -5336,7 +5484,7 @@
           <p:cNvPr id="16" name="">
             <a:extLst xmlns:a="http://schemas.openxmlformats.org/drawingml/2006/main">
               <a:ext uri="{FF2B5EF4-FFF2-40B4-BE49-F238E27FC236}">
-                <a16:creationId xmlns:a16="http://schemas.microsoft.com/office/drawing/2014/main" id="{A673FDCF-8B03-4927-8368-2C0184A7063B}"/>
+                <a16:creationId xmlns:a16="http://schemas.microsoft.com/office/drawing/2014/main" id="{3F2B8DED-235A-4653-8356-B56A8AA84FD3}"/>
               </a:ext>
             </a:extLst>
           </p:cNvPr>
@@ -5376,7 +5524,7 @@
                   <a:srgbClr val="0E6E73"/>
                 </a:solidFill>
               </a:rPr>
-              <a:t>DATA</a:t>
+              <a:t>WORKED EXAMPLE</a:t>
             </a:r>
           </a:p>
         </p:txBody>
@@ -5386,7 +5534,7 @@
           <p:cNvPr id="2" name="">
             <a:extLst xmlns:a="http://schemas.openxmlformats.org/drawingml/2006/main">
               <a:ext uri="{FF2B5EF4-FFF2-40B4-BE49-F238E27FC236}">
-                <a16:creationId xmlns:a16="http://schemas.microsoft.com/office/drawing/2014/main" id="{1B536814-E68D-455A-8C4A-8DE7721C9EB9}"/>
+                <a16:creationId xmlns:a16="http://schemas.microsoft.com/office/drawing/2014/main" id="{1CAD3A2C-CA59-4387-AD1F-BB1E49B087AB}"/>
               </a:ext>
             </a:extLst>
           </p:cNvPr>
@@ -5417,7 +5565,7 @@
           <p:cNvPr id="3" name="">
             <a:extLst xmlns:a="http://schemas.openxmlformats.org/drawingml/2006/main">
               <a:ext uri="{FF2B5EF4-FFF2-40B4-BE49-F238E27FC236}">
-                <a16:creationId xmlns:a16="http://schemas.microsoft.com/office/drawing/2014/main" id="{34927B63-4023-4FCE-AEF6-09748E5999C1}"/>
+                <a16:creationId xmlns:a16="http://schemas.microsoft.com/office/drawing/2014/main" id="{8F2D0D52-12FC-4D35-88D8-DFF83B58B000}"/>
               </a:ext>
             </a:extLst>
           </p:cNvPr>
@@ -5467,7 +5615,7 @@
           <p:cNvPr id="4" name="">
             <a:extLst xmlns:a="http://schemas.openxmlformats.org/drawingml/2006/main">
               <a:ext uri="{FF2B5EF4-FFF2-40B4-BE49-F238E27FC236}">
-                <a16:creationId xmlns:a16="http://schemas.microsoft.com/office/drawing/2014/main" id="{2FE115A9-AD3C-4C89-B863-B949322A908F}"/>
+                <a16:creationId xmlns:a16="http://schemas.microsoft.com/office/drawing/2014/main" id="{8DE70715-C34D-4BEE-B1CE-24C60C89A690}"/>
               </a:ext>
             </a:extLst>
           </p:cNvPr>
@@ -5479,7 +5627,7 @@
         <p:spPr>
           <a:xfrm xmlns:a="http://schemas.openxmlformats.org/drawingml/2006/main">
             <a:off x="685800" y="914400"/>
-            <a:ext cx="7239000" cy="1000125"/>
+            <a:ext cx="5810250" cy="914400"/>
           </a:xfrm>
           <a:prstGeom xmlns:a="http://schemas.openxmlformats.org/drawingml/2006/main" prst="rect">
             <a:avLst/>
@@ -5507,7 +5655,7 @@
                   <a:srgbClr val="10231F"/>
                 </a:solidFill>
               </a:rPr>
-              <a:t>Occurrence records are evidence, but not a sampling design</a:t>
+              <a:t>Case study: Aedes aegypti in Brazil</a:t>
             </a:r>
           </a:p>
         </p:txBody>
@@ -5521,13 +5669,13 @@
           <p:nvPr/>
         </p:nvPicPr>
         <p:blipFill>
-          <a:blip xmlns:r="http://schemas.openxmlformats.org/officeDocument/2006/relationships" xmlns:a="http://schemas.openxmlformats.org/drawingml/2006/main" r:embed="R3621369227834b03"/>
+          <a:blip xmlns:r="http://schemas.openxmlformats.org/officeDocument/2006/relationships" xmlns:a="http://schemas.openxmlformats.org/drawingml/2006/main" r:embed="Rf19a24ff348b469c"/>
           <a:stretch xmlns:a="http://schemas.openxmlformats.org/drawingml/2006/main"/>
         </p:blipFill>
         <p:spPr>
           <a:xfrm xmlns:a="http://schemas.openxmlformats.org/drawingml/2006/main">
-            <a:off x="6715125" y="1114425"/>
-            <a:ext cx="4000500" cy="4000500"/>
+            <a:off x="6953250" y="1619250"/>
+            <a:ext cx="3714750" cy="3714750"/>
           </a:xfrm>
           <a:prstGeom xmlns:a="http://schemas.openxmlformats.org/drawingml/2006/main" prst="rect">
             <a:avLst/>
@@ -5539,19 +5687,19 @@
           <p:cNvPr id="6" name="">
             <a:extLst xmlns:a="http://schemas.openxmlformats.org/drawingml/2006/main">
               <a:ext uri="{FF2B5EF4-FFF2-40B4-BE49-F238E27FC236}">
-                <a16:creationId xmlns:a16="http://schemas.microsoft.com/office/drawing/2014/main" id="{53E12AB0-3BD4-4861-853E-72466EAADF9A}"/>
-              </a:ext>
-            </a:extLst>
-          </p:cNvPr>
-          <p:cNvSpPr>
-            <a:spLocks xmlns:a="http://schemas.openxmlformats.org/drawingml/2006/main" noGrp="1"/>
-          </p:cNvSpPr>
-          <p:nvPr/>
-        </p:nvSpPr>
-        <p:spPr>
-          <a:xfrm xmlns:a="http://schemas.openxmlformats.org/drawingml/2006/main">
-            <a:off x="723900" y="2038350"/>
-            <a:ext cx="5143500" cy="819150"/>
+                <a16:creationId xmlns:a16="http://schemas.microsoft.com/office/drawing/2014/main" id="{0E608842-86E3-4924-BF16-BBBEA7B10C8F}"/>
+              </a:ext>
+            </a:extLst>
+          </p:cNvPr>
+          <p:cNvSpPr>
+            <a:spLocks xmlns:a="http://schemas.openxmlformats.org/drawingml/2006/main" noGrp="1"/>
+          </p:cNvSpPr>
+          <p:nvPr/>
+        </p:nvSpPr>
+        <p:spPr>
+          <a:xfrm xmlns:a="http://schemas.openxmlformats.org/drawingml/2006/main">
+            <a:off x="723900" y="2095500"/>
+            <a:ext cx="3429000" cy="323850"/>
           </a:xfrm>
           <a:prstGeom xmlns:a="http://schemas.openxmlformats.org/drawingml/2006/main" prst="rect">
             <a:avLst/>
@@ -5567,19 +5715,19 @@
           <a:lstStyle xmlns:a="http://schemas.openxmlformats.org/drawingml/2006/main"/>
           <a:p xmlns:a="http://schemas.openxmlformats.org/drawingml/2006/main">
             <a:pPr algn="l">
-              <a:defRPr sz="2025" b="1" i="0">
-                <a:solidFill>
-                  <a:srgbClr val="10231F"/>
-                </a:solidFill>
-              </a:defRPr>
-            </a:pPr>
-            <a:r>
-              <a:rPr sz="2025" b="1" i="0">
-                <a:solidFill>
-                  <a:srgbClr val="10231F"/>
-                </a:solidFill>
-              </a:rPr>
-              <a:t>GBIF gives us reach and reuse. It does not give us equal effort, perfect coordinates, or true absences.</a:t>
+              <a:defRPr sz="2250" b="1" i="0">
+                <a:solidFill>
+                  <a:srgbClr val="D96445"/>
+                </a:solidFill>
+              </a:defRPr>
+            </a:pPr>
+            <a:r>
+              <a:rPr sz="2250" b="1" i="0">
+                <a:solidFill>
+                  <a:srgbClr val="D96445"/>
+                </a:solidFill>
+              </a:rPr>
+              <a:t>Why this example?</a:t>
             </a:r>
           </a:p>
         </p:txBody>
@@ -5589,18 +5737,18 @@
           <p:cNvPr id="7" name="">
             <a:extLst xmlns:a="http://schemas.openxmlformats.org/drawingml/2006/main">
               <a:ext uri="{FF2B5EF4-FFF2-40B4-BE49-F238E27FC236}">
-                <a16:creationId xmlns:a16="http://schemas.microsoft.com/office/drawing/2014/main" id="{C1549E64-F5F3-4523-8F0F-11C8EBA019B6}"/>
-              </a:ext>
-            </a:extLst>
-          </p:cNvPr>
-          <p:cNvSpPr>
-            <a:spLocks xmlns:a="http://schemas.openxmlformats.org/drawingml/2006/main" noGrp="1"/>
-          </p:cNvSpPr>
-          <p:nvPr/>
-        </p:nvSpPr>
-        <p:spPr>
-          <a:xfrm xmlns:a="http://schemas.openxmlformats.org/drawingml/2006/main">
-            <a:off x="781050" y="3467100"/>
+                <a16:creationId xmlns:a16="http://schemas.microsoft.com/office/drawing/2014/main" id="{57B07F6E-A470-42AD-9913-68C03E7608BD}"/>
+              </a:ext>
+            </a:extLst>
+          </p:cNvPr>
+          <p:cNvSpPr>
+            <a:spLocks xmlns:a="http://schemas.openxmlformats.org/drawingml/2006/main" noGrp="1"/>
+          </p:cNvSpPr>
+          <p:nvPr/>
+        </p:nvSpPr>
+        <p:spPr>
+          <a:xfrm xmlns:a="http://schemas.openxmlformats.org/drawingml/2006/main">
+            <a:off x="781050" y="2895600"/>
             <a:ext cx="85725" cy="85725"/>
           </a:xfrm>
           <a:prstGeom xmlns:a="http://schemas.openxmlformats.org/drawingml/2006/main" prst="ellipse">
@@ -5620,19 +5768,19 @@
           <p:cNvPr id="8" name="">
             <a:extLst xmlns:a="http://schemas.openxmlformats.org/drawingml/2006/main">
               <a:ext uri="{FF2B5EF4-FFF2-40B4-BE49-F238E27FC236}">
-                <a16:creationId xmlns:a16="http://schemas.microsoft.com/office/drawing/2014/main" id="{7D5D9C2B-BA79-4D24-A4ED-51EDB0E8239A}"/>
-              </a:ext>
-            </a:extLst>
-          </p:cNvPr>
-          <p:cNvSpPr>
-            <a:spLocks xmlns:a="http://schemas.openxmlformats.org/drawingml/2006/main" noGrp="1"/>
-          </p:cNvSpPr>
-          <p:nvPr/>
-        </p:nvSpPr>
-        <p:spPr>
-          <a:xfrm xmlns:a="http://schemas.openxmlformats.org/drawingml/2006/main">
-            <a:off x="1009650" y="3371850"/>
-            <a:ext cx="4914900" cy="400050"/>
+                <a16:creationId xmlns:a16="http://schemas.microsoft.com/office/drawing/2014/main" id="{AA7C76C3-A5DB-4092-8C44-C5A21636AD3D}"/>
+              </a:ext>
+            </a:extLst>
+          </p:cNvPr>
+          <p:cNvSpPr>
+            <a:spLocks xmlns:a="http://schemas.openxmlformats.org/drawingml/2006/main" noGrp="1"/>
+          </p:cNvSpPr>
+          <p:nvPr/>
+        </p:nvSpPr>
+        <p:spPr>
+          <a:xfrm xmlns:a="http://schemas.openxmlformats.org/drawingml/2006/main">
+            <a:off x="1009650" y="2800350"/>
+            <a:ext cx="5105400" cy="400050"/>
           </a:xfrm>
           <a:prstGeom xmlns:a="http://schemas.openxmlformats.org/drawingml/2006/main" prst="rect">
             <a:avLst/>
@@ -5660,7 +5808,7 @@
                   <a:srgbClr val="10231F"/>
                 </a:solidFill>
               </a:rPr>
-              <a:t>Remove missing and impossible coordinates.</a:t>
+              <a:t>The species is epidemiologically relevant.</a:t>
             </a:r>
           </a:p>
         </p:txBody>
@@ -5670,18 +5818,18 @@
           <p:cNvPr id="9" name="">
             <a:extLst xmlns:a="http://schemas.openxmlformats.org/drawingml/2006/main">
               <a:ext uri="{FF2B5EF4-FFF2-40B4-BE49-F238E27FC236}">
-                <a16:creationId xmlns:a16="http://schemas.microsoft.com/office/drawing/2014/main" id="{AF1F09DA-AF30-45D3-B787-1603C3C61FF5}"/>
-              </a:ext>
-            </a:extLst>
-          </p:cNvPr>
-          <p:cNvSpPr>
-            <a:spLocks xmlns:a="http://schemas.openxmlformats.org/drawingml/2006/main" noGrp="1"/>
-          </p:cNvSpPr>
-          <p:nvPr/>
-        </p:nvSpPr>
-        <p:spPr>
-          <a:xfrm xmlns:a="http://schemas.openxmlformats.org/drawingml/2006/main">
-            <a:off x="781050" y="4000500"/>
+                <a16:creationId xmlns:a16="http://schemas.microsoft.com/office/drawing/2014/main" id="{91654E42-93C1-44E0-8FC6-943C41426623}"/>
+              </a:ext>
+            </a:extLst>
+          </p:cNvPr>
+          <p:cNvSpPr>
+            <a:spLocks xmlns:a="http://schemas.openxmlformats.org/drawingml/2006/main" noGrp="1"/>
+          </p:cNvSpPr>
+          <p:nvPr/>
+        </p:nvSpPr>
+        <p:spPr>
+          <a:xfrm xmlns:a="http://schemas.openxmlformats.org/drawingml/2006/main">
+            <a:off x="781050" y="3467100"/>
             <a:ext cx="85725" cy="85725"/>
           </a:xfrm>
           <a:prstGeom xmlns:a="http://schemas.openxmlformats.org/drawingml/2006/main" prst="ellipse">
@@ -5701,19 +5849,19 @@
           <p:cNvPr id="10" name="">
             <a:extLst xmlns:a="http://schemas.openxmlformats.org/drawingml/2006/main">
               <a:ext uri="{FF2B5EF4-FFF2-40B4-BE49-F238E27FC236}">
-                <a16:creationId xmlns:a16="http://schemas.microsoft.com/office/drawing/2014/main" id="{8C1BBE0B-14E2-4864-A240-F941B0084ADC}"/>
-              </a:ext>
-            </a:extLst>
-          </p:cNvPr>
-          <p:cNvSpPr>
-            <a:spLocks xmlns:a="http://schemas.openxmlformats.org/drawingml/2006/main" noGrp="1"/>
-          </p:cNvSpPr>
-          <p:nvPr/>
-        </p:nvSpPr>
-        <p:spPr>
-          <a:xfrm xmlns:a="http://schemas.openxmlformats.org/drawingml/2006/main">
-            <a:off x="1009650" y="3905250"/>
-            <a:ext cx="4914900" cy="400050"/>
+                <a16:creationId xmlns:a16="http://schemas.microsoft.com/office/drawing/2014/main" id="{99C303A4-BF31-4679-9ABA-D5E56D31678A}"/>
+              </a:ext>
+            </a:extLst>
+          </p:cNvPr>
+          <p:cNvSpPr>
+            <a:spLocks xmlns:a="http://schemas.openxmlformats.org/drawingml/2006/main" noGrp="1"/>
+          </p:cNvSpPr>
+          <p:nvPr/>
+        </p:nvSpPr>
+        <p:spPr>
+          <a:xfrm xmlns:a="http://schemas.openxmlformats.org/drawingml/2006/main">
+            <a:off x="1009650" y="3371850"/>
+            <a:ext cx="5105400" cy="400050"/>
           </a:xfrm>
           <a:prstGeom xmlns:a="http://schemas.openxmlformats.org/drawingml/2006/main" prst="rect">
             <a:avLst/>
@@ -5741,7 +5889,7 @@
                   <a:srgbClr val="10231F"/>
                 </a:solidFill>
               </a:rPr>
-              <a:t>Thin duplicate records inside raster cells.</a:t>
+              <a:t>GBIF provides reusable occurrence records.</a:t>
             </a:r>
           </a:p>
         </p:txBody>
@@ -5751,18 +5899,18 @@
           <p:cNvPr id="11" name="">
             <a:extLst xmlns:a="http://schemas.openxmlformats.org/drawingml/2006/main">
               <a:ext uri="{FF2B5EF4-FFF2-40B4-BE49-F238E27FC236}">
-                <a16:creationId xmlns:a16="http://schemas.microsoft.com/office/drawing/2014/main" id="{EFA65568-2E64-4DF5-B069-7E895B4E8E69}"/>
-              </a:ext>
-            </a:extLst>
-          </p:cNvPr>
-          <p:cNvSpPr>
-            <a:spLocks xmlns:a="http://schemas.openxmlformats.org/drawingml/2006/main" noGrp="1"/>
-          </p:cNvSpPr>
-          <p:nvPr/>
-        </p:nvSpPr>
-        <p:spPr>
-          <a:xfrm xmlns:a="http://schemas.openxmlformats.org/drawingml/2006/main">
-            <a:off x="781050" y="4533900"/>
+                <a16:creationId xmlns:a16="http://schemas.microsoft.com/office/drawing/2014/main" id="{E89F161C-ADB7-40F9-9843-21B0F80F04FC}"/>
+              </a:ext>
+            </a:extLst>
+          </p:cNvPr>
+          <p:cNvSpPr>
+            <a:spLocks xmlns:a="http://schemas.openxmlformats.org/drawingml/2006/main" noGrp="1"/>
+          </p:cNvSpPr>
+          <p:nvPr/>
+        </p:nvSpPr>
+        <p:spPr>
+          <a:xfrm xmlns:a="http://schemas.openxmlformats.org/drawingml/2006/main">
+            <a:off x="781050" y="4038600"/>
             <a:ext cx="85725" cy="85725"/>
           </a:xfrm>
           <a:prstGeom xmlns:a="http://schemas.openxmlformats.org/drawingml/2006/main" prst="ellipse">
@@ -5782,19 +5930,19 @@
           <p:cNvPr id="12" name="">
             <a:extLst xmlns:a="http://schemas.openxmlformats.org/drawingml/2006/main">
               <a:ext uri="{FF2B5EF4-FFF2-40B4-BE49-F238E27FC236}">
-                <a16:creationId xmlns:a16="http://schemas.microsoft.com/office/drawing/2014/main" id="{7B5D29AE-7087-4C16-9E1E-AD6F85EF2714}"/>
-              </a:ext>
-            </a:extLst>
-          </p:cNvPr>
-          <p:cNvSpPr>
-            <a:spLocks xmlns:a="http://schemas.openxmlformats.org/drawingml/2006/main" noGrp="1"/>
-          </p:cNvSpPr>
-          <p:nvPr/>
-        </p:nvSpPr>
-        <p:spPr>
-          <a:xfrm xmlns:a="http://schemas.openxmlformats.org/drawingml/2006/main">
-            <a:off x="1009650" y="4438650"/>
-            <a:ext cx="4914900" cy="400050"/>
+                <a16:creationId xmlns:a16="http://schemas.microsoft.com/office/drawing/2014/main" id="{DC9FA3F8-9D4A-4269-BF71-3E39A1E7030F}"/>
+              </a:ext>
+            </a:extLst>
+          </p:cNvPr>
+          <p:cNvSpPr>
+            <a:spLocks xmlns:a="http://schemas.openxmlformats.org/drawingml/2006/main" noGrp="1"/>
+          </p:cNvSpPr>
+          <p:nvPr/>
+        </p:nvSpPr>
+        <p:spPr>
+          <a:xfrm xmlns:a="http://schemas.openxmlformats.org/drawingml/2006/main">
+            <a:off x="1009650" y="3943350"/>
+            <a:ext cx="5105400" cy="400050"/>
           </a:xfrm>
           <a:prstGeom xmlns:a="http://schemas.openxmlformats.org/drawingml/2006/main" prst="rect">
             <a:avLst/>
@@ -5822,7 +5970,7 @@
                   <a:srgbClr val="10231F"/>
                 </a:solidFill>
               </a:rPr>
-              <a:t>Keep a cached clean file so the workshop runs.</a:t>
+              <a:t>Brazil gives a national-scale projection problem.</a:t>
             </a:r>
           </a:p>
         </p:txBody>
@@ -5832,18 +5980,18 @@
           <p:cNvPr id="13" name="">
             <a:extLst xmlns:a="http://schemas.openxmlformats.org/drawingml/2006/main">
               <a:ext uri="{FF2B5EF4-FFF2-40B4-BE49-F238E27FC236}">
-                <a16:creationId xmlns:a16="http://schemas.microsoft.com/office/drawing/2014/main" id="{928EAB5C-657C-4FDD-BE30-0F8238FE2718}"/>
-              </a:ext>
-            </a:extLst>
-          </p:cNvPr>
-          <p:cNvSpPr>
-            <a:spLocks xmlns:a="http://schemas.openxmlformats.org/drawingml/2006/main" noGrp="1"/>
-          </p:cNvSpPr>
-          <p:nvPr/>
-        </p:nvSpPr>
-        <p:spPr>
-          <a:xfrm xmlns:a="http://schemas.openxmlformats.org/drawingml/2006/main">
-            <a:off x="781050" y="5067300"/>
+                <a16:creationId xmlns:a16="http://schemas.microsoft.com/office/drawing/2014/main" id="{5FCC6BA0-2313-446E-B48E-3A6A6F97C44B}"/>
+              </a:ext>
+            </a:extLst>
+          </p:cNvPr>
+          <p:cNvSpPr>
+            <a:spLocks xmlns:a="http://schemas.openxmlformats.org/drawingml/2006/main" noGrp="1"/>
+          </p:cNvSpPr>
+          <p:nvPr/>
+        </p:nvSpPr>
+        <p:spPr>
+          <a:xfrm xmlns:a="http://schemas.openxmlformats.org/drawingml/2006/main">
+            <a:off x="781050" y="4610100"/>
             <a:ext cx="85725" cy="85725"/>
           </a:xfrm>
           <a:prstGeom xmlns:a="http://schemas.openxmlformats.org/drawingml/2006/main" prst="ellipse">
@@ -5863,19 +6011,19 @@
           <p:cNvPr id="14" name="">
             <a:extLst xmlns:a="http://schemas.openxmlformats.org/drawingml/2006/main">
               <a:ext uri="{FF2B5EF4-FFF2-40B4-BE49-F238E27FC236}">
-                <a16:creationId xmlns:a16="http://schemas.microsoft.com/office/drawing/2014/main" id="{0BD3226D-D551-4A16-BAE5-3D79225BA83A}"/>
-              </a:ext>
-            </a:extLst>
-          </p:cNvPr>
-          <p:cNvSpPr>
-            <a:spLocks xmlns:a="http://schemas.openxmlformats.org/drawingml/2006/main" noGrp="1"/>
-          </p:cNvSpPr>
-          <p:nvPr/>
-        </p:nvSpPr>
-        <p:spPr>
-          <a:xfrm xmlns:a="http://schemas.openxmlformats.org/drawingml/2006/main">
-            <a:off x="1009650" y="4972050"/>
-            <a:ext cx="4914900" cy="400050"/>
+                <a16:creationId xmlns:a16="http://schemas.microsoft.com/office/drawing/2014/main" id="{FCB0DA0E-C6D4-4F46-903E-CFBBBBC3AAF8}"/>
+              </a:ext>
+            </a:extLst>
+          </p:cNvPr>
+          <p:cNvSpPr>
+            <a:spLocks xmlns:a="http://schemas.openxmlformats.org/drawingml/2006/main" noGrp="1"/>
+          </p:cNvSpPr>
+          <p:nvPr/>
+        </p:nvSpPr>
+        <p:spPr>
+          <a:xfrm xmlns:a="http://schemas.openxmlformats.org/drawingml/2006/main">
+            <a:off x="1009650" y="4514850"/>
+            <a:ext cx="5105400" cy="400050"/>
           </a:xfrm>
           <a:prstGeom xmlns:a="http://schemas.openxmlformats.org/drawingml/2006/main" prst="rect">
             <a:avLst/>
@@ -5903,7 +6051,7 @@
                   <a:srgbClr val="10231F"/>
                 </a:solidFill>
               </a:rPr>
-              <a:t>Interpret dense points as sampling effort and occurrence.</a:t>
+              <a:t>The result is vector suitability, not dengue risk.</a:t>
             </a:r>
           </a:p>
         </p:txBody>
@@ -5913,7 +6061,7 @@
           <p:cNvPr id="15" name="">
             <a:extLst xmlns:a="http://schemas.openxmlformats.org/drawingml/2006/main">
               <a:ext uri="{FF2B5EF4-FFF2-40B4-BE49-F238E27FC236}">
-                <a16:creationId xmlns:a16="http://schemas.microsoft.com/office/drawing/2014/main" id="{8C6D8F73-FC2E-4A9D-A782-97BD15DD0D12}"/>
+                <a16:creationId xmlns:a16="http://schemas.microsoft.com/office/drawing/2014/main" id="{A75A6F20-85C7-4A5C-861D-4C2140E4BFCE}"/>
               </a:ext>
             </a:extLst>
           </p:cNvPr>
@@ -5925,7 +6073,7 @@
         <p:spPr>
           <a:xfrm xmlns:a="http://schemas.openxmlformats.org/drawingml/2006/main">
             <a:off x="685800" y="6419850"/>
-            <a:ext cx="4000500" cy="171450"/>
+            <a:ext cx="3048000" cy="171450"/>
           </a:xfrm>
           <a:prstGeom xmlns:a="http://schemas.openxmlformats.org/drawingml/2006/main" prst="rect">
             <a:avLst/>
@@ -5953,7 +6101,7 @@
                   <a:srgbClr val="9A948B"/>
                 </a:solidFill>
               </a:rPr>
-              <a:t>Species distribution modelling for dengue vector mapping</a:t>
+              <a:t>Species distribution modelling workshop</a:t>
             </a:r>
           </a:p>
         </p:txBody>
@@ -5961,7 +6109,7 @@
     </p:spTree>
     <p:extLst>
       <p:ext uri="{BB962C8B-B14F-4D97-AF65-F5344CB8AC3E}">
-        <p14:creationId xmlns:p14="http://schemas.microsoft.com/office/powerpoint/2010/main" val="1460388119"/>
+        <p14:creationId xmlns:p14="http://schemas.microsoft.com/office/powerpoint/2010/main" val="2074076444"/>
       </p:ext>
     </p:extLst>
   </p:cSld>
@@ -5992,7 +6140,7 @@
           <p:cNvPr id="11" name="">
             <a:extLst xmlns:a="http://schemas.openxmlformats.org/drawingml/2006/main">
               <a:ext uri="{FF2B5EF4-FFF2-40B4-BE49-F238E27FC236}">
-                <a16:creationId xmlns:a16="http://schemas.microsoft.com/office/drawing/2014/main" id="{10EBD5AA-C69D-449B-A815-12F30E05623C}"/>
+                <a16:creationId xmlns:a16="http://schemas.microsoft.com/office/drawing/2014/main" id="{B56695A8-E8F4-4C46-9CC8-8EE05637D6A3}"/>
               </a:ext>
             </a:extLst>
           </p:cNvPr>
@@ -6042,7 +6190,7 @@
           <p:cNvPr id="2" name="">
             <a:extLst xmlns:a="http://schemas.openxmlformats.org/drawingml/2006/main">
               <a:ext uri="{FF2B5EF4-FFF2-40B4-BE49-F238E27FC236}">
-                <a16:creationId xmlns:a16="http://schemas.microsoft.com/office/drawing/2014/main" id="{9E5D9531-D16C-4341-8F32-6A883CF86F30}"/>
+                <a16:creationId xmlns:a16="http://schemas.microsoft.com/office/drawing/2014/main" id="{7F33CD03-3F33-4989-9850-AB6C831D2522}"/>
               </a:ext>
             </a:extLst>
           </p:cNvPr>
@@ -6073,7 +6221,7 @@
           <p:cNvPr id="3" name="">
             <a:extLst xmlns:a="http://schemas.openxmlformats.org/drawingml/2006/main">
               <a:ext uri="{FF2B5EF4-FFF2-40B4-BE49-F238E27FC236}">
-                <a16:creationId xmlns:a16="http://schemas.microsoft.com/office/drawing/2014/main" id="{6C02F36D-B6A4-4ECC-87E5-6B2E63400C33}"/>
+                <a16:creationId xmlns:a16="http://schemas.microsoft.com/office/drawing/2014/main" id="{88E4F911-9205-4207-9121-F1E4BDA7C42D}"/>
               </a:ext>
             </a:extLst>
           </p:cNvPr>
@@ -6123,7 +6271,7 @@
           <p:cNvPr id="4" name="">
             <a:extLst xmlns:a="http://schemas.openxmlformats.org/drawingml/2006/main">
               <a:ext uri="{FF2B5EF4-FFF2-40B4-BE49-F238E27FC236}">
-                <a16:creationId xmlns:a16="http://schemas.microsoft.com/office/drawing/2014/main" id="{DE761DB3-934D-4F0A-95FD-D0408A6F29E6}"/>
+                <a16:creationId xmlns:a16="http://schemas.microsoft.com/office/drawing/2014/main" id="{D488675F-3D1F-4B68-AFF5-0B2330F0EED1}"/>
               </a:ext>
             </a:extLst>
           </p:cNvPr>
@@ -6177,7 +6325,7 @@
           <p:nvPr/>
         </p:nvPicPr>
         <p:blipFill>
-          <a:blip xmlns:r="http://schemas.openxmlformats.org/officeDocument/2006/relationships" xmlns:a="http://schemas.openxmlformats.org/drawingml/2006/main" r:embed="Rff5413f2f43d4a35"/>
+          <a:blip xmlns:r="http://schemas.openxmlformats.org/officeDocument/2006/relationships" xmlns:a="http://schemas.openxmlformats.org/drawingml/2006/main" r:embed="R7166f8a47cf44d42"/>
           <a:stretch xmlns:a="http://schemas.openxmlformats.org/drawingml/2006/main"/>
         </p:blipFill>
         <p:spPr>
@@ -6195,7 +6343,7 @@
           <p:cNvPr id="6" name="">
             <a:extLst xmlns:a="http://schemas.openxmlformats.org/drawingml/2006/main">
               <a:ext uri="{FF2B5EF4-FFF2-40B4-BE49-F238E27FC236}">
-                <a16:creationId xmlns:a16="http://schemas.microsoft.com/office/drawing/2014/main" id="{3668E5F1-FB38-4767-89A6-9324219DFF22}"/>
+                <a16:creationId xmlns:a16="http://schemas.microsoft.com/office/drawing/2014/main" id="{6C1152E6-A011-459C-AACE-BF32A828F798}"/>
               </a:ext>
             </a:extLst>
           </p:cNvPr>
@@ -6245,7 +6393,7 @@
           <p:cNvPr id="7" name="">
             <a:extLst xmlns:a="http://schemas.openxmlformats.org/drawingml/2006/main">
               <a:ext uri="{FF2B5EF4-FFF2-40B4-BE49-F238E27FC236}">
-                <a16:creationId xmlns:a16="http://schemas.microsoft.com/office/drawing/2014/main" id="{25F6EA16-5185-4188-9FCB-DFE00CF2C6FE}"/>
+                <a16:creationId xmlns:a16="http://schemas.microsoft.com/office/drawing/2014/main" id="{1827292B-6F2E-41E4-A2A5-D90B71BF6E35}"/>
               </a:ext>
             </a:extLst>
           </p:cNvPr>
@@ -6276,7 +6424,7 @@
           <p:cNvPr id="8" name="">
             <a:extLst xmlns:a="http://schemas.openxmlformats.org/drawingml/2006/main">
               <a:ext uri="{FF2B5EF4-FFF2-40B4-BE49-F238E27FC236}">
-                <a16:creationId xmlns:a16="http://schemas.microsoft.com/office/drawing/2014/main" id="{BEB3ADC3-4C4D-49A2-8681-8535F150C8C4}"/>
+                <a16:creationId xmlns:a16="http://schemas.microsoft.com/office/drawing/2014/main" id="{4408BDD7-8284-45A7-A3F3-099AE4F95AE8}"/>
               </a:ext>
             </a:extLst>
           </p:cNvPr>
@@ -6377,7 +6525,7 @@
           <p:cNvPr id="9" name="">
             <a:extLst xmlns:a="http://schemas.openxmlformats.org/drawingml/2006/main">
               <a:ext uri="{FF2B5EF4-FFF2-40B4-BE49-F238E27FC236}">
-                <a16:creationId xmlns:a16="http://schemas.microsoft.com/office/drawing/2014/main" id="{1CE6C140-D611-4752-8B84-C8B270201A76}"/>
+                <a16:creationId xmlns:a16="http://schemas.microsoft.com/office/drawing/2014/main" id="{FA8D9624-DB0A-4595-AAD0-343565DA08F4}"/>
               </a:ext>
             </a:extLst>
           </p:cNvPr>
@@ -6427,7 +6575,7 @@
           <p:cNvPr id="10" name="">
             <a:extLst xmlns:a="http://schemas.openxmlformats.org/drawingml/2006/main">
               <a:ext uri="{FF2B5EF4-FFF2-40B4-BE49-F238E27FC236}">
-                <a16:creationId xmlns:a16="http://schemas.microsoft.com/office/drawing/2014/main" id="{3A3DB867-AC01-4FCF-BA45-9EACB51EAD05}"/>
+                <a16:creationId xmlns:a16="http://schemas.microsoft.com/office/drawing/2014/main" id="{99E26402-E404-4689-9BD9-C8482D74ADC1}"/>
               </a:ext>
             </a:extLst>
           </p:cNvPr>
@@ -6439,7 +6587,7 @@
         <p:spPr>
           <a:xfrm xmlns:a="http://schemas.openxmlformats.org/drawingml/2006/main">
             <a:off x="685800" y="6419850"/>
-            <a:ext cx="4000500" cy="171450"/>
+            <a:ext cx="3048000" cy="171450"/>
           </a:xfrm>
           <a:prstGeom xmlns:a="http://schemas.openxmlformats.org/drawingml/2006/main" prst="rect">
             <a:avLst/>
@@ -6467,7 +6615,7 @@
                   <a:srgbClr val="9A948B"/>
                 </a:solidFill>
               </a:rPr>
-              <a:t>Species distribution modelling for dengue vector mapping</a:t>
+              <a:t>Species distribution modelling workshop</a:t>
             </a:r>
           </a:p>
         </p:txBody>
@@ -6475,7 +6623,7 @@
     </p:spTree>
     <p:extLst>
       <p:ext uri="{BB962C8B-B14F-4D97-AF65-F5344CB8AC3E}">
-        <p14:creationId xmlns:p14="http://schemas.microsoft.com/office/powerpoint/2010/main" val="1420434407"/>
+        <p14:creationId xmlns:p14="http://schemas.microsoft.com/office/powerpoint/2010/main" val="132872471"/>
       </p:ext>
     </p:extLst>
   </p:cSld>
@@ -6506,7 +6654,7 @@
           <p:cNvPr id="16" name="">
             <a:extLst xmlns:a="http://schemas.openxmlformats.org/drawingml/2006/main">
               <a:ext uri="{FF2B5EF4-FFF2-40B4-BE49-F238E27FC236}">
-                <a16:creationId xmlns:a16="http://schemas.microsoft.com/office/drawing/2014/main" id="{20F611AC-D1FD-420A-9750-58B4B5C8F560}"/>
+                <a16:creationId xmlns:a16="http://schemas.microsoft.com/office/drawing/2014/main" id="{D7ED5768-FABB-4633-8C67-A1A8C551BF6B}"/>
               </a:ext>
             </a:extLst>
           </p:cNvPr>
@@ -6556,7 +6704,7 @@
           <p:cNvPr id="2" name="">
             <a:extLst xmlns:a="http://schemas.openxmlformats.org/drawingml/2006/main">
               <a:ext uri="{FF2B5EF4-FFF2-40B4-BE49-F238E27FC236}">
-                <a16:creationId xmlns:a16="http://schemas.microsoft.com/office/drawing/2014/main" id="{29C08B21-5248-4DBD-A91D-26F8264F640C}"/>
+                <a16:creationId xmlns:a16="http://schemas.microsoft.com/office/drawing/2014/main" id="{F6EF9901-A9D8-4DF6-85AA-614027F74A79}"/>
               </a:ext>
             </a:extLst>
           </p:cNvPr>
@@ -6587,7 +6735,7 @@
           <p:cNvPr id="3" name="">
             <a:extLst xmlns:a="http://schemas.openxmlformats.org/drawingml/2006/main">
               <a:ext uri="{FF2B5EF4-FFF2-40B4-BE49-F238E27FC236}">
-                <a16:creationId xmlns:a16="http://schemas.microsoft.com/office/drawing/2014/main" id="{222C31BB-7C3F-4EB9-9648-50B912E83628}"/>
+                <a16:creationId xmlns:a16="http://schemas.microsoft.com/office/drawing/2014/main" id="{A061E391-B9F7-4677-A657-E212755BB6A0}"/>
               </a:ext>
             </a:extLst>
           </p:cNvPr>
@@ -6637,7 +6785,7 @@
           <p:cNvPr id="4" name="">
             <a:extLst xmlns:a="http://schemas.openxmlformats.org/drawingml/2006/main">
               <a:ext uri="{FF2B5EF4-FFF2-40B4-BE49-F238E27FC236}">
-                <a16:creationId xmlns:a16="http://schemas.microsoft.com/office/drawing/2014/main" id="{DE3DFD4B-10D4-40D7-B813-3D6A2D2D29E8}"/>
+                <a16:creationId xmlns:a16="http://schemas.microsoft.com/office/drawing/2014/main" id="{947ADA76-2486-45BF-B373-1E15FD05398C}"/>
               </a:ext>
             </a:extLst>
           </p:cNvPr>
@@ -6687,7 +6835,7 @@
           <p:cNvPr id="5" name="">
             <a:extLst xmlns:a="http://schemas.openxmlformats.org/drawingml/2006/main">
               <a:ext uri="{FF2B5EF4-FFF2-40B4-BE49-F238E27FC236}">
-                <a16:creationId xmlns:a16="http://schemas.microsoft.com/office/drawing/2014/main" id="{6351528C-AEC6-4CA6-ADB6-4CA1C1CD7FF9}"/>
+                <a16:creationId xmlns:a16="http://schemas.microsoft.com/office/drawing/2014/main" id="{E9986D08-A9FD-496E-AF10-0CC5D2DE9F52}"/>
               </a:ext>
             </a:extLst>
           </p:cNvPr>
@@ -6737,7 +6885,7 @@
           <p:cNvPr id="6" name="">
             <a:extLst xmlns:a="http://schemas.openxmlformats.org/drawingml/2006/main">
               <a:ext uri="{FF2B5EF4-FFF2-40B4-BE49-F238E27FC236}">
-                <a16:creationId xmlns:a16="http://schemas.microsoft.com/office/drawing/2014/main" id="{CCCC5B37-2D58-43BB-A009-169F385496C0}"/>
+                <a16:creationId xmlns:a16="http://schemas.microsoft.com/office/drawing/2014/main" id="{B4928BD2-328A-4940-8210-311C07543343}"/>
               </a:ext>
             </a:extLst>
           </p:cNvPr>
@@ -6768,7 +6916,7 @@
           <p:cNvPr id="7" name="">
             <a:extLst xmlns:a="http://schemas.openxmlformats.org/drawingml/2006/main">
               <a:ext uri="{FF2B5EF4-FFF2-40B4-BE49-F238E27FC236}">
-                <a16:creationId xmlns:a16="http://schemas.microsoft.com/office/drawing/2014/main" id="{35AAD5C9-9C50-484D-AF11-4C5655214550}"/>
+                <a16:creationId xmlns:a16="http://schemas.microsoft.com/office/drawing/2014/main" id="{E89D6F7C-1DB7-4CE8-BC73-FF6B37423FC5}"/>
               </a:ext>
             </a:extLst>
           </p:cNvPr>
@@ -6818,7 +6966,7 @@
           <p:cNvPr id="8" name="">
             <a:extLst xmlns:a="http://schemas.openxmlformats.org/drawingml/2006/main">
               <a:ext uri="{FF2B5EF4-FFF2-40B4-BE49-F238E27FC236}">
-                <a16:creationId xmlns:a16="http://schemas.microsoft.com/office/drawing/2014/main" id="{603F08BB-3AD4-4D04-B136-35950A3DBA55}"/>
+                <a16:creationId xmlns:a16="http://schemas.microsoft.com/office/drawing/2014/main" id="{36175088-ED49-469E-9C60-4B02D87C4FA4}"/>
               </a:ext>
             </a:extLst>
           </p:cNvPr>
@@ -6868,7 +7016,7 @@
           <p:cNvPr id="9" name="">
             <a:extLst xmlns:a="http://schemas.openxmlformats.org/drawingml/2006/main">
               <a:ext uri="{FF2B5EF4-FFF2-40B4-BE49-F238E27FC236}">
-                <a16:creationId xmlns:a16="http://schemas.microsoft.com/office/drawing/2014/main" id="{FE47EFFC-D997-4CF4-8D50-7E5143BFF354}"/>
+                <a16:creationId xmlns:a16="http://schemas.microsoft.com/office/drawing/2014/main" id="{D8C3F609-C699-471F-A5AE-9A4B3EDD56A2}"/>
               </a:ext>
             </a:extLst>
           </p:cNvPr>
@@ -6899,7 +7047,7 @@
           <p:cNvPr id="10" name="">
             <a:extLst xmlns:a="http://schemas.openxmlformats.org/drawingml/2006/main">
               <a:ext uri="{FF2B5EF4-FFF2-40B4-BE49-F238E27FC236}">
-                <a16:creationId xmlns:a16="http://schemas.microsoft.com/office/drawing/2014/main" id="{7D5C1693-B423-43E1-A610-1AF4CC6296A4}"/>
+                <a16:creationId xmlns:a16="http://schemas.microsoft.com/office/drawing/2014/main" id="{072A9F31-0C8C-4D8F-8827-A166842FDBF2}"/>
               </a:ext>
             </a:extLst>
           </p:cNvPr>
@@ -6949,7 +7097,7 @@
           <p:cNvPr id="11" name="">
             <a:extLst xmlns:a="http://schemas.openxmlformats.org/drawingml/2006/main">
               <a:ext uri="{FF2B5EF4-FFF2-40B4-BE49-F238E27FC236}">
-                <a16:creationId xmlns:a16="http://schemas.microsoft.com/office/drawing/2014/main" id="{C8078848-F789-468B-B185-F4D12B40C97E}"/>
+                <a16:creationId xmlns:a16="http://schemas.microsoft.com/office/drawing/2014/main" id="{3BC3D38E-EE49-46D0-9E95-9F06F6EB4B74}"/>
               </a:ext>
             </a:extLst>
           </p:cNvPr>
@@ -6999,7 +7147,7 @@
           <p:cNvPr id="12" name="">
             <a:extLst xmlns:a="http://schemas.openxmlformats.org/drawingml/2006/main">
               <a:ext uri="{FF2B5EF4-FFF2-40B4-BE49-F238E27FC236}">
-                <a16:creationId xmlns:a16="http://schemas.microsoft.com/office/drawing/2014/main" id="{819CA14D-DEF9-4FC3-BEFB-E3F7C78E388D}"/>
+                <a16:creationId xmlns:a16="http://schemas.microsoft.com/office/drawing/2014/main" id="{11290296-B673-4646-8CE2-EB4DF8AF4804}"/>
               </a:ext>
             </a:extLst>
           </p:cNvPr>
@@ -7030,7 +7178,7 @@
           <p:cNvPr id="13" name="">
             <a:extLst xmlns:a="http://schemas.openxmlformats.org/drawingml/2006/main">
               <a:ext uri="{FF2B5EF4-FFF2-40B4-BE49-F238E27FC236}">
-                <a16:creationId xmlns:a16="http://schemas.microsoft.com/office/drawing/2014/main" id="{B6921BEE-9665-4168-8E48-0C827A6D2253}"/>
+                <a16:creationId xmlns:a16="http://schemas.microsoft.com/office/drawing/2014/main" id="{E7729319-95DF-4FA2-BCEB-18D47F6DFEF9}"/>
               </a:ext>
             </a:extLst>
           </p:cNvPr>
@@ -7080,7 +7228,7 @@
           <p:cNvPr id="14" name="">
             <a:extLst xmlns:a="http://schemas.openxmlformats.org/drawingml/2006/main">
               <a:ext uri="{FF2B5EF4-FFF2-40B4-BE49-F238E27FC236}">
-                <a16:creationId xmlns:a16="http://schemas.microsoft.com/office/drawing/2014/main" id="{366F0563-7DD9-4726-8FD0-DCAD928E4ECC}"/>
+                <a16:creationId xmlns:a16="http://schemas.microsoft.com/office/drawing/2014/main" id="{CFCA8A4D-C68E-4DA5-9194-6D0F60280EA7}"/>
               </a:ext>
             </a:extLst>
           </p:cNvPr>
@@ -7130,7 +7278,7 @@
           <p:cNvPr id="15" name="">
             <a:extLst xmlns:a="http://schemas.openxmlformats.org/drawingml/2006/main">
               <a:ext uri="{FF2B5EF4-FFF2-40B4-BE49-F238E27FC236}">
-                <a16:creationId xmlns:a16="http://schemas.microsoft.com/office/drawing/2014/main" id="{DC176693-CFE8-40D0-AD61-B470E3E997EB}"/>
+                <a16:creationId xmlns:a16="http://schemas.microsoft.com/office/drawing/2014/main" id="{9C48B5E6-EBA7-4895-A7C0-7C82EB972997}"/>
               </a:ext>
             </a:extLst>
           </p:cNvPr>
@@ -7142,7 +7290,7 @@
         <p:spPr>
           <a:xfrm xmlns:a="http://schemas.openxmlformats.org/drawingml/2006/main">
             <a:off x="685800" y="6419850"/>
-            <a:ext cx="4000500" cy="171450"/>
+            <a:ext cx="3048000" cy="171450"/>
           </a:xfrm>
           <a:prstGeom xmlns:a="http://schemas.openxmlformats.org/drawingml/2006/main" prst="rect">
             <a:avLst/>
@@ -7170,7 +7318,7 @@
                   <a:srgbClr val="87AAA5"/>
                 </a:solidFill>
               </a:rPr>
-              <a:t>Species distribution modelling for dengue vector mapping</a:t>
+              <a:t>Species distribution modelling workshop</a:t>
             </a:r>
           </a:p>
         </p:txBody>
@@ -7178,7 +7326,7 @@
     </p:spTree>
     <p:extLst>
       <p:ext uri="{BB962C8B-B14F-4D97-AF65-F5344CB8AC3E}">
-        <p14:creationId xmlns:p14="http://schemas.microsoft.com/office/powerpoint/2010/main" val="1475478439"/>
+        <p14:creationId xmlns:p14="http://schemas.microsoft.com/office/powerpoint/2010/main" val="1070897542"/>
       </p:ext>
     </p:extLst>
   </p:cSld>
@@ -7209,7 +7357,7 @@
           <p:cNvPr id="17" name="">
             <a:extLst xmlns:a="http://schemas.openxmlformats.org/drawingml/2006/main">
               <a:ext uri="{FF2B5EF4-FFF2-40B4-BE49-F238E27FC236}">
-                <a16:creationId xmlns:a16="http://schemas.microsoft.com/office/drawing/2014/main" id="{704D96BF-F363-4C07-A37D-9A3C8B70E106}"/>
+                <a16:creationId xmlns:a16="http://schemas.microsoft.com/office/drawing/2014/main" id="{4CC62F89-AC74-4B52-9496-1C55213B03CB}"/>
               </a:ext>
             </a:extLst>
           </p:cNvPr>
@@ -7259,7 +7407,7 @@
           <p:cNvPr id="2" name="">
             <a:extLst xmlns:a="http://schemas.openxmlformats.org/drawingml/2006/main">
               <a:ext uri="{FF2B5EF4-FFF2-40B4-BE49-F238E27FC236}">
-                <a16:creationId xmlns:a16="http://schemas.microsoft.com/office/drawing/2014/main" id="{85B8938F-4475-4584-8849-A37095B16D27}"/>
+                <a16:creationId xmlns:a16="http://schemas.microsoft.com/office/drawing/2014/main" id="{F5251D53-310F-4E48-8E2F-961564D031DD}"/>
               </a:ext>
             </a:extLst>
           </p:cNvPr>
@@ -7290,7 +7438,7 @@
           <p:cNvPr id="3" name="">
             <a:extLst xmlns:a="http://schemas.openxmlformats.org/drawingml/2006/main">
               <a:ext uri="{FF2B5EF4-FFF2-40B4-BE49-F238E27FC236}">
-                <a16:creationId xmlns:a16="http://schemas.microsoft.com/office/drawing/2014/main" id="{7720AF72-1A1D-45FF-8538-49AEB212D3BB}"/>
+                <a16:creationId xmlns:a16="http://schemas.microsoft.com/office/drawing/2014/main" id="{AC63F8AF-31B8-4F9A-A33F-B9FF6D03840D}"/>
               </a:ext>
             </a:extLst>
           </p:cNvPr>
@@ -7340,7 +7488,7 @@
           <p:cNvPr id="4" name="">
             <a:extLst xmlns:a="http://schemas.openxmlformats.org/drawingml/2006/main">
               <a:ext uri="{FF2B5EF4-FFF2-40B4-BE49-F238E27FC236}">
-                <a16:creationId xmlns:a16="http://schemas.microsoft.com/office/drawing/2014/main" id="{5A10430C-32FB-44ED-8A53-28C3D34BAB23}"/>
+                <a16:creationId xmlns:a16="http://schemas.microsoft.com/office/drawing/2014/main" id="{6A2EBC8B-EF70-4CD9-98EC-582E240326F3}"/>
               </a:ext>
             </a:extLst>
           </p:cNvPr>
@@ -7390,7 +7538,7 @@
           <p:cNvPr id="5" name="">
             <a:extLst xmlns:a="http://schemas.openxmlformats.org/drawingml/2006/main">
               <a:ext uri="{FF2B5EF4-FFF2-40B4-BE49-F238E27FC236}">
-                <a16:creationId xmlns:a16="http://schemas.microsoft.com/office/drawing/2014/main" id="{F737EBFE-4A9B-49CC-956F-F9C357DA4A5F}"/>
+                <a16:creationId xmlns:a16="http://schemas.microsoft.com/office/drawing/2014/main" id="{9431D2C2-5325-4359-8409-176840205A15}"/>
               </a:ext>
             </a:extLst>
           </p:cNvPr>
@@ -7440,7 +7588,7 @@
           <p:cNvPr id="6" name="">
             <a:extLst xmlns:a="http://schemas.openxmlformats.org/drawingml/2006/main">
               <a:ext uri="{FF2B5EF4-FFF2-40B4-BE49-F238E27FC236}">
-                <a16:creationId xmlns:a16="http://schemas.microsoft.com/office/drawing/2014/main" id="{3C78162C-F0BF-4B01-AC89-721707456B5A}"/>
+                <a16:creationId xmlns:a16="http://schemas.microsoft.com/office/drawing/2014/main" id="{59CF191B-403A-437F-8FEA-D3D207C623CB}"/>
               </a:ext>
             </a:extLst>
           </p:cNvPr>
@@ -7471,7 +7619,7 @@
           <p:cNvPr id="7" name="">
             <a:extLst xmlns:a="http://schemas.openxmlformats.org/drawingml/2006/main">
               <a:ext uri="{FF2B5EF4-FFF2-40B4-BE49-F238E27FC236}">
-                <a16:creationId xmlns:a16="http://schemas.microsoft.com/office/drawing/2014/main" id="{61E2CAEB-497B-4D63-97AD-608A1EFF8B09}"/>
+                <a16:creationId xmlns:a16="http://schemas.microsoft.com/office/drawing/2014/main" id="{28993BDD-AF7B-4757-9E72-82FD3F881B66}"/>
               </a:ext>
             </a:extLst>
           </p:cNvPr>
@@ -7521,7 +7669,7 @@
           <p:cNvPr id="8" name="">
             <a:extLst xmlns:a="http://schemas.openxmlformats.org/drawingml/2006/main">
               <a:ext uri="{FF2B5EF4-FFF2-40B4-BE49-F238E27FC236}">
-                <a16:creationId xmlns:a16="http://schemas.microsoft.com/office/drawing/2014/main" id="{9B2D986A-66B4-4960-9F50-DC585C5452B6}"/>
+                <a16:creationId xmlns:a16="http://schemas.microsoft.com/office/drawing/2014/main" id="{69CFE9DC-253F-4046-98B8-DFA9452E601D}"/>
               </a:ext>
             </a:extLst>
           </p:cNvPr>
@@ -7571,7 +7719,7 @@
           <p:cNvPr id="9" name="">
             <a:extLst xmlns:a="http://schemas.openxmlformats.org/drawingml/2006/main">
               <a:ext uri="{FF2B5EF4-FFF2-40B4-BE49-F238E27FC236}">
-                <a16:creationId xmlns:a16="http://schemas.microsoft.com/office/drawing/2014/main" id="{5E42FC7B-BA45-4B63-B914-3B51347B1278}"/>
+                <a16:creationId xmlns:a16="http://schemas.microsoft.com/office/drawing/2014/main" id="{5B8EB94A-F850-4306-B6FF-0C993512FDF7}"/>
               </a:ext>
             </a:extLst>
           </p:cNvPr>
@@ -7621,7 +7769,7 @@
           <p:cNvPr id="10" name="">
             <a:extLst xmlns:a="http://schemas.openxmlformats.org/drawingml/2006/main">
               <a:ext uri="{FF2B5EF4-FFF2-40B4-BE49-F238E27FC236}">
-                <a16:creationId xmlns:a16="http://schemas.microsoft.com/office/drawing/2014/main" id="{98169F29-78BD-4805-AF94-AD1CB383A849}"/>
+                <a16:creationId xmlns:a16="http://schemas.microsoft.com/office/drawing/2014/main" id="{AF1CDCEC-F5C0-4AE8-8D3D-8FE42EC5C902}"/>
               </a:ext>
             </a:extLst>
           </p:cNvPr>
@@ -7671,7 +7819,7 @@
           <p:cNvPr id="11" name="">
             <a:extLst xmlns:a="http://schemas.openxmlformats.org/drawingml/2006/main">
               <a:ext uri="{FF2B5EF4-FFF2-40B4-BE49-F238E27FC236}">
-                <a16:creationId xmlns:a16="http://schemas.microsoft.com/office/drawing/2014/main" id="{7A4E45CA-9ED2-40B4-9095-9291C3D311B0}"/>
+                <a16:creationId xmlns:a16="http://schemas.microsoft.com/office/drawing/2014/main" id="{B6F2804E-BC24-43EA-AF9C-7F7FCE61F412}"/>
               </a:ext>
             </a:extLst>
           </p:cNvPr>
@@ -7721,7 +7869,7 @@
           <p:cNvPr id="12" name="">
             <a:extLst xmlns:a="http://schemas.openxmlformats.org/drawingml/2006/main">
               <a:ext uri="{FF2B5EF4-FFF2-40B4-BE49-F238E27FC236}">
-                <a16:creationId xmlns:a16="http://schemas.microsoft.com/office/drawing/2014/main" id="{17237023-1A8A-49FB-A6E8-A9AD2416D738}"/>
+                <a16:creationId xmlns:a16="http://schemas.microsoft.com/office/drawing/2014/main" id="{0F68D552-2B15-4F69-A6D0-F49D822F712E}"/>
               </a:ext>
             </a:extLst>
           </p:cNvPr>
@@ -7771,7 +7919,7 @@
           <p:cNvPr id="13" name="">
             <a:extLst xmlns:a="http://schemas.openxmlformats.org/drawingml/2006/main">
               <a:ext uri="{FF2B5EF4-FFF2-40B4-BE49-F238E27FC236}">
-                <a16:creationId xmlns:a16="http://schemas.microsoft.com/office/drawing/2014/main" id="{25FBC33C-C916-452B-903A-34BA60EA2DA8}"/>
+                <a16:creationId xmlns:a16="http://schemas.microsoft.com/office/drawing/2014/main" id="{BCE53BFE-12BF-4D56-B39D-3E3AEC71B9B7}"/>
               </a:ext>
             </a:extLst>
           </p:cNvPr>
@@ -7821,7 +7969,7 @@
           <p:cNvPr id="14" name="">
             <a:extLst xmlns:a="http://schemas.openxmlformats.org/drawingml/2006/main">
               <a:ext uri="{FF2B5EF4-FFF2-40B4-BE49-F238E27FC236}">
-                <a16:creationId xmlns:a16="http://schemas.microsoft.com/office/drawing/2014/main" id="{FCC7181C-11CA-428A-B135-E88124B57CDF}"/>
+                <a16:creationId xmlns:a16="http://schemas.microsoft.com/office/drawing/2014/main" id="{A7787D8E-02CB-4D94-9925-73E8BC1E1CAC}"/>
               </a:ext>
             </a:extLst>
           </p:cNvPr>
@@ -7871,7 +8019,7 @@
           <p:cNvPr id="15" name="">
             <a:extLst xmlns:a="http://schemas.openxmlformats.org/drawingml/2006/main">
               <a:ext uri="{FF2B5EF4-FFF2-40B4-BE49-F238E27FC236}">
-                <a16:creationId xmlns:a16="http://schemas.microsoft.com/office/drawing/2014/main" id="{F647DD84-8BE1-4F7D-AC2E-D412EEFCBEC7}"/>
+                <a16:creationId xmlns:a16="http://schemas.microsoft.com/office/drawing/2014/main" id="{3D50FB76-7837-425C-AEAD-E3D45B906C3E}"/>
               </a:ext>
             </a:extLst>
           </p:cNvPr>
@@ -7921,7 +8069,7 @@
           <p:cNvPr id="16" name="">
             <a:extLst xmlns:a="http://schemas.openxmlformats.org/drawingml/2006/main">
               <a:ext uri="{FF2B5EF4-FFF2-40B4-BE49-F238E27FC236}">
-                <a16:creationId xmlns:a16="http://schemas.microsoft.com/office/drawing/2014/main" id="{83AD9E03-4BB6-4AF5-8978-0D897B99C1F1}"/>
+                <a16:creationId xmlns:a16="http://schemas.microsoft.com/office/drawing/2014/main" id="{D2BD5B9A-1100-4346-9A16-8BE1EF28C75C}"/>
               </a:ext>
             </a:extLst>
           </p:cNvPr>
@@ -7933,7 +8081,7 @@
         <p:spPr>
           <a:xfrm xmlns:a="http://schemas.openxmlformats.org/drawingml/2006/main">
             <a:off x="685800" y="6419850"/>
-            <a:ext cx="4000500" cy="171450"/>
+            <a:ext cx="3048000" cy="171450"/>
           </a:xfrm>
           <a:prstGeom xmlns:a="http://schemas.openxmlformats.org/drawingml/2006/main" prst="rect">
             <a:avLst/>
@@ -7961,7 +8109,7 @@
                   <a:srgbClr val="9A948B"/>
                 </a:solidFill>
               </a:rPr>
-              <a:t>Species distribution modelling for dengue vector mapping</a:t>
+              <a:t>Species distribution modelling workshop</a:t>
             </a:r>
           </a:p>
         </p:txBody>
@@ -7969,7 +8117,7 @@
     </p:spTree>
     <p:extLst>
       <p:ext uri="{BB962C8B-B14F-4D97-AF65-F5344CB8AC3E}">
-        <p14:creationId xmlns:p14="http://schemas.microsoft.com/office/powerpoint/2010/main" val="707277138"/>
+        <p14:creationId xmlns:p14="http://schemas.microsoft.com/office/powerpoint/2010/main" val="1311919339"/>
       </p:ext>
     </p:extLst>
   </p:cSld>
@@ -8000,7 +8148,7 @@
           <p:cNvPr id="16" name="">
             <a:extLst xmlns:a="http://schemas.openxmlformats.org/drawingml/2006/main">
               <a:ext uri="{FF2B5EF4-FFF2-40B4-BE49-F238E27FC236}">
-                <a16:creationId xmlns:a16="http://schemas.microsoft.com/office/drawing/2014/main" id="{68C8530C-246A-45F0-A716-9F71D76DC9BB}"/>
+                <a16:creationId xmlns:a16="http://schemas.microsoft.com/office/drawing/2014/main" id="{200AB901-B87F-4DCC-8365-D49FA5A09533}"/>
               </a:ext>
             </a:extLst>
           </p:cNvPr>
@@ -8050,7 +8198,7 @@
           <p:cNvPr id="2" name="">
             <a:extLst xmlns:a="http://schemas.openxmlformats.org/drawingml/2006/main">
               <a:ext uri="{FF2B5EF4-FFF2-40B4-BE49-F238E27FC236}">
-                <a16:creationId xmlns:a16="http://schemas.microsoft.com/office/drawing/2014/main" id="{656DBAB4-4E9D-4605-A687-B86A9FDC120A}"/>
+                <a16:creationId xmlns:a16="http://schemas.microsoft.com/office/drawing/2014/main" id="{F6B84ECF-E087-4EC5-A8F9-0D1B5CCDB7CC}"/>
               </a:ext>
             </a:extLst>
           </p:cNvPr>
@@ -8081,7 +8229,7 @@
           <p:cNvPr id="3" name="">
             <a:extLst xmlns:a="http://schemas.openxmlformats.org/drawingml/2006/main">
               <a:ext uri="{FF2B5EF4-FFF2-40B4-BE49-F238E27FC236}">
-                <a16:creationId xmlns:a16="http://schemas.microsoft.com/office/drawing/2014/main" id="{53EDEBB6-4CBF-41C5-B4EC-F83961FD9283}"/>
+                <a16:creationId xmlns:a16="http://schemas.microsoft.com/office/drawing/2014/main" id="{E3DA6DAB-0E06-4AF7-A72E-984C1F43E30F}"/>
               </a:ext>
             </a:extLst>
           </p:cNvPr>
@@ -8131,7 +8279,7 @@
           <p:cNvPr id="4" name="">
             <a:extLst xmlns:a="http://schemas.openxmlformats.org/drawingml/2006/main">
               <a:ext uri="{FF2B5EF4-FFF2-40B4-BE49-F238E27FC236}">
-                <a16:creationId xmlns:a16="http://schemas.microsoft.com/office/drawing/2014/main" id="{C1B1D16E-F912-48DD-93BF-2F86A0A36C15}"/>
+                <a16:creationId xmlns:a16="http://schemas.microsoft.com/office/drawing/2014/main" id="{3607C459-2055-49CE-BDF4-5B01A7A51B8E}"/>
               </a:ext>
             </a:extLst>
           </p:cNvPr>
@@ -8181,7 +8329,7 @@
           <p:cNvPr id="5" name="">
             <a:extLst xmlns:a="http://schemas.openxmlformats.org/drawingml/2006/main">
               <a:ext uri="{FF2B5EF4-FFF2-40B4-BE49-F238E27FC236}">
-                <a16:creationId xmlns:a16="http://schemas.microsoft.com/office/drawing/2014/main" id="{97606E0D-6D3E-4D96-AC69-549A6683A3CD}"/>
+                <a16:creationId xmlns:a16="http://schemas.microsoft.com/office/drawing/2014/main" id="{453B8019-D553-4E6E-B4EB-D997B278236D}"/>
               </a:ext>
             </a:extLst>
           </p:cNvPr>
@@ -8231,7 +8379,7 @@
           <p:cNvPr id="6" name="">
             <a:extLst xmlns:a="http://schemas.openxmlformats.org/drawingml/2006/main">
               <a:ext uri="{FF2B5EF4-FFF2-40B4-BE49-F238E27FC236}">
-                <a16:creationId xmlns:a16="http://schemas.microsoft.com/office/drawing/2014/main" id="{6A883236-86C7-4371-89F6-BD536A8A69B7}"/>
+                <a16:creationId xmlns:a16="http://schemas.microsoft.com/office/drawing/2014/main" id="{6B199EE0-0E8D-41C7-90DA-F81E93F20D6D}"/>
               </a:ext>
             </a:extLst>
           </p:cNvPr>
@@ -8262,7 +8410,7 @@
           <p:cNvPr id="7" name="">
             <a:extLst xmlns:a="http://schemas.openxmlformats.org/drawingml/2006/main">
               <a:ext uri="{FF2B5EF4-FFF2-40B4-BE49-F238E27FC236}">
-                <a16:creationId xmlns:a16="http://schemas.microsoft.com/office/drawing/2014/main" id="{D03469B9-4D9E-409E-94A9-A63A1E6F91FB}"/>
+                <a16:creationId xmlns:a16="http://schemas.microsoft.com/office/drawing/2014/main" id="{85D8FC63-5401-4A6D-93A4-58608F54014D}"/>
               </a:ext>
             </a:extLst>
           </p:cNvPr>
@@ -8312,7 +8460,7 @@
           <p:cNvPr id="8" name="">
             <a:extLst xmlns:a="http://schemas.openxmlformats.org/drawingml/2006/main">
               <a:ext uri="{FF2B5EF4-FFF2-40B4-BE49-F238E27FC236}">
-                <a16:creationId xmlns:a16="http://schemas.microsoft.com/office/drawing/2014/main" id="{C94492CD-6E27-4141-B5E2-701B10A0C44F}"/>
+                <a16:creationId xmlns:a16="http://schemas.microsoft.com/office/drawing/2014/main" id="{44291374-29D0-43CE-9D3C-96BAA3E4AD4C}"/>
               </a:ext>
             </a:extLst>
           </p:cNvPr>
@@ -8343,7 +8491,7 @@
           <p:cNvPr id="9" name="">
             <a:extLst xmlns:a="http://schemas.openxmlformats.org/drawingml/2006/main">
               <a:ext uri="{FF2B5EF4-FFF2-40B4-BE49-F238E27FC236}">
-                <a16:creationId xmlns:a16="http://schemas.microsoft.com/office/drawing/2014/main" id="{9157913F-12B2-4AED-B4F2-1093A6CFED0D}"/>
+                <a16:creationId xmlns:a16="http://schemas.microsoft.com/office/drawing/2014/main" id="{064ACA50-E6F6-4E9A-A741-65808F5F7246}"/>
               </a:ext>
             </a:extLst>
           </p:cNvPr>
@@ -8393,7 +8541,7 @@
           <p:cNvPr id="10" name="">
             <a:extLst xmlns:a="http://schemas.openxmlformats.org/drawingml/2006/main">
               <a:ext uri="{FF2B5EF4-FFF2-40B4-BE49-F238E27FC236}">
-                <a16:creationId xmlns:a16="http://schemas.microsoft.com/office/drawing/2014/main" id="{141BFEAF-6664-4204-AF5E-1AF1E1257A79}"/>
+                <a16:creationId xmlns:a16="http://schemas.microsoft.com/office/drawing/2014/main" id="{5548C1E1-BBC6-4CD5-8C46-6FFEC54F948E}"/>
               </a:ext>
             </a:extLst>
           </p:cNvPr>
@@ -8443,7 +8591,7 @@
           <p:cNvPr id="11" name="">
             <a:extLst xmlns:a="http://schemas.openxmlformats.org/drawingml/2006/main">
               <a:ext uri="{FF2B5EF4-FFF2-40B4-BE49-F238E27FC236}">
-                <a16:creationId xmlns:a16="http://schemas.microsoft.com/office/drawing/2014/main" id="{8261463C-F105-4639-B222-6F19F9C0E775}"/>
+                <a16:creationId xmlns:a16="http://schemas.microsoft.com/office/drawing/2014/main" id="{3AF498C1-C104-4AD6-B566-F46C177250FE}"/>
               </a:ext>
             </a:extLst>
           </p:cNvPr>
@@ -8493,7 +8641,7 @@
           <p:cNvPr id="12" name="">
             <a:extLst xmlns:a="http://schemas.openxmlformats.org/drawingml/2006/main">
               <a:ext uri="{FF2B5EF4-FFF2-40B4-BE49-F238E27FC236}">
-                <a16:creationId xmlns:a16="http://schemas.microsoft.com/office/drawing/2014/main" id="{181F4740-F069-431B-B813-CE73AB2CDDFF}"/>
+                <a16:creationId xmlns:a16="http://schemas.microsoft.com/office/drawing/2014/main" id="{74A01D11-FDDB-4D86-84A8-1617F573672B}"/>
               </a:ext>
             </a:extLst>
           </p:cNvPr>
@@ -8543,7 +8691,7 @@
           <p:cNvPr id="13" name="">
             <a:extLst xmlns:a="http://schemas.openxmlformats.org/drawingml/2006/main">
               <a:ext uri="{FF2B5EF4-FFF2-40B4-BE49-F238E27FC236}">
-                <a16:creationId xmlns:a16="http://schemas.microsoft.com/office/drawing/2014/main" id="{4F5D295D-781F-4541-96B3-C2E33F7B281F}"/>
+                <a16:creationId xmlns:a16="http://schemas.microsoft.com/office/drawing/2014/main" id="{1DAEB522-1E15-4F97-9A91-CB94A90CEA14}"/>
               </a:ext>
             </a:extLst>
           </p:cNvPr>
@@ -8593,7 +8741,7 @@
           <p:cNvPr id="14" name="">
             <a:extLst xmlns:a="http://schemas.openxmlformats.org/drawingml/2006/main">
               <a:ext uri="{FF2B5EF4-FFF2-40B4-BE49-F238E27FC236}">
-                <a16:creationId xmlns:a16="http://schemas.microsoft.com/office/drawing/2014/main" id="{1340A57E-28CE-4A85-A6C3-FB16F26C56FC}"/>
+                <a16:creationId xmlns:a16="http://schemas.microsoft.com/office/drawing/2014/main" id="{788E33E6-BD6B-4AF0-8988-940556772E4C}"/>
               </a:ext>
             </a:extLst>
           </p:cNvPr>
@@ -8643,7 +8791,7 @@
           <p:cNvPr id="15" name="">
             <a:extLst xmlns:a="http://schemas.openxmlformats.org/drawingml/2006/main">
               <a:ext uri="{FF2B5EF4-FFF2-40B4-BE49-F238E27FC236}">
-                <a16:creationId xmlns:a16="http://schemas.microsoft.com/office/drawing/2014/main" id="{C64A1FEA-FE55-4C53-A90E-CFEFE602FAD2}"/>
+                <a16:creationId xmlns:a16="http://schemas.microsoft.com/office/drawing/2014/main" id="{4B240D0D-8DC0-4B55-B2D2-87581C6BC485}"/>
               </a:ext>
             </a:extLst>
           </p:cNvPr>
@@ -8655,7 +8803,7 @@
         <p:spPr>
           <a:xfrm xmlns:a="http://schemas.openxmlformats.org/drawingml/2006/main">
             <a:off x="685800" y="6419850"/>
-            <a:ext cx="4000500" cy="171450"/>
+            <a:ext cx="3048000" cy="171450"/>
           </a:xfrm>
           <a:prstGeom xmlns:a="http://schemas.openxmlformats.org/drawingml/2006/main" prst="rect">
             <a:avLst/>
@@ -8683,7 +8831,7 @@
                   <a:srgbClr val="9A948B"/>
                 </a:solidFill>
               </a:rPr>
-              <a:t>Species distribution modelling for dengue vector mapping</a:t>
+              <a:t>Species distribution modelling workshop</a:t>
             </a:r>
           </a:p>
         </p:txBody>
@@ -8691,7 +8839,7 @@
     </p:spTree>
     <p:extLst>
       <p:ext uri="{BB962C8B-B14F-4D97-AF65-F5344CB8AC3E}">
-        <p14:creationId xmlns:p14="http://schemas.microsoft.com/office/powerpoint/2010/main" val="1145814386"/>
+        <p14:creationId xmlns:p14="http://schemas.microsoft.com/office/powerpoint/2010/main" val="1671957795"/>
       </p:ext>
     </p:extLst>
   </p:cSld>
@@ -8722,7 +8870,7 @@
           <p:cNvPr id="14" name="">
             <a:extLst xmlns:a="http://schemas.openxmlformats.org/drawingml/2006/main">
               <a:ext uri="{FF2B5EF4-FFF2-40B4-BE49-F238E27FC236}">
-                <a16:creationId xmlns:a16="http://schemas.microsoft.com/office/drawing/2014/main" id="{DEAC71E7-0C5D-469F-A7F4-18E9FDB7C12A}"/>
+                <a16:creationId xmlns:a16="http://schemas.microsoft.com/office/drawing/2014/main" id="{DDCA59A8-282A-47F5-A181-55CC22013066}"/>
               </a:ext>
             </a:extLst>
           </p:cNvPr>
@@ -8772,7 +8920,7 @@
           <p:cNvPr id="2" name="">
             <a:extLst xmlns:a="http://schemas.openxmlformats.org/drawingml/2006/main">
               <a:ext uri="{FF2B5EF4-FFF2-40B4-BE49-F238E27FC236}">
-                <a16:creationId xmlns:a16="http://schemas.microsoft.com/office/drawing/2014/main" id="{7A1A6732-9F67-421A-91FA-A6381BB7F827}"/>
+                <a16:creationId xmlns:a16="http://schemas.microsoft.com/office/drawing/2014/main" id="{36476968-B2D0-4533-AA3F-523F164E5AD7}"/>
               </a:ext>
             </a:extLst>
           </p:cNvPr>
@@ -8803,7 +8951,7 @@
           <p:cNvPr id="3" name="">
             <a:extLst xmlns:a="http://schemas.openxmlformats.org/drawingml/2006/main">
               <a:ext uri="{FF2B5EF4-FFF2-40B4-BE49-F238E27FC236}">
-                <a16:creationId xmlns:a16="http://schemas.microsoft.com/office/drawing/2014/main" id="{B5FE2525-8F5C-4EA2-A1C4-9228A81FFFEA}"/>
+                <a16:creationId xmlns:a16="http://schemas.microsoft.com/office/drawing/2014/main" id="{B2CFF7B9-1B8E-4CC6-AFC9-81CE44ADD01E}"/>
               </a:ext>
             </a:extLst>
           </p:cNvPr>
@@ -8853,7 +9001,7 @@
           <p:cNvPr id="4" name="">
             <a:extLst xmlns:a="http://schemas.openxmlformats.org/drawingml/2006/main">
               <a:ext uri="{FF2B5EF4-FFF2-40B4-BE49-F238E27FC236}">
-                <a16:creationId xmlns:a16="http://schemas.microsoft.com/office/drawing/2014/main" id="{707FEBE9-72C8-4CBF-AAE6-36EC09BA6299}"/>
+                <a16:creationId xmlns:a16="http://schemas.microsoft.com/office/drawing/2014/main" id="{8EAE17DC-B845-478E-BCBE-FCCCF12CD041}"/>
               </a:ext>
             </a:extLst>
           </p:cNvPr>
@@ -8907,7 +9055,7 @@
           <p:nvPr/>
         </p:nvPicPr>
         <p:blipFill>
-          <a:blip xmlns:r="http://schemas.openxmlformats.org/officeDocument/2006/relationships" xmlns:a="http://schemas.openxmlformats.org/drawingml/2006/main" r:embed="Rede35b005db94a9a"/>
+          <a:blip xmlns:r="http://schemas.openxmlformats.org/officeDocument/2006/relationships" xmlns:a="http://schemas.openxmlformats.org/drawingml/2006/main" r:embed="Rfa257262d7444daf"/>
           <a:stretch xmlns:a="http://schemas.openxmlformats.org/drawingml/2006/main"/>
         </p:blipFill>
         <p:spPr>
@@ -8925,7 +9073,7 @@
           <p:cNvPr id="6" name="">
             <a:extLst xmlns:a="http://schemas.openxmlformats.org/drawingml/2006/main">
               <a:ext uri="{FF2B5EF4-FFF2-40B4-BE49-F238E27FC236}">
-                <a16:creationId xmlns:a16="http://schemas.microsoft.com/office/drawing/2014/main" id="{0EAA165B-5554-416C-97EB-3BAB0C83804B}"/>
+                <a16:creationId xmlns:a16="http://schemas.microsoft.com/office/drawing/2014/main" id="{8CB78072-7C89-4EEF-8183-8B250745FA19}"/>
               </a:ext>
             </a:extLst>
           </p:cNvPr>
@@ -8975,7 +9123,7 @@
           <p:cNvPr id="7" name="">
             <a:extLst xmlns:a="http://schemas.openxmlformats.org/drawingml/2006/main">
               <a:ext uri="{FF2B5EF4-FFF2-40B4-BE49-F238E27FC236}">
-                <a16:creationId xmlns:a16="http://schemas.microsoft.com/office/drawing/2014/main" id="{0AD8F1CC-D8CA-41C7-90C8-B18F7E6D3B6E}"/>
+                <a16:creationId xmlns:a16="http://schemas.microsoft.com/office/drawing/2014/main" id="{81AF96F6-0662-4DF5-9231-21CD1AFB1754}"/>
               </a:ext>
             </a:extLst>
           </p:cNvPr>
@@ -9006,7 +9154,7 @@
           <p:cNvPr id="8" name="">
             <a:extLst xmlns:a="http://schemas.openxmlformats.org/drawingml/2006/main">
               <a:ext uri="{FF2B5EF4-FFF2-40B4-BE49-F238E27FC236}">
-                <a16:creationId xmlns:a16="http://schemas.microsoft.com/office/drawing/2014/main" id="{54B58690-D8C1-4547-9886-41B588F53C09}"/>
+                <a16:creationId xmlns:a16="http://schemas.microsoft.com/office/drawing/2014/main" id="{0EE72B89-A325-447A-B580-272AE839A8E3}"/>
               </a:ext>
             </a:extLst>
           </p:cNvPr>
@@ -9056,7 +9204,7 @@
           <p:cNvPr id="9" name="">
             <a:extLst xmlns:a="http://schemas.openxmlformats.org/drawingml/2006/main">
               <a:ext uri="{FF2B5EF4-FFF2-40B4-BE49-F238E27FC236}">
-                <a16:creationId xmlns:a16="http://schemas.microsoft.com/office/drawing/2014/main" id="{1A129DDD-3A47-424A-9328-CAEEB08F0EBA}"/>
+                <a16:creationId xmlns:a16="http://schemas.microsoft.com/office/drawing/2014/main" id="{212DF97C-BA35-47F2-A5F6-52331F8987C8}"/>
               </a:ext>
             </a:extLst>
           </p:cNvPr>
@@ -9087,7 +9235,7 @@
           <p:cNvPr id="10" name="">
             <a:extLst xmlns:a="http://schemas.openxmlformats.org/drawingml/2006/main">
               <a:ext uri="{FF2B5EF4-FFF2-40B4-BE49-F238E27FC236}">
-                <a16:creationId xmlns:a16="http://schemas.microsoft.com/office/drawing/2014/main" id="{604457E1-3D14-4B82-BC50-6D865B1A2FC1}"/>
+                <a16:creationId xmlns:a16="http://schemas.microsoft.com/office/drawing/2014/main" id="{EF78F19E-B71C-4996-AEAA-A95598535202}"/>
               </a:ext>
             </a:extLst>
           </p:cNvPr>
@@ -9137,7 +9285,7 @@
           <p:cNvPr id="11" name="">
             <a:extLst xmlns:a="http://schemas.openxmlformats.org/drawingml/2006/main">
               <a:ext uri="{FF2B5EF4-FFF2-40B4-BE49-F238E27FC236}">
-                <a16:creationId xmlns:a16="http://schemas.microsoft.com/office/drawing/2014/main" id="{BA9D56CF-14EA-4C55-ADD8-D942646294B9}"/>
+                <a16:creationId xmlns:a16="http://schemas.microsoft.com/office/drawing/2014/main" id="{015197B7-87F4-4F13-847F-2E164388FDC2}"/>
               </a:ext>
             </a:extLst>
           </p:cNvPr>
@@ -9168,7 +9316,7 @@
           <p:cNvPr id="12" name="">
             <a:extLst xmlns:a="http://schemas.openxmlformats.org/drawingml/2006/main">
               <a:ext uri="{FF2B5EF4-FFF2-40B4-BE49-F238E27FC236}">
-                <a16:creationId xmlns:a16="http://schemas.microsoft.com/office/drawing/2014/main" id="{3342A207-64BD-4C54-8495-AEC0E2A42AE9}"/>
+                <a16:creationId xmlns:a16="http://schemas.microsoft.com/office/drawing/2014/main" id="{BC47FE60-29CA-45E5-93C6-F946C185089A}"/>
               </a:ext>
             </a:extLst>
           </p:cNvPr>
@@ -9218,7 +9366,7 @@
           <p:cNvPr id="13" name="">
             <a:extLst xmlns:a="http://schemas.openxmlformats.org/drawingml/2006/main">
               <a:ext uri="{FF2B5EF4-FFF2-40B4-BE49-F238E27FC236}">
-                <a16:creationId xmlns:a16="http://schemas.microsoft.com/office/drawing/2014/main" id="{734655A3-A30C-485B-A27E-B13CFE3BF802}"/>
+                <a16:creationId xmlns:a16="http://schemas.microsoft.com/office/drawing/2014/main" id="{35ECF09D-8DE2-4BAE-90F2-2366FAA7B934}"/>
               </a:ext>
             </a:extLst>
           </p:cNvPr>
@@ -9230,7 +9378,7 @@
         <p:spPr>
           <a:xfrm xmlns:a="http://schemas.openxmlformats.org/drawingml/2006/main">
             <a:off x="685800" y="6419850"/>
-            <a:ext cx="4000500" cy="171450"/>
+            <a:ext cx="3048000" cy="171450"/>
           </a:xfrm>
           <a:prstGeom xmlns:a="http://schemas.openxmlformats.org/drawingml/2006/main" prst="rect">
             <a:avLst/>
@@ -9258,7 +9406,7 @@
                   <a:srgbClr val="9A948B"/>
                 </a:solidFill>
               </a:rPr>
-              <a:t>Species distribution modelling for dengue vector mapping</a:t>
+              <a:t>Species distribution modelling workshop</a:t>
             </a:r>
           </a:p>
         </p:txBody>
@@ -9266,7 +9414,7 @@
     </p:spTree>
     <p:extLst>
       <p:ext uri="{BB962C8B-B14F-4D97-AF65-F5344CB8AC3E}">
-        <p14:creationId xmlns:p14="http://schemas.microsoft.com/office/powerpoint/2010/main" val="2062169384"/>
+        <p14:creationId xmlns:p14="http://schemas.microsoft.com/office/powerpoint/2010/main" val="939811114"/>
       </p:ext>
     </p:extLst>
   </p:cSld>

</xml_diff>

<commit_message>
Correct intro slide deck brand colours
</commit_message>
<xml_diff>
--- a/slides/intro_sdm_dengue_brazil.pptx
+++ b/slides/intro_sdm_dengue_brazil.pptx
@@ -2,24 +2,24 @@
 <file path=ppt/presentation.xml><?xml version="1.0" encoding="utf-8"?>
 <p:presentation xmlns:p="http://schemas.openxmlformats.org/presentationml/2006/main">
   <p:sldMasterIdLst>
-    <p:sldMasterId xmlns:r="http://schemas.openxmlformats.org/officeDocument/2006/relationships" id="2147483648" r:id="Re7dee899282a43e2"/>
+    <p:sldMasterId xmlns:r="http://schemas.openxmlformats.org/officeDocument/2006/relationships" id="2147483648" r:id="R51a0efb64ea94e8d"/>
   </p:sldMasterIdLst>
   <p:notesMasterIdLst>
-    <p:notesMasterId xmlns:r="http://schemas.openxmlformats.org/officeDocument/2006/relationships" r:id="R820f09f5aac84743"/>
+    <p:notesMasterId xmlns:r="http://schemas.openxmlformats.org/officeDocument/2006/relationships" r:id="R77a609535c554662"/>
   </p:notesMasterIdLst>
   <p:sldIdLst>
-    <p:sldId xmlns:r="http://schemas.openxmlformats.org/officeDocument/2006/relationships" id="256" r:id="Rdbefc72ce9ca4def"/>
-    <p:sldId xmlns:r="http://schemas.openxmlformats.org/officeDocument/2006/relationships" id="257" r:id="Rebc45a5cb06d4d4f"/>
-    <p:sldId xmlns:r="http://schemas.openxmlformats.org/officeDocument/2006/relationships" id="258" r:id="Re04c32ecd00a4663"/>
-    <p:sldId xmlns:r="http://schemas.openxmlformats.org/officeDocument/2006/relationships" id="259" r:id="Rc279fcdbab604fa7"/>
-    <p:sldId xmlns:r="http://schemas.openxmlformats.org/officeDocument/2006/relationships" id="260" r:id="Ra212aceddb2045cd"/>
-    <p:sldId xmlns:r="http://schemas.openxmlformats.org/officeDocument/2006/relationships" id="261" r:id="R1ade9f994d84412c"/>
-    <p:sldId xmlns:r="http://schemas.openxmlformats.org/officeDocument/2006/relationships" id="262" r:id="R6bc5d1938db2420c"/>
-    <p:sldId xmlns:r="http://schemas.openxmlformats.org/officeDocument/2006/relationships" id="263" r:id="R1d9c4c2b9d4c49af"/>
-    <p:sldId xmlns:r="http://schemas.openxmlformats.org/officeDocument/2006/relationships" id="264" r:id="R4b805b5db7474246"/>
-    <p:sldId xmlns:r="http://schemas.openxmlformats.org/officeDocument/2006/relationships" id="265" r:id="R0ecd829432be4e6b"/>
-    <p:sldId xmlns:r="http://schemas.openxmlformats.org/officeDocument/2006/relationships" id="266" r:id="R132fd2def518499d"/>
-    <p:sldId xmlns:r="http://schemas.openxmlformats.org/officeDocument/2006/relationships" id="267" r:id="R8af50ac7de2f4685"/>
+    <p:sldId xmlns:r="http://schemas.openxmlformats.org/officeDocument/2006/relationships" id="256" r:id="R3f62dcfe0c6647b3"/>
+    <p:sldId xmlns:r="http://schemas.openxmlformats.org/officeDocument/2006/relationships" id="257" r:id="R94290649a728487a"/>
+    <p:sldId xmlns:r="http://schemas.openxmlformats.org/officeDocument/2006/relationships" id="258" r:id="R7d474fd6ce2e4ef8"/>
+    <p:sldId xmlns:r="http://schemas.openxmlformats.org/officeDocument/2006/relationships" id="259" r:id="Rea0714d415954156"/>
+    <p:sldId xmlns:r="http://schemas.openxmlformats.org/officeDocument/2006/relationships" id="260" r:id="Rd4c1fe32e52c4965"/>
+    <p:sldId xmlns:r="http://schemas.openxmlformats.org/officeDocument/2006/relationships" id="261" r:id="R0d8fb9a7ecee44eb"/>
+    <p:sldId xmlns:r="http://schemas.openxmlformats.org/officeDocument/2006/relationships" id="262" r:id="Ra67f8d5dc89f4674"/>
+    <p:sldId xmlns:r="http://schemas.openxmlformats.org/officeDocument/2006/relationships" id="263" r:id="R2beed40e0801450f"/>
+    <p:sldId xmlns:r="http://schemas.openxmlformats.org/officeDocument/2006/relationships" id="264" r:id="R5f58fb6ec90040cd"/>
+    <p:sldId xmlns:r="http://schemas.openxmlformats.org/officeDocument/2006/relationships" id="265" r:id="Rb9b030994ded494c"/>
+    <p:sldId xmlns:r="http://schemas.openxmlformats.org/officeDocument/2006/relationships" id="266" r:id="R28a363dbcb13487b"/>
+    <p:sldId xmlns:r="http://schemas.openxmlformats.org/officeDocument/2006/relationships" id="267" r:id="Rddd3d53c84874080"/>
   </p:sldIdLst>
   <p:sldSz cx="12192000" cy="6858000"/>
   <p:notesSz cx="6858000" cy="9144000"/>
@@ -185,13 +185,13 @@
         <a:srgbClr val="FFFFFF"/>
       </a:lt2>
       <a:accent1>
-        <a:srgbClr val="18A303"/>
+        <a:srgbClr val="6B173D"/>
       </a:accent1>
       <a:accent2>
-        <a:srgbClr val="0369A3"/>
+        <a:srgbClr val="B79961"/>
       </a:accent2>
       <a:accent3>
-        <a:srgbClr val="A33E03"/>
+        <a:srgbClr val="B79961"/>
       </a:accent3>
       <a:accent4>
         <a:srgbClr val="8E03A3"/>
@@ -1201,7 +1201,7 @@
           <p:cNvPr id="2" name="White.Strip.Footer">
             <a:extLst xmlns:a="http://schemas.openxmlformats.org/drawingml/2006/main">
               <a:ext uri="{FF2B5EF4-FFF2-40B4-BE49-F238E27FC236}">
-                <a16:creationId xmlns:a16="http://schemas.microsoft.com/office/drawing/2014/main" id="{3755FCEB-C41F-404F-83B9-7E4D470BCCBD}"/>
+                <a16:creationId xmlns:a16="http://schemas.microsoft.com/office/drawing/2014/main" id="{1487F42E-9B2A-4812-A61F-45EE83AF70A1}"/>
               </a:ext>
             </a:extLst>
           </p:cNvPr>
@@ -1265,7 +1265,7 @@
           <p:cNvPr id="3" name="Footer">
             <a:extLst xmlns:a="http://schemas.openxmlformats.org/drawingml/2006/main">
               <a:ext uri="{FF2B5EF4-FFF2-40B4-BE49-F238E27FC236}">
-                <a16:creationId xmlns:a16="http://schemas.microsoft.com/office/drawing/2014/main" id="{CFCCB36C-023F-46DB-BF1F-0D264C661A8A}"/>
+                <a16:creationId xmlns:a16="http://schemas.microsoft.com/office/drawing/2014/main" id="{5700117A-F259-4147-9EC5-04F323822D71}"/>
               </a:ext>
             </a:extLst>
           </p:cNvPr>
@@ -1346,7 +1346,7 @@
           <p:cNvPr id="5" name="PlaceHolder 1">
             <a:extLst xmlns:a="http://schemas.openxmlformats.org/drawingml/2006/main">
               <a:ext uri="{FF2B5EF4-FFF2-40B4-BE49-F238E27FC236}">
-                <a16:creationId xmlns:a16="http://schemas.microsoft.com/office/drawing/2014/main" id="{2491AA08-DB95-4612-88D8-CBB6DF6A872B}"/>
+                <a16:creationId xmlns:a16="http://schemas.microsoft.com/office/drawing/2014/main" id="{E53AD9A6-0DFB-48B4-A975-BD31168AD8BB}"/>
               </a:ext>
             </a:extLst>
           </p:cNvPr>
@@ -1628,7 +1628,7 @@
           <p:cNvPr id="6" name="White.Banner.Top">
             <a:extLst xmlns:a="http://schemas.openxmlformats.org/drawingml/2006/main">
               <a:ext uri="{FF2B5EF4-FFF2-40B4-BE49-F238E27FC236}">
-                <a16:creationId xmlns:a16="http://schemas.microsoft.com/office/drawing/2014/main" id="{AE81BD26-446A-45C1-891D-3D1130AA61C0}"/>
+                <a16:creationId xmlns:a16="http://schemas.microsoft.com/office/drawing/2014/main" id="{FA4DE99C-38CE-4C6F-B9F7-75EBE70B51FE}"/>
               </a:ext>
             </a:extLst>
           </p:cNvPr>
@@ -1692,7 +1692,7 @@
           <p:cNvPr id="7" name="PlaceHolder 2">
             <a:extLst xmlns:a="http://schemas.openxmlformats.org/drawingml/2006/main">
               <a:ext uri="{FF2B5EF4-FFF2-40B4-BE49-F238E27FC236}">
-                <a16:creationId xmlns:a16="http://schemas.microsoft.com/office/drawing/2014/main" id="{D8C7E402-76A0-48FA-9A60-EFC409F09D67}"/>
+                <a16:creationId xmlns:a16="http://schemas.microsoft.com/office/drawing/2014/main" id="{81A226EB-FCA3-4417-BCE3-3D21FD1FD310}"/>
               </a:ext>
             </a:extLst>
           </p:cNvPr>
@@ -1787,7 +1787,7 @@
           <p:cNvPr id="9" name="Rectangle 17">
             <a:extLst xmlns:a="http://schemas.openxmlformats.org/drawingml/2006/main">
               <a:ext uri="{FF2B5EF4-FFF2-40B4-BE49-F238E27FC236}">
-                <a16:creationId xmlns:a16="http://schemas.microsoft.com/office/drawing/2014/main" id="{F92B5602-0BD0-4C71-AC76-BE0E616C7D3C}"/>
+                <a16:creationId xmlns:a16="http://schemas.microsoft.com/office/drawing/2014/main" id="{7460413E-0920-42D2-9900-996FE88A3F35}"/>
               </a:ext>
             </a:extLst>
           </p:cNvPr>
@@ -1854,7 +1854,7 @@
           <p:cNvPr id="10" name="Rectangle 18">
             <a:extLst xmlns:a="http://schemas.openxmlformats.org/drawingml/2006/main">
               <a:ext uri="{FF2B5EF4-FFF2-40B4-BE49-F238E27FC236}">
-                <a16:creationId xmlns:a16="http://schemas.microsoft.com/office/drawing/2014/main" id="{2BF8E8D0-624F-4A41-A18F-4FE9132EDE0D}"/>
+                <a16:creationId xmlns:a16="http://schemas.microsoft.com/office/drawing/2014/main" id="{6AB5A71E-0343-462B-9A7A-B822EDC09172}"/>
               </a:ext>
             </a:extLst>
           </p:cNvPr>
@@ -1948,7 +1948,7 @@
           <p:cNvPr id="12" name="Rectangle 22">
             <a:extLst xmlns:a="http://schemas.openxmlformats.org/drawingml/2006/main">
               <a:ext uri="{FF2B5EF4-FFF2-40B4-BE49-F238E27FC236}">
-                <a16:creationId xmlns:a16="http://schemas.microsoft.com/office/drawing/2014/main" id="{0D99D3C3-F215-40D4-BA1F-A616F4500AF1}"/>
+                <a16:creationId xmlns:a16="http://schemas.microsoft.com/office/drawing/2014/main" id="{326284A9-015E-4141-9F4A-98A408ABC90F}"/>
               </a:ext>
             </a:extLst>
           </p:cNvPr>
@@ -2046,7 +2046,7 @@
           <p:nvPr/>
         </p:nvPicPr>
         <p:blipFill>
-          <a:blip xmlns:r="http://schemas.openxmlformats.org/officeDocument/2006/relationships" xmlns:a="http://schemas.openxmlformats.org/drawingml/2006/main" r:embed="R34f1d877f55547bb"/>
+          <a:blip xmlns:r="http://schemas.openxmlformats.org/officeDocument/2006/relationships" xmlns:a="http://schemas.openxmlformats.org/drawingml/2006/main" r:embed="Raed33602ca6346f0"/>
           <a:stretch xmlns:a="http://schemas.openxmlformats.org/drawingml/2006/main"/>
         </p:blipFill>
         <p:spPr>
@@ -2091,7 +2091,7 @@
           <p:cNvPr id="107" name="White.Strip.Footer">
             <a:extLst xmlns:a="http://schemas.openxmlformats.org/drawingml/2006/main">
               <a:ext uri="{FF2B5EF4-FFF2-40B4-BE49-F238E27FC236}">
-                <a16:creationId xmlns:a16="http://schemas.microsoft.com/office/drawing/2014/main" id="{12368AC1-AA34-4708-AAF0-FC6C555487F1}"/>
+                <a16:creationId xmlns:a16="http://schemas.microsoft.com/office/drawing/2014/main" id="{36642C06-955A-4A56-B084-FAA553AA0F14}"/>
               </a:ext>
             </a:extLst>
           </p:cNvPr>
@@ -2155,7 +2155,7 @@
           <p:cNvPr id="108" name="Footer">
             <a:extLst xmlns:a="http://schemas.openxmlformats.org/drawingml/2006/main">
               <a:ext uri="{FF2B5EF4-FFF2-40B4-BE49-F238E27FC236}">
-                <a16:creationId xmlns:a16="http://schemas.microsoft.com/office/drawing/2014/main" id="{098D753B-70B1-4199-A55B-24DB89089952}"/>
+                <a16:creationId xmlns:a16="http://schemas.microsoft.com/office/drawing/2014/main" id="{0C5BCCFB-D1C7-4C2A-8372-722F6EDD0F60}"/>
               </a:ext>
             </a:extLst>
           </p:cNvPr>
@@ -2236,7 +2236,7 @@
           <p:cNvPr id="110" name="White.Banner.Top">
             <a:extLst xmlns:a="http://schemas.openxmlformats.org/drawingml/2006/main">
               <a:ext uri="{FF2B5EF4-FFF2-40B4-BE49-F238E27FC236}">
-                <a16:creationId xmlns:a16="http://schemas.microsoft.com/office/drawing/2014/main" id="{40C42198-A4CF-4919-918C-8C99D7D30974}"/>
+                <a16:creationId xmlns:a16="http://schemas.microsoft.com/office/drawing/2014/main" id="{53BF555E-84F3-4D9C-A4B2-D7A362B746E0}"/>
               </a:ext>
             </a:extLst>
           </p:cNvPr>
@@ -2325,7 +2325,7 @@
           <p:cNvPr id="112" name="Rectangle 17">
             <a:extLst xmlns:a="http://schemas.openxmlformats.org/drawingml/2006/main">
               <a:ext uri="{FF2B5EF4-FFF2-40B4-BE49-F238E27FC236}">
-                <a16:creationId xmlns:a16="http://schemas.microsoft.com/office/drawing/2014/main" id="{7E43EDB2-5476-412F-A030-61D025618D18}"/>
+                <a16:creationId xmlns:a16="http://schemas.microsoft.com/office/drawing/2014/main" id="{A29D6526-562D-4167-B90C-C3710380B247}"/>
               </a:ext>
             </a:extLst>
           </p:cNvPr>
@@ -2392,7 +2392,7 @@
           <p:cNvPr id="113" name="Rectangle 18">
             <a:extLst xmlns:a="http://schemas.openxmlformats.org/drawingml/2006/main">
               <a:ext uri="{FF2B5EF4-FFF2-40B4-BE49-F238E27FC236}">
-                <a16:creationId xmlns:a16="http://schemas.microsoft.com/office/drawing/2014/main" id="{669BE814-0271-4DB1-9952-BA6AA64239A5}"/>
+                <a16:creationId xmlns:a16="http://schemas.microsoft.com/office/drawing/2014/main" id="{A802838C-68BD-4C84-9D24-9040ADC83453}"/>
               </a:ext>
             </a:extLst>
           </p:cNvPr>
@@ -2486,7 +2486,7 @@
           <p:cNvPr id="115" name="Rectangle 22">
             <a:extLst xmlns:a="http://schemas.openxmlformats.org/drawingml/2006/main">
               <a:ext uri="{FF2B5EF4-FFF2-40B4-BE49-F238E27FC236}">
-                <a16:creationId xmlns:a16="http://schemas.microsoft.com/office/drawing/2014/main" id="{DAB79844-5A1E-42E5-9FA1-109795E44353}"/>
+                <a16:creationId xmlns:a16="http://schemas.microsoft.com/office/drawing/2014/main" id="{45CB47C8-29D8-463A-8738-14F9A2773A3B}"/>
               </a:ext>
             </a:extLst>
           </p:cNvPr>
@@ -2584,7 +2584,7 @@
           <p:nvPr/>
         </p:nvPicPr>
         <p:blipFill>
-          <a:blip xmlns:r="http://schemas.openxmlformats.org/officeDocument/2006/relationships" xmlns:a="http://schemas.openxmlformats.org/drawingml/2006/main" r:embed="R40b452b1ef7740ca"/>
+          <a:blip xmlns:r="http://schemas.openxmlformats.org/officeDocument/2006/relationships" xmlns:a="http://schemas.openxmlformats.org/drawingml/2006/main" r:embed="Ra70ad7b77d5242d7"/>
           <a:stretch xmlns:a="http://schemas.openxmlformats.org/drawingml/2006/main"/>
         </p:blipFill>
         <p:spPr>
@@ -2629,7 +2629,7 @@
           <p:cNvPr id="118" name="White.Strip.Footer">
             <a:extLst xmlns:a="http://schemas.openxmlformats.org/drawingml/2006/main">
               <a:ext uri="{FF2B5EF4-FFF2-40B4-BE49-F238E27FC236}">
-                <a16:creationId xmlns:a16="http://schemas.microsoft.com/office/drawing/2014/main" id="{3920BB29-1D63-4F41-8EF5-3A1B0FE903A6}"/>
+                <a16:creationId xmlns:a16="http://schemas.microsoft.com/office/drawing/2014/main" id="{F6D60F58-9C25-4F23-954C-B9A0B2D5BDE9}"/>
               </a:ext>
             </a:extLst>
           </p:cNvPr>
@@ -2693,7 +2693,7 @@
           <p:cNvPr id="119" name="Footer">
             <a:extLst xmlns:a="http://schemas.openxmlformats.org/drawingml/2006/main">
               <a:ext uri="{FF2B5EF4-FFF2-40B4-BE49-F238E27FC236}">
-                <a16:creationId xmlns:a16="http://schemas.microsoft.com/office/drawing/2014/main" id="{A1AAAC34-7B3A-4A49-922A-202906F838D4}"/>
+                <a16:creationId xmlns:a16="http://schemas.microsoft.com/office/drawing/2014/main" id="{198171A9-4357-4CBB-A6BB-7A87858BF24C}"/>
               </a:ext>
             </a:extLst>
           </p:cNvPr>
@@ -2774,7 +2774,7 @@
           <p:cNvPr id="121" name="White.Banner.Top">
             <a:extLst xmlns:a="http://schemas.openxmlformats.org/drawingml/2006/main">
               <a:ext uri="{FF2B5EF4-FFF2-40B4-BE49-F238E27FC236}">
-                <a16:creationId xmlns:a16="http://schemas.microsoft.com/office/drawing/2014/main" id="{EC98B3F4-8D69-4EFE-A4BF-90CD3D260FEF}"/>
+                <a16:creationId xmlns:a16="http://schemas.microsoft.com/office/drawing/2014/main" id="{89254749-78DB-42E0-9BD0-8B5DCCA6D669}"/>
               </a:ext>
             </a:extLst>
           </p:cNvPr>
@@ -2863,7 +2863,7 @@
           <p:cNvPr id="123" name="Rectangle 17">
             <a:extLst xmlns:a="http://schemas.openxmlformats.org/drawingml/2006/main">
               <a:ext uri="{FF2B5EF4-FFF2-40B4-BE49-F238E27FC236}">
-                <a16:creationId xmlns:a16="http://schemas.microsoft.com/office/drawing/2014/main" id="{29F4E474-08BD-4894-A13C-373F2ABCB0DF}"/>
+                <a16:creationId xmlns:a16="http://schemas.microsoft.com/office/drawing/2014/main" id="{99CDCAF4-E6C4-4FF9-99C6-9D81846DDFFF}"/>
               </a:ext>
             </a:extLst>
           </p:cNvPr>
@@ -2930,7 +2930,7 @@
           <p:cNvPr id="124" name="Rectangle 18">
             <a:extLst xmlns:a="http://schemas.openxmlformats.org/drawingml/2006/main">
               <a:ext uri="{FF2B5EF4-FFF2-40B4-BE49-F238E27FC236}">
-                <a16:creationId xmlns:a16="http://schemas.microsoft.com/office/drawing/2014/main" id="{EE61A0EC-36F9-429A-8F5E-ADD0A76E9E72}"/>
+                <a16:creationId xmlns:a16="http://schemas.microsoft.com/office/drawing/2014/main" id="{4EA72285-7825-4B72-A10F-9D19FCC7DAC9}"/>
               </a:ext>
             </a:extLst>
           </p:cNvPr>
@@ -3024,7 +3024,7 @@
           <p:cNvPr id="126" name="Rectangle 22">
             <a:extLst xmlns:a="http://schemas.openxmlformats.org/drawingml/2006/main">
               <a:ext uri="{FF2B5EF4-FFF2-40B4-BE49-F238E27FC236}">
-                <a16:creationId xmlns:a16="http://schemas.microsoft.com/office/drawing/2014/main" id="{D37D6E96-3331-4F9B-94A5-4E145174EBDB}"/>
+                <a16:creationId xmlns:a16="http://schemas.microsoft.com/office/drawing/2014/main" id="{18EE0B87-E16A-437A-A693-860322CF3E0B}"/>
               </a:ext>
             </a:extLst>
           </p:cNvPr>
@@ -3122,7 +3122,7 @@
           <p:nvPr/>
         </p:nvPicPr>
         <p:blipFill>
-          <a:blip xmlns:r="http://schemas.openxmlformats.org/officeDocument/2006/relationships" xmlns:a="http://schemas.openxmlformats.org/drawingml/2006/main" r:embed="R22b586d20ee447a1"/>
+          <a:blip xmlns:r="http://schemas.openxmlformats.org/officeDocument/2006/relationships" xmlns:a="http://schemas.openxmlformats.org/drawingml/2006/main" r:embed="R615ae791617e42bf"/>
           <a:stretch xmlns:a="http://schemas.openxmlformats.org/drawingml/2006/main"/>
         </p:blipFill>
         <p:spPr>
@@ -3167,7 +3167,7 @@
           <p:cNvPr id="129" name="White.Strip.Footer">
             <a:extLst xmlns:a="http://schemas.openxmlformats.org/drawingml/2006/main">
               <a:ext uri="{FF2B5EF4-FFF2-40B4-BE49-F238E27FC236}">
-                <a16:creationId xmlns:a16="http://schemas.microsoft.com/office/drawing/2014/main" id="{C1E63EB4-7FC9-487A-80C3-EC15F3E13627}"/>
+                <a16:creationId xmlns:a16="http://schemas.microsoft.com/office/drawing/2014/main" id="{B673E546-0FF1-4EC4-94E9-92C236A5303B}"/>
               </a:ext>
             </a:extLst>
           </p:cNvPr>
@@ -3231,7 +3231,7 @@
           <p:cNvPr id="130" name="Footer">
             <a:extLst xmlns:a="http://schemas.openxmlformats.org/drawingml/2006/main">
               <a:ext uri="{FF2B5EF4-FFF2-40B4-BE49-F238E27FC236}">
-                <a16:creationId xmlns:a16="http://schemas.microsoft.com/office/drawing/2014/main" id="{CF2FBEB4-45CD-42D1-8E55-533F604C50FC}"/>
+                <a16:creationId xmlns:a16="http://schemas.microsoft.com/office/drawing/2014/main" id="{CFC91ED1-C8ED-481D-8FAF-254CEBBC6A07}"/>
               </a:ext>
             </a:extLst>
           </p:cNvPr>
@@ -3312,7 +3312,7 @@
           <p:cNvPr id="132" name="White.Banner.Top">
             <a:extLst xmlns:a="http://schemas.openxmlformats.org/drawingml/2006/main">
               <a:ext uri="{FF2B5EF4-FFF2-40B4-BE49-F238E27FC236}">
-                <a16:creationId xmlns:a16="http://schemas.microsoft.com/office/drawing/2014/main" id="{8888BD89-72E9-410B-B0A6-123CDC6A660B}"/>
+                <a16:creationId xmlns:a16="http://schemas.microsoft.com/office/drawing/2014/main" id="{BA4D9C18-881D-4D90-B817-9704EE42F3C6}"/>
               </a:ext>
             </a:extLst>
           </p:cNvPr>
@@ -3401,7 +3401,7 @@
           <p:cNvPr id="134" name="Rectangle 17">
             <a:extLst xmlns:a="http://schemas.openxmlformats.org/drawingml/2006/main">
               <a:ext uri="{FF2B5EF4-FFF2-40B4-BE49-F238E27FC236}">
-                <a16:creationId xmlns:a16="http://schemas.microsoft.com/office/drawing/2014/main" id="{AA3679C3-F401-449F-953C-9581A2D00D77}"/>
+                <a16:creationId xmlns:a16="http://schemas.microsoft.com/office/drawing/2014/main" id="{3B94B8D5-237A-4E3F-92C3-FBF5269261EE}"/>
               </a:ext>
             </a:extLst>
           </p:cNvPr>
@@ -3468,7 +3468,7 @@
           <p:cNvPr id="135" name="Rectangle 18">
             <a:extLst xmlns:a="http://schemas.openxmlformats.org/drawingml/2006/main">
               <a:ext uri="{FF2B5EF4-FFF2-40B4-BE49-F238E27FC236}">
-                <a16:creationId xmlns:a16="http://schemas.microsoft.com/office/drawing/2014/main" id="{252796A9-A3F9-486A-9AC9-400EB1BE9002}"/>
+                <a16:creationId xmlns:a16="http://schemas.microsoft.com/office/drawing/2014/main" id="{A9369B5C-1715-470A-BE45-87C42EC860C9}"/>
               </a:ext>
             </a:extLst>
           </p:cNvPr>
@@ -3562,7 +3562,7 @@
           <p:cNvPr id="137" name="Rectangle 22">
             <a:extLst xmlns:a="http://schemas.openxmlformats.org/drawingml/2006/main">
               <a:ext uri="{FF2B5EF4-FFF2-40B4-BE49-F238E27FC236}">
-                <a16:creationId xmlns:a16="http://schemas.microsoft.com/office/drawing/2014/main" id="{1E20E027-5310-4E20-9EC5-2E1555DD31D7}"/>
+                <a16:creationId xmlns:a16="http://schemas.microsoft.com/office/drawing/2014/main" id="{7A536D68-9446-4D47-9E50-1F7259B6237F}"/>
               </a:ext>
             </a:extLst>
           </p:cNvPr>
@@ -3660,7 +3660,7 @@
           <p:nvPr/>
         </p:nvPicPr>
         <p:blipFill>
-          <a:blip xmlns:r="http://schemas.openxmlformats.org/officeDocument/2006/relationships" xmlns:a="http://schemas.openxmlformats.org/drawingml/2006/main" r:embed="Re2bd9d927a2f4820"/>
+          <a:blip xmlns:r="http://schemas.openxmlformats.org/officeDocument/2006/relationships" xmlns:a="http://schemas.openxmlformats.org/drawingml/2006/main" r:embed="Ra6aa3c591df74bef"/>
           <a:stretch xmlns:a="http://schemas.openxmlformats.org/drawingml/2006/main"/>
         </p:blipFill>
         <p:spPr>
@@ -3681,7 +3681,7 @@
           <p:cNvPr id="140" name="PlaceHolder 1">
             <a:extLst xmlns:a="http://schemas.openxmlformats.org/drawingml/2006/main">
               <a:ext uri="{FF2B5EF4-FFF2-40B4-BE49-F238E27FC236}">
-                <a16:creationId xmlns:a16="http://schemas.microsoft.com/office/drawing/2014/main" id="{4B4E8825-9B2C-40B2-B48B-64592CF5273C}"/>
+                <a16:creationId xmlns:a16="http://schemas.microsoft.com/office/drawing/2014/main" id="{12E0691C-9191-485B-B35D-DF0B41D96A58}"/>
               </a:ext>
             </a:extLst>
           </p:cNvPr>
@@ -3745,7 +3745,7 @@
           <p:cNvPr id="141" name="PlaceHolder 2">
             <a:extLst xmlns:a="http://schemas.openxmlformats.org/drawingml/2006/main">
               <a:ext uri="{FF2B5EF4-FFF2-40B4-BE49-F238E27FC236}">
-                <a16:creationId xmlns:a16="http://schemas.microsoft.com/office/drawing/2014/main" id="{21405F91-936D-4725-98BA-1FB8FF168F4F}"/>
+                <a16:creationId xmlns:a16="http://schemas.microsoft.com/office/drawing/2014/main" id="{B37F514F-8D7E-4FE4-9807-59FEF27D3D9E}"/>
               </a:ext>
             </a:extLst>
           </p:cNvPr>
@@ -4107,7 +4107,7 @@
           <p:cNvPr id="142" name="White.Strip.Footer">
             <a:extLst xmlns:a="http://schemas.openxmlformats.org/drawingml/2006/main">
               <a:ext uri="{FF2B5EF4-FFF2-40B4-BE49-F238E27FC236}">
-                <a16:creationId xmlns:a16="http://schemas.microsoft.com/office/drawing/2014/main" id="{8C20B556-C290-4B1C-A0F6-4C298CCDF94B}"/>
+                <a16:creationId xmlns:a16="http://schemas.microsoft.com/office/drawing/2014/main" id="{12227972-9AD5-453C-81AB-A44653EE7D3C}"/>
               </a:ext>
             </a:extLst>
           </p:cNvPr>
@@ -4171,7 +4171,7 @@
           <p:cNvPr id="143" name="Footer">
             <a:extLst xmlns:a="http://schemas.openxmlformats.org/drawingml/2006/main">
               <a:ext uri="{FF2B5EF4-FFF2-40B4-BE49-F238E27FC236}">
-                <a16:creationId xmlns:a16="http://schemas.microsoft.com/office/drawing/2014/main" id="{56EB257A-7C2A-4411-907A-7162F703D709}"/>
+                <a16:creationId xmlns:a16="http://schemas.microsoft.com/office/drawing/2014/main" id="{E95AE918-E9BA-4CFC-BFF2-28BE64AF77B8}"/>
               </a:ext>
             </a:extLst>
           </p:cNvPr>
@@ -4252,7 +4252,7 @@
           <p:cNvPr id="145" name="White.Banner.Top">
             <a:extLst xmlns:a="http://schemas.openxmlformats.org/drawingml/2006/main">
               <a:ext uri="{FF2B5EF4-FFF2-40B4-BE49-F238E27FC236}">
-                <a16:creationId xmlns:a16="http://schemas.microsoft.com/office/drawing/2014/main" id="{18F36B82-B93A-401A-AB68-AA8AC742EBDB}"/>
+                <a16:creationId xmlns:a16="http://schemas.microsoft.com/office/drawing/2014/main" id="{06148970-7E12-45BA-BF9D-9821CEC23837}"/>
               </a:ext>
             </a:extLst>
           </p:cNvPr>
@@ -4341,7 +4341,7 @@
           <p:cNvPr id="147" name="Rectangle 17">
             <a:extLst xmlns:a="http://schemas.openxmlformats.org/drawingml/2006/main">
               <a:ext uri="{FF2B5EF4-FFF2-40B4-BE49-F238E27FC236}">
-                <a16:creationId xmlns:a16="http://schemas.microsoft.com/office/drawing/2014/main" id="{77108B39-FD5E-4782-9B34-A18D2273F914}"/>
+                <a16:creationId xmlns:a16="http://schemas.microsoft.com/office/drawing/2014/main" id="{4C997CB6-9D69-477A-A7DF-85F81E1C8D77}"/>
               </a:ext>
             </a:extLst>
           </p:cNvPr>
@@ -4408,7 +4408,7 @@
           <p:cNvPr id="148" name="Rectangle 18">
             <a:extLst xmlns:a="http://schemas.openxmlformats.org/drawingml/2006/main">
               <a:ext uri="{FF2B5EF4-FFF2-40B4-BE49-F238E27FC236}">
-                <a16:creationId xmlns:a16="http://schemas.microsoft.com/office/drawing/2014/main" id="{297F700C-17E0-4C32-8EB6-EA8DE00E4A01}"/>
+                <a16:creationId xmlns:a16="http://schemas.microsoft.com/office/drawing/2014/main" id="{1AE838FA-931A-46E3-82BB-CE462251050A}"/>
               </a:ext>
             </a:extLst>
           </p:cNvPr>
@@ -4502,7 +4502,7 @@
           <p:cNvPr id="150" name="Rectangle 22">
             <a:extLst xmlns:a="http://schemas.openxmlformats.org/drawingml/2006/main">
               <a:ext uri="{FF2B5EF4-FFF2-40B4-BE49-F238E27FC236}">
-                <a16:creationId xmlns:a16="http://schemas.microsoft.com/office/drawing/2014/main" id="{C5B2C4F5-540E-48BD-8DDA-A34A6E5924FB}"/>
+                <a16:creationId xmlns:a16="http://schemas.microsoft.com/office/drawing/2014/main" id="{E28BE8C8-332D-4723-99DC-4C9FBF0E66BF}"/>
               </a:ext>
             </a:extLst>
           </p:cNvPr>
@@ -4600,7 +4600,7 @@
           <p:nvPr/>
         </p:nvPicPr>
         <p:blipFill>
-          <a:blip xmlns:r="http://schemas.openxmlformats.org/officeDocument/2006/relationships" xmlns:a="http://schemas.openxmlformats.org/drawingml/2006/main" r:embed="R07f1554c78e14022"/>
+          <a:blip xmlns:r="http://schemas.openxmlformats.org/officeDocument/2006/relationships" xmlns:a="http://schemas.openxmlformats.org/drawingml/2006/main" r:embed="R5f5012e095294316"/>
           <a:stretch xmlns:a="http://schemas.openxmlformats.org/drawingml/2006/main"/>
         </p:blipFill>
         <p:spPr>
@@ -4621,7 +4621,7 @@
           <p:cNvPr id="153" name="PlaceHolder 1">
             <a:extLst xmlns:a="http://schemas.openxmlformats.org/drawingml/2006/main">
               <a:ext uri="{FF2B5EF4-FFF2-40B4-BE49-F238E27FC236}">
-                <a16:creationId xmlns:a16="http://schemas.microsoft.com/office/drawing/2014/main" id="{597AB599-344E-4DDE-B5D4-7FDB6E710831}"/>
+                <a16:creationId xmlns:a16="http://schemas.microsoft.com/office/drawing/2014/main" id="{72B9DECE-D2E3-486C-8047-60ED2A0F02F7}"/>
               </a:ext>
             </a:extLst>
           </p:cNvPr>
@@ -4685,7 +4685,7 @@
           <p:cNvPr id="154" name="PlaceHolder 2">
             <a:extLst xmlns:a="http://schemas.openxmlformats.org/drawingml/2006/main">
               <a:ext uri="{FF2B5EF4-FFF2-40B4-BE49-F238E27FC236}">
-                <a16:creationId xmlns:a16="http://schemas.microsoft.com/office/drawing/2014/main" id="{4F197A98-9902-4066-AA38-353AE8CE9478}"/>
+                <a16:creationId xmlns:a16="http://schemas.microsoft.com/office/drawing/2014/main" id="{44665D04-054C-4CFA-AF90-4DF96AF126FD}"/>
               </a:ext>
             </a:extLst>
           </p:cNvPr>
@@ -5047,7 +5047,7 @@
           <p:cNvPr id="155" name="White.Strip.Footer">
             <a:extLst xmlns:a="http://schemas.openxmlformats.org/drawingml/2006/main">
               <a:ext uri="{FF2B5EF4-FFF2-40B4-BE49-F238E27FC236}">
-                <a16:creationId xmlns:a16="http://schemas.microsoft.com/office/drawing/2014/main" id="{8015DEE9-DFD3-442E-B975-E4B3905BD11B}"/>
+                <a16:creationId xmlns:a16="http://schemas.microsoft.com/office/drawing/2014/main" id="{43B22C14-E1B2-4E2C-B1A7-FEB837355020}"/>
               </a:ext>
             </a:extLst>
           </p:cNvPr>
@@ -5111,7 +5111,7 @@
           <p:cNvPr id="156" name="Footer">
             <a:extLst xmlns:a="http://schemas.openxmlformats.org/drawingml/2006/main">
               <a:ext uri="{FF2B5EF4-FFF2-40B4-BE49-F238E27FC236}">
-                <a16:creationId xmlns:a16="http://schemas.microsoft.com/office/drawing/2014/main" id="{A20039C5-25BF-42A7-A0B0-750CCF8D2C9D}"/>
+                <a16:creationId xmlns:a16="http://schemas.microsoft.com/office/drawing/2014/main" id="{AE522022-73FA-43FB-8996-4B0A387FB34F}"/>
               </a:ext>
             </a:extLst>
           </p:cNvPr>
@@ -5192,7 +5192,7 @@
           <p:cNvPr id="158" name="White.Banner.Top">
             <a:extLst xmlns:a="http://schemas.openxmlformats.org/drawingml/2006/main">
               <a:ext uri="{FF2B5EF4-FFF2-40B4-BE49-F238E27FC236}">
-                <a16:creationId xmlns:a16="http://schemas.microsoft.com/office/drawing/2014/main" id="{1AE5B86D-97B2-420A-8940-B2F32E38B773}"/>
+                <a16:creationId xmlns:a16="http://schemas.microsoft.com/office/drawing/2014/main" id="{C248CA76-83CC-410F-89CF-D25C3729FA4B}"/>
               </a:ext>
             </a:extLst>
           </p:cNvPr>
@@ -5281,7 +5281,7 @@
           <p:cNvPr id="160" name="Rectangle 17">
             <a:extLst xmlns:a="http://schemas.openxmlformats.org/drawingml/2006/main">
               <a:ext uri="{FF2B5EF4-FFF2-40B4-BE49-F238E27FC236}">
-                <a16:creationId xmlns:a16="http://schemas.microsoft.com/office/drawing/2014/main" id="{0D25A62F-303F-41D0-A6B0-30243C678C17}"/>
+                <a16:creationId xmlns:a16="http://schemas.microsoft.com/office/drawing/2014/main" id="{43738A9C-51F7-4C0A-B2F8-7EF9DF69932D}"/>
               </a:ext>
             </a:extLst>
           </p:cNvPr>
@@ -5348,7 +5348,7 @@
           <p:cNvPr id="161" name="Rectangle 18">
             <a:extLst xmlns:a="http://schemas.openxmlformats.org/drawingml/2006/main">
               <a:ext uri="{FF2B5EF4-FFF2-40B4-BE49-F238E27FC236}">
-                <a16:creationId xmlns:a16="http://schemas.microsoft.com/office/drawing/2014/main" id="{F76F9833-B5F4-477D-95CA-B84D1149AA9C}"/>
+                <a16:creationId xmlns:a16="http://schemas.microsoft.com/office/drawing/2014/main" id="{75BB06AE-8226-4817-8C3E-0FB69F9B18C5}"/>
               </a:ext>
             </a:extLst>
           </p:cNvPr>
@@ -5442,7 +5442,7 @@
           <p:cNvPr id="163" name="Rectangle 22">
             <a:extLst xmlns:a="http://schemas.openxmlformats.org/drawingml/2006/main">
               <a:ext uri="{FF2B5EF4-FFF2-40B4-BE49-F238E27FC236}">
-                <a16:creationId xmlns:a16="http://schemas.microsoft.com/office/drawing/2014/main" id="{E6919305-9965-4FBE-AD57-DC4C34C375E2}"/>
+                <a16:creationId xmlns:a16="http://schemas.microsoft.com/office/drawing/2014/main" id="{54EA73D3-5F61-4142-8B5A-EE737E38683E}"/>
               </a:ext>
             </a:extLst>
           </p:cNvPr>
@@ -5540,7 +5540,7 @@
           <p:nvPr/>
         </p:nvPicPr>
         <p:blipFill>
-          <a:blip xmlns:r="http://schemas.openxmlformats.org/officeDocument/2006/relationships" xmlns:a="http://schemas.openxmlformats.org/drawingml/2006/main" r:embed="Rb960cdfcdfc14ce8"/>
+          <a:blip xmlns:r="http://schemas.openxmlformats.org/officeDocument/2006/relationships" xmlns:a="http://schemas.openxmlformats.org/drawingml/2006/main" r:embed="R0f76fa782d4f46a3"/>
           <a:stretch xmlns:a="http://schemas.openxmlformats.org/drawingml/2006/main"/>
         </p:blipFill>
         <p:spPr>
@@ -5561,7 +5561,7 @@
           <p:cNvPr id="166" name="PlaceHolder 1">
             <a:extLst xmlns:a="http://schemas.openxmlformats.org/drawingml/2006/main">
               <a:ext uri="{FF2B5EF4-FFF2-40B4-BE49-F238E27FC236}">
-                <a16:creationId xmlns:a16="http://schemas.microsoft.com/office/drawing/2014/main" id="{29482BF7-7E55-42D1-9248-6586072EFA7D}"/>
+                <a16:creationId xmlns:a16="http://schemas.microsoft.com/office/drawing/2014/main" id="{2F302557-7C34-4EA3-B5E4-2B84107B2990}"/>
               </a:ext>
             </a:extLst>
           </p:cNvPr>
@@ -5625,7 +5625,7 @@
           <p:cNvPr id="167" name="PlaceHolder 2">
             <a:extLst xmlns:a="http://schemas.openxmlformats.org/drawingml/2006/main">
               <a:ext uri="{FF2B5EF4-FFF2-40B4-BE49-F238E27FC236}">
-                <a16:creationId xmlns:a16="http://schemas.microsoft.com/office/drawing/2014/main" id="{618E8505-071E-4593-A3E6-EDC5CC66346C}"/>
+                <a16:creationId xmlns:a16="http://schemas.microsoft.com/office/drawing/2014/main" id="{EC279A2C-E9F4-4AE8-AA73-CAC7EBE01D5A}"/>
               </a:ext>
             </a:extLst>
           </p:cNvPr>
@@ -5987,7 +5987,7 @@
           <p:cNvPr id="168" name="White.Strip.Footer">
             <a:extLst xmlns:a="http://schemas.openxmlformats.org/drawingml/2006/main">
               <a:ext uri="{FF2B5EF4-FFF2-40B4-BE49-F238E27FC236}">
-                <a16:creationId xmlns:a16="http://schemas.microsoft.com/office/drawing/2014/main" id="{8283C5F0-D490-445A-8FAE-584C6C4845D0}"/>
+                <a16:creationId xmlns:a16="http://schemas.microsoft.com/office/drawing/2014/main" id="{99D0FF27-803D-430C-A5B3-31C6BF224180}"/>
               </a:ext>
             </a:extLst>
           </p:cNvPr>
@@ -6051,7 +6051,7 @@
           <p:cNvPr id="169" name="Footer">
             <a:extLst xmlns:a="http://schemas.openxmlformats.org/drawingml/2006/main">
               <a:ext uri="{FF2B5EF4-FFF2-40B4-BE49-F238E27FC236}">
-                <a16:creationId xmlns:a16="http://schemas.microsoft.com/office/drawing/2014/main" id="{F76395F1-CCCF-48FE-89B1-C5D3C8E780AE}"/>
+                <a16:creationId xmlns:a16="http://schemas.microsoft.com/office/drawing/2014/main" id="{48CAF03D-5A94-4A99-9D34-C1C1E712A651}"/>
               </a:ext>
             </a:extLst>
           </p:cNvPr>
@@ -6132,7 +6132,7 @@
           <p:cNvPr id="171" name="White.Banner.Top">
             <a:extLst xmlns:a="http://schemas.openxmlformats.org/drawingml/2006/main">
               <a:ext uri="{FF2B5EF4-FFF2-40B4-BE49-F238E27FC236}">
-                <a16:creationId xmlns:a16="http://schemas.microsoft.com/office/drawing/2014/main" id="{EE6DC3EE-2318-41F2-88F4-785B4F355E2B}"/>
+                <a16:creationId xmlns:a16="http://schemas.microsoft.com/office/drawing/2014/main" id="{5FF13CEF-D514-4C1C-B1A1-F9764EE8DEB0}"/>
               </a:ext>
             </a:extLst>
           </p:cNvPr>
@@ -6221,7 +6221,7 @@
           <p:cNvPr id="173" name="Rectangle 17">
             <a:extLst xmlns:a="http://schemas.openxmlformats.org/drawingml/2006/main">
               <a:ext uri="{FF2B5EF4-FFF2-40B4-BE49-F238E27FC236}">
-                <a16:creationId xmlns:a16="http://schemas.microsoft.com/office/drawing/2014/main" id="{90D2FEAD-3298-407D-A32D-EC7802B52AF8}"/>
+                <a16:creationId xmlns:a16="http://schemas.microsoft.com/office/drawing/2014/main" id="{7C840BAA-3796-4A06-91E4-6A8E593ECA9A}"/>
               </a:ext>
             </a:extLst>
           </p:cNvPr>
@@ -6288,7 +6288,7 @@
           <p:cNvPr id="174" name="Rectangle 18">
             <a:extLst xmlns:a="http://schemas.openxmlformats.org/drawingml/2006/main">
               <a:ext uri="{FF2B5EF4-FFF2-40B4-BE49-F238E27FC236}">
-                <a16:creationId xmlns:a16="http://schemas.microsoft.com/office/drawing/2014/main" id="{7290A8B8-ED5F-4480-A28E-7E14A04E5C86}"/>
+                <a16:creationId xmlns:a16="http://schemas.microsoft.com/office/drawing/2014/main" id="{FA891FE0-A8ED-4C29-8C0A-4EDC114F2CB3}"/>
               </a:ext>
             </a:extLst>
           </p:cNvPr>
@@ -6382,7 +6382,7 @@
           <p:cNvPr id="176" name="Rectangle 22">
             <a:extLst xmlns:a="http://schemas.openxmlformats.org/drawingml/2006/main">
               <a:ext uri="{FF2B5EF4-FFF2-40B4-BE49-F238E27FC236}">
-                <a16:creationId xmlns:a16="http://schemas.microsoft.com/office/drawing/2014/main" id="{F09206C8-A195-47D5-90D0-68CC5BB8C656}"/>
+                <a16:creationId xmlns:a16="http://schemas.microsoft.com/office/drawing/2014/main" id="{C9EE32CB-6732-4D0C-85E6-AFF42ED21C5E}"/>
               </a:ext>
             </a:extLst>
           </p:cNvPr>
@@ -6480,7 +6480,7 @@
           <p:nvPr/>
         </p:nvPicPr>
         <p:blipFill>
-          <a:blip xmlns:r="http://schemas.openxmlformats.org/officeDocument/2006/relationships" xmlns:a="http://schemas.openxmlformats.org/drawingml/2006/main" r:embed="R6244c5a9afc3417e"/>
+          <a:blip xmlns:r="http://schemas.openxmlformats.org/officeDocument/2006/relationships" xmlns:a="http://schemas.openxmlformats.org/drawingml/2006/main" r:embed="R7d5b9b40c9ad4bee"/>
           <a:stretch xmlns:a="http://schemas.openxmlformats.org/drawingml/2006/main"/>
         </p:blipFill>
         <p:spPr>
@@ -6501,7 +6501,7 @@
           <p:cNvPr id="179" name="PlaceHolder 1">
             <a:extLst xmlns:a="http://schemas.openxmlformats.org/drawingml/2006/main">
               <a:ext uri="{FF2B5EF4-FFF2-40B4-BE49-F238E27FC236}">
-                <a16:creationId xmlns:a16="http://schemas.microsoft.com/office/drawing/2014/main" id="{00369E43-EA55-4E89-9EE3-13CEC083D477}"/>
+                <a16:creationId xmlns:a16="http://schemas.microsoft.com/office/drawing/2014/main" id="{942D1954-43A2-4F91-AD46-B385573B4A1F}"/>
               </a:ext>
             </a:extLst>
           </p:cNvPr>
@@ -6565,7 +6565,7 @@
           <p:cNvPr id="180" name="PlaceHolder 2">
             <a:extLst xmlns:a="http://schemas.openxmlformats.org/drawingml/2006/main">
               <a:ext uri="{FF2B5EF4-FFF2-40B4-BE49-F238E27FC236}">
-                <a16:creationId xmlns:a16="http://schemas.microsoft.com/office/drawing/2014/main" id="{9CED58E7-5FB7-46E5-B167-6713996A6B77}"/>
+                <a16:creationId xmlns:a16="http://schemas.microsoft.com/office/drawing/2014/main" id="{EDD270D1-B24E-4043-A651-7AF48A495F2C}"/>
               </a:ext>
             </a:extLst>
           </p:cNvPr>
@@ -6927,7 +6927,7 @@
           <p:cNvPr id="181" name="White.Strip.Footer">
             <a:extLst xmlns:a="http://schemas.openxmlformats.org/drawingml/2006/main">
               <a:ext uri="{FF2B5EF4-FFF2-40B4-BE49-F238E27FC236}">
-                <a16:creationId xmlns:a16="http://schemas.microsoft.com/office/drawing/2014/main" id="{E48C7656-C23C-435E-A7CF-B2245CD7402C}"/>
+                <a16:creationId xmlns:a16="http://schemas.microsoft.com/office/drawing/2014/main" id="{170E57A2-6B97-42F9-9123-A10666F3A2BD}"/>
               </a:ext>
             </a:extLst>
           </p:cNvPr>
@@ -6991,7 +6991,7 @@
           <p:cNvPr id="182" name="Footer">
             <a:extLst xmlns:a="http://schemas.openxmlformats.org/drawingml/2006/main">
               <a:ext uri="{FF2B5EF4-FFF2-40B4-BE49-F238E27FC236}">
-                <a16:creationId xmlns:a16="http://schemas.microsoft.com/office/drawing/2014/main" id="{53D64F50-E5D3-4E51-8EAD-1243EE6D2D79}"/>
+                <a16:creationId xmlns:a16="http://schemas.microsoft.com/office/drawing/2014/main" id="{930C8B17-33BF-4734-9CB8-EEC3105D9BC8}"/>
               </a:ext>
             </a:extLst>
           </p:cNvPr>
@@ -7072,7 +7072,7 @@
           <p:cNvPr id="184" name="White.Banner.Top">
             <a:extLst xmlns:a="http://schemas.openxmlformats.org/drawingml/2006/main">
               <a:ext uri="{FF2B5EF4-FFF2-40B4-BE49-F238E27FC236}">
-                <a16:creationId xmlns:a16="http://schemas.microsoft.com/office/drawing/2014/main" id="{4F9DF1FA-9F4E-4FA8-8630-9CD2C20B100C}"/>
+                <a16:creationId xmlns:a16="http://schemas.microsoft.com/office/drawing/2014/main" id="{0549D233-871F-47E0-89BD-4E1871BD97A6}"/>
               </a:ext>
             </a:extLst>
           </p:cNvPr>
@@ -7161,7 +7161,7 @@
           <p:cNvPr id="186" name="Rectangle 17">
             <a:extLst xmlns:a="http://schemas.openxmlformats.org/drawingml/2006/main">
               <a:ext uri="{FF2B5EF4-FFF2-40B4-BE49-F238E27FC236}">
-                <a16:creationId xmlns:a16="http://schemas.microsoft.com/office/drawing/2014/main" id="{AA19A3B5-1C64-4034-9012-8F4D2EE691AF}"/>
+                <a16:creationId xmlns:a16="http://schemas.microsoft.com/office/drawing/2014/main" id="{56CFF95A-9265-4EFF-B6F6-94EC206EE319}"/>
               </a:ext>
             </a:extLst>
           </p:cNvPr>
@@ -7228,7 +7228,7 @@
           <p:cNvPr id="187" name="Rectangle 18">
             <a:extLst xmlns:a="http://schemas.openxmlformats.org/drawingml/2006/main">
               <a:ext uri="{FF2B5EF4-FFF2-40B4-BE49-F238E27FC236}">
-                <a16:creationId xmlns:a16="http://schemas.microsoft.com/office/drawing/2014/main" id="{62217DF0-9C08-4CEE-81B5-1C7C3D520A18}"/>
+                <a16:creationId xmlns:a16="http://schemas.microsoft.com/office/drawing/2014/main" id="{6DED4758-5B17-4007-861F-D801E5A3FEA0}"/>
               </a:ext>
             </a:extLst>
           </p:cNvPr>
@@ -7322,7 +7322,7 @@
           <p:cNvPr id="189" name="Rectangle 22">
             <a:extLst xmlns:a="http://schemas.openxmlformats.org/drawingml/2006/main">
               <a:ext uri="{FF2B5EF4-FFF2-40B4-BE49-F238E27FC236}">
-                <a16:creationId xmlns:a16="http://schemas.microsoft.com/office/drawing/2014/main" id="{8830F293-1F60-4B53-83C0-8731F662FA08}"/>
+                <a16:creationId xmlns:a16="http://schemas.microsoft.com/office/drawing/2014/main" id="{D2501EE4-218F-45C1-9716-979D95748DAC}"/>
               </a:ext>
             </a:extLst>
           </p:cNvPr>
@@ -7420,7 +7420,7 @@
           <p:nvPr/>
         </p:nvPicPr>
         <p:blipFill>
-          <a:blip xmlns:r="http://schemas.openxmlformats.org/officeDocument/2006/relationships" xmlns:a="http://schemas.openxmlformats.org/drawingml/2006/main" r:embed="Raee3137a812c4722"/>
+          <a:blip xmlns:r="http://schemas.openxmlformats.org/officeDocument/2006/relationships" xmlns:a="http://schemas.openxmlformats.org/drawingml/2006/main" r:embed="Rb1a734ac035f4d3b"/>
           <a:stretch xmlns:a="http://schemas.openxmlformats.org/drawingml/2006/main"/>
         </p:blipFill>
         <p:spPr>
@@ -7441,7 +7441,7 @@
           <p:cNvPr id="192" name="PlaceHolder 1">
             <a:extLst xmlns:a="http://schemas.openxmlformats.org/drawingml/2006/main">
               <a:ext uri="{FF2B5EF4-FFF2-40B4-BE49-F238E27FC236}">
-                <a16:creationId xmlns:a16="http://schemas.microsoft.com/office/drawing/2014/main" id="{02E81631-AE7D-4AB4-8D2F-6E2E92FAD095}"/>
+                <a16:creationId xmlns:a16="http://schemas.microsoft.com/office/drawing/2014/main" id="{4EA404E1-2491-40F4-973B-5E5D73936F8F}"/>
               </a:ext>
             </a:extLst>
           </p:cNvPr>
@@ -7529,7 +7529,7 @@
           <p:cNvPr id="194" name="White.Strip.Footer">
             <a:extLst xmlns:a="http://schemas.openxmlformats.org/drawingml/2006/main">
               <a:ext uri="{FF2B5EF4-FFF2-40B4-BE49-F238E27FC236}">
-                <a16:creationId xmlns:a16="http://schemas.microsoft.com/office/drawing/2014/main" id="{4071A4CC-C2EB-4A0F-A4B2-77ED149B3978}"/>
+                <a16:creationId xmlns:a16="http://schemas.microsoft.com/office/drawing/2014/main" id="{CF69D4A7-CD68-4211-877F-DA5B7322B513}"/>
               </a:ext>
             </a:extLst>
           </p:cNvPr>
@@ -7593,7 +7593,7 @@
           <p:cNvPr id="195" name="Footer">
             <a:extLst xmlns:a="http://schemas.openxmlformats.org/drawingml/2006/main">
               <a:ext uri="{FF2B5EF4-FFF2-40B4-BE49-F238E27FC236}">
-                <a16:creationId xmlns:a16="http://schemas.microsoft.com/office/drawing/2014/main" id="{0070A04C-B240-422E-B3FF-FF2A67812C17}"/>
+                <a16:creationId xmlns:a16="http://schemas.microsoft.com/office/drawing/2014/main" id="{BF24466D-15BA-4EC8-910C-67A4D2E1EE43}"/>
               </a:ext>
             </a:extLst>
           </p:cNvPr>
@@ -7674,7 +7674,7 @@
           <p:cNvPr id="197" name="White.Banner.Top">
             <a:extLst xmlns:a="http://schemas.openxmlformats.org/drawingml/2006/main">
               <a:ext uri="{FF2B5EF4-FFF2-40B4-BE49-F238E27FC236}">
-                <a16:creationId xmlns:a16="http://schemas.microsoft.com/office/drawing/2014/main" id="{50FE14CF-68A1-4241-A480-0C4A1C7C26B4}"/>
+                <a16:creationId xmlns:a16="http://schemas.microsoft.com/office/drawing/2014/main" id="{D73AD073-8A26-4178-ADCC-E8799EEBEB77}"/>
               </a:ext>
             </a:extLst>
           </p:cNvPr>
@@ -7763,7 +7763,7 @@
           <p:cNvPr id="199" name="Rectangle 17">
             <a:extLst xmlns:a="http://schemas.openxmlformats.org/drawingml/2006/main">
               <a:ext uri="{FF2B5EF4-FFF2-40B4-BE49-F238E27FC236}">
-                <a16:creationId xmlns:a16="http://schemas.microsoft.com/office/drawing/2014/main" id="{1723D358-5B9E-416D-B940-5843FC902FF0}"/>
+                <a16:creationId xmlns:a16="http://schemas.microsoft.com/office/drawing/2014/main" id="{3FCFD5A4-98D1-4934-AD0C-1E7CFB207D0D}"/>
               </a:ext>
             </a:extLst>
           </p:cNvPr>
@@ -7830,7 +7830,7 @@
           <p:cNvPr id="200" name="Rectangle 18">
             <a:extLst xmlns:a="http://schemas.openxmlformats.org/drawingml/2006/main">
               <a:ext uri="{FF2B5EF4-FFF2-40B4-BE49-F238E27FC236}">
-                <a16:creationId xmlns:a16="http://schemas.microsoft.com/office/drawing/2014/main" id="{F88C632F-27E8-4E03-9B40-05C6EFA89A32}"/>
+                <a16:creationId xmlns:a16="http://schemas.microsoft.com/office/drawing/2014/main" id="{6D9CD350-DB48-4DB8-A45E-FBBB3D552DB2}"/>
               </a:ext>
             </a:extLst>
           </p:cNvPr>
@@ -7924,7 +7924,7 @@
           <p:cNvPr id="202" name="Rectangle 22">
             <a:extLst xmlns:a="http://schemas.openxmlformats.org/drawingml/2006/main">
               <a:ext uri="{FF2B5EF4-FFF2-40B4-BE49-F238E27FC236}">
-                <a16:creationId xmlns:a16="http://schemas.microsoft.com/office/drawing/2014/main" id="{47A2BBAD-66A3-4F10-A231-92297FC57A8E}"/>
+                <a16:creationId xmlns:a16="http://schemas.microsoft.com/office/drawing/2014/main" id="{967DD977-4008-41FF-998E-C012BD2BA346}"/>
               </a:ext>
             </a:extLst>
           </p:cNvPr>
@@ -8022,7 +8022,7 @@
           <p:nvPr/>
         </p:nvPicPr>
         <p:blipFill>
-          <a:blip xmlns:r="http://schemas.openxmlformats.org/officeDocument/2006/relationships" xmlns:a="http://schemas.openxmlformats.org/drawingml/2006/main" r:embed="R48b3f2e69a074835"/>
+          <a:blip xmlns:r="http://schemas.openxmlformats.org/officeDocument/2006/relationships" xmlns:a="http://schemas.openxmlformats.org/drawingml/2006/main" r:embed="R1db600435e154778"/>
           <a:stretch xmlns:a="http://schemas.openxmlformats.org/drawingml/2006/main"/>
         </p:blipFill>
         <p:spPr>
@@ -8043,7 +8043,7 @@
           <p:cNvPr id="205" name="PlaceHolder 1">
             <a:extLst xmlns:a="http://schemas.openxmlformats.org/drawingml/2006/main">
               <a:ext uri="{FF2B5EF4-FFF2-40B4-BE49-F238E27FC236}">
-                <a16:creationId xmlns:a16="http://schemas.microsoft.com/office/drawing/2014/main" id="{222855C1-EE44-40E0-B641-139219EABDF3}"/>
+                <a16:creationId xmlns:a16="http://schemas.microsoft.com/office/drawing/2014/main" id="{FBB43943-5F7E-4E06-8968-1F6F4FBA9A8E}"/>
               </a:ext>
             </a:extLst>
           </p:cNvPr>
@@ -8107,7 +8107,7 @@
           <p:cNvPr id="206" name="PlaceHolder 2">
             <a:extLst xmlns:a="http://schemas.openxmlformats.org/drawingml/2006/main">
               <a:ext uri="{FF2B5EF4-FFF2-40B4-BE49-F238E27FC236}">
-                <a16:creationId xmlns:a16="http://schemas.microsoft.com/office/drawing/2014/main" id="{B9D9CB8D-8CFD-4384-8769-5C0CB3CD12A7}"/>
+                <a16:creationId xmlns:a16="http://schemas.microsoft.com/office/drawing/2014/main" id="{46243C4B-6746-425E-9D34-982A037624CE}"/>
               </a:ext>
             </a:extLst>
           </p:cNvPr>
@@ -8469,7 +8469,7 @@
           <p:cNvPr id="207" name="White.Strip.Footer">
             <a:extLst xmlns:a="http://schemas.openxmlformats.org/drawingml/2006/main">
               <a:ext uri="{FF2B5EF4-FFF2-40B4-BE49-F238E27FC236}">
-                <a16:creationId xmlns:a16="http://schemas.microsoft.com/office/drawing/2014/main" id="{1B5BB177-47E3-48DC-B580-8C627CA7DE16}"/>
+                <a16:creationId xmlns:a16="http://schemas.microsoft.com/office/drawing/2014/main" id="{2FA4A0CA-5A5C-44D1-84E4-236664825076}"/>
               </a:ext>
             </a:extLst>
           </p:cNvPr>
@@ -8533,7 +8533,7 @@
           <p:cNvPr id="208" name="Footer">
             <a:extLst xmlns:a="http://schemas.openxmlformats.org/drawingml/2006/main">
               <a:ext uri="{FF2B5EF4-FFF2-40B4-BE49-F238E27FC236}">
-                <a16:creationId xmlns:a16="http://schemas.microsoft.com/office/drawing/2014/main" id="{1F9364F0-3322-4049-9A24-DFD8119201C3}"/>
+                <a16:creationId xmlns:a16="http://schemas.microsoft.com/office/drawing/2014/main" id="{D552DABF-8955-4D43-B7B8-4EC72D5FF696}"/>
               </a:ext>
             </a:extLst>
           </p:cNvPr>
@@ -8614,7 +8614,7 @@
           <p:cNvPr id="210" name="White.Banner.Top">
             <a:extLst xmlns:a="http://schemas.openxmlformats.org/drawingml/2006/main">
               <a:ext uri="{FF2B5EF4-FFF2-40B4-BE49-F238E27FC236}">
-                <a16:creationId xmlns:a16="http://schemas.microsoft.com/office/drawing/2014/main" id="{C63A2FA4-31C5-4F75-9DE8-84D627FC4921}"/>
+                <a16:creationId xmlns:a16="http://schemas.microsoft.com/office/drawing/2014/main" id="{8AE09116-F270-4DB3-A091-2D759D131F22}"/>
               </a:ext>
             </a:extLst>
           </p:cNvPr>
@@ -8703,7 +8703,7 @@
           <p:cNvPr id="212" name="Rectangle 17">
             <a:extLst xmlns:a="http://schemas.openxmlformats.org/drawingml/2006/main">
               <a:ext uri="{FF2B5EF4-FFF2-40B4-BE49-F238E27FC236}">
-                <a16:creationId xmlns:a16="http://schemas.microsoft.com/office/drawing/2014/main" id="{BCB1A03F-8538-4697-9A5F-53A6F4C20B06}"/>
+                <a16:creationId xmlns:a16="http://schemas.microsoft.com/office/drawing/2014/main" id="{366BA5BB-F0AB-4EBA-8838-D3AF44E9C511}"/>
               </a:ext>
             </a:extLst>
           </p:cNvPr>
@@ -8770,7 +8770,7 @@
           <p:cNvPr id="213" name="Rectangle 18">
             <a:extLst xmlns:a="http://schemas.openxmlformats.org/drawingml/2006/main">
               <a:ext uri="{FF2B5EF4-FFF2-40B4-BE49-F238E27FC236}">
-                <a16:creationId xmlns:a16="http://schemas.microsoft.com/office/drawing/2014/main" id="{E3F411DD-B470-4D57-B099-9AFBECD74FA3}"/>
+                <a16:creationId xmlns:a16="http://schemas.microsoft.com/office/drawing/2014/main" id="{71CCF482-96A5-4E4F-9587-9F7F6AF83BA3}"/>
               </a:ext>
             </a:extLst>
           </p:cNvPr>
@@ -8864,7 +8864,7 @@
           <p:cNvPr id="215" name="Rectangle 22">
             <a:extLst xmlns:a="http://schemas.openxmlformats.org/drawingml/2006/main">
               <a:ext uri="{FF2B5EF4-FFF2-40B4-BE49-F238E27FC236}">
-                <a16:creationId xmlns:a16="http://schemas.microsoft.com/office/drawing/2014/main" id="{D5F99D8F-E1B5-4DAA-A773-646F10823E46}"/>
+                <a16:creationId xmlns:a16="http://schemas.microsoft.com/office/drawing/2014/main" id="{2A6ED774-FC25-406A-9B27-C244D6A9EF2F}"/>
               </a:ext>
             </a:extLst>
           </p:cNvPr>
@@ -8962,7 +8962,7 @@
           <p:nvPr/>
         </p:nvPicPr>
         <p:blipFill>
-          <a:blip xmlns:r="http://schemas.openxmlformats.org/officeDocument/2006/relationships" xmlns:a="http://schemas.openxmlformats.org/drawingml/2006/main" r:embed="Rbd569d6017ac4a1c"/>
+          <a:blip xmlns:r="http://schemas.openxmlformats.org/officeDocument/2006/relationships" xmlns:a="http://schemas.openxmlformats.org/drawingml/2006/main" r:embed="R936bed5fc7e34ca7"/>
           <a:stretch xmlns:a="http://schemas.openxmlformats.org/drawingml/2006/main"/>
         </p:blipFill>
         <p:spPr>
@@ -8983,7 +8983,7 @@
           <p:cNvPr id="218" name="PlaceHolder 1">
             <a:extLst xmlns:a="http://schemas.openxmlformats.org/drawingml/2006/main">
               <a:ext uri="{FF2B5EF4-FFF2-40B4-BE49-F238E27FC236}">
-                <a16:creationId xmlns:a16="http://schemas.microsoft.com/office/drawing/2014/main" id="{848F77F2-BD6F-42F7-B032-208ED7C8439A}"/>
+                <a16:creationId xmlns:a16="http://schemas.microsoft.com/office/drawing/2014/main" id="{EA48F8ED-2BB7-45EC-86B9-DE35D5954DF6}"/>
               </a:ext>
             </a:extLst>
           </p:cNvPr>
@@ -9047,7 +9047,7 @@
           <p:cNvPr id="219" name="PlaceHolder 2">
             <a:extLst xmlns:a="http://schemas.openxmlformats.org/drawingml/2006/main">
               <a:ext uri="{FF2B5EF4-FFF2-40B4-BE49-F238E27FC236}">
-                <a16:creationId xmlns:a16="http://schemas.microsoft.com/office/drawing/2014/main" id="{9DB6F5CF-6CE6-41AB-B160-A73E521CE3E4}"/>
+                <a16:creationId xmlns:a16="http://schemas.microsoft.com/office/drawing/2014/main" id="{A2BD2821-6429-4F10-ABF1-F06187756923}"/>
               </a:ext>
             </a:extLst>
           </p:cNvPr>
@@ -9433,7 +9433,7 @@
           <p:cNvPr id="15" name="White.Strip.Footer">
             <a:extLst xmlns:a="http://schemas.openxmlformats.org/drawingml/2006/main">
               <a:ext uri="{FF2B5EF4-FFF2-40B4-BE49-F238E27FC236}">
-                <a16:creationId xmlns:a16="http://schemas.microsoft.com/office/drawing/2014/main" id="{3B603D80-48EB-46B0-A9FD-1AE4136C3F00}"/>
+                <a16:creationId xmlns:a16="http://schemas.microsoft.com/office/drawing/2014/main" id="{313B2502-F8D7-4BD2-8967-6A5DA23B441F}"/>
               </a:ext>
             </a:extLst>
           </p:cNvPr>
@@ -9497,7 +9497,7 @@
           <p:cNvPr id="16" name="Footer">
             <a:extLst xmlns:a="http://schemas.openxmlformats.org/drawingml/2006/main">
               <a:ext uri="{FF2B5EF4-FFF2-40B4-BE49-F238E27FC236}">
-                <a16:creationId xmlns:a16="http://schemas.microsoft.com/office/drawing/2014/main" id="{E6B9E846-F194-4C5D-B54D-2D44DCDB1BEF}"/>
+                <a16:creationId xmlns:a16="http://schemas.microsoft.com/office/drawing/2014/main" id="{484EA4EB-4A4D-438B-94C7-BECE5057C25B}"/>
               </a:ext>
             </a:extLst>
           </p:cNvPr>
@@ -9578,7 +9578,7 @@
           <p:cNvPr id="18" name="White.Banner.Top">
             <a:extLst xmlns:a="http://schemas.openxmlformats.org/drawingml/2006/main">
               <a:ext uri="{FF2B5EF4-FFF2-40B4-BE49-F238E27FC236}">
-                <a16:creationId xmlns:a16="http://schemas.microsoft.com/office/drawing/2014/main" id="{0648DC7B-D9FA-4F70-B916-5A67DE604552}"/>
+                <a16:creationId xmlns:a16="http://schemas.microsoft.com/office/drawing/2014/main" id="{00B3E669-624E-4496-BF82-2633EC6D192E}"/>
               </a:ext>
             </a:extLst>
           </p:cNvPr>
@@ -9667,7 +9667,7 @@
           <p:cNvPr id="20" name="Rectangle 17">
             <a:extLst xmlns:a="http://schemas.openxmlformats.org/drawingml/2006/main">
               <a:ext uri="{FF2B5EF4-FFF2-40B4-BE49-F238E27FC236}">
-                <a16:creationId xmlns:a16="http://schemas.microsoft.com/office/drawing/2014/main" id="{F3F2AFA6-D917-4062-BC64-DC40D9B2C620}"/>
+                <a16:creationId xmlns:a16="http://schemas.microsoft.com/office/drawing/2014/main" id="{D1803039-D920-482C-ADF9-4EDDA9B5B760}"/>
               </a:ext>
             </a:extLst>
           </p:cNvPr>
@@ -9734,7 +9734,7 @@
           <p:cNvPr id="21" name="Rectangle 18">
             <a:extLst xmlns:a="http://schemas.openxmlformats.org/drawingml/2006/main">
               <a:ext uri="{FF2B5EF4-FFF2-40B4-BE49-F238E27FC236}">
-                <a16:creationId xmlns:a16="http://schemas.microsoft.com/office/drawing/2014/main" id="{351897EC-8788-4B01-91AA-72BB392E5EB1}"/>
+                <a16:creationId xmlns:a16="http://schemas.microsoft.com/office/drawing/2014/main" id="{80EC1D8F-B550-49EF-A5D1-DDE0EE953288}"/>
               </a:ext>
             </a:extLst>
           </p:cNvPr>
@@ -9828,7 +9828,7 @@
           <p:cNvPr id="23" name="Rectangle 22">
             <a:extLst xmlns:a="http://schemas.openxmlformats.org/drawingml/2006/main">
               <a:ext uri="{FF2B5EF4-FFF2-40B4-BE49-F238E27FC236}">
-                <a16:creationId xmlns:a16="http://schemas.microsoft.com/office/drawing/2014/main" id="{1575F680-4CBE-48ED-841E-7CB15CE0E03B}"/>
+                <a16:creationId xmlns:a16="http://schemas.microsoft.com/office/drawing/2014/main" id="{5E0BE21E-7477-4F9E-9637-8EC28BAA84C0}"/>
               </a:ext>
             </a:extLst>
           </p:cNvPr>
@@ -9926,7 +9926,7 @@
           <p:nvPr/>
         </p:nvPicPr>
         <p:blipFill>
-          <a:blip xmlns:r="http://schemas.openxmlformats.org/officeDocument/2006/relationships" xmlns:a="http://schemas.openxmlformats.org/drawingml/2006/main" r:embed="R5dd0a71ef1494e40"/>
+          <a:blip xmlns:r="http://schemas.openxmlformats.org/officeDocument/2006/relationships" xmlns:a="http://schemas.openxmlformats.org/drawingml/2006/main" r:embed="Ra49983bc94a044dc"/>
           <a:stretch xmlns:a="http://schemas.openxmlformats.org/drawingml/2006/main"/>
         </p:blipFill>
         <p:spPr>
@@ -9971,7 +9971,7 @@
           <p:cNvPr id="220" name="White.Strip.Footer">
             <a:extLst xmlns:a="http://schemas.openxmlformats.org/drawingml/2006/main">
               <a:ext uri="{FF2B5EF4-FFF2-40B4-BE49-F238E27FC236}">
-                <a16:creationId xmlns:a16="http://schemas.microsoft.com/office/drawing/2014/main" id="{6BDAEAB2-5AF8-48AD-A8FC-D403B4B26EBD}"/>
+                <a16:creationId xmlns:a16="http://schemas.microsoft.com/office/drawing/2014/main" id="{1143034B-C9DB-41DB-8045-A256D476D8D7}"/>
               </a:ext>
             </a:extLst>
           </p:cNvPr>
@@ -10035,7 +10035,7 @@
           <p:cNvPr id="221" name="Footer">
             <a:extLst xmlns:a="http://schemas.openxmlformats.org/drawingml/2006/main">
               <a:ext uri="{FF2B5EF4-FFF2-40B4-BE49-F238E27FC236}">
-                <a16:creationId xmlns:a16="http://schemas.microsoft.com/office/drawing/2014/main" id="{495760BE-00CE-40EF-B35A-620D2A2487E1}"/>
+                <a16:creationId xmlns:a16="http://schemas.microsoft.com/office/drawing/2014/main" id="{9ED30A98-BFFD-45E3-8FBB-80023CF9FFEF}"/>
               </a:ext>
             </a:extLst>
           </p:cNvPr>
@@ -10116,7 +10116,7 @@
           <p:cNvPr id="223" name="White.Banner.Top">
             <a:extLst xmlns:a="http://schemas.openxmlformats.org/drawingml/2006/main">
               <a:ext uri="{FF2B5EF4-FFF2-40B4-BE49-F238E27FC236}">
-                <a16:creationId xmlns:a16="http://schemas.microsoft.com/office/drawing/2014/main" id="{0FCA2AFB-F0DE-475C-AE94-0C6535A39DA1}"/>
+                <a16:creationId xmlns:a16="http://schemas.microsoft.com/office/drawing/2014/main" id="{B4F47F55-DC68-4142-852A-388B39E1BFA7}"/>
               </a:ext>
             </a:extLst>
           </p:cNvPr>
@@ -10205,7 +10205,7 @@
           <p:cNvPr id="225" name="Rectangle 17">
             <a:extLst xmlns:a="http://schemas.openxmlformats.org/drawingml/2006/main">
               <a:ext uri="{FF2B5EF4-FFF2-40B4-BE49-F238E27FC236}">
-                <a16:creationId xmlns:a16="http://schemas.microsoft.com/office/drawing/2014/main" id="{7F660F79-D6C8-4541-AA1D-835CE9DAF012}"/>
+                <a16:creationId xmlns:a16="http://schemas.microsoft.com/office/drawing/2014/main" id="{5B834FE1-68BA-4D51-9363-78C73CC158C4}"/>
               </a:ext>
             </a:extLst>
           </p:cNvPr>
@@ -10272,7 +10272,7 @@
           <p:cNvPr id="226" name="Rectangle 18">
             <a:extLst xmlns:a="http://schemas.openxmlformats.org/drawingml/2006/main">
               <a:ext uri="{FF2B5EF4-FFF2-40B4-BE49-F238E27FC236}">
-                <a16:creationId xmlns:a16="http://schemas.microsoft.com/office/drawing/2014/main" id="{D06DD59B-E33A-4291-A3D5-4E3D66BF21C4}"/>
+                <a16:creationId xmlns:a16="http://schemas.microsoft.com/office/drawing/2014/main" id="{9660198A-B985-4416-90A7-E56E73711309}"/>
               </a:ext>
             </a:extLst>
           </p:cNvPr>
@@ -10366,7 +10366,7 @@
           <p:cNvPr id="228" name="Rectangle 22">
             <a:extLst xmlns:a="http://schemas.openxmlformats.org/drawingml/2006/main">
               <a:ext uri="{FF2B5EF4-FFF2-40B4-BE49-F238E27FC236}">
-                <a16:creationId xmlns:a16="http://schemas.microsoft.com/office/drawing/2014/main" id="{A9809324-43A7-425F-BDCB-04EE286B5E80}"/>
+                <a16:creationId xmlns:a16="http://schemas.microsoft.com/office/drawing/2014/main" id="{8ADC9411-81A2-45F1-9E94-F30A4A55C56E}"/>
               </a:ext>
             </a:extLst>
           </p:cNvPr>
@@ -10464,7 +10464,7 @@
           <p:nvPr/>
         </p:nvPicPr>
         <p:blipFill>
-          <a:blip xmlns:r="http://schemas.openxmlformats.org/officeDocument/2006/relationships" xmlns:a="http://schemas.openxmlformats.org/drawingml/2006/main" r:embed="R4cfc7576c79349f9"/>
+          <a:blip xmlns:r="http://schemas.openxmlformats.org/officeDocument/2006/relationships" xmlns:a="http://schemas.openxmlformats.org/drawingml/2006/main" r:embed="R4c5b40475f7646ee"/>
           <a:stretch xmlns:a="http://schemas.openxmlformats.org/drawingml/2006/main"/>
         </p:blipFill>
         <p:spPr>
@@ -10485,7 +10485,7 @@
           <p:cNvPr id="231" name="PlaceHolder 1">
             <a:extLst xmlns:a="http://schemas.openxmlformats.org/drawingml/2006/main">
               <a:ext uri="{FF2B5EF4-FFF2-40B4-BE49-F238E27FC236}">
-                <a16:creationId xmlns:a16="http://schemas.microsoft.com/office/drawing/2014/main" id="{DC87DB39-8DFB-43EE-B6A1-544C717A666B}"/>
+                <a16:creationId xmlns:a16="http://schemas.microsoft.com/office/drawing/2014/main" id="{5AEE997A-D2B4-453F-8D4E-30DF9F626A5F}"/>
               </a:ext>
             </a:extLst>
           </p:cNvPr>
@@ -10549,7 +10549,7 @@
           <p:cNvPr id="232" name="PlaceHolder 2">
             <a:extLst xmlns:a="http://schemas.openxmlformats.org/drawingml/2006/main">
               <a:ext uri="{FF2B5EF4-FFF2-40B4-BE49-F238E27FC236}">
-                <a16:creationId xmlns:a16="http://schemas.microsoft.com/office/drawing/2014/main" id="{0405A875-0434-4EF9-AD60-0F45409F5C3A}"/>
+                <a16:creationId xmlns:a16="http://schemas.microsoft.com/office/drawing/2014/main" id="{6B1507EB-317E-4342-8AFF-7079AB0FA08F}"/>
               </a:ext>
             </a:extLst>
           </p:cNvPr>
@@ -10911,7 +10911,7 @@
           <p:cNvPr id="233" name="White.Strip.Footer">
             <a:extLst xmlns:a="http://schemas.openxmlformats.org/drawingml/2006/main">
               <a:ext uri="{FF2B5EF4-FFF2-40B4-BE49-F238E27FC236}">
-                <a16:creationId xmlns:a16="http://schemas.microsoft.com/office/drawing/2014/main" id="{50651CDB-6A7C-4018-9E1D-5DFF3FE2431D}"/>
+                <a16:creationId xmlns:a16="http://schemas.microsoft.com/office/drawing/2014/main" id="{56A87952-D518-4214-B305-F1FB53AF1865}"/>
               </a:ext>
             </a:extLst>
           </p:cNvPr>
@@ -10975,7 +10975,7 @@
           <p:cNvPr id="234" name="Footer">
             <a:extLst xmlns:a="http://schemas.openxmlformats.org/drawingml/2006/main">
               <a:ext uri="{FF2B5EF4-FFF2-40B4-BE49-F238E27FC236}">
-                <a16:creationId xmlns:a16="http://schemas.microsoft.com/office/drawing/2014/main" id="{25885D9E-3956-4C34-9001-2C78FD2D1B88}"/>
+                <a16:creationId xmlns:a16="http://schemas.microsoft.com/office/drawing/2014/main" id="{E83B0618-5E91-42D6-B1D2-5E7EB18F0DD8}"/>
               </a:ext>
             </a:extLst>
           </p:cNvPr>
@@ -11056,7 +11056,7 @@
           <p:cNvPr id="236" name="White.Banner.Top">
             <a:extLst xmlns:a="http://schemas.openxmlformats.org/drawingml/2006/main">
               <a:ext uri="{FF2B5EF4-FFF2-40B4-BE49-F238E27FC236}">
-                <a16:creationId xmlns:a16="http://schemas.microsoft.com/office/drawing/2014/main" id="{BC1D0D77-1C1C-4021-A1C9-454F7C67C7D7}"/>
+                <a16:creationId xmlns:a16="http://schemas.microsoft.com/office/drawing/2014/main" id="{3107C49C-F245-433D-93F4-2019178FE7B7}"/>
               </a:ext>
             </a:extLst>
           </p:cNvPr>
@@ -11145,7 +11145,7 @@
           <p:cNvPr id="238" name="Rectangle 17">
             <a:extLst xmlns:a="http://schemas.openxmlformats.org/drawingml/2006/main">
               <a:ext uri="{FF2B5EF4-FFF2-40B4-BE49-F238E27FC236}">
-                <a16:creationId xmlns:a16="http://schemas.microsoft.com/office/drawing/2014/main" id="{83BD651E-047A-4A42-AFE5-E81D95177ABC}"/>
+                <a16:creationId xmlns:a16="http://schemas.microsoft.com/office/drawing/2014/main" id="{D6F6916D-B6AD-476D-98F5-FC7FC53AD1AF}"/>
               </a:ext>
             </a:extLst>
           </p:cNvPr>
@@ -11212,7 +11212,7 @@
           <p:cNvPr id="239" name="Rectangle 18">
             <a:extLst xmlns:a="http://schemas.openxmlformats.org/drawingml/2006/main">
               <a:ext uri="{FF2B5EF4-FFF2-40B4-BE49-F238E27FC236}">
-                <a16:creationId xmlns:a16="http://schemas.microsoft.com/office/drawing/2014/main" id="{7ADD6D57-51D3-4DC9-A205-D2AAC465D4F7}"/>
+                <a16:creationId xmlns:a16="http://schemas.microsoft.com/office/drawing/2014/main" id="{81BC038A-F6F8-46C1-A1F1-36A174BE1246}"/>
               </a:ext>
             </a:extLst>
           </p:cNvPr>
@@ -11306,7 +11306,7 @@
           <p:cNvPr id="241" name="Rectangle 22">
             <a:extLst xmlns:a="http://schemas.openxmlformats.org/drawingml/2006/main">
               <a:ext uri="{FF2B5EF4-FFF2-40B4-BE49-F238E27FC236}">
-                <a16:creationId xmlns:a16="http://schemas.microsoft.com/office/drawing/2014/main" id="{DBCB3DD2-BA58-422C-A6DB-B3939CC742C9}"/>
+                <a16:creationId xmlns:a16="http://schemas.microsoft.com/office/drawing/2014/main" id="{C57F4290-A234-4475-ABA9-FB133CC4EFCB}"/>
               </a:ext>
             </a:extLst>
           </p:cNvPr>
@@ -11404,7 +11404,7 @@
           <p:nvPr/>
         </p:nvPicPr>
         <p:blipFill>
-          <a:blip xmlns:r="http://schemas.openxmlformats.org/officeDocument/2006/relationships" xmlns:a="http://schemas.openxmlformats.org/drawingml/2006/main" r:embed="R154f6c31cf1046ae"/>
+          <a:blip xmlns:r="http://schemas.openxmlformats.org/officeDocument/2006/relationships" xmlns:a="http://schemas.openxmlformats.org/drawingml/2006/main" r:embed="R9ada0b2d53894acd"/>
           <a:stretch xmlns:a="http://schemas.openxmlformats.org/drawingml/2006/main"/>
         </p:blipFill>
         <p:spPr>
@@ -11425,7 +11425,7 @@
           <p:cNvPr id="244" name="PlaceHolder 1">
             <a:extLst xmlns:a="http://schemas.openxmlformats.org/drawingml/2006/main">
               <a:ext uri="{FF2B5EF4-FFF2-40B4-BE49-F238E27FC236}">
-                <a16:creationId xmlns:a16="http://schemas.microsoft.com/office/drawing/2014/main" id="{59C20F0A-96FB-4023-B036-B857355EDF9F}"/>
+                <a16:creationId xmlns:a16="http://schemas.microsoft.com/office/drawing/2014/main" id="{32381910-28EB-42A8-A255-0BD19BECF50F}"/>
               </a:ext>
             </a:extLst>
           </p:cNvPr>
@@ -11489,7 +11489,7 @@
           <p:cNvPr id="245" name="PlaceHolder 2">
             <a:extLst xmlns:a="http://schemas.openxmlformats.org/drawingml/2006/main">
               <a:ext uri="{FF2B5EF4-FFF2-40B4-BE49-F238E27FC236}">
-                <a16:creationId xmlns:a16="http://schemas.microsoft.com/office/drawing/2014/main" id="{91DD1FB6-8D8B-4C4E-B2E0-8770F7333087}"/>
+                <a16:creationId xmlns:a16="http://schemas.microsoft.com/office/drawing/2014/main" id="{B60B344B-3357-41E3-B96F-5BADC1CD5402}"/>
               </a:ext>
             </a:extLst>
           </p:cNvPr>
@@ -11851,7 +11851,7 @@
           <p:cNvPr id="246" name="White.Strip.Footer">
             <a:extLst xmlns:a="http://schemas.openxmlformats.org/drawingml/2006/main">
               <a:ext uri="{FF2B5EF4-FFF2-40B4-BE49-F238E27FC236}">
-                <a16:creationId xmlns:a16="http://schemas.microsoft.com/office/drawing/2014/main" id="{C186116F-0FC1-4E82-B2C0-4B59E313F046}"/>
+                <a16:creationId xmlns:a16="http://schemas.microsoft.com/office/drawing/2014/main" id="{312B6268-1ED1-48E0-BF43-1B2EEA54F1F7}"/>
               </a:ext>
             </a:extLst>
           </p:cNvPr>
@@ -11915,7 +11915,7 @@
           <p:cNvPr id="247" name="Footer">
             <a:extLst xmlns:a="http://schemas.openxmlformats.org/drawingml/2006/main">
               <a:ext uri="{FF2B5EF4-FFF2-40B4-BE49-F238E27FC236}">
-                <a16:creationId xmlns:a16="http://schemas.microsoft.com/office/drawing/2014/main" id="{15FD91D9-48E7-4BDB-9F25-A94E12235F7D}"/>
+                <a16:creationId xmlns:a16="http://schemas.microsoft.com/office/drawing/2014/main" id="{071D3FF1-E75C-45D5-A6A6-C552C6D97FDB}"/>
               </a:ext>
             </a:extLst>
           </p:cNvPr>
@@ -11996,7 +11996,7 @@
           <p:cNvPr id="249" name="White.Banner.Top">
             <a:extLst xmlns:a="http://schemas.openxmlformats.org/drawingml/2006/main">
               <a:ext uri="{FF2B5EF4-FFF2-40B4-BE49-F238E27FC236}">
-                <a16:creationId xmlns:a16="http://schemas.microsoft.com/office/drawing/2014/main" id="{DA599A38-C668-413A-A49A-516BFAE10451}"/>
+                <a16:creationId xmlns:a16="http://schemas.microsoft.com/office/drawing/2014/main" id="{4231D6FD-D810-4015-9D6B-5B0A8DD08134}"/>
               </a:ext>
             </a:extLst>
           </p:cNvPr>
@@ -12085,7 +12085,7 @@
           <p:cNvPr id="251" name="Rectangle 17">
             <a:extLst xmlns:a="http://schemas.openxmlformats.org/drawingml/2006/main">
               <a:ext uri="{FF2B5EF4-FFF2-40B4-BE49-F238E27FC236}">
-                <a16:creationId xmlns:a16="http://schemas.microsoft.com/office/drawing/2014/main" id="{604521DD-91F2-44C2-A318-94D2379EAC9E}"/>
+                <a16:creationId xmlns:a16="http://schemas.microsoft.com/office/drawing/2014/main" id="{7307675D-4723-4A41-8942-464C79D1BD33}"/>
               </a:ext>
             </a:extLst>
           </p:cNvPr>
@@ -12152,7 +12152,7 @@
           <p:cNvPr id="252" name="Rectangle 18">
             <a:extLst xmlns:a="http://schemas.openxmlformats.org/drawingml/2006/main">
               <a:ext uri="{FF2B5EF4-FFF2-40B4-BE49-F238E27FC236}">
-                <a16:creationId xmlns:a16="http://schemas.microsoft.com/office/drawing/2014/main" id="{ED48DA21-E992-46DB-86DD-FF714A6CE9D8}"/>
+                <a16:creationId xmlns:a16="http://schemas.microsoft.com/office/drawing/2014/main" id="{AF3C749E-E1BD-4A09-AFA1-4B7D30A9DBBD}"/>
               </a:ext>
             </a:extLst>
           </p:cNvPr>
@@ -12246,7 +12246,7 @@
           <p:cNvPr id="254" name="Rectangle 22">
             <a:extLst xmlns:a="http://schemas.openxmlformats.org/drawingml/2006/main">
               <a:ext uri="{FF2B5EF4-FFF2-40B4-BE49-F238E27FC236}">
-                <a16:creationId xmlns:a16="http://schemas.microsoft.com/office/drawing/2014/main" id="{DBA5D9F9-05B9-47F8-8758-19DF384E1E0C}"/>
+                <a16:creationId xmlns:a16="http://schemas.microsoft.com/office/drawing/2014/main" id="{2CA9326D-B59A-42D0-8C9F-0836B43B291F}"/>
               </a:ext>
             </a:extLst>
           </p:cNvPr>
@@ -12344,7 +12344,7 @@
           <p:nvPr/>
         </p:nvPicPr>
         <p:blipFill>
-          <a:blip xmlns:r="http://schemas.openxmlformats.org/officeDocument/2006/relationships" xmlns:a="http://schemas.openxmlformats.org/drawingml/2006/main" r:embed="R7ef63c5940714726"/>
+          <a:blip xmlns:r="http://schemas.openxmlformats.org/officeDocument/2006/relationships" xmlns:a="http://schemas.openxmlformats.org/drawingml/2006/main" r:embed="R307e8bca32c14193"/>
           <a:stretch xmlns:a="http://schemas.openxmlformats.org/drawingml/2006/main"/>
         </p:blipFill>
         <p:spPr>
@@ -12365,7 +12365,7 @@
           <p:cNvPr id="257" name="PlaceHolder 1">
             <a:extLst xmlns:a="http://schemas.openxmlformats.org/drawingml/2006/main">
               <a:ext uri="{FF2B5EF4-FFF2-40B4-BE49-F238E27FC236}">
-                <a16:creationId xmlns:a16="http://schemas.microsoft.com/office/drawing/2014/main" id="{FEBF5FE1-E82D-4388-8A45-D759C7C58EB2}"/>
+                <a16:creationId xmlns:a16="http://schemas.microsoft.com/office/drawing/2014/main" id="{C90733F2-30A8-49DC-9E14-7FD4B7FA6538}"/>
               </a:ext>
             </a:extLst>
           </p:cNvPr>
@@ -12406,7 +12406,7 @@
           <p:cNvPr id="258" name="PlaceHolder 2">
             <a:extLst xmlns:a="http://schemas.openxmlformats.org/drawingml/2006/main">
               <a:ext uri="{FF2B5EF4-FFF2-40B4-BE49-F238E27FC236}">
-                <a16:creationId xmlns:a16="http://schemas.microsoft.com/office/drawing/2014/main" id="{EC721874-82EB-473F-8965-056A51850454}"/>
+                <a16:creationId xmlns:a16="http://schemas.microsoft.com/office/drawing/2014/main" id="{709BC515-7CEA-44B5-A000-51FBBBFACF9B}"/>
               </a:ext>
             </a:extLst>
           </p:cNvPr>
@@ -12476,7 +12476,7 @@
           <p:cNvPr id="259" name="PlaceHolder 3">
             <a:extLst xmlns:a="http://schemas.openxmlformats.org/drawingml/2006/main">
               <a:ext uri="{FF2B5EF4-FFF2-40B4-BE49-F238E27FC236}">
-                <a16:creationId xmlns:a16="http://schemas.microsoft.com/office/drawing/2014/main" id="{3A51D7F3-CA9D-4EC5-B7F8-A63190EC71EC}"/>
+                <a16:creationId xmlns:a16="http://schemas.microsoft.com/office/drawing/2014/main" id="{E8221194-F86E-40CF-8E4E-E89C8978BE0D}"/>
               </a:ext>
             </a:extLst>
           </p:cNvPr>
@@ -12540,7 +12540,7 @@
           <p:cNvPr id="260" name="PlaceHolder 4">
             <a:extLst xmlns:a="http://schemas.openxmlformats.org/drawingml/2006/main">
               <a:ext uri="{FF2B5EF4-FFF2-40B4-BE49-F238E27FC236}">
-                <a16:creationId xmlns:a16="http://schemas.microsoft.com/office/drawing/2014/main" id="{8F458F93-467F-49BA-A29B-19322248FF59}"/>
+                <a16:creationId xmlns:a16="http://schemas.microsoft.com/office/drawing/2014/main" id="{F0ABB578-CBDB-427F-B400-C6194D8C93C4}"/>
               </a:ext>
             </a:extLst>
           </p:cNvPr>
@@ -12902,7 +12902,7 @@
           <p:cNvPr id="26" name="White.Strip.Footer">
             <a:extLst xmlns:a="http://schemas.openxmlformats.org/drawingml/2006/main">
               <a:ext uri="{FF2B5EF4-FFF2-40B4-BE49-F238E27FC236}">
-                <a16:creationId xmlns:a16="http://schemas.microsoft.com/office/drawing/2014/main" id="{E17D1330-BBE6-451E-933A-36B9FAB223CA}"/>
+                <a16:creationId xmlns:a16="http://schemas.microsoft.com/office/drawing/2014/main" id="{A3C14206-2CFE-4644-ADED-9275E0881285}"/>
               </a:ext>
             </a:extLst>
           </p:cNvPr>
@@ -12966,7 +12966,7 @@
           <p:cNvPr id="27" name="Footer">
             <a:extLst xmlns:a="http://schemas.openxmlformats.org/drawingml/2006/main">
               <a:ext uri="{FF2B5EF4-FFF2-40B4-BE49-F238E27FC236}">
-                <a16:creationId xmlns:a16="http://schemas.microsoft.com/office/drawing/2014/main" id="{62848410-E548-47C1-A1FD-0BBCC57DD1E2}"/>
+                <a16:creationId xmlns:a16="http://schemas.microsoft.com/office/drawing/2014/main" id="{4315F8D8-A510-4C6B-B45F-D79801E05E38}"/>
               </a:ext>
             </a:extLst>
           </p:cNvPr>
@@ -13047,7 +13047,7 @@
           <p:cNvPr id="29" name="White.Banner.Top">
             <a:extLst xmlns:a="http://schemas.openxmlformats.org/drawingml/2006/main">
               <a:ext uri="{FF2B5EF4-FFF2-40B4-BE49-F238E27FC236}">
-                <a16:creationId xmlns:a16="http://schemas.microsoft.com/office/drawing/2014/main" id="{706A70C7-1F3D-4DD4-8FA0-364998C81634}"/>
+                <a16:creationId xmlns:a16="http://schemas.microsoft.com/office/drawing/2014/main" id="{2CCD75DB-2C76-45FE-ABA1-E649A4BB9D4E}"/>
               </a:ext>
             </a:extLst>
           </p:cNvPr>
@@ -13136,7 +13136,7 @@
           <p:cNvPr id="31" name="Rectangle 17">
             <a:extLst xmlns:a="http://schemas.openxmlformats.org/drawingml/2006/main">
               <a:ext uri="{FF2B5EF4-FFF2-40B4-BE49-F238E27FC236}">
-                <a16:creationId xmlns:a16="http://schemas.microsoft.com/office/drawing/2014/main" id="{07BDBB51-46ED-401A-AA47-FA2B0E47EF82}"/>
+                <a16:creationId xmlns:a16="http://schemas.microsoft.com/office/drawing/2014/main" id="{7D828443-D99C-496F-AA06-644FE1CE42C3}"/>
               </a:ext>
             </a:extLst>
           </p:cNvPr>
@@ -13203,7 +13203,7 @@
           <p:cNvPr id="32" name="Rectangle 18">
             <a:extLst xmlns:a="http://schemas.openxmlformats.org/drawingml/2006/main">
               <a:ext uri="{FF2B5EF4-FFF2-40B4-BE49-F238E27FC236}">
-                <a16:creationId xmlns:a16="http://schemas.microsoft.com/office/drawing/2014/main" id="{D7E565D6-1EC7-4808-BC5D-34AFE882057D}"/>
+                <a16:creationId xmlns:a16="http://schemas.microsoft.com/office/drawing/2014/main" id="{ADC1FAE0-59DB-457F-8269-3E7848C83A4F}"/>
               </a:ext>
             </a:extLst>
           </p:cNvPr>
@@ -13297,7 +13297,7 @@
           <p:cNvPr id="34" name="Rectangle 22">
             <a:extLst xmlns:a="http://schemas.openxmlformats.org/drawingml/2006/main">
               <a:ext uri="{FF2B5EF4-FFF2-40B4-BE49-F238E27FC236}">
-                <a16:creationId xmlns:a16="http://schemas.microsoft.com/office/drawing/2014/main" id="{695CE73F-08D0-4071-ABEF-1A3EF832B1EB}"/>
+                <a16:creationId xmlns:a16="http://schemas.microsoft.com/office/drawing/2014/main" id="{D5A26448-C937-44D8-A75F-E2E2154862AA}"/>
               </a:ext>
             </a:extLst>
           </p:cNvPr>
@@ -13395,7 +13395,7 @@
           <p:nvPr/>
         </p:nvPicPr>
         <p:blipFill>
-          <a:blip xmlns:r="http://schemas.openxmlformats.org/officeDocument/2006/relationships" xmlns:a="http://schemas.openxmlformats.org/drawingml/2006/main" r:embed="R01217476f31042f3"/>
+          <a:blip xmlns:r="http://schemas.openxmlformats.org/officeDocument/2006/relationships" xmlns:a="http://schemas.openxmlformats.org/drawingml/2006/main" r:embed="Rbd0772c0f5264263"/>
           <a:stretch xmlns:a="http://schemas.openxmlformats.org/drawingml/2006/main"/>
         </p:blipFill>
         <p:spPr>
@@ -13440,7 +13440,7 @@
           <p:cNvPr id="37" name="White.Strip.Footer">
             <a:extLst xmlns:a="http://schemas.openxmlformats.org/drawingml/2006/main">
               <a:ext uri="{FF2B5EF4-FFF2-40B4-BE49-F238E27FC236}">
-                <a16:creationId xmlns:a16="http://schemas.microsoft.com/office/drawing/2014/main" id="{D06DB1F9-AE3E-4C3A-B88C-BA1CFE4C02F9}"/>
+                <a16:creationId xmlns:a16="http://schemas.microsoft.com/office/drawing/2014/main" id="{16D8979C-E731-458E-B9A6-92D0BA145662}"/>
               </a:ext>
             </a:extLst>
           </p:cNvPr>
@@ -13504,7 +13504,7 @@
           <p:cNvPr id="38" name="Footer">
             <a:extLst xmlns:a="http://schemas.openxmlformats.org/drawingml/2006/main">
               <a:ext uri="{FF2B5EF4-FFF2-40B4-BE49-F238E27FC236}">
-                <a16:creationId xmlns:a16="http://schemas.microsoft.com/office/drawing/2014/main" id="{2BCC28AD-CD95-4E9B-95A8-FE9529E9A86A}"/>
+                <a16:creationId xmlns:a16="http://schemas.microsoft.com/office/drawing/2014/main" id="{51567E04-B108-4184-BFB7-AFBE9CAC19A6}"/>
               </a:ext>
             </a:extLst>
           </p:cNvPr>
@@ -13585,7 +13585,7 @@
           <p:cNvPr id="40" name="White.Banner.Top">
             <a:extLst xmlns:a="http://schemas.openxmlformats.org/drawingml/2006/main">
               <a:ext uri="{FF2B5EF4-FFF2-40B4-BE49-F238E27FC236}">
-                <a16:creationId xmlns:a16="http://schemas.microsoft.com/office/drawing/2014/main" id="{9D9B84D1-CADB-4AE3-9EB2-303FC88503B2}"/>
+                <a16:creationId xmlns:a16="http://schemas.microsoft.com/office/drawing/2014/main" id="{187426D6-D576-4D15-B38B-B6E0BDCA3E7A}"/>
               </a:ext>
             </a:extLst>
           </p:cNvPr>
@@ -13674,7 +13674,7 @@
           <p:cNvPr id="42" name="Rectangle 17">
             <a:extLst xmlns:a="http://schemas.openxmlformats.org/drawingml/2006/main">
               <a:ext uri="{FF2B5EF4-FFF2-40B4-BE49-F238E27FC236}">
-                <a16:creationId xmlns:a16="http://schemas.microsoft.com/office/drawing/2014/main" id="{57BFBD6A-A470-4DE7-8B12-4CE833582DC7}"/>
+                <a16:creationId xmlns:a16="http://schemas.microsoft.com/office/drawing/2014/main" id="{52B25BA2-7F99-46EA-93E2-90DD3C55DBB8}"/>
               </a:ext>
             </a:extLst>
           </p:cNvPr>
@@ -13741,7 +13741,7 @@
           <p:cNvPr id="43" name="Rectangle 18">
             <a:extLst xmlns:a="http://schemas.openxmlformats.org/drawingml/2006/main">
               <a:ext uri="{FF2B5EF4-FFF2-40B4-BE49-F238E27FC236}">
-                <a16:creationId xmlns:a16="http://schemas.microsoft.com/office/drawing/2014/main" id="{E19B06A8-EE1A-44E3-98C7-FC92594B75BB}"/>
+                <a16:creationId xmlns:a16="http://schemas.microsoft.com/office/drawing/2014/main" id="{AB4C4191-F423-4FD2-B692-7D4BDBE79A75}"/>
               </a:ext>
             </a:extLst>
           </p:cNvPr>
@@ -13835,7 +13835,7 @@
           <p:cNvPr id="45" name="Rectangle 22">
             <a:extLst xmlns:a="http://schemas.openxmlformats.org/drawingml/2006/main">
               <a:ext uri="{FF2B5EF4-FFF2-40B4-BE49-F238E27FC236}">
-                <a16:creationId xmlns:a16="http://schemas.microsoft.com/office/drawing/2014/main" id="{AD2C2796-6BB1-48C8-90F9-EA3D0B29318C}"/>
+                <a16:creationId xmlns:a16="http://schemas.microsoft.com/office/drawing/2014/main" id="{88240CE8-4D6E-45C2-8684-1541235596D5}"/>
               </a:ext>
             </a:extLst>
           </p:cNvPr>
@@ -13933,7 +13933,7 @@
           <p:nvPr/>
         </p:nvPicPr>
         <p:blipFill>
-          <a:blip xmlns:r="http://schemas.openxmlformats.org/officeDocument/2006/relationships" xmlns:a="http://schemas.openxmlformats.org/drawingml/2006/main" r:embed="Raee96bc1e2c7472b"/>
+          <a:blip xmlns:r="http://schemas.openxmlformats.org/officeDocument/2006/relationships" xmlns:a="http://schemas.openxmlformats.org/drawingml/2006/main" r:embed="R0f831782a6a044a8"/>
           <a:stretch xmlns:a="http://schemas.openxmlformats.org/drawingml/2006/main"/>
         </p:blipFill>
         <p:spPr>
@@ -13978,7 +13978,7 @@
           <p:cNvPr id="48" name="White.Strip.Footer">
             <a:extLst xmlns:a="http://schemas.openxmlformats.org/drawingml/2006/main">
               <a:ext uri="{FF2B5EF4-FFF2-40B4-BE49-F238E27FC236}">
-                <a16:creationId xmlns:a16="http://schemas.microsoft.com/office/drawing/2014/main" id="{007E6B28-1AAF-4C70-8693-4E51CADB3F38}"/>
+                <a16:creationId xmlns:a16="http://schemas.microsoft.com/office/drawing/2014/main" id="{85541343-E844-4AD9-B7CF-52FD6954F8F1}"/>
               </a:ext>
             </a:extLst>
           </p:cNvPr>
@@ -14042,7 +14042,7 @@
           <p:cNvPr id="49" name="Footer">
             <a:extLst xmlns:a="http://schemas.openxmlformats.org/drawingml/2006/main">
               <a:ext uri="{FF2B5EF4-FFF2-40B4-BE49-F238E27FC236}">
-                <a16:creationId xmlns:a16="http://schemas.microsoft.com/office/drawing/2014/main" id="{716C2A53-8D7C-42A4-A969-0B7B5C121A7A}"/>
+                <a16:creationId xmlns:a16="http://schemas.microsoft.com/office/drawing/2014/main" id="{C6106DF9-3A99-4B20-80D7-2FFF9464F957}"/>
               </a:ext>
             </a:extLst>
           </p:cNvPr>
@@ -14123,7 +14123,7 @@
           <p:cNvPr id="51" name="White.Banner.Top">
             <a:extLst xmlns:a="http://schemas.openxmlformats.org/drawingml/2006/main">
               <a:ext uri="{FF2B5EF4-FFF2-40B4-BE49-F238E27FC236}">
-                <a16:creationId xmlns:a16="http://schemas.microsoft.com/office/drawing/2014/main" id="{5293CE93-820C-47EE-B917-F102C993A7DA}"/>
+                <a16:creationId xmlns:a16="http://schemas.microsoft.com/office/drawing/2014/main" id="{15B54BAC-A7AB-4802-88AE-27EC6F40B3A1}"/>
               </a:ext>
             </a:extLst>
           </p:cNvPr>
@@ -14212,7 +14212,7 @@
           <p:cNvPr id="53" name="Rectangle 17">
             <a:extLst xmlns:a="http://schemas.openxmlformats.org/drawingml/2006/main">
               <a:ext uri="{FF2B5EF4-FFF2-40B4-BE49-F238E27FC236}">
-                <a16:creationId xmlns:a16="http://schemas.microsoft.com/office/drawing/2014/main" id="{979CE638-9460-4458-979B-F23F84D5E698}"/>
+                <a16:creationId xmlns:a16="http://schemas.microsoft.com/office/drawing/2014/main" id="{9C96D127-AF8D-4BBC-8B3F-D7C15C7CC669}"/>
               </a:ext>
             </a:extLst>
           </p:cNvPr>
@@ -14279,7 +14279,7 @@
           <p:cNvPr id="54" name="Rectangle 18">
             <a:extLst xmlns:a="http://schemas.openxmlformats.org/drawingml/2006/main">
               <a:ext uri="{FF2B5EF4-FFF2-40B4-BE49-F238E27FC236}">
-                <a16:creationId xmlns:a16="http://schemas.microsoft.com/office/drawing/2014/main" id="{F4C654AE-6124-4E34-B115-231517C20C31}"/>
+                <a16:creationId xmlns:a16="http://schemas.microsoft.com/office/drawing/2014/main" id="{6177A85D-6577-4F06-9D8A-77862498BFAA}"/>
               </a:ext>
             </a:extLst>
           </p:cNvPr>
@@ -14373,7 +14373,7 @@
           <p:cNvPr id="56" name="Rectangle 22">
             <a:extLst xmlns:a="http://schemas.openxmlformats.org/drawingml/2006/main">
               <a:ext uri="{FF2B5EF4-FFF2-40B4-BE49-F238E27FC236}">
-                <a16:creationId xmlns:a16="http://schemas.microsoft.com/office/drawing/2014/main" id="{FB2176AF-FAFF-474F-A511-D7A7CFEF399E}"/>
+                <a16:creationId xmlns:a16="http://schemas.microsoft.com/office/drawing/2014/main" id="{27143509-ADEA-4ECF-A8F9-9FB7250DD9CC}"/>
               </a:ext>
             </a:extLst>
           </p:cNvPr>
@@ -14471,7 +14471,7 @@
           <p:nvPr/>
         </p:nvPicPr>
         <p:blipFill>
-          <a:blip xmlns:r="http://schemas.openxmlformats.org/officeDocument/2006/relationships" xmlns:a="http://schemas.openxmlformats.org/drawingml/2006/main" r:embed="R65d37ce590be4370"/>
+          <a:blip xmlns:r="http://schemas.openxmlformats.org/officeDocument/2006/relationships" xmlns:a="http://schemas.openxmlformats.org/drawingml/2006/main" r:embed="R0407d0816a874bbb"/>
           <a:stretch xmlns:a="http://schemas.openxmlformats.org/drawingml/2006/main"/>
         </p:blipFill>
         <p:spPr>
@@ -14492,7 +14492,7 @@
           <p:cNvPr id="59" name="PlaceHolder 1">
             <a:extLst xmlns:a="http://schemas.openxmlformats.org/drawingml/2006/main">
               <a:ext uri="{FF2B5EF4-FFF2-40B4-BE49-F238E27FC236}">
-                <a16:creationId xmlns:a16="http://schemas.microsoft.com/office/drawing/2014/main" id="{8BD020D5-ACC3-4920-9871-91C9BE40B273}"/>
+                <a16:creationId xmlns:a16="http://schemas.microsoft.com/office/drawing/2014/main" id="{0B2987A9-BD45-46C3-9CFD-B4B00EC4718E}"/>
               </a:ext>
             </a:extLst>
           </p:cNvPr>
@@ -14556,7 +14556,7 @@
           <p:cNvPr id="60" name="PlaceHolder 2">
             <a:extLst xmlns:a="http://schemas.openxmlformats.org/drawingml/2006/main">
               <a:ext uri="{FF2B5EF4-FFF2-40B4-BE49-F238E27FC236}">
-                <a16:creationId xmlns:a16="http://schemas.microsoft.com/office/drawing/2014/main" id="{F92309D7-6293-4888-83F1-4349ECD9FF1C}"/>
+                <a16:creationId xmlns:a16="http://schemas.microsoft.com/office/drawing/2014/main" id="{B56D9622-DFFB-4B50-BB0E-FCE07E6352A6}"/>
               </a:ext>
             </a:extLst>
           </p:cNvPr>
@@ -14918,7 +14918,7 @@
           <p:cNvPr id="61" name="White.Strip.Footer">
             <a:extLst xmlns:a="http://schemas.openxmlformats.org/drawingml/2006/main">
               <a:ext uri="{FF2B5EF4-FFF2-40B4-BE49-F238E27FC236}">
-                <a16:creationId xmlns:a16="http://schemas.microsoft.com/office/drawing/2014/main" id="{4F5E1E17-24D9-4BD3-BE21-135A30BA3FD4}"/>
+                <a16:creationId xmlns:a16="http://schemas.microsoft.com/office/drawing/2014/main" id="{91DE9D89-42C7-48A5-A82F-B070809D01BF}"/>
               </a:ext>
             </a:extLst>
           </p:cNvPr>
@@ -14982,7 +14982,7 @@
           <p:cNvPr id="62" name="Footer">
             <a:extLst xmlns:a="http://schemas.openxmlformats.org/drawingml/2006/main">
               <a:ext uri="{FF2B5EF4-FFF2-40B4-BE49-F238E27FC236}">
-                <a16:creationId xmlns:a16="http://schemas.microsoft.com/office/drawing/2014/main" id="{05F249FB-9F1F-472C-9C8A-93F2FCF9F3DF}"/>
+                <a16:creationId xmlns:a16="http://schemas.microsoft.com/office/drawing/2014/main" id="{A48B5308-0149-4C53-BD0C-CD74A91DE841}"/>
               </a:ext>
             </a:extLst>
           </p:cNvPr>
@@ -15063,7 +15063,7 @@
           <p:cNvPr id="64" name="White.Banner.Top">
             <a:extLst xmlns:a="http://schemas.openxmlformats.org/drawingml/2006/main">
               <a:ext uri="{FF2B5EF4-FFF2-40B4-BE49-F238E27FC236}">
-                <a16:creationId xmlns:a16="http://schemas.microsoft.com/office/drawing/2014/main" id="{2D2C196C-1B63-46BA-BBB8-2F3CCADFFFA1}"/>
+                <a16:creationId xmlns:a16="http://schemas.microsoft.com/office/drawing/2014/main" id="{94CABEBA-7D6C-4F0E-8B9E-B99B2F706FDC}"/>
               </a:ext>
             </a:extLst>
           </p:cNvPr>
@@ -15152,7 +15152,7 @@
           <p:cNvPr id="66" name="Rectangle 17">
             <a:extLst xmlns:a="http://schemas.openxmlformats.org/drawingml/2006/main">
               <a:ext uri="{FF2B5EF4-FFF2-40B4-BE49-F238E27FC236}">
-                <a16:creationId xmlns:a16="http://schemas.microsoft.com/office/drawing/2014/main" id="{6E327B49-188B-4CD4-BC77-9362DAFC9789}"/>
+                <a16:creationId xmlns:a16="http://schemas.microsoft.com/office/drawing/2014/main" id="{6D8E6736-9B15-44CE-973E-D930750031A5}"/>
               </a:ext>
             </a:extLst>
           </p:cNvPr>
@@ -15219,7 +15219,7 @@
           <p:cNvPr id="67" name="Rectangle 18">
             <a:extLst xmlns:a="http://schemas.openxmlformats.org/drawingml/2006/main">
               <a:ext uri="{FF2B5EF4-FFF2-40B4-BE49-F238E27FC236}">
-                <a16:creationId xmlns:a16="http://schemas.microsoft.com/office/drawing/2014/main" id="{3A5A543B-0CE3-4680-842F-B3E149DE4117}"/>
+                <a16:creationId xmlns:a16="http://schemas.microsoft.com/office/drawing/2014/main" id="{500787F3-23DE-4EF8-831E-852B4ED37A87}"/>
               </a:ext>
             </a:extLst>
           </p:cNvPr>
@@ -15313,7 +15313,7 @@
           <p:cNvPr id="69" name="Rectangle 22">
             <a:extLst xmlns:a="http://schemas.openxmlformats.org/drawingml/2006/main">
               <a:ext uri="{FF2B5EF4-FFF2-40B4-BE49-F238E27FC236}">
-                <a16:creationId xmlns:a16="http://schemas.microsoft.com/office/drawing/2014/main" id="{0F6754E2-E9C8-4C55-906A-188D5DF7C1A7}"/>
+                <a16:creationId xmlns:a16="http://schemas.microsoft.com/office/drawing/2014/main" id="{CF3D08FD-8777-44B5-BE00-ACEB0867FB7E}"/>
               </a:ext>
             </a:extLst>
           </p:cNvPr>
@@ -15411,7 +15411,7 @@
           <p:nvPr/>
         </p:nvPicPr>
         <p:blipFill>
-          <a:blip xmlns:r="http://schemas.openxmlformats.org/officeDocument/2006/relationships" xmlns:a="http://schemas.openxmlformats.org/drawingml/2006/main" r:embed="Rc64092bf1fef4781"/>
+          <a:blip xmlns:r="http://schemas.openxmlformats.org/officeDocument/2006/relationships" xmlns:a="http://schemas.openxmlformats.org/drawingml/2006/main" r:embed="R09383c268bf04e6b"/>
           <a:stretch xmlns:a="http://schemas.openxmlformats.org/drawingml/2006/main"/>
         </p:blipFill>
         <p:spPr>
@@ -15432,7 +15432,7 @@
           <p:cNvPr id="72" name="PlaceHolder 1">
             <a:extLst xmlns:a="http://schemas.openxmlformats.org/drawingml/2006/main">
               <a:ext uri="{FF2B5EF4-FFF2-40B4-BE49-F238E27FC236}">
-                <a16:creationId xmlns:a16="http://schemas.microsoft.com/office/drawing/2014/main" id="{444E6FDA-3190-41AC-8373-D6FBFB36FC08}"/>
+                <a16:creationId xmlns:a16="http://schemas.microsoft.com/office/drawing/2014/main" id="{209F44FF-6CBD-45E1-9E79-58C5602E80E4}"/>
               </a:ext>
             </a:extLst>
           </p:cNvPr>
@@ -15496,7 +15496,7 @@
           <p:cNvPr id="73" name="PlaceHolder 2">
             <a:extLst xmlns:a="http://schemas.openxmlformats.org/drawingml/2006/main">
               <a:ext uri="{FF2B5EF4-FFF2-40B4-BE49-F238E27FC236}">
-                <a16:creationId xmlns:a16="http://schemas.microsoft.com/office/drawing/2014/main" id="{0425E3A9-F07E-427B-9CD3-B83C998476FA}"/>
+                <a16:creationId xmlns:a16="http://schemas.microsoft.com/office/drawing/2014/main" id="{0D86B4E5-E759-4A5E-9837-881F7FCB2B4A}"/>
               </a:ext>
             </a:extLst>
           </p:cNvPr>
@@ -15858,7 +15858,7 @@
           <p:cNvPr id="74" name="White.Strip.Footer">
             <a:extLst xmlns:a="http://schemas.openxmlformats.org/drawingml/2006/main">
               <a:ext uri="{FF2B5EF4-FFF2-40B4-BE49-F238E27FC236}">
-                <a16:creationId xmlns:a16="http://schemas.microsoft.com/office/drawing/2014/main" id="{4AD1DB0E-1410-4481-BE8B-50D2C3ADBE49}"/>
+                <a16:creationId xmlns:a16="http://schemas.microsoft.com/office/drawing/2014/main" id="{558278BF-E57F-4465-9307-D10DD6217A2D}"/>
               </a:ext>
             </a:extLst>
           </p:cNvPr>
@@ -15922,7 +15922,7 @@
           <p:cNvPr id="75" name="Footer">
             <a:extLst xmlns:a="http://schemas.openxmlformats.org/drawingml/2006/main">
               <a:ext uri="{FF2B5EF4-FFF2-40B4-BE49-F238E27FC236}">
-                <a16:creationId xmlns:a16="http://schemas.microsoft.com/office/drawing/2014/main" id="{F398DC40-F870-408C-807E-F0D343C43820}"/>
+                <a16:creationId xmlns:a16="http://schemas.microsoft.com/office/drawing/2014/main" id="{794F8FCA-6535-46E1-AA96-A3058200A6B3}"/>
               </a:ext>
             </a:extLst>
           </p:cNvPr>
@@ -16003,7 +16003,7 @@
           <p:cNvPr id="77" name="White.Banner.Top">
             <a:extLst xmlns:a="http://schemas.openxmlformats.org/drawingml/2006/main">
               <a:ext uri="{FF2B5EF4-FFF2-40B4-BE49-F238E27FC236}">
-                <a16:creationId xmlns:a16="http://schemas.microsoft.com/office/drawing/2014/main" id="{F61650EB-C279-4EFA-B42B-3E0A75798A01}"/>
+                <a16:creationId xmlns:a16="http://schemas.microsoft.com/office/drawing/2014/main" id="{13DD4E14-01E5-460E-B43F-1EB6149798BE}"/>
               </a:ext>
             </a:extLst>
           </p:cNvPr>
@@ -16092,7 +16092,7 @@
           <p:cNvPr id="79" name="Rectangle 17">
             <a:extLst xmlns:a="http://schemas.openxmlformats.org/drawingml/2006/main">
               <a:ext uri="{FF2B5EF4-FFF2-40B4-BE49-F238E27FC236}">
-                <a16:creationId xmlns:a16="http://schemas.microsoft.com/office/drawing/2014/main" id="{1A93693C-7727-42BB-8BBE-2EFC017C84AE}"/>
+                <a16:creationId xmlns:a16="http://schemas.microsoft.com/office/drawing/2014/main" id="{AE618EFA-1C01-459F-9C91-19EA61B9B659}"/>
               </a:ext>
             </a:extLst>
           </p:cNvPr>
@@ -16159,7 +16159,7 @@
           <p:cNvPr id="80" name="Rectangle 18">
             <a:extLst xmlns:a="http://schemas.openxmlformats.org/drawingml/2006/main">
               <a:ext uri="{FF2B5EF4-FFF2-40B4-BE49-F238E27FC236}">
-                <a16:creationId xmlns:a16="http://schemas.microsoft.com/office/drawing/2014/main" id="{F5B02E07-3DF4-4A5C-B5CE-604C3D3A8FF7}"/>
+                <a16:creationId xmlns:a16="http://schemas.microsoft.com/office/drawing/2014/main" id="{FD63C0CD-61A0-4901-996A-CCC79C280821}"/>
               </a:ext>
             </a:extLst>
           </p:cNvPr>
@@ -16253,7 +16253,7 @@
           <p:cNvPr id="82" name="Rectangle 22">
             <a:extLst xmlns:a="http://schemas.openxmlformats.org/drawingml/2006/main">
               <a:ext uri="{FF2B5EF4-FFF2-40B4-BE49-F238E27FC236}">
-                <a16:creationId xmlns:a16="http://schemas.microsoft.com/office/drawing/2014/main" id="{CB826947-5192-4C4F-8DEA-D693FF408B90}"/>
+                <a16:creationId xmlns:a16="http://schemas.microsoft.com/office/drawing/2014/main" id="{E059EE5C-E764-4ED4-99C6-6DA6D4825AF7}"/>
               </a:ext>
             </a:extLst>
           </p:cNvPr>
@@ -16351,7 +16351,7 @@
           <p:nvPr/>
         </p:nvPicPr>
         <p:blipFill>
-          <a:blip xmlns:r="http://schemas.openxmlformats.org/officeDocument/2006/relationships" xmlns:a="http://schemas.openxmlformats.org/drawingml/2006/main" r:embed="R911e0ace9fb2484e"/>
+          <a:blip xmlns:r="http://schemas.openxmlformats.org/officeDocument/2006/relationships" xmlns:a="http://schemas.openxmlformats.org/drawingml/2006/main" r:embed="R47fb3283f23b4174"/>
           <a:stretch xmlns:a="http://schemas.openxmlformats.org/drawingml/2006/main"/>
         </p:blipFill>
         <p:spPr>
@@ -16396,7 +16396,7 @@
           <p:cNvPr id="85" name="White.Strip.Footer">
             <a:extLst xmlns:a="http://schemas.openxmlformats.org/drawingml/2006/main">
               <a:ext uri="{FF2B5EF4-FFF2-40B4-BE49-F238E27FC236}">
-                <a16:creationId xmlns:a16="http://schemas.microsoft.com/office/drawing/2014/main" id="{BDD4767D-B35E-4300-9108-132A91BB4B56}"/>
+                <a16:creationId xmlns:a16="http://schemas.microsoft.com/office/drawing/2014/main" id="{249E9D82-61CD-4689-A4A9-B2611194F2AE}"/>
               </a:ext>
             </a:extLst>
           </p:cNvPr>
@@ -16460,7 +16460,7 @@
           <p:cNvPr id="86" name="Footer">
             <a:extLst xmlns:a="http://schemas.openxmlformats.org/drawingml/2006/main">
               <a:ext uri="{FF2B5EF4-FFF2-40B4-BE49-F238E27FC236}">
-                <a16:creationId xmlns:a16="http://schemas.microsoft.com/office/drawing/2014/main" id="{23C4F3C2-2B52-4E2D-B8F5-4EA72DB9FC33}"/>
+                <a16:creationId xmlns:a16="http://schemas.microsoft.com/office/drawing/2014/main" id="{B8A5EABA-4972-4333-813F-53802198D29F}"/>
               </a:ext>
             </a:extLst>
           </p:cNvPr>
@@ -16541,7 +16541,7 @@
           <p:cNvPr id="88" name="White.Banner.Top">
             <a:extLst xmlns:a="http://schemas.openxmlformats.org/drawingml/2006/main">
               <a:ext uri="{FF2B5EF4-FFF2-40B4-BE49-F238E27FC236}">
-                <a16:creationId xmlns:a16="http://schemas.microsoft.com/office/drawing/2014/main" id="{CAF3BA25-BC2F-4EC2-ADA7-875A186E6F2A}"/>
+                <a16:creationId xmlns:a16="http://schemas.microsoft.com/office/drawing/2014/main" id="{DD18B2EC-4C68-486B-B45D-3E459745ED43}"/>
               </a:ext>
             </a:extLst>
           </p:cNvPr>
@@ -16630,7 +16630,7 @@
           <p:cNvPr id="90" name="Rectangle 17">
             <a:extLst xmlns:a="http://schemas.openxmlformats.org/drawingml/2006/main">
               <a:ext uri="{FF2B5EF4-FFF2-40B4-BE49-F238E27FC236}">
-                <a16:creationId xmlns:a16="http://schemas.microsoft.com/office/drawing/2014/main" id="{02FBA29E-805E-42C4-B34E-6C1C4EEC3E4C}"/>
+                <a16:creationId xmlns:a16="http://schemas.microsoft.com/office/drawing/2014/main" id="{8DE24735-0969-40AF-AB12-74EFA0132D32}"/>
               </a:ext>
             </a:extLst>
           </p:cNvPr>
@@ -16697,7 +16697,7 @@
           <p:cNvPr id="91" name="Rectangle 18">
             <a:extLst xmlns:a="http://schemas.openxmlformats.org/drawingml/2006/main">
               <a:ext uri="{FF2B5EF4-FFF2-40B4-BE49-F238E27FC236}">
-                <a16:creationId xmlns:a16="http://schemas.microsoft.com/office/drawing/2014/main" id="{6D04722D-CE9F-4978-A3A2-D2C4564F7E3F}"/>
+                <a16:creationId xmlns:a16="http://schemas.microsoft.com/office/drawing/2014/main" id="{9DAC6EAC-8696-4EC7-8BB8-ED62C6BB3399}"/>
               </a:ext>
             </a:extLst>
           </p:cNvPr>
@@ -16791,7 +16791,7 @@
           <p:cNvPr id="93" name="Rectangle 22">
             <a:extLst xmlns:a="http://schemas.openxmlformats.org/drawingml/2006/main">
               <a:ext uri="{FF2B5EF4-FFF2-40B4-BE49-F238E27FC236}">
-                <a16:creationId xmlns:a16="http://schemas.microsoft.com/office/drawing/2014/main" id="{605364CE-5B78-42A7-A73A-5EC04CFCD488}"/>
+                <a16:creationId xmlns:a16="http://schemas.microsoft.com/office/drawing/2014/main" id="{7052C320-DBF3-4BB5-B6B7-7D348AE88778}"/>
               </a:ext>
             </a:extLst>
           </p:cNvPr>
@@ -16889,7 +16889,7 @@
           <p:nvPr/>
         </p:nvPicPr>
         <p:blipFill>
-          <a:blip xmlns:r="http://schemas.openxmlformats.org/officeDocument/2006/relationships" xmlns:a="http://schemas.openxmlformats.org/drawingml/2006/main" r:embed="Ra487056fb221432c"/>
+          <a:blip xmlns:r="http://schemas.openxmlformats.org/officeDocument/2006/relationships" xmlns:a="http://schemas.openxmlformats.org/drawingml/2006/main" r:embed="R8a28fef13e6a433c"/>
           <a:stretch xmlns:a="http://schemas.openxmlformats.org/drawingml/2006/main"/>
         </p:blipFill>
         <p:spPr>
@@ -16934,7 +16934,7 @@
           <p:cNvPr id="96" name="White.Strip.Footer">
             <a:extLst xmlns:a="http://schemas.openxmlformats.org/drawingml/2006/main">
               <a:ext uri="{FF2B5EF4-FFF2-40B4-BE49-F238E27FC236}">
-                <a16:creationId xmlns:a16="http://schemas.microsoft.com/office/drawing/2014/main" id="{8462F0E4-6644-468C-A032-CDABB34C4A5C}"/>
+                <a16:creationId xmlns:a16="http://schemas.microsoft.com/office/drawing/2014/main" id="{57F2CF87-DF77-4F90-9BAE-49A2CAF80A65}"/>
               </a:ext>
             </a:extLst>
           </p:cNvPr>
@@ -16998,7 +16998,7 @@
           <p:cNvPr id="97" name="Footer">
             <a:extLst xmlns:a="http://schemas.openxmlformats.org/drawingml/2006/main">
               <a:ext uri="{FF2B5EF4-FFF2-40B4-BE49-F238E27FC236}">
-                <a16:creationId xmlns:a16="http://schemas.microsoft.com/office/drawing/2014/main" id="{6C612FFB-D132-411A-87D3-38CB2E728BCA}"/>
+                <a16:creationId xmlns:a16="http://schemas.microsoft.com/office/drawing/2014/main" id="{1CFA8776-5A1C-45A9-B5A2-5D359BAEC5F8}"/>
               </a:ext>
             </a:extLst>
           </p:cNvPr>
@@ -17079,7 +17079,7 @@
           <p:cNvPr id="99" name="White.Banner.Top">
             <a:extLst xmlns:a="http://schemas.openxmlformats.org/drawingml/2006/main">
               <a:ext uri="{FF2B5EF4-FFF2-40B4-BE49-F238E27FC236}">
-                <a16:creationId xmlns:a16="http://schemas.microsoft.com/office/drawing/2014/main" id="{907F8C93-4155-484F-BADC-A4180F24AB6F}"/>
+                <a16:creationId xmlns:a16="http://schemas.microsoft.com/office/drawing/2014/main" id="{2149F0C2-1F18-40D6-A7A3-5C1807AF04D9}"/>
               </a:ext>
             </a:extLst>
           </p:cNvPr>
@@ -17168,7 +17168,7 @@
           <p:cNvPr id="101" name="Rectangle 17">
             <a:extLst xmlns:a="http://schemas.openxmlformats.org/drawingml/2006/main">
               <a:ext uri="{FF2B5EF4-FFF2-40B4-BE49-F238E27FC236}">
-                <a16:creationId xmlns:a16="http://schemas.microsoft.com/office/drawing/2014/main" id="{7A23CD89-2A2E-46D1-A6D3-157DBC77DFD5}"/>
+                <a16:creationId xmlns:a16="http://schemas.microsoft.com/office/drawing/2014/main" id="{F8359B35-78B8-4603-9DC2-BA6015492D3C}"/>
               </a:ext>
             </a:extLst>
           </p:cNvPr>
@@ -17235,7 +17235,7 @@
           <p:cNvPr id="102" name="Rectangle 18">
             <a:extLst xmlns:a="http://schemas.openxmlformats.org/drawingml/2006/main">
               <a:ext uri="{FF2B5EF4-FFF2-40B4-BE49-F238E27FC236}">
-                <a16:creationId xmlns:a16="http://schemas.microsoft.com/office/drawing/2014/main" id="{5FE39887-8591-4D5A-9E0E-8D78149E50EF}"/>
+                <a16:creationId xmlns:a16="http://schemas.microsoft.com/office/drawing/2014/main" id="{83EC6A17-B835-46C7-BE0E-18034E9B6F94}"/>
               </a:ext>
             </a:extLst>
           </p:cNvPr>
@@ -17329,7 +17329,7 @@
           <p:cNvPr id="104" name="Rectangle 22">
             <a:extLst xmlns:a="http://schemas.openxmlformats.org/drawingml/2006/main">
               <a:ext uri="{FF2B5EF4-FFF2-40B4-BE49-F238E27FC236}">
-                <a16:creationId xmlns:a16="http://schemas.microsoft.com/office/drawing/2014/main" id="{A592044C-54F9-4746-8430-4619D6B42F88}"/>
+                <a16:creationId xmlns:a16="http://schemas.microsoft.com/office/drawing/2014/main" id="{067530ED-3305-43CC-8E01-9E990471EA26}"/>
               </a:ext>
             </a:extLst>
           </p:cNvPr>
@@ -17427,7 +17427,7 @@
           <p:nvPr/>
         </p:nvPicPr>
         <p:blipFill>
-          <a:blip xmlns:r="http://schemas.openxmlformats.org/officeDocument/2006/relationships" xmlns:a="http://schemas.openxmlformats.org/drawingml/2006/main" r:embed="Rdd88dcb0a3714329"/>
+          <a:blip xmlns:r="http://schemas.openxmlformats.org/officeDocument/2006/relationships" xmlns:a="http://schemas.openxmlformats.org/drawingml/2006/main" r:embed="Rb6481262f164462a"/>
           <a:stretch xmlns:a="http://schemas.openxmlformats.org/drawingml/2006/main"/>
         </p:blipFill>
         <p:spPr>
@@ -17464,28 +17464,28 @@
   </p:cSld>
   <p:clrMap bg1="lt1" tx1="dk1" bg2="lt2" tx2="dk2" accent1="accent1" accent2="accent2" accent3="accent3" accent4="accent4" accent5="accent5" accent6="accent6" hlink="hlink" folHlink="folHlink"/>
   <p:sldLayoutIdLst>
-    <p:sldLayoutId xmlns:r="http://schemas.openxmlformats.org/officeDocument/2006/relationships" id="2147483649" r:id="R8e8568c9c9994820"/>
-    <p:sldLayoutId xmlns:r="http://schemas.openxmlformats.org/officeDocument/2006/relationships" id="2147483650" r:id="R34de1d4d3f3644ea"/>
-    <p:sldLayoutId xmlns:r="http://schemas.openxmlformats.org/officeDocument/2006/relationships" id="2147483651" r:id="Rea4997ff20eb45c7"/>
-    <p:sldLayoutId xmlns:r="http://schemas.openxmlformats.org/officeDocument/2006/relationships" id="2147483652" r:id="R45e31f3876ba46c3"/>
-    <p:sldLayoutId xmlns:r="http://schemas.openxmlformats.org/officeDocument/2006/relationships" id="2147483653" r:id="R5c96410a52534198"/>
-    <p:sldLayoutId xmlns:r="http://schemas.openxmlformats.org/officeDocument/2006/relationships" id="2147483654" r:id="R562d627632684fd3"/>
-    <p:sldLayoutId xmlns:r="http://schemas.openxmlformats.org/officeDocument/2006/relationships" id="2147483655" r:id="R629ab60cab104d08"/>
-    <p:sldLayoutId xmlns:r="http://schemas.openxmlformats.org/officeDocument/2006/relationships" id="2147483656" r:id="R34ad87070ded4686"/>
-    <p:sldLayoutId xmlns:r="http://schemas.openxmlformats.org/officeDocument/2006/relationships" id="2147483657" r:id="R22b4eb54997449e8"/>
-    <p:sldLayoutId xmlns:r="http://schemas.openxmlformats.org/officeDocument/2006/relationships" id="2147483658" r:id="R0a678d8742f747a5"/>
-    <p:sldLayoutId xmlns:r="http://schemas.openxmlformats.org/officeDocument/2006/relationships" id="2147483659" r:id="Rc0f1900952c64ffb"/>
-    <p:sldLayoutId xmlns:r="http://schemas.openxmlformats.org/officeDocument/2006/relationships" id="2147483660" r:id="R12e075c252264dd1"/>
-    <p:sldLayoutId xmlns:r="http://schemas.openxmlformats.org/officeDocument/2006/relationships" id="2147483661" r:id="Ra5a2773e95bb49f6"/>
-    <p:sldLayoutId xmlns:r="http://schemas.openxmlformats.org/officeDocument/2006/relationships" id="2147483662" r:id="Re14aac06988641d1"/>
-    <p:sldLayoutId xmlns:r="http://schemas.openxmlformats.org/officeDocument/2006/relationships" id="2147483663" r:id="Rd6d4d55a9519465a"/>
-    <p:sldLayoutId xmlns:r="http://schemas.openxmlformats.org/officeDocument/2006/relationships" id="2147483664" r:id="R8d8cc61204d54649"/>
-    <p:sldLayoutId xmlns:r="http://schemas.openxmlformats.org/officeDocument/2006/relationships" id="2147483665" r:id="Rdb14e054408d4c85"/>
-    <p:sldLayoutId xmlns:r="http://schemas.openxmlformats.org/officeDocument/2006/relationships" id="2147483666" r:id="R68346cd114ea472e"/>
-    <p:sldLayoutId xmlns:r="http://schemas.openxmlformats.org/officeDocument/2006/relationships" id="2147483667" r:id="R650a45132c7b4b57"/>
-    <p:sldLayoutId xmlns:r="http://schemas.openxmlformats.org/officeDocument/2006/relationships" id="2147483668" r:id="R9097167488854f08"/>
-    <p:sldLayoutId xmlns:r="http://schemas.openxmlformats.org/officeDocument/2006/relationships" id="2147483669" r:id="R4d946495f71e4344"/>
-    <p:sldLayoutId xmlns:r="http://schemas.openxmlformats.org/officeDocument/2006/relationships" id="2147483670" r:id="Rce530fa94d8948bc"/>
+    <p:sldLayoutId xmlns:r="http://schemas.openxmlformats.org/officeDocument/2006/relationships" id="2147483649" r:id="R88f06c8b541846a8"/>
+    <p:sldLayoutId xmlns:r="http://schemas.openxmlformats.org/officeDocument/2006/relationships" id="2147483650" r:id="R12b7699d53ea4819"/>
+    <p:sldLayoutId xmlns:r="http://schemas.openxmlformats.org/officeDocument/2006/relationships" id="2147483651" r:id="R209fcf60cf244335"/>
+    <p:sldLayoutId xmlns:r="http://schemas.openxmlformats.org/officeDocument/2006/relationships" id="2147483652" r:id="Rf383f10ba8de49d3"/>
+    <p:sldLayoutId xmlns:r="http://schemas.openxmlformats.org/officeDocument/2006/relationships" id="2147483653" r:id="R9c6a412f8aa142d4"/>
+    <p:sldLayoutId xmlns:r="http://schemas.openxmlformats.org/officeDocument/2006/relationships" id="2147483654" r:id="R194680adc2dc4650"/>
+    <p:sldLayoutId xmlns:r="http://schemas.openxmlformats.org/officeDocument/2006/relationships" id="2147483655" r:id="R82cb6d24174b4586"/>
+    <p:sldLayoutId xmlns:r="http://schemas.openxmlformats.org/officeDocument/2006/relationships" id="2147483656" r:id="R151e95108f194b8a"/>
+    <p:sldLayoutId xmlns:r="http://schemas.openxmlformats.org/officeDocument/2006/relationships" id="2147483657" r:id="Rb1983eb520754717"/>
+    <p:sldLayoutId xmlns:r="http://schemas.openxmlformats.org/officeDocument/2006/relationships" id="2147483658" r:id="R2c3fed45ef344351"/>
+    <p:sldLayoutId xmlns:r="http://schemas.openxmlformats.org/officeDocument/2006/relationships" id="2147483659" r:id="R620d247c7f2741b1"/>
+    <p:sldLayoutId xmlns:r="http://schemas.openxmlformats.org/officeDocument/2006/relationships" id="2147483660" r:id="Raa486d2b53294f36"/>
+    <p:sldLayoutId xmlns:r="http://schemas.openxmlformats.org/officeDocument/2006/relationships" id="2147483661" r:id="R96729685d2074cac"/>
+    <p:sldLayoutId xmlns:r="http://schemas.openxmlformats.org/officeDocument/2006/relationships" id="2147483662" r:id="Re8732d8f419842b6"/>
+    <p:sldLayoutId xmlns:r="http://schemas.openxmlformats.org/officeDocument/2006/relationships" id="2147483663" r:id="Rd9d0ff2b70344ad5"/>
+    <p:sldLayoutId xmlns:r="http://schemas.openxmlformats.org/officeDocument/2006/relationships" id="2147483664" r:id="Rf716ac972fa14102"/>
+    <p:sldLayoutId xmlns:r="http://schemas.openxmlformats.org/officeDocument/2006/relationships" id="2147483665" r:id="Rad5a71cdaab74917"/>
+    <p:sldLayoutId xmlns:r="http://schemas.openxmlformats.org/officeDocument/2006/relationships" id="2147483666" r:id="R8c9d20c5816f483d"/>
+    <p:sldLayoutId xmlns:r="http://schemas.openxmlformats.org/officeDocument/2006/relationships" id="2147483667" r:id="Rc7e8836a938c4da3"/>
+    <p:sldLayoutId xmlns:r="http://schemas.openxmlformats.org/officeDocument/2006/relationships" id="2147483668" r:id="R1325eabc7fe44ae0"/>
+    <p:sldLayoutId xmlns:r="http://schemas.openxmlformats.org/officeDocument/2006/relationships" id="2147483669" r:id="Ree55af51a75f4f92"/>
+    <p:sldLayoutId xmlns:r="http://schemas.openxmlformats.org/officeDocument/2006/relationships" id="2147483670" r:id="R535b5aa16a8d47fa"/>
   </p:sldLayoutIdLst>
 </p:sldMaster>
 </file>
@@ -17507,13 +17507,13 @@
         <a:srgbClr val="FFFFFF"/>
       </a:lt2>
       <a:accent1>
-        <a:srgbClr val="18A303"/>
+        <a:srgbClr val="6B173D"/>
       </a:accent1>
       <a:accent2>
-        <a:srgbClr val="0369A3"/>
+        <a:srgbClr val="B79961"/>
       </a:accent2>
       <a:accent3>
-        <a:srgbClr val="A33E03"/>
+        <a:srgbClr val="B79961"/>
       </a:accent3>
       <a:accent4>
         <a:srgbClr val="8E03A3"/>
@@ -17621,7 +17621,7 @@
           <p:nvPr/>
         </p:nvPicPr>
         <p:blipFill>
-          <a:blip xmlns:r="http://schemas.openxmlformats.org/officeDocument/2006/relationships" xmlns:a="http://schemas.openxmlformats.org/drawingml/2006/main" r:embed="R6d1c49e35edd4402"/>
+          <a:blip xmlns:r="http://schemas.openxmlformats.org/officeDocument/2006/relationships" xmlns:a="http://schemas.openxmlformats.org/drawingml/2006/main" r:embed="R12aaf17569d5407a"/>
           <a:stretch xmlns:a="http://schemas.openxmlformats.org/drawingml/2006/main"/>
         </p:blipFill>
         <p:spPr>
@@ -17642,7 +17642,7 @@
           <p:cNvPr id="268" name="Rectangle 14">
             <a:extLst xmlns:a="http://schemas.openxmlformats.org/drawingml/2006/main">
               <a:ext uri="{FF2B5EF4-FFF2-40B4-BE49-F238E27FC236}">
-                <a16:creationId xmlns:a16="http://schemas.microsoft.com/office/drawing/2014/main" id="{BAB8695D-BCD7-4D63-8008-4F1C39B79B74}"/>
+                <a16:creationId xmlns:a16="http://schemas.microsoft.com/office/drawing/2014/main" id="{069AE2FB-E6C3-4584-B7DD-95D5BAC53EC2}"/>
               </a:ext>
             </a:extLst>
           </p:cNvPr>
@@ -17682,7 +17682,7 @@
                 <a:srgbClr val="000000"/>
               </a:gs>
               <a:gs pos="100000">
-                <a:srgbClr val="00194B"/>
+                <a:srgbClr val="6B173D"/>
               </a:gs>
             </a:gsLst>
             <a:lin ang="5400000"/>
@@ -17714,7 +17714,7 @@
           <p:cNvPr id="270" name="Rectangle">
             <a:extLst xmlns:a="http://schemas.openxmlformats.org/drawingml/2006/main">
               <a:ext uri="{FF2B5EF4-FFF2-40B4-BE49-F238E27FC236}">
-                <a16:creationId xmlns:a16="http://schemas.microsoft.com/office/drawing/2014/main" id="{E0260228-C888-4EBF-A8B0-BA616650A6DF}"/>
+                <a16:creationId xmlns:a16="http://schemas.microsoft.com/office/drawing/2014/main" id="{27A06D78-8176-437C-91E2-A78DA85632FE}"/>
               </a:ext>
             </a:extLst>
           </p:cNvPr>
@@ -17778,7 +17778,7 @@
           <p:cNvPr id="271" name="Rectangle">
             <a:extLst xmlns:a="http://schemas.openxmlformats.org/drawingml/2006/main">
               <a:ext uri="{FF2B5EF4-FFF2-40B4-BE49-F238E27FC236}">
-                <a16:creationId xmlns:a16="http://schemas.microsoft.com/office/drawing/2014/main" id="{2DF4D6B5-DB57-4AFF-A6A8-BF0864F23DB2}"/>
+                <a16:creationId xmlns:a16="http://schemas.microsoft.com/office/drawing/2014/main" id="{F3524E88-AB81-4CB2-B7C3-5ADF98DEED3D}"/>
               </a:ext>
             </a:extLst>
           </p:cNvPr>
@@ -17846,7 +17846,7 @@
           <p:nvPr/>
         </p:nvPicPr>
         <p:blipFill>
-          <a:blip xmlns:r="http://schemas.openxmlformats.org/officeDocument/2006/relationships" xmlns:a="http://schemas.openxmlformats.org/drawingml/2006/main" r:embed="R3778cd4a20c84e5d"/>
+          <a:blip xmlns:r="http://schemas.openxmlformats.org/officeDocument/2006/relationships" xmlns:a="http://schemas.openxmlformats.org/drawingml/2006/main" r:embed="Rc8b491bbe724458b"/>
           <a:stretch xmlns:a="http://schemas.openxmlformats.org/drawingml/2006/main"/>
         </p:blipFill>
         <p:spPr>
@@ -17867,7 +17867,7 @@
           <p:cNvPr id="273" name="Photo by ...">
             <a:extLst xmlns:a="http://schemas.openxmlformats.org/drawingml/2006/main">
               <a:ext uri="{FF2B5EF4-FFF2-40B4-BE49-F238E27FC236}">
-                <a16:creationId xmlns:a16="http://schemas.microsoft.com/office/drawing/2014/main" id="{EE53A088-3007-40B3-A562-8ECE370C2919}"/>
+                <a16:creationId xmlns:a16="http://schemas.microsoft.com/office/drawing/2014/main" id="{B7C6EAE7-E7B6-4028-968E-0CF5B714BC42}"/>
               </a:ext>
             </a:extLst>
           </p:cNvPr>
@@ -17920,7 +17920,7 @@
           <p:cNvPr id="274" name="PlaceHolder 1">
             <a:extLst xmlns:a="http://schemas.openxmlformats.org/drawingml/2006/main">
               <a:ext uri="{FF2B5EF4-FFF2-40B4-BE49-F238E27FC236}">
-                <a16:creationId xmlns:a16="http://schemas.microsoft.com/office/drawing/2014/main" id="{FAB66F60-2BB8-45F1-9E8C-2916FCE5D16F}"/>
+                <a16:creationId xmlns:a16="http://schemas.microsoft.com/office/drawing/2014/main" id="{84B4B463-2BDA-4A0A-9699-93BFBEE25265}"/>
               </a:ext>
             </a:extLst>
           </p:cNvPr>
@@ -18002,7 +18002,7 @@
     </p:spTree>
     <p:extLst>
       <p:ext uri="{BB962C8B-B14F-4D97-AF65-F5344CB8AC3E}">
-        <p14:creationId xmlns:p14="http://schemas.microsoft.com/office/powerpoint/2010/main" val="130961473"/>
+        <p14:creationId xmlns:p14="http://schemas.microsoft.com/office/powerpoint/2010/main" val="1580234188"/>
       </p:ext>
     </p:extLst>
   </p:cSld>
@@ -18033,7 +18033,7 @@
           <p:cNvPr id="11" name="">
             <a:extLst xmlns:a="http://schemas.openxmlformats.org/drawingml/2006/main">
               <a:ext uri="{FF2B5EF4-FFF2-40B4-BE49-F238E27FC236}">
-                <a16:creationId xmlns:a16="http://schemas.microsoft.com/office/drawing/2014/main" id="{C05C1E54-D57F-46BC-826B-AB58764F706F}"/>
+                <a16:creationId xmlns:a16="http://schemas.microsoft.com/office/drawing/2014/main" id="{380180C0-6BE7-4FBB-A665-ABCEABCE6D76}"/>
               </a:ext>
             </a:extLst>
           </p:cNvPr>
@@ -18063,14 +18063,14 @@
             <a:pPr algn="l">
               <a:defRPr sz="2550" b="1" i="0">
                 <a:solidFill>
-                  <a:srgbClr val="00132E"/>
+                  <a:srgbClr val="FFFFFF"/>
                 </a:solidFill>
               </a:defRPr>
             </a:pPr>
             <a:r>
               <a:rPr sz="2550" b="1" i="0">
                 <a:solidFill>
-                  <a:srgbClr val="00132E"/>
+                  <a:srgbClr val="FFFFFF"/>
                 </a:solidFill>
               </a:rPr>
               <a:t>Variable importance: from output to questions</a:t>
@@ -18083,7 +18083,7 @@
           <p:cNvPr id="2" name="">
             <a:extLst xmlns:a="http://schemas.openxmlformats.org/drawingml/2006/main">
               <a:ext uri="{FF2B5EF4-FFF2-40B4-BE49-F238E27FC236}">
-                <a16:creationId xmlns:a16="http://schemas.microsoft.com/office/drawing/2014/main" id="{D53D734E-BC6C-40F7-93E1-6A295B7B8C82}"/>
+                <a16:creationId xmlns:a16="http://schemas.microsoft.com/office/drawing/2014/main" id="{565D195A-4B24-4C3F-BC93-BE3E2B38131B}"/>
               </a:ext>
             </a:extLst>
           </p:cNvPr>
@@ -18113,14 +18113,14 @@
             <a:pPr algn="l">
               <a:defRPr sz="1350" b="0" i="0">
                 <a:solidFill>
-                  <a:srgbClr val="111111"/>
+                  <a:srgbClr val="FFFFFF"/>
                 </a:solidFill>
               </a:defRPr>
             </a:pPr>
             <a:r>
               <a:rPr sz="1350" b="0" i="0">
                 <a:solidFill>
-                  <a:srgbClr val="111111"/>
+                  <a:srgbClr val="FFFFFF"/>
                 </a:solidFill>
               </a:rPr>
               <a:t>Importance is model sensitivity, not biological proof.</a:t>
@@ -18137,7 +18137,7 @@
           <p:nvPr/>
         </p:nvPicPr>
         <p:blipFill>
-          <a:blip xmlns:r="http://schemas.openxmlformats.org/officeDocument/2006/relationships" xmlns:a="http://schemas.openxmlformats.org/drawingml/2006/main" r:embed="R59d7757a49874b0f"/>
+          <a:blip xmlns:r="http://schemas.openxmlformats.org/officeDocument/2006/relationships" xmlns:a="http://schemas.openxmlformats.org/drawingml/2006/main" r:embed="Ra41c5ac4dff8444f"/>
           <a:stretch xmlns:a="http://schemas.openxmlformats.org/drawingml/2006/main"/>
         </p:blipFill>
         <p:spPr>
@@ -18155,7 +18155,7 @@
           <p:cNvPr id="4" name="">
             <a:extLst xmlns:a="http://schemas.openxmlformats.org/drawingml/2006/main">
               <a:ext uri="{FF2B5EF4-FFF2-40B4-BE49-F238E27FC236}">
-                <a16:creationId xmlns:a16="http://schemas.microsoft.com/office/drawing/2014/main" id="{3C0F6CA6-0469-46F7-81B2-11A69279E07D}"/>
+                <a16:creationId xmlns:a16="http://schemas.microsoft.com/office/drawing/2014/main" id="{2891A357-4B57-4739-83A3-01B433E8EF06}"/>
               </a:ext>
             </a:extLst>
           </p:cNvPr>
@@ -18185,14 +18185,14 @@
             <a:pPr algn="l">
               <a:defRPr sz="2250" b="1" i="0">
                 <a:solidFill>
-                  <a:srgbClr val="006B28"/>
+                  <a:srgbClr val="6B173D"/>
                 </a:solidFill>
               </a:defRPr>
             </a:pPr>
             <a:r>
               <a:rPr sz="2250" b="1" i="0">
                 <a:solidFill>
-                  <a:srgbClr val="006B28"/>
+                  <a:srgbClr val="6B173D"/>
                 </a:solidFill>
               </a:rPr>
               <a:t>Ask</a:t>
@@ -18205,7 +18205,7 @@
           <p:cNvPr id="5" name="">
             <a:extLst xmlns:a="http://schemas.openxmlformats.org/drawingml/2006/main">
               <a:ext uri="{FF2B5EF4-FFF2-40B4-BE49-F238E27FC236}">
-                <a16:creationId xmlns:a16="http://schemas.microsoft.com/office/drawing/2014/main" id="{02702441-9551-444F-AA64-708726245E78}"/>
+                <a16:creationId xmlns:a16="http://schemas.microsoft.com/office/drawing/2014/main" id="{D2E04F39-8568-4564-8A08-E98DBB0B2BC8}"/>
               </a:ext>
             </a:extLst>
           </p:cNvPr>
@@ -18223,7 +18223,7 @@
             <a:avLst/>
           </a:prstGeom>
           <a:solidFill xmlns:a="http://schemas.openxmlformats.org/drawingml/2006/main">
-            <a:srgbClr val="E35D2F"/>
+            <a:srgbClr val="B79961"/>
           </a:solidFill>
           <a:ln xmlns:a="http://schemas.openxmlformats.org/drawingml/2006/main" w="0">
             <a:noFill/>
@@ -18236,7 +18236,7 @@
           <p:cNvPr id="6" name="">
             <a:extLst xmlns:a="http://schemas.openxmlformats.org/drawingml/2006/main">
               <a:ext uri="{FF2B5EF4-FFF2-40B4-BE49-F238E27FC236}">
-                <a16:creationId xmlns:a16="http://schemas.microsoft.com/office/drawing/2014/main" id="{F3A959B6-0C3F-4217-8D1C-CC9D5B49159D}"/>
+                <a16:creationId xmlns:a16="http://schemas.microsoft.com/office/drawing/2014/main" id="{CEB74E17-F546-4CE4-8A87-534904738F53}"/>
               </a:ext>
             </a:extLst>
           </p:cNvPr>
@@ -18286,7 +18286,7 @@
           <p:cNvPr id="7" name="">
             <a:extLst xmlns:a="http://schemas.openxmlformats.org/drawingml/2006/main">
               <a:ext uri="{FF2B5EF4-FFF2-40B4-BE49-F238E27FC236}">
-                <a16:creationId xmlns:a16="http://schemas.microsoft.com/office/drawing/2014/main" id="{412FC6E9-B01B-4DB1-A691-79D9ACACBB4E}"/>
+                <a16:creationId xmlns:a16="http://schemas.microsoft.com/office/drawing/2014/main" id="{5259E108-BA95-42F7-88FB-53A3792376BF}"/>
               </a:ext>
             </a:extLst>
           </p:cNvPr>
@@ -18304,7 +18304,7 @@
             <a:avLst/>
           </a:prstGeom>
           <a:solidFill xmlns:a="http://schemas.openxmlformats.org/drawingml/2006/main">
-            <a:srgbClr val="E35D2F"/>
+            <a:srgbClr val="B79961"/>
           </a:solidFill>
           <a:ln xmlns:a="http://schemas.openxmlformats.org/drawingml/2006/main" w="0">
             <a:noFill/>
@@ -18317,7 +18317,7 @@
           <p:cNvPr id="8" name="">
             <a:extLst xmlns:a="http://schemas.openxmlformats.org/drawingml/2006/main">
               <a:ext uri="{FF2B5EF4-FFF2-40B4-BE49-F238E27FC236}">
-                <a16:creationId xmlns:a16="http://schemas.microsoft.com/office/drawing/2014/main" id="{28C053B5-18A6-4683-BB3F-67B02152B476}"/>
+                <a16:creationId xmlns:a16="http://schemas.microsoft.com/office/drawing/2014/main" id="{D20326B2-4F09-462C-A348-E45432141D20}"/>
               </a:ext>
             </a:extLst>
           </p:cNvPr>
@@ -18367,7 +18367,7 @@
           <p:cNvPr id="9" name="">
             <a:extLst xmlns:a="http://schemas.openxmlformats.org/drawingml/2006/main">
               <a:ext uri="{FF2B5EF4-FFF2-40B4-BE49-F238E27FC236}">
-                <a16:creationId xmlns:a16="http://schemas.microsoft.com/office/drawing/2014/main" id="{E1BFD3D8-1A93-4F89-8396-24CD07BCCF6E}"/>
+                <a16:creationId xmlns:a16="http://schemas.microsoft.com/office/drawing/2014/main" id="{F97A66A7-63B6-41A0-BB9F-3390B979B752}"/>
               </a:ext>
             </a:extLst>
           </p:cNvPr>
@@ -18385,7 +18385,7 @@
             <a:avLst/>
           </a:prstGeom>
           <a:solidFill xmlns:a="http://schemas.openxmlformats.org/drawingml/2006/main">
-            <a:srgbClr val="E35D2F"/>
+            <a:srgbClr val="B79961"/>
           </a:solidFill>
           <a:ln xmlns:a="http://schemas.openxmlformats.org/drawingml/2006/main" w="0">
             <a:noFill/>
@@ -18398,7 +18398,7 @@
           <p:cNvPr id="10" name="">
             <a:extLst xmlns:a="http://schemas.openxmlformats.org/drawingml/2006/main">
               <a:ext uri="{FF2B5EF4-FFF2-40B4-BE49-F238E27FC236}">
-                <a16:creationId xmlns:a16="http://schemas.microsoft.com/office/drawing/2014/main" id="{A929B1E6-7698-4B14-9F16-BFAA834C7186}"/>
+                <a16:creationId xmlns:a16="http://schemas.microsoft.com/office/drawing/2014/main" id="{1FFF4A25-2324-44BC-A118-49427A68B2BD}"/>
               </a:ext>
             </a:extLst>
           </p:cNvPr>
@@ -18446,7 +18446,7 @@
     </p:spTree>
     <p:extLst>
       <p:ext uri="{BB962C8B-B14F-4D97-AF65-F5344CB8AC3E}">
-        <p14:creationId xmlns:p14="http://schemas.microsoft.com/office/powerpoint/2010/main" val="1093942105"/>
+        <p14:creationId xmlns:p14="http://schemas.microsoft.com/office/powerpoint/2010/main" val="184329128"/>
       </p:ext>
     </p:extLst>
   </p:cSld>
@@ -18477,7 +18477,7 @@
           <p:cNvPr id="7" name="">
             <a:extLst xmlns:a="http://schemas.openxmlformats.org/drawingml/2006/main">
               <a:ext uri="{FF2B5EF4-FFF2-40B4-BE49-F238E27FC236}">
-                <a16:creationId xmlns:a16="http://schemas.microsoft.com/office/drawing/2014/main" id="{4DD23BA4-6AEC-448C-B64D-53F503629810}"/>
+                <a16:creationId xmlns:a16="http://schemas.microsoft.com/office/drawing/2014/main" id="{17344300-35EB-4B2C-A163-3FA708F9AD94}"/>
               </a:ext>
             </a:extLst>
           </p:cNvPr>
@@ -18507,14 +18507,14 @@
             <a:pPr algn="l">
               <a:defRPr sz="2550" b="1" i="0">
                 <a:solidFill>
-                  <a:srgbClr val="00132E"/>
+                  <a:srgbClr val="FFFFFF"/>
                 </a:solidFill>
               </a:defRPr>
             </a:pPr>
             <a:r>
               <a:rPr sz="2550" b="1" i="0">
                 <a:solidFill>
-                  <a:srgbClr val="00132E"/>
+                  <a:srgbClr val="FFFFFF"/>
                 </a:solidFill>
               </a:rPr>
               <a:t>Ensembles and projections make choices visible</a:t>
@@ -18527,7 +18527,7 @@
           <p:cNvPr id="2" name="">
             <a:extLst xmlns:a="http://schemas.openxmlformats.org/drawingml/2006/main">
               <a:ext uri="{FF2B5EF4-FFF2-40B4-BE49-F238E27FC236}">
-                <a16:creationId xmlns:a16="http://schemas.microsoft.com/office/drawing/2014/main" id="{5AB0CCBC-9890-4B73-BB56-3E4BF7241B5A}"/>
+                <a16:creationId xmlns:a16="http://schemas.microsoft.com/office/drawing/2014/main" id="{72306A56-22C8-4756-A2F1-B973C90053C3}"/>
               </a:ext>
             </a:extLst>
           </p:cNvPr>
@@ -18557,14 +18557,14 @@
             <a:pPr algn="l">
               <a:defRPr sz="1350" b="0" i="0">
                 <a:solidFill>
-                  <a:srgbClr val="111111"/>
+                  <a:srgbClr val="FFFFFF"/>
                 </a:solidFill>
               </a:defRPr>
             </a:pPr>
             <a:r>
               <a:rPr sz="1350" b="0" i="0">
                 <a:solidFill>
-                  <a:srgbClr val="111111"/>
+                  <a:srgbClr val="FFFFFF"/>
                 </a:solidFill>
               </a:rPr>
               <a:t>The map is a synthesis of model behaviour across Brazil.</a:t>
@@ -18581,7 +18581,7 @@
           <p:nvPr/>
         </p:nvPicPr>
         <p:blipFill>
-          <a:blip xmlns:r="http://schemas.openxmlformats.org/officeDocument/2006/relationships" xmlns:a="http://schemas.openxmlformats.org/drawingml/2006/main" r:embed="R0efb3cdbd63645ea"/>
+          <a:blip xmlns:r="http://schemas.openxmlformats.org/officeDocument/2006/relationships" xmlns:a="http://schemas.openxmlformats.org/drawingml/2006/main" r:embed="R9a4397835c47471b"/>
           <a:stretch xmlns:a="http://schemas.openxmlformats.org/drawingml/2006/main"/>
         </p:blipFill>
         <p:spPr>
@@ -18603,7 +18603,7 @@
           <p:nvPr/>
         </p:nvPicPr>
         <p:blipFill>
-          <a:blip xmlns:r="http://schemas.openxmlformats.org/officeDocument/2006/relationships" xmlns:a="http://schemas.openxmlformats.org/drawingml/2006/main" r:embed="Rcab0d97f007e40e6"/>
+          <a:blip xmlns:r="http://schemas.openxmlformats.org/officeDocument/2006/relationships" xmlns:a="http://schemas.openxmlformats.org/drawingml/2006/main" r:embed="Rf098b6793501475a"/>
           <a:stretch xmlns:a="http://schemas.openxmlformats.org/drawingml/2006/main"/>
         </p:blipFill>
         <p:spPr>
@@ -18621,7 +18621,7 @@
           <p:cNvPr id="5" name="">
             <a:extLst xmlns:a="http://schemas.openxmlformats.org/drawingml/2006/main">
               <a:ext uri="{FF2B5EF4-FFF2-40B4-BE49-F238E27FC236}">
-                <a16:creationId xmlns:a16="http://schemas.microsoft.com/office/drawing/2014/main" id="{CADACE69-66E7-45EB-8A0F-5F7C807E8A55}"/>
+                <a16:creationId xmlns:a16="http://schemas.microsoft.com/office/drawing/2014/main" id="{F7FE50DD-0FC0-4501-B017-5666F7FC5F48}"/>
               </a:ext>
             </a:extLst>
           </p:cNvPr>
@@ -18651,14 +18651,14 @@
             <a:pPr algn="ctr">
               <a:defRPr sz="1500" b="1" i="0">
                 <a:solidFill>
-                  <a:srgbClr val="006B28"/>
+                  <a:srgbClr val="6B173D"/>
                 </a:solidFill>
               </a:defRPr>
             </a:pPr>
             <a:r>
               <a:rPr sz="1500" b="1" i="0">
                 <a:solidFill>
-                  <a:srgbClr val="006B28"/>
+                  <a:srgbClr val="6B173D"/>
                 </a:solidFill>
               </a:rPr>
               <a:t>individual model average</a:t>
@@ -18671,7 +18671,7 @@
           <p:cNvPr id="6" name="">
             <a:extLst xmlns:a="http://schemas.openxmlformats.org/drawingml/2006/main">
               <a:ext uri="{FF2B5EF4-FFF2-40B4-BE49-F238E27FC236}">
-                <a16:creationId xmlns:a16="http://schemas.microsoft.com/office/drawing/2014/main" id="{5F26096A-303C-4B38-AE9E-D0B124507306}"/>
+                <a16:creationId xmlns:a16="http://schemas.microsoft.com/office/drawing/2014/main" id="{7BD5F591-55BA-4A46-B32D-E48E9CC16214}"/>
               </a:ext>
             </a:extLst>
           </p:cNvPr>
@@ -18701,14 +18701,14 @@
             <a:pPr algn="ctr">
               <a:defRPr sz="1500" b="1" i="0">
                 <a:solidFill>
-                  <a:srgbClr val="006B28"/>
+                  <a:srgbClr val="6B173D"/>
                 </a:solidFill>
               </a:defRPr>
             </a:pPr>
             <a:r>
               <a:rPr sz="1500" b="1" i="0">
                 <a:solidFill>
-                  <a:srgbClr val="006B28"/>
+                  <a:srgbClr val="6B173D"/>
                 </a:solidFill>
               </a:rPr>
               <a:t>ensemble projection</a:t>
@@ -18719,7 +18719,7 @@
     </p:spTree>
     <p:extLst>
       <p:ext uri="{BB962C8B-B14F-4D97-AF65-F5344CB8AC3E}">
-        <p14:creationId xmlns:p14="http://schemas.microsoft.com/office/powerpoint/2010/main" val="1093942105"/>
+        <p14:creationId xmlns:p14="http://schemas.microsoft.com/office/powerpoint/2010/main" val="184329128"/>
       </p:ext>
     </p:extLst>
   </p:cSld>
@@ -18750,7 +18750,7 @@
           <p:cNvPr id="15" name="">
             <a:extLst xmlns:a="http://schemas.openxmlformats.org/drawingml/2006/main">
               <a:ext uri="{FF2B5EF4-FFF2-40B4-BE49-F238E27FC236}">
-                <a16:creationId xmlns:a16="http://schemas.microsoft.com/office/drawing/2014/main" id="{4C9F2C41-CF2A-4D2C-8F12-9900759F5037}"/>
+                <a16:creationId xmlns:a16="http://schemas.microsoft.com/office/drawing/2014/main" id="{5D5D611E-FBD4-4CB9-81FC-150E9BB7F815}"/>
               </a:ext>
             </a:extLst>
           </p:cNvPr>
@@ -18780,14 +18780,14 @@
             <a:pPr algn="l">
               <a:defRPr sz="2550" b="1" i="0">
                 <a:solidFill>
-                  <a:srgbClr val="00132E"/>
+                  <a:srgbClr val="FFFFFF"/>
                 </a:solidFill>
               </a:defRPr>
             </a:pPr>
             <a:r>
               <a:rPr sz="2550" b="1" i="0">
                 <a:solidFill>
-                  <a:srgbClr val="00132E"/>
+                  <a:srgbClr val="FFFFFF"/>
                 </a:solidFill>
               </a:rPr>
               <a:t>A good SDM should sharpen the next conversation</a:t>
@@ -18800,7 +18800,7 @@
           <p:cNvPr id="2" name="">
             <a:extLst xmlns:a="http://schemas.openxmlformats.org/drawingml/2006/main">
               <a:ext uri="{FF2B5EF4-FFF2-40B4-BE49-F238E27FC236}">
-                <a16:creationId xmlns:a16="http://schemas.microsoft.com/office/drawing/2014/main" id="{EB28AEBF-D247-488A-9AF4-6F4B8D3A0D01}"/>
+                <a16:creationId xmlns:a16="http://schemas.microsoft.com/office/drawing/2014/main" id="{AC07E247-DFE3-4432-B827-48AB8FE0BEE2}"/>
               </a:ext>
             </a:extLst>
           </p:cNvPr>
@@ -18830,14 +18830,14 @@
             <a:pPr algn="l">
               <a:defRPr sz="1350" b="0" i="0">
                 <a:solidFill>
-                  <a:srgbClr val="111111"/>
+                  <a:srgbClr val="FFFFFF"/>
                 </a:solidFill>
               </a:defRPr>
             </a:pPr>
             <a:r>
               <a:rPr sz="1350" b="0" i="0">
                 <a:solidFill>
-                  <a:srgbClr val="111111"/>
+                  <a:srgbClr val="FFFFFF"/>
                 </a:solidFill>
               </a:rPr>
               <a:t>Now we build the model line by line in R.</a:t>
@@ -18854,7 +18854,7 @@
           <p:nvPr/>
         </p:nvPicPr>
         <p:blipFill>
-          <a:blip xmlns:r="http://schemas.openxmlformats.org/officeDocument/2006/relationships" xmlns:a="http://schemas.openxmlformats.org/drawingml/2006/main" r:embed="Rc5353fa52add4813"/>
+          <a:blip xmlns:r="http://schemas.openxmlformats.org/officeDocument/2006/relationships" xmlns:a="http://schemas.openxmlformats.org/drawingml/2006/main" r:embed="R259937b4f9814902"/>
           <a:stretch xmlns:a="http://schemas.openxmlformats.org/drawingml/2006/main"/>
         </p:blipFill>
         <p:spPr>
@@ -18872,7 +18872,7 @@
           <p:cNvPr id="4" name="">
             <a:extLst xmlns:a="http://schemas.openxmlformats.org/drawingml/2006/main">
               <a:ext uri="{FF2B5EF4-FFF2-40B4-BE49-F238E27FC236}">
-                <a16:creationId xmlns:a16="http://schemas.microsoft.com/office/drawing/2014/main" id="{A9440229-A4EE-4242-8E89-73F74D265863}"/>
+                <a16:creationId xmlns:a16="http://schemas.microsoft.com/office/drawing/2014/main" id="{2887A2AE-F0F0-4A11-B702-4058649F44BF}"/>
               </a:ext>
             </a:extLst>
           </p:cNvPr>
@@ -18902,14 +18902,14 @@
             <a:pPr algn="l">
               <a:defRPr sz="2175" b="1" i="0">
                 <a:solidFill>
-                  <a:srgbClr val="006B28"/>
+                  <a:srgbClr val="6B173D"/>
                 </a:solidFill>
               </a:defRPr>
             </a:pPr>
             <a:r>
               <a:rPr sz="2175" b="1" i="0">
                 <a:solidFill>
-                  <a:srgbClr val="006B28"/>
+                  <a:srgbClr val="6B173D"/>
                 </a:solidFill>
               </a:rPr>
               <a:t>Before acting on a map, ask:</a:t>
@@ -18922,7 +18922,7 @@
           <p:cNvPr id="5" name="">
             <a:extLst xmlns:a="http://schemas.openxmlformats.org/drawingml/2006/main">
               <a:ext uri="{FF2B5EF4-FFF2-40B4-BE49-F238E27FC236}">
-                <a16:creationId xmlns:a16="http://schemas.microsoft.com/office/drawing/2014/main" id="{1695E3AC-1160-4F17-B029-A8DC361B0C75}"/>
+                <a16:creationId xmlns:a16="http://schemas.microsoft.com/office/drawing/2014/main" id="{10995534-0795-47C1-83CE-F000C31B7F50}"/>
               </a:ext>
             </a:extLst>
           </p:cNvPr>
@@ -18940,7 +18940,7 @@
             <a:avLst/>
           </a:prstGeom>
           <a:solidFill xmlns:a="http://schemas.openxmlformats.org/drawingml/2006/main">
-            <a:srgbClr val="E35D2F"/>
+            <a:srgbClr val="B79961"/>
           </a:solidFill>
           <a:ln xmlns:a="http://schemas.openxmlformats.org/drawingml/2006/main" w="0">
             <a:noFill/>
@@ -18953,7 +18953,7 @@
           <p:cNvPr id="6" name="">
             <a:extLst xmlns:a="http://schemas.openxmlformats.org/drawingml/2006/main">
               <a:ext uri="{FF2B5EF4-FFF2-40B4-BE49-F238E27FC236}">
-                <a16:creationId xmlns:a16="http://schemas.microsoft.com/office/drawing/2014/main" id="{4636AA46-1659-43CC-A961-C7F8BFC53BBD}"/>
+                <a16:creationId xmlns:a16="http://schemas.microsoft.com/office/drawing/2014/main" id="{FA4D50F3-1CB3-4A26-911E-5709FF9DE755}"/>
               </a:ext>
             </a:extLst>
           </p:cNvPr>
@@ -19003,7 +19003,7 @@
           <p:cNvPr id="7" name="">
             <a:extLst xmlns:a="http://schemas.openxmlformats.org/drawingml/2006/main">
               <a:ext uri="{FF2B5EF4-FFF2-40B4-BE49-F238E27FC236}">
-                <a16:creationId xmlns:a16="http://schemas.microsoft.com/office/drawing/2014/main" id="{40758DA8-2094-453F-825A-BFA298857F65}"/>
+                <a16:creationId xmlns:a16="http://schemas.microsoft.com/office/drawing/2014/main" id="{94686311-8F66-47AA-9EC2-F2D1D67199B0}"/>
               </a:ext>
             </a:extLst>
           </p:cNvPr>
@@ -19021,7 +19021,7 @@
             <a:avLst/>
           </a:prstGeom>
           <a:solidFill xmlns:a="http://schemas.openxmlformats.org/drawingml/2006/main">
-            <a:srgbClr val="E35D2F"/>
+            <a:srgbClr val="B79961"/>
           </a:solidFill>
           <a:ln xmlns:a="http://schemas.openxmlformats.org/drawingml/2006/main" w="0">
             <a:noFill/>
@@ -19034,7 +19034,7 @@
           <p:cNvPr id="8" name="">
             <a:extLst xmlns:a="http://schemas.openxmlformats.org/drawingml/2006/main">
               <a:ext uri="{FF2B5EF4-FFF2-40B4-BE49-F238E27FC236}">
-                <a16:creationId xmlns:a16="http://schemas.microsoft.com/office/drawing/2014/main" id="{216C8DC6-B9CF-4137-839E-59232B5C6793}"/>
+                <a16:creationId xmlns:a16="http://schemas.microsoft.com/office/drawing/2014/main" id="{FD5977AE-C795-4542-8CCC-7D3FCCAA006A}"/>
               </a:ext>
             </a:extLst>
           </p:cNvPr>
@@ -19084,7 +19084,7 @@
           <p:cNvPr id="9" name="">
             <a:extLst xmlns:a="http://schemas.openxmlformats.org/drawingml/2006/main">
               <a:ext uri="{FF2B5EF4-FFF2-40B4-BE49-F238E27FC236}">
-                <a16:creationId xmlns:a16="http://schemas.microsoft.com/office/drawing/2014/main" id="{EF7BB08E-33B9-41A0-B9D9-DC9E7842E5CC}"/>
+                <a16:creationId xmlns:a16="http://schemas.microsoft.com/office/drawing/2014/main" id="{8C966852-B1C7-4BF1-B4D3-A12955921AA1}"/>
               </a:ext>
             </a:extLst>
           </p:cNvPr>
@@ -19102,7 +19102,7 @@
             <a:avLst/>
           </a:prstGeom>
           <a:solidFill xmlns:a="http://schemas.openxmlformats.org/drawingml/2006/main">
-            <a:srgbClr val="E35D2F"/>
+            <a:srgbClr val="B79961"/>
           </a:solidFill>
           <a:ln xmlns:a="http://schemas.openxmlformats.org/drawingml/2006/main" w="0">
             <a:noFill/>
@@ -19115,7 +19115,7 @@
           <p:cNvPr id="10" name="">
             <a:extLst xmlns:a="http://schemas.openxmlformats.org/drawingml/2006/main">
               <a:ext uri="{FF2B5EF4-FFF2-40B4-BE49-F238E27FC236}">
-                <a16:creationId xmlns:a16="http://schemas.microsoft.com/office/drawing/2014/main" id="{9225CA48-E0CF-4111-A090-A3F05023D125}"/>
+                <a16:creationId xmlns:a16="http://schemas.microsoft.com/office/drawing/2014/main" id="{0BA2E966-962D-4DB7-AE4B-54F35140017E}"/>
               </a:ext>
             </a:extLst>
           </p:cNvPr>
@@ -19165,7 +19165,7 @@
           <p:cNvPr id="11" name="">
             <a:extLst xmlns:a="http://schemas.openxmlformats.org/drawingml/2006/main">
               <a:ext uri="{FF2B5EF4-FFF2-40B4-BE49-F238E27FC236}">
-                <a16:creationId xmlns:a16="http://schemas.microsoft.com/office/drawing/2014/main" id="{889E21AB-DB64-44F8-95C0-190850E702E7}"/>
+                <a16:creationId xmlns:a16="http://schemas.microsoft.com/office/drawing/2014/main" id="{0D18659D-1C07-40E1-9D4E-7DA86E58EDA1}"/>
               </a:ext>
             </a:extLst>
           </p:cNvPr>
@@ -19183,7 +19183,7 @@
             <a:avLst/>
           </a:prstGeom>
           <a:solidFill xmlns:a="http://schemas.openxmlformats.org/drawingml/2006/main">
-            <a:srgbClr val="E35D2F"/>
+            <a:srgbClr val="B79961"/>
           </a:solidFill>
           <a:ln xmlns:a="http://schemas.openxmlformats.org/drawingml/2006/main" w="0">
             <a:noFill/>
@@ -19196,7 +19196,7 @@
           <p:cNvPr id="12" name="">
             <a:extLst xmlns:a="http://schemas.openxmlformats.org/drawingml/2006/main">
               <a:ext uri="{FF2B5EF4-FFF2-40B4-BE49-F238E27FC236}">
-                <a16:creationId xmlns:a16="http://schemas.microsoft.com/office/drawing/2014/main" id="{2E0BF2AE-E085-48A8-A7E6-006533589569}"/>
+                <a16:creationId xmlns:a16="http://schemas.microsoft.com/office/drawing/2014/main" id="{9B6EAFDB-8A99-4B61-93E8-E9B48E123AF1}"/>
               </a:ext>
             </a:extLst>
           </p:cNvPr>
@@ -19246,7 +19246,7 @@
           <p:cNvPr id="13" name="">
             <a:extLst xmlns:a="http://schemas.openxmlformats.org/drawingml/2006/main">
               <a:ext uri="{FF2B5EF4-FFF2-40B4-BE49-F238E27FC236}">
-                <a16:creationId xmlns:a16="http://schemas.microsoft.com/office/drawing/2014/main" id="{A64F393B-6BEE-40C9-87C0-22E1A3ADDB67}"/>
+                <a16:creationId xmlns:a16="http://schemas.microsoft.com/office/drawing/2014/main" id="{6578E548-303F-4A52-B16A-0FA543D4488E}"/>
               </a:ext>
             </a:extLst>
           </p:cNvPr>
@@ -19264,7 +19264,7 @@
             <a:avLst/>
           </a:prstGeom>
           <a:solidFill xmlns:a="http://schemas.openxmlformats.org/drawingml/2006/main">
-            <a:srgbClr val="E35D2F"/>
+            <a:srgbClr val="B79961"/>
           </a:solidFill>
           <a:ln xmlns:a="http://schemas.openxmlformats.org/drawingml/2006/main" w="0">
             <a:noFill/>
@@ -19277,7 +19277,7 @@
           <p:cNvPr id="14" name="">
             <a:extLst xmlns:a="http://schemas.openxmlformats.org/drawingml/2006/main">
               <a:ext uri="{FF2B5EF4-FFF2-40B4-BE49-F238E27FC236}">
-                <a16:creationId xmlns:a16="http://schemas.microsoft.com/office/drawing/2014/main" id="{DB04F733-EC14-4486-A057-50130F11A96D}"/>
+                <a16:creationId xmlns:a16="http://schemas.microsoft.com/office/drawing/2014/main" id="{209A4581-161F-4553-B097-C34CAE83E1C6}"/>
               </a:ext>
             </a:extLst>
           </p:cNvPr>
@@ -19325,7 +19325,7 @@
     </p:spTree>
     <p:extLst>
       <p:ext uri="{BB962C8B-B14F-4D97-AF65-F5344CB8AC3E}">
-        <p14:creationId xmlns:p14="http://schemas.microsoft.com/office/powerpoint/2010/main" val="1093942105"/>
+        <p14:creationId xmlns:p14="http://schemas.microsoft.com/office/powerpoint/2010/main" val="184329128"/>
       </p:ext>
     </p:extLst>
   </p:cSld>
@@ -19356,7 +19356,7 @@
           <p:cNvPr id="11" name="">
             <a:extLst xmlns:a="http://schemas.openxmlformats.org/drawingml/2006/main">
               <a:ext uri="{FF2B5EF4-FFF2-40B4-BE49-F238E27FC236}">
-                <a16:creationId xmlns:a16="http://schemas.microsoft.com/office/drawing/2014/main" id="{D37A6DA6-34DE-4CA0-9027-4E13E2E5E922}"/>
+                <a16:creationId xmlns:a16="http://schemas.microsoft.com/office/drawing/2014/main" id="{09B6010A-CA9D-4126-8DFB-2BFAC55012C2}"/>
               </a:ext>
             </a:extLst>
           </p:cNvPr>
@@ -19386,14 +19386,14 @@
             <a:pPr algn="l">
               <a:defRPr sz="2550" b="1" i="0">
                 <a:solidFill>
-                  <a:srgbClr val="00132E"/>
+                  <a:srgbClr val="FFFFFF"/>
                 </a:solidFill>
               </a:defRPr>
             </a:pPr>
             <a:r>
               <a:rPr sz="2550" b="1" i="0">
                 <a:solidFill>
-                  <a:srgbClr val="00132E"/>
+                  <a:srgbClr val="FFFFFF"/>
                 </a:solidFill>
               </a:rPr>
               <a:t>What does a species distribution model do?</a:t>
@@ -19406,7 +19406,7 @@
           <p:cNvPr id="2" name="">
             <a:extLst xmlns:a="http://schemas.openxmlformats.org/drawingml/2006/main">
               <a:ext uri="{FF2B5EF4-FFF2-40B4-BE49-F238E27FC236}">
-                <a16:creationId xmlns:a16="http://schemas.microsoft.com/office/drawing/2014/main" id="{441A28DE-2E9C-4D1E-9BB8-843EC0D564C7}"/>
+                <a16:creationId xmlns:a16="http://schemas.microsoft.com/office/drawing/2014/main" id="{C123148F-2D45-4753-A1A9-A1AED3B116CC}"/>
               </a:ext>
             </a:extLst>
           </p:cNvPr>
@@ -19436,14 +19436,14 @@
             <a:pPr algn="l">
               <a:defRPr sz="1350" b="0" i="0">
                 <a:solidFill>
-                  <a:srgbClr val="111111"/>
+                  <a:srgbClr val="FFFFFF"/>
                 </a:solidFill>
               </a:defRPr>
             </a:pPr>
             <a:r>
               <a:rPr sz="1350" b="0" i="0">
                 <a:solidFill>
-                  <a:srgbClr val="111111"/>
+                  <a:srgbClr val="FFFFFF"/>
                 </a:solidFill>
               </a:rPr>
               <a:t>It links observed records to environmental conditions, then projects that relationship across space.</a:t>
@@ -19456,7 +19456,7 @@
           <p:cNvPr id="3" name="">
             <a:extLst xmlns:a="http://schemas.openxmlformats.org/drawingml/2006/main">
               <a:ext uri="{FF2B5EF4-FFF2-40B4-BE49-F238E27FC236}">
-                <a16:creationId xmlns:a16="http://schemas.microsoft.com/office/drawing/2014/main" id="{9CCDEDDE-59C2-4E47-B9B8-6293BBD03AD8}"/>
+                <a16:creationId xmlns:a16="http://schemas.microsoft.com/office/drawing/2014/main" id="{A1BDF85F-2138-46C3-A1A6-51667428532A}"/>
               </a:ext>
             </a:extLst>
           </p:cNvPr>
@@ -19486,14 +19486,14 @@
             <a:pPr algn="ctr">
               <a:defRPr sz="2250" b="1" i="0">
                 <a:solidFill>
-                  <a:srgbClr val="006B28"/>
+                  <a:srgbClr val="6B173D"/>
                 </a:solidFill>
               </a:defRPr>
             </a:pPr>
             <a:r>
               <a:rPr sz="2250" b="1" i="0">
                 <a:solidFill>
-                  <a:srgbClr val="006B28"/>
+                  <a:srgbClr val="6B173D"/>
                 </a:solidFill>
               </a:rPr>
               <a:t>Records</a:t>
@@ -19506,7 +19506,7 @@
           <p:cNvPr id="4" name="">
             <a:extLst xmlns:a="http://schemas.openxmlformats.org/drawingml/2006/main">
               <a:ext uri="{FF2B5EF4-FFF2-40B4-BE49-F238E27FC236}">
-                <a16:creationId xmlns:a16="http://schemas.microsoft.com/office/drawing/2014/main" id="{9646FC47-FFC6-465C-B9C0-554159C64768}"/>
+                <a16:creationId xmlns:a16="http://schemas.microsoft.com/office/drawing/2014/main" id="{38963E0F-17D0-4AE5-9FAC-1BA8FD4215B8}"/>
               </a:ext>
             </a:extLst>
           </p:cNvPr>
@@ -19556,7 +19556,7 @@
           <p:cNvPr id="5" name="">
             <a:extLst xmlns:a="http://schemas.openxmlformats.org/drawingml/2006/main">
               <a:ext uri="{FF2B5EF4-FFF2-40B4-BE49-F238E27FC236}">
-                <a16:creationId xmlns:a16="http://schemas.microsoft.com/office/drawing/2014/main" id="{8CE08F0C-23FC-4168-9D32-9240A8610739}"/>
+                <a16:creationId xmlns:a16="http://schemas.microsoft.com/office/drawing/2014/main" id="{6D71CE66-57CB-442A-891B-8AE320CCE7E9}"/>
               </a:ext>
             </a:extLst>
           </p:cNvPr>
@@ -19574,7 +19574,7 @@
             <a:avLst/>
           </a:prstGeom>
           <a:solidFill xmlns:a="http://schemas.openxmlformats.org/drawingml/2006/main">
-            <a:srgbClr val="08A000"/>
+            <a:srgbClr val="6B173D"/>
           </a:solidFill>
           <a:ln xmlns:a="http://schemas.openxmlformats.org/drawingml/2006/main" w="0">
             <a:noFill/>
@@ -19587,7 +19587,7 @@
           <p:cNvPr id="6" name="">
             <a:extLst xmlns:a="http://schemas.openxmlformats.org/drawingml/2006/main">
               <a:ext uri="{FF2B5EF4-FFF2-40B4-BE49-F238E27FC236}">
-                <a16:creationId xmlns:a16="http://schemas.microsoft.com/office/drawing/2014/main" id="{A8A83512-CFB3-4FA7-93A2-D2BF89E81AEC}"/>
+                <a16:creationId xmlns:a16="http://schemas.microsoft.com/office/drawing/2014/main" id="{D055A3D7-5574-4E9B-827F-3C2DE43FD384}"/>
               </a:ext>
             </a:extLst>
           </p:cNvPr>
@@ -19617,14 +19617,14 @@
             <a:pPr algn="ctr">
               <a:defRPr sz="2250" b="1" i="0">
                 <a:solidFill>
-                  <a:srgbClr val="006B28"/>
+                  <a:srgbClr val="6B173D"/>
                 </a:solidFill>
               </a:defRPr>
             </a:pPr>
             <a:r>
               <a:rPr sz="2250" b="1" i="0">
                 <a:solidFill>
-                  <a:srgbClr val="006B28"/>
+                  <a:srgbClr val="6B173D"/>
                 </a:solidFill>
               </a:rPr>
               <a:t>Environment</a:t>
@@ -19637,7 +19637,7 @@
           <p:cNvPr id="7" name="">
             <a:extLst xmlns:a="http://schemas.openxmlformats.org/drawingml/2006/main">
               <a:ext uri="{FF2B5EF4-FFF2-40B4-BE49-F238E27FC236}">
-                <a16:creationId xmlns:a16="http://schemas.microsoft.com/office/drawing/2014/main" id="{81708688-675B-4F59-9883-8DC90B08F8B8}"/>
+                <a16:creationId xmlns:a16="http://schemas.microsoft.com/office/drawing/2014/main" id="{BAE8C6F4-A61B-47B5-A273-AF46C04CBD1E}"/>
               </a:ext>
             </a:extLst>
           </p:cNvPr>
@@ -19687,7 +19687,7 @@
           <p:cNvPr id="8" name="">
             <a:extLst xmlns:a="http://schemas.openxmlformats.org/drawingml/2006/main">
               <a:ext uri="{FF2B5EF4-FFF2-40B4-BE49-F238E27FC236}">
-                <a16:creationId xmlns:a16="http://schemas.microsoft.com/office/drawing/2014/main" id="{EBEB24AA-C274-4045-BCED-F19CA7D78AB0}"/>
+                <a16:creationId xmlns:a16="http://schemas.microsoft.com/office/drawing/2014/main" id="{36617ACF-65C1-45EB-83A9-AF841FD252F4}"/>
               </a:ext>
             </a:extLst>
           </p:cNvPr>
@@ -19705,7 +19705,7 @@
             <a:avLst/>
           </a:prstGeom>
           <a:solidFill xmlns:a="http://schemas.openxmlformats.org/drawingml/2006/main">
-            <a:srgbClr val="08A000"/>
+            <a:srgbClr val="6B173D"/>
           </a:solidFill>
           <a:ln xmlns:a="http://schemas.openxmlformats.org/drawingml/2006/main" w="0">
             <a:noFill/>
@@ -19718,7 +19718,7 @@
           <p:cNvPr id="9" name="">
             <a:extLst xmlns:a="http://schemas.openxmlformats.org/drawingml/2006/main">
               <a:ext uri="{FF2B5EF4-FFF2-40B4-BE49-F238E27FC236}">
-                <a16:creationId xmlns:a16="http://schemas.microsoft.com/office/drawing/2014/main" id="{E02F1633-0040-47D2-959A-00F6159AAF81}"/>
+                <a16:creationId xmlns:a16="http://schemas.microsoft.com/office/drawing/2014/main" id="{1465B5B2-0EB4-444C-801D-1CF832C1E133}"/>
               </a:ext>
             </a:extLst>
           </p:cNvPr>
@@ -19748,14 +19748,14 @@
             <a:pPr algn="ctr">
               <a:defRPr sz="2250" b="1" i="0">
                 <a:solidFill>
-                  <a:srgbClr val="006B28"/>
+                  <a:srgbClr val="6B173D"/>
                 </a:solidFill>
               </a:defRPr>
             </a:pPr>
             <a:r>
               <a:rPr sz="2250" b="1" i="0">
                 <a:solidFill>
-                  <a:srgbClr val="006B28"/>
+                  <a:srgbClr val="6B173D"/>
                 </a:solidFill>
               </a:rPr>
               <a:t>Suitability</a:t>
@@ -19768,7 +19768,7 @@
           <p:cNvPr id="10" name="">
             <a:extLst xmlns:a="http://schemas.openxmlformats.org/drawingml/2006/main">
               <a:ext uri="{FF2B5EF4-FFF2-40B4-BE49-F238E27FC236}">
-                <a16:creationId xmlns:a16="http://schemas.microsoft.com/office/drawing/2014/main" id="{AA5CCC0B-81C3-47C7-ABC3-61A73F883F7F}"/>
+                <a16:creationId xmlns:a16="http://schemas.microsoft.com/office/drawing/2014/main" id="{BEC9FCF4-E87E-4BDF-870C-A4ABC251BD72}"/>
               </a:ext>
             </a:extLst>
           </p:cNvPr>
@@ -19833,7 +19833,7 @@
     </p:spTree>
     <p:extLst>
       <p:ext uri="{BB962C8B-B14F-4D97-AF65-F5344CB8AC3E}">
-        <p14:creationId xmlns:p14="http://schemas.microsoft.com/office/powerpoint/2010/main" val="1093942105"/>
+        <p14:creationId xmlns:p14="http://schemas.microsoft.com/office/powerpoint/2010/main" val="184329128"/>
       </p:ext>
     </p:extLst>
   </p:cSld>
@@ -19864,7 +19864,7 @@
           <p:cNvPr id="15" name="">
             <a:extLst xmlns:a="http://schemas.openxmlformats.org/drawingml/2006/main">
               <a:ext uri="{FF2B5EF4-FFF2-40B4-BE49-F238E27FC236}">
-                <a16:creationId xmlns:a16="http://schemas.microsoft.com/office/drawing/2014/main" id="{645DB9AA-C788-442C-9B3F-2EB068476FF9}"/>
+                <a16:creationId xmlns:a16="http://schemas.microsoft.com/office/drawing/2014/main" id="{0AC188DA-FBFE-454B-BBE9-51BCA9B8852E}"/>
               </a:ext>
             </a:extLst>
           </p:cNvPr>
@@ -19894,14 +19894,14 @@
             <a:pPr algn="l">
               <a:defRPr sz="2550" b="1" i="0">
                 <a:solidFill>
-                  <a:srgbClr val="00132E"/>
+                  <a:srgbClr val="FFFFFF"/>
                 </a:solidFill>
               </a:defRPr>
             </a:pPr>
             <a:r>
               <a:rPr sz="2550" b="1" i="0">
                 <a:solidFill>
-                  <a:srgbClr val="00132E"/>
+                  <a:srgbClr val="FFFFFF"/>
                 </a:solidFill>
               </a:rPr>
               <a:t>Suitability is not the same as distribution</a:t>
@@ -19914,7 +19914,7 @@
           <p:cNvPr id="2" name="">
             <a:extLst xmlns:a="http://schemas.openxmlformats.org/drawingml/2006/main">
               <a:ext uri="{FF2B5EF4-FFF2-40B4-BE49-F238E27FC236}">
-                <a16:creationId xmlns:a16="http://schemas.microsoft.com/office/drawing/2014/main" id="{C0C5190E-38D4-4E7A-8080-7DAE18A6F1E3}"/>
+                <a16:creationId xmlns:a16="http://schemas.microsoft.com/office/drawing/2014/main" id="{E9041E79-375D-407D-9EF0-72F38BF85CD3}"/>
               </a:ext>
             </a:extLst>
           </p:cNvPr>
@@ -19944,14 +19944,14 @@
             <a:pPr algn="l">
               <a:defRPr sz="1350" b="0" i="0">
                 <a:solidFill>
-                  <a:srgbClr val="111111"/>
+                  <a:srgbClr val="FFFFFF"/>
                 </a:solidFill>
               </a:defRPr>
             </a:pPr>
             <a:r>
               <a:rPr sz="1350" b="0" i="0">
                 <a:solidFill>
-                  <a:srgbClr val="111111"/>
+                  <a:srgbClr val="FFFFFF"/>
                 </a:solidFill>
               </a:rPr>
               <a:t>Species may fail to occupy all suitable habitat, and records may miss places where the species occurs.</a:t>
@@ -19964,7 +19964,7 @@
           <p:cNvPr id="3" name="">
             <a:extLst xmlns:a="http://schemas.openxmlformats.org/drawingml/2006/main">
               <a:ext uri="{FF2B5EF4-FFF2-40B4-BE49-F238E27FC236}">
-                <a16:creationId xmlns:a16="http://schemas.microsoft.com/office/drawing/2014/main" id="{6DC29600-0149-462B-837D-EBACF66F7A46}"/>
+                <a16:creationId xmlns:a16="http://schemas.microsoft.com/office/drawing/2014/main" id="{1890D588-DF38-4D87-9562-F60CE483B8A2}"/>
               </a:ext>
             </a:extLst>
           </p:cNvPr>
@@ -19982,7 +19982,7 @@
             <a:avLst/>
           </a:prstGeom>
           <a:solidFill xmlns:a="http://schemas.openxmlformats.org/drawingml/2006/main">
-            <a:srgbClr val="E35D2F"/>
+            <a:srgbClr val="B79961"/>
           </a:solidFill>
           <a:ln xmlns:a="http://schemas.openxmlformats.org/drawingml/2006/main" w="0">
             <a:noFill/>
@@ -19995,7 +19995,7 @@
           <p:cNvPr id="4" name="">
             <a:extLst xmlns:a="http://schemas.openxmlformats.org/drawingml/2006/main">
               <a:ext uri="{FF2B5EF4-FFF2-40B4-BE49-F238E27FC236}">
-                <a16:creationId xmlns:a16="http://schemas.microsoft.com/office/drawing/2014/main" id="{22FEF9E2-B289-4F1D-BB1B-9D0FF42CB97D}"/>
+                <a16:creationId xmlns:a16="http://schemas.microsoft.com/office/drawing/2014/main" id="{53982DA2-7B0A-40E7-8B45-59A6A246FCFA}"/>
               </a:ext>
             </a:extLst>
           </p:cNvPr>
@@ -20045,7 +20045,7 @@
           <p:cNvPr id="5" name="">
             <a:extLst xmlns:a="http://schemas.openxmlformats.org/drawingml/2006/main">
               <a:ext uri="{FF2B5EF4-FFF2-40B4-BE49-F238E27FC236}">
-                <a16:creationId xmlns:a16="http://schemas.microsoft.com/office/drawing/2014/main" id="{3BC4EFBC-C795-4B63-8CD6-7C483DDC13D8}"/>
+                <a16:creationId xmlns:a16="http://schemas.microsoft.com/office/drawing/2014/main" id="{FDC4CB20-C711-4D76-A303-44601550EBD8}"/>
               </a:ext>
             </a:extLst>
           </p:cNvPr>
@@ -20063,7 +20063,7 @@
             <a:avLst/>
           </a:prstGeom>
           <a:solidFill xmlns:a="http://schemas.openxmlformats.org/drawingml/2006/main">
-            <a:srgbClr val="E35D2F"/>
+            <a:srgbClr val="B79961"/>
           </a:solidFill>
           <a:ln xmlns:a="http://schemas.openxmlformats.org/drawingml/2006/main" w="0">
             <a:noFill/>
@@ -20076,7 +20076,7 @@
           <p:cNvPr id="6" name="">
             <a:extLst xmlns:a="http://schemas.openxmlformats.org/drawingml/2006/main">
               <a:ext uri="{FF2B5EF4-FFF2-40B4-BE49-F238E27FC236}">
-                <a16:creationId xmlns:a16="http://schemas.microsoft.com/office/drawing/2014/main" id="{68741022-9C09-41FC-93A0-E6DA9E107577}"/>
+                <a16:creationId xmlns:a16="http://schemas.microsoft.com/office/drawing/2014/main" id="{3B85338B-732C-45CD-93B2-D12A48F75AEE}"/>
               </a:ext>
             </a:extLst>
           </p:cNvPr>
@@ -20126,7 +20126,7 @@
           <p:cNvPr id="7" name="">
             <a:extLst xmlns:a="http://schemas.openxmlformats.org/drawingml/2006/main">
               <a:ext uri="{FF2B5EF4-FFF2-40B4-BE49-F238E27FC236}">
-                <a16:creationId xmlns:a16="http://schemas.microsoft.com/office/drawing/2014/main" id="{880C460A-6C48-422C-A2E8-EECBC8B6C144}"/>
+                <a16:creationId xmlns:a16="http://schemas.microsoft.com/office/drawing/2014/main" id="{CF0AF984-0933-41AA-BC74-CDE354FB1979}"/>
               </a:ext>
             </a:extLst>
           </p:cNvPr>
@@ -20144,7 +20144,7 @@
             <a:avLst/>
           </a:prstGeom>
           <a:solidFill xmlns:a="http://schemas.openxmlformats.org/drawingml/2006/main">
-            <a:srgbClr val="E35D2F"/>
+            <a:srgbClr val="B79961"/>
           </a:solidFill>
           <a:ln xmlns:a="http://schemas.openxmlformats.org/drawingml/2006/main" w="0">
             <a:noFill/>
@@ -20157,7 +20157,7 @@
           <p:cNvPr id="8" name="">
             <a:extLst xmlns:a="http://schemas.openxmlformats.org/drawingml/2006/main">
               <a:ext uri="{FF2B5EF4-FFF2-40B4-BE49-F238E27FC236}">
-                <a16:creationId xmlns:a16="http://schemas.microsoft.com/office/drawing/2014/main" id="{2AD92666-D105-4250-AC03-71B79A25D96B}"/>
+                <a16:creationId xmlns:a16="http://schemas.microsoft.com/office/drawing/2014/main" id="{9DA42DCF-A193-4AFD-9101-4ED7AFAE3DF8}"/>
               </a:ext>
             </a:extLst>
           </p:cNvPr>
@@ -20207,7 +20207,7 @@
           <p:cNvPr id="9" name="">
             <a:extLst xmlns:a="http://schemas.openxmlformats.org/drawingml/2006/main">
               <a:ext uri="{FF2B5EF4-FFF2-40B4-BE49-F238E27FC236}">
-                <a16:creationId xmlns:a16="http://schemas.microsoft.com/office/drawing/2014/main" id="{EE6B8338-F2BD-4EB0-AF97-19623E32A039}"/>
+                <a16:creationId xmlns:a16="http://schemas.microsoft.com/office/drawing/2014/main" id="{690A7E31-643D-44CB-B9FA-07DA4DCF8859}"/>
               </a:ext>
             </a:extLst>
           </p:cNvPr>
@@ -20225,7 +20225,7 @@
             <a:avLst/>
           </a:prstGeom>
           <a:solidFill xmlns:a="http://schemas.openxmlformats.org/drawingml/2006/main">
-            <a:srgbClr val="E35D2F"/>
+            <a:srgbClr val="B79961"/>
           </a:solidFill>
           <a:ln xmlns:a="http://schemas.openxmlformats.org/drawingml/2006/main" w="0">
             <a:noFill/>
@@ -20238,7 +20238,7 @@
           <p:cNvPr id="10" name="">
             <a:extLst xmlns:a="http://schemas.openxmlformats.org/drawingml/2006/main">
               <a:ext uri="{FF2B5EF4-FFF2-40B4-BE49-F238E27FC236}">
-                <a16:creationId xmlns:a16="http://schemas.microsoft.com/office/drawing/2014/main" id="{B615DAF2-E5A9-4694-AE2D-4CFBA30BF321}"/>
+                <a16:creationId xmlns:a16="http://schemas.microsoft.com/office/drawing/2014/main" id="{725AA1C5-95EE-43EE-8349-6D1BF0B2B758}"/>
               </a:ext>
             </a:extLst>
           </p:cNvPr>
@@ -20288,7 +20288,7 @@
           <p:cNvPr id="11" name="">
             <a:extLst xmlns:a="http://schemas.openxmlformats.org/drawingml/2006/main">
               <a:ext uri="{FF2B5EF4-FFF2-40B4-BE49-F238E27FC236}">
-                <a16:creationId xmlns:a16="http://schemas.microsoft.com/office/drawing/2014/main" id="{E58D8ED0-2CD2-41A3-B256-D50FC3D67EEB}"/>
+                <a16:creationId xmlns:a16="http://schemas.microsoft.com/office/drawing/2014/main" id="{B56C8B8B-179A-48C9-B11F-2AA92D0738BE}"/>
               </a:ext>
             </a:extLst>
           </p:cNvPr>
@@ -20306,11 +20306,11 @@
             <a:avLst/>
           </a:prstGeom>
           <a:solidFill xmlns:a="http://schemas.openxmlformats.org/drawingml/2006/main">
-            <a:srgbClr val="ECF7EA"/>
+            <a:srgbClr val="F8F5F7"/>
           </a:solidFill>
           <a:ln xmlns:a="http://schemas.openxmlformats.org/drawingml/2006/main" w="9525">
             <a:solidFill>
-              <a:srgbClr val="08A000"/>
+              <a:srgbClr val="6B173D"/>
             </a:solidFill>
             <a:prstDash val="solid"/>
           </a:ln>
@@ -20321,7 +20321,7 @@
           <p:cNvPr id="12" name="">
             <a:extLst xmlns:a="http://schemas.openxmlformats.org/drawingml/2006/main">
               <a:ext uri="{FF2B5EF4-FFF2-40B4-BE49-F238E27FC236}">
-                <a16:creationId xmlns:a16="http://schemas.microsoft.com/office/drawing/2014/main" id="{00C88F14-BEE7-4799-B821-61A9B8AB7BFA}"/>
+                <a16:creationId xmlns:a16="http://schemas.microsoft.com/office/drawing/2014/main" id="{4353CE7A-2EB3-4589-8256-48CE3D2400F4}"/>
               </a:ext>
             </a:extLst>
           </p:cNvPr>
@@ -20351,14 +20351,14 @@
             <a:pPr algn="ctr">
               <a:defRPr sz="2325" b="1" i="0">
                 <a:solidFill>
-                  <a:srgbClr val="006B28"/>
+                  <a:srgbClr val="6B173D"/>
                 </a:solidFill>
               </a:defRPr>
             </a:pPr>
             <a:r>
               <a:rPr sz="2325" b="1" i="0">
                 <a:solidFill>
-                  <a:srgbClr val="006B28"/>
+                  <a:srgbClr val="6B173D"/>
                 </a:solidFill>
               </a:rPr>
               <a:t>SDM output</a:t>
@@ -20371,7 +20371,7 @@
           <p:cNvPr id="13" name="">
             <a:extLst xmlns:a="http://schemas.openxmlformats.org/drawingml/2006/main">
               <a:ext uri="{FF2B5EF4-FFF2-40B4-BE49-F238E27FC236}">
-                <a16:creationId xmlns:a16="http://schemas.microsoft.com/office/drawing/2014/main" id="{0AC592CC-A74B-4D71-B08F-97532BE23127}"/>
+                <a16:creationId xmlns:a16="http://schemas.microsoft.com/office/drawing/2014/main" id="{7A55631C-D7D2-4F1C-9845-A853B9E5C2EE}"/>
               </a:ext>
             </a:extLst>
           </p:cNvPr>
@@ -20421,7 +20421,7 @@
           <p:cNvPr id="14" name="">
             <a:extLst xmlns:a="http://schemas.openxmlformats.org/drawingml/2006/main">
               <a:ext uri="{FF2B5EF4-FFF2-40B4-BE49-F238E27FC236}">
-                <a16:creationId xmlns:a16="http://schemas.microsoft.com/office/drawing/2014/main" id="{DF89C7E8-EE83-4CC3-89A6-F37E6E8309BE}"/>
+                <a16:creationId xmlns:a16="http://schemas.microsoft.com/office/drawing/2014/main" id="{093FBB75-41C0-4D02-8B3E-F1DCE4420467}"/>
               </a:ext>
             </a:extLst>
           </p:cNvPr>
@@ -20469,7 +20469,7 @@
     </p:spTree>
     <p:extLst>
       <p:ext uri="{BB962C8B-B14F-4D97-AF65-F5344CB8AC3E}">
-        <p14:creationId xmlns:p14="http://schemas.microsoft.com/office/powerpoint/2010/main" val="1093942105"/>
+        <p14:creationId xmlns:p14="http://schemas.microsoft.com/office/powerpoint/2010/main" val="184329128"/>
       </p:ext>
     </p:extLst>
   </p:cSld>
@@ -20500,7 +20500,7 @@
           <p:cNvPr id="12" name="">
             <a:extLst xmlns:a="http://schemas.openxmlformats.org/drawingml/2006/main">
               <a:ext uri="{FF2B5EF4-FFF2-40B4-BE49-F238E27FC236}">
-                <a16:creationId xmlns:a16="http://schemas.microsoft.com/office/drawing/2014/main" id="{AEFBAF3C-86AF-4059-9025-D7E5CD671895}"/>
+                <a16:creationId xmlns:a16="http://schemas.microsoft.com/office/drawing/2014/main" id="{D9D6219C-6283-47D4-AEFE-1936CDA9A60D}"/>
               </a:ext>
             </a:extLst>
           </p:cNvPr>
@@ -20530,14 +20530,14 @@
             <a:pPr algn="l">
               <a:defRPr sz="2550" b="1" i="0">
                 <a:solidFill>
-                  <a:srgbClr val="00132E"/>
+                  <a:srgbClr val="FFFFFF"/>
                 </a:solidFill>
               </a:defRPr>
             </a:pPr>
             <a:r>
               <a:rPr sz="2550" b="1" i="0">
                 <a:solidFill>
-                  <a:srgbClr val="00132E"/>
+                  <a:srgbClr val="FFFFFF"/>
                 </a:solidFill>
               </a:rPr>
               <a:t>Worked example: Aedes aegypti in Brazil</a:t>
@@ -20550,7 +20550,7 @@
           <p:cNvPr id="2" name="">
             <a:extLst xmlns:a="http://schemas.openxmlformats.org/drawingml/2006/main">
               <a:ext uri="{FF2B5EF4-FFF2-40B4-BE49-F238E27FC236}">
-                <a16:creationId xmlns:a16="http://schemas.microsoft.com/office/drawing/2014/main" id="{CB4080E7-CE9C-41AD-942B-87B1412F1F5C}"/>
+                <a16:creationId xmlns:a16="http://schemas.microsoft.com/office/drawing/2014/main" id="{3023C930-112A-4639-8C89-ACD2F4B288B8}"/>
               </a:ext>
             </a:extLst>
           </p:cNvPr>
@@ -20580,14 +20580,14 @@
             <a:pPr algn="l">
               <a:defRPr sz="1350" b="0" i="0">
                 <a:solidFill>
-                  <a:srgbClr val="111111"/>
+                  <a:srgbClr val="FFFFFF"/>
                 </a:solidFill>
               </a:defRPr>
             </a:pPr>
             <a:r>
               <a:rPr sz="1350" b="0" i="0">
                 <a:solidFill>
-                  <a:srgbClr val="111111"/>
+                  <a:srgbClr val="FFFFFF"/>
                 </a:solidFill>
               </a:rPr>
               <a:t>After the foundation, the workshop uses a dengue vector as a practical modelling case.</a:t>
@@ -20600,7 +20600,7 @@
           <p:cNvPr id="3" name="">
             <a:extLst xmlns:a="http://schemas.openxmlformats.org/drawingml/2006/main">
               <a:ext uri="{FF2B5EF4-FFF2-40B4-BE49-F238E27FC236}">
-                <a16:creationId xmlns:a16="http://schemas.microsoft.com/office/drawing/2014/main" id="{28CB48E3-E77D-4D13-B660-1E7A9F0CC889}"/>
+                <a16:creationId xmlns:a16="http://schemas.microsoft.com/office/drawing/2014/main" id="{ADF698ED-68F7-4A48-A737-87D8A21E1983}"/>
               </a:ext>
             </a:extLst>
           </p:cNvPr>
@@ -20618,7 +20618,7 @@
             <a:avLst/>
           </a:prstGeom>
           <a:solidFill xmlns:a="http://schemas.openxmlformats.org/drawingml/2006/main">
-            <a:srgbClr val="E35D2F"/>
+            <a:srgbClr val="B79961"/>
           </a:solidFill>
           <a:ln xmlns:a="http://schemas.openxmlformats.org/drawingml/2006/main" w="0">
             <a:noFill/>
@@ -20631,7 +20631,7 @@
           <p:cNvPr id="4" name="">
             <a:extLst xmlns:a="http://schemas.openxmlformats.org/drawingml/2006/main">
               <a:ext uri="{FF2B5EF4-FFF2-40B4-BE49-F238E27FC236}">
-                <a16:creationId xmlns:a16="http://schemas.microsoft.com/office/drawing/2014/main" id="{0804BA09-B455-4FE7-A65A-8B9D8B01027B}"/>
+                <a16:creationId xmlns:a16="http://schemas.microsoft.com/office/drawing/2014/main" id="{9D4264D9-8D76-47F0-9B78-1E5142F8457D}"/>
               </a:ext>
             </a:extLst>
           </p:cNvPr>
@@ -20681,7 +20681,7 @@
           <p:cNvPr id="5" name="">
             <a:extLst xmlns:a="http://schemas.openxmlformats.org/drawingml/2006/main">
               <a:ext uri="{FF2B5EF4-FFF2-40B4-BE49-F238E27FC236}">
-                <a16:creationId xmlns:a16="http://schemas.microsoft.com/office/drawing/2014/main" id="{A8413DFE-CCDC-4476-95BB-C2EBC0821390}"/>
+                <a16:creationId xmlns:a16="http://schemas.microsoft.com/office/drawing/2014/main" id="{6BC513B6-2F76-473B-ABC8-DA36597362C3}"/>
               </a:ext>
             </a:extLst>
           </p:cNvPr>
@@ -20699,7 +20699,7 @@
             <a:avLst/>
           </a:prstGeom>
           <a:solidFill xmlns:a="http://schemas.openxmlformats.org/drawingml/2006/main">
-            <a:srgbClr val="E35D2F"/>
+            <a:srgbClr val="B79961"/>
           </a:solidFill>
           <a:ln xmlns:a="http://schemas.openxmlformats.org/drawingml/2006/main" w="0">
             <a:noFill/>
@@ -20712,7 +20712,7 @@
           <p:cNvPr id="6" name="">
             <a:extLst xmlns:a="http://schemas.openxmlformats.org/drawingml/2006/main">
               <a:ext uri="{FF2B5EF4-FFF2-40B4-BE49-F238E27FC236}">
-                <a16:creationId xmlns:a16="http://schemas.microsoft.com/office/drawing/2014/main" id="{0C1A7FF2-404D-4977-96A6-DC8646A4884E}"/>
+                <a16:creationId xmlns:a16="http://schemas.microsoft.com/office/drawing/2014/main" id="{26EC585D-488C-4186-875C-27D0AC41A5FA}"/>
               </a:ext>
             </a:extLst>
           </p:cNvPr>
@@ -20762,7 +20762,7 @@
           <p:cNvPr id="7" name="">
             <a:extLst xmlns:a="http://schemas.openxmlformats.org/drawingml/2006/main">
               <a:ext uri="{FF2B5EF4-FFF2-40B4-BE49-F238E27FC236}">
-                <a16:creationId xmlns:a16="http://schemas.microsoft.com/office/drawing/2014/main" id="{3E8787FE-D7AF-4EDD-9C3E-B3CE67A2A2F9}"/>
+                <a16:creationId xmlns:a16="http://schemas.microsoft.com/office/drawing/2014/main" id="{C32B348D-9265-4CAA-A219-DD02AD108C91}"/>
               </a:ext>
             </a:extLst>
           </p:cNvPr>
@@ -20780,7 +20780,7 @@
             <a:avLst/>
           </a:prstGeom>
           <a:solidFill xmlns:a="http://schemas.openxmlformats.org/drawingml/2006/main">
-            <a:srgbClr val="E35D2F"/>
+            <a:srgbClr val="B79961"/>
           </a:solidFill>
           <a:ln xmlns:a="http://schemas.openxmlformats.org/drawingml/2006/main" w="0">
             <a:noFill/>
@@ -20793,7 +20793,7 @@
           <p:cNvPr id="8" name="">
             <a:extLst xmlns:a="http://schemas.openxmlformats.org/drawingml/2006/main">
               <a:ext uri="{FF2B5EF4-FFF2-40B4-BE49-F238E27FC236}">
-                <a16:creationId xmlns:a16="http://schemas.microsoft.com/office/drawing/2014/main" id="{31C67844-5DA6-4581-8BD4-5AC6D8708D7F}"/>
+                <a16:creationId xmlns:a16="http://schemas.microsoft.com/office/drawing/2014/main" id="{93436B3D-ECFB-4D48-B4E4-92FFA27D16A3}"/>
               </a:ext>
             </a:extLst>
           </p:cNvPr>
@@ -20843,7 +20843,7 @@
           <p:cNvPr id="9" name="">
             <a:extLst xmlns:a="http://schemas.openxmlformats.org/drawingml/2006/main">
               <a:ext uri="{FF2B5EF4-FFF2-40B4-BE49-F238E27FC236}">
-                <a16:creationId xmlns:a16="http://schemas.microsoft.com/office/drawing/2014/main" id="{FC4544F0-A844-445D-9B7E-962002B3DF75}"/>
+                <a16:creationId xmlns:a16="http://schemas.microsoft.com/office/drawing/2014/main" id="{0443C150-3997-4112-AC3C-10FF8F9FF5D3}"/>
               </a:ext>
             </a:extLst>
           </p:cNvPr>
@@ -20861,7 +20861,7 @@
             <a:avLst/>
           </a:prstGeom>
           <a:solidFill xmlns:a="http://schemas.openxmlformats.org/drawingml/2006/main">
-            <a:srgbClr val="E35D2F"/>
+            <a:srgbClr val="B79961"/>
           </a:solidFill>
           <a:ln xmlns:a="http://schemas.openxmlformats.org/drawingml/2006/main" w="0">
             <a:noFill/>
@@ -20874,7 +20874,7 @@
           <p:cNvPr id="10" name="">
             <a:extLst xmlns:a="http://schemas.openxmlformats.org/drawingml/2006/main">
               <a:ext uri="{FF2B5EF4-FFF2-40B4-BE49-F238E27FC236}">
-                <a16:creationId xmlns:a16="http://schemas.microsoft.com/office/drawing/2014/main" id="{382FCB41-DEBC-4547-88D9-0CFC6452B372}"/>
+                <a16:creationId xmlns:a16="http://schemas.microsoft.com/office/drawing/2014/main" id="{D2135A82-69B7-4867-BCDD-DED0C097FE07}"/>
               </a:ext>
             </a:extLst>
           </p:cNvPr>
@@ -20928,7 +20928,7 @@
           <p:nvPr/>
         </p:nvPicPr>
         <p:blipFill>
-          <a:blip xmlns:r="http://schemas.openxmlformats.org/officeDocument/2006/relationships" xmlns:a="http://schemas.openxmlformats.org/drawingml/2006/main" r:embed="Rd3cac0806f3f4c26"/>
+          <a:blip xmlns:r="http://schemas.openxmlformats.org/officeDocument/2006/relationships" xmlns:a="http://schemas.openxmlformats.org/drawingml/2006/main" r:embed="R739c96c8f6e141d8"/>
           <a:stretch xmlns:a="http://schemas.openxmlformats.org/drawingml/2006/main"/>
         </p:blipFill>
         <p:spPr>
@@ -20944,7 +20944,7 @@
     </p:spTree>
     <p:extLst>
       <p:ext uri="{BB962C8B-B14F-4D97-AF65-F5344CB8AC3E}">
-        <p14:creationId xmlns:p14="http://schemas.microsoft.com/office/powerpoint/2010/main" val="1093942105"/>
+        <p14:creationId xmlns:p14="http://schemas.microsoft.com/office/powerpoint/2010/main" val="184329128"/>
       </p:ext>
     </p:extLst>
   </p:cSld>
@@ -20975,7 +20975,7 @@
           <p:cNvPr id="13" name="">
             <a:extLst xmlns:a="http://schemas.openxmlformats.org/drawingml/2006/main">
               <a:ext uri="{FF2B5EF4-FFF2-40B4-BE49-F238E27FC236}">
-                <a16:creationId xmlns:a16="http://schemas.microsoft.com/office/drawing/2014/main" id="{2E9EBA5F-516B-437F-A3C9-5E76A05045D6}"/>
+                <a16:creationId xmlns:a16="http://schemas.microsoft.com/office/drawing/2014/main" id="{E75F6064-BA57-4065-BA74-997295D901E0}"/>
               </a:ext>
             </a:extLst>
           </p:cNvPr>
@@ -21005,14 +21005,14 @@
             <a:pPr algn="l">
               <a:defRPr sz="2550" b="1" i="0">
                 <a:solidFill>
-                  <a:srgbClr val="00132E"/>
+                  <a:srgbClr val="FFFFFF"/>
                 </a:solidFill>
               </a:defRPr>
             </a:pPr>
             <a:r>
               <a:rPr sz="2550" b="1" i="0">
                 <a:solidFill>
-                  <a:srgbClr val="00132E"/>
+                  <a:srgbClr val="FFFFFF"/>
                 </a:solidFill>
               </a:rPr>
               <a:t>Occurrence data: useful, messy, teachable</a:t>
@@ -21025,7 +21025,7 @@
           <p:cNvPr id="2" name="">
             <a:extLst xmlns:a="http://schemas.openxmlformats.org/drawingml/2006/main">
               <a:ext uri="{FF2B5EF4-FFF2-40B4-BE49-F238E27FC236}">
-                <a16:creationId xmlns:a16="http://schemas.microsoft.com/office/drawing/2014/main" id="{73DCC56A-0C40-45C2-B40C-6087049F7A1E}"/>
+                <a16:creationId xmlns:a16="http://schemas.microsoft.com/office/drawing/2014/main" id="{660CCB9E-E0CF-4B60-951D-BB77DCB4B101}"/>
               </a:ext>
             </a:extLst>
           </p:cNvPr>
@@ -21055,14 +21055,14 @@
             <a:pPr algn="l">
               <a:defRPr sz="1350" b="0" i="0">
                 <a:solidFill>
-                  <a:srgbClr val="111111"/>
+                  <a:srgbClr val="FFFFFF"/>
                 </a:solidFill>
               </a:defRPr>
             </a:pPr>
             <a:r>
               <a:rPr sz="1350" b="0" i="0">
                 <a:solidFill>
-                  <a:srgbClr val="111111"/>
+                  <a:srgbClr val="FFFFFF"/>
                 </a:solidFill>
               </a:rPr>
               <a:t>The first modelling decision is whether the records are good enough for the question.</a:t>
@@ -21079,7 +21079,7 @@
           <p:nvPr/>
         </p:nvPicPr>
         <p:blipFill>
-          <a:blip xmlns:r="http://schemas.openxmlformats.org/officeDocument/2006/relationships" xmlns:a="http://schemas.openxmlformats.org/drawingml/2006/main" r:embed="Raeb92ec415bb40ab"/>
+          <a:blip xmlns:r="http://schemas.openxmlformats.org/officeDocument/2006/relationships" xmlns:a="http://schemas.openxmlformats.org/drawingml/2006/main" r:embed="Re652a891f02f420d"/>
           <a:stretch xmlns:a="http://schemas.openxmlformats.org/drawingml/2006/main"/>
         </p:blipFill>
         <p:spPr>
@@ -21097,7 +21097,7 @@
           <p:cNvPr id="4" name="">
             <a:extLst xmlns:a="http://schemas.openxmlformats.org/drawingml/2006/main">
               <a:ext uri="{FF2B5EF4-FFF2-40B4-BE49-F238E27FC236}">
-                <a16:creationId xmlns:a16="http://schemas.microsoft.com/office/drawing/2014/main" id="{E9EF5619-2FD6-4EA5-AA68-91097BF993E4}"/>
+                <a16:creationId xmlns:a16="http://schemas.microsoft.com/office/drawing/2014/main" id="{CB24BE28-076F-443D-A7F3-DA3E1AEA0310}"/>
               </a:ext>
             </a:extLst>
           </p:cNvPr>
@@ -21127,14 +21127,14 @@
             <a:pPr algn="l">
               <a:defRPr sz="2100" b="1" i="0">
                 <a:solidFill>
-                  <a:srgbClr val="006B28"/>
+                  <a:srgbClr val="6B173D"/>
                 </a:solidFill>
               </a:defRPr>
             </a:pPr>
             <a:r>
               <a:rPr sz="2100" b="1" i="0">
                 <a:solidFill>
-                  <a:srgbClr val="006B28"/>
+                  <a:srgbClr val="6B173D"/>
                 </a:solidFill>
               </a:rPr>
               <a:t>Before modelling</a:t>
@@ -21147,7 +21147,7 @@
           <p:cNvPr id="5" name="">
             <a:extLst xmlns:a="http://schemas.openxmlformats.org/drawingml/2006/main">
               <a:ext uri="{FF2B5EF4-FFF2-40B4-BE49-F238E27FC236}">
-                <a16:creationId xmlns:a16="http://schemas.microsoft.com/office/drawing/2014/main" id="{7FFAA6FD-7EF0-4776-B6DC-D66AF6A5F739}"/>
+                <a16:creationId xmlns:a16="http://schemas.microsoft.com/office/drawing/2014/main" id="{090E6773-8D19-451B-B884-EA5409360946}"/>
               </a:ext>
             </a:extLst>
           </p:cNvPr>
@@ -21165,7 +21165,7 @@
             <a:avLst/>
           </a:prstGeom>
           <a:solidFill xmlns:a="http://schemas.openxmlformats.org/drawingml/2006/main">
-            <a:srgbClr val="E35D2F"/>
+            <a:srgbClr val="B79961"/>
           </a:solidFill>
           <a:ln xmlns:a="http://schemas.openxmlformats.org/drawingml/2006/main" w="0">
             <a:noFill/>
@@ -21178,7 +21178,7 @@
           <p:cNvPr id="6" name="">
             <a:extLst xmlns:a="http://schemas.openxmlformats.org/drawingml/2006/main">
               <a:ext uri="{FF2B5EF4-FFF2-40B4-BE49-F238E27FC236}">
-                <a16:creationId xmlns:a16="http://schemas.microsoft.com/office/drawing/2014/main" id="{8C56B323-42C0-494C-B341-FDD9DD5EEBBC}"/>
+                <a16:creationId xmlns:a16="http://schemas.microsoft.com/office/drawing/2014/main" id="{863F5DDD-D4FF-4F67-AD21-6CEED5686B3D}"/>
               </a:ext>
             </a:extLst>
           </p:cNvPr>
@@ -21228,7 +21228,7 @@
           <p:cNvPr id="7" name="">
             <a:extLst xmlns:a="http://schemas.openxmlformats.org/drawingml/2006/main">
               <a:ext uri="{FF2B5EF4-FFF2-40B4-BE49-F238E27FC236}">
-                <a16:creationId xmlns:a16="http://schemas.microsoft.com/office/drawing/2014/main" id="{032BD9A5-6A6E-4864-B0FA-535EC988E66E}"/>
+                <a16:creationId xmlns:a16="http://schemas.microsoft.com/office/drawing/2014/main" id="{BFF9496A-3C05-4395-B095-B3DF017B1ABE}"/>
               </a:ext>
             </a:extLst>
           </p:cNvPr>
@@ -21246,7 +21246,7 @@
             <a:avLst/>
           </a:prstGeom>
           <a:solidFill xmlns:a="http://schemas.openxmlformats.org/drawingml/2006/main">
-            <a:srgbClr val="E35D2F"/>
+            <a:srgbClr val="B79961"/>
           </a:solidFill>
           <a:ln xmlns:a="http://schemas.openxmlformats.org/drawingml/2006/main" w="0">
             <a:noFill/>
@@ -21259,7 +21259,7 @@
           <p:cNvPr id="8" name="">
             <a:extLst xmlns:a="http://schemas.openxmlformats.org/drawingml/2006/main">
               <a:ext uri="{FF2B5EF4-FFF2-40B4-BE49-F238E27FC236}">
-                <a16:creationId xmlns:a16="http://schemas.microsoft.com/office/drawing/2014/main" id="{33E0DB4D-6DA1-417B-871B-D376D91B58C6}"/>
+                <a16:creationId xmlns:a16="http://schemas.microsoft.com/office/drawing/2014/main" id="{28EFF6B5-F0BB-4680-83B6-3CA0CE282922}"/>
               </a:ext>
             </a:extLst>
           </p:cNvPr>
@@ -21309,7 +21309,7 @@
           <p:cNvPr id="9" name="">
             <a:extLst xmlns:a="http://schemas.openxmlformats.org/drawingml/2006/main">
               <a:ext uri="{FF2B5EF4-FFF2-40B4-BE49-F238E27FC236}">
-                <a16:creationId xmlns:a16="http://schemas.microsoft.com/office/drawing/2014/main" id="{B94BEE49-9BAC-440A-85DD-C127882102AE}"/>
+                <a16:creationId xmlns:a16="http://schemas.microsoft.com/office/drawing/2014/main" id="{6A7A8755-63B8-40D2-BCDB-A549D583310D}"/>
               </a:ext>
             </a:extLst>
           </p:cNvPr>
@@ -21327,7 +21327,7 @@
             <a:avLst/>
           </a:prstGeom>
           <a:solidFill xmlns:a="http://schemas.openxmlformats.org/drawingml/2006/main">
-            <a:srgbClr val="E35D2F"/>
+            <a:srgbClr val="B79961"/>
           </a:solidFill>
           <a:ln xmlns:a="http://schemas.openxmlformats.org/drawingml/2006/main" w="0">
             <a:noFill/>
@@ -21340,7 +21340,7 @@
           <p:cNvPr id="10" name="">
             <a:extLst xmlns:a="http://schemas.openxmlformats.org/drawingml/2006/main">
               <a:ext uri="{FF2B5EF4-FFF2-40B4-BE49-F238E27FC236}">
-                <a16:creationId xmlns:a16="http://schemas.microsoft.com/office/drawing/2014/main" id="{8B4CD223-F652-4D23-A6D3-1F221368C00A}"/>
+                <a16:creationId xmlns:a16="http://schemas.microsoft.com/office/drawing/2014/main" id="{C0648704-443E-41BC-BE90-B84D67E682F4}"/>
               </a:ext>
             </a:extLst>
           </p:cNvPr>
@@ -21390,7 +21390,7 @@
           <p:cNvPr id="11" name="">
             <a:extLst xmlns:a="http://schemas.openxmlformats.org/drawingml/2006/main">
               <a:ext uri="{FF2B5EF4-FFF2-40B4-BE49-F238E27FC236}">
-                <a16:creationId xmlns:a16="http://schemas.microsoft.com/office/drawing/2014/main" id="{D432B9BE-9ECD-4A0F-BAA5-4DFF72E1A62E}"/>
+                <a16:creationId xmlns:a16="http://schemas.microsoft.com/office/drawing/2014/main" id="{F5A3CBC9-6B72-4483-A0AA-BFA231BCB9B0}"/>
               </a:ext>
             </a:extLst>
           </p:cNvPr>
@@ -21408,7 +21408,7 @@
             <a:avLst/>
           </a:prstGeom>
           <a:solidFill xmlns:a="http://schemas.openxmlformats.org/drawingml/2006/main">
-            <a:srgbClr val="E35D2F"/>
+            <a:srgbClr val="B79961"/>
           </a:solidFill>
           <a:ln xmlns:a="http://schemas.openxmlformats.org/drawingml/2006/main" w="0">
             <a:noFill/>
@@ -21421,7 +21421,7 @@
           <p:cNvPr id="12" name="">
             <a:extLst xmlns:a="http://schemas.openxmlformats.org/drawingml/2006/main">
               <a:ext uri="{FF2B5EF4-FFF2-40B4-BE49-F238E27FC236}">
-                <a16:creationId xmlns:a16="http://schemas.microsoft.com/office/drawing/2014/main" id="{38B99B0F-3E89-405B-803F-280D23DAAC26}"/>
+                <a16:creationId xmlns:a16="http://schemas.microsoft.com/office/drawing/2014/main" id="{E01EBA2F-6558-4C5C-A053-C1F394831987}"/>
               </a:ext>
             </a:extLst>
           </p:cNvPr>
@@ -21469,7 +21469,7 @@
     </p:spTree>
     <p:extLst>
       <p:ext uri="{BB962C8B-B14F-4D97-AF65-F5344CB8AC3E}">
-        <p14:creationId xmlns:p14="http://schemas.microsoft.com/office/powerpoint/2010/main" val="1093942105"/>
+        <p14:creationId xmlns:p14="http://schemas.microsoft.com/office/powerpoint/2010/main" val="184329128"/>
       </p:ext>
     </p:extLst>
   </p:cSld>
@@ -21500,7 +21500,7 @@
           <p:cNvPr id="13" name="">
             <a:extLst xmlns:a="http://schemas.openxmlformats.org/drawingml/2006/main">
               <a:ext uri="{FF2B5EF4-FFF2-40B4-BE49-F238E27FC236}">
-                <a16:creationId xmlns:a16="http://schemas.microsoft.com/office/drawing/2014/main" id="{271F5ACC-41B1-4472-85A8-25C398206CBF}"/>
+                <a16:creationId xmlns:a16="http://schemas.microsoft.com/office/drawing/2014/main" id="{EE9E07CF-8CA1-4CF6-8851-0FD5ECBEDCC2}"/>
               </a:ext>
             </a:extLst>
           </p:cNvPr>
@@ -21530,14 +21530,14 @@
             <a:pPr algn="l">
               <a:defRPr sz="2550" b="1" i="0">
                 <a:solidFill>
-                  <a:srgbClr val="00132E"/>
+                  <a:srgbClr val="FFFFFF"/>
                 </a:solidFill>
               </a:defRPr>
             </a:pPr>
             <a:r>
               <a:rPr sz="2550" b="1" i="0">
                 <a:solidFill>
-                  <a:srgbClr val="00132E"/>
+                  <a:srgbClr val="FFFFFF"/>
                 </a:solidFill>
               </a:rPr>
               <a:t>Predictors define the environmental lens</a:t>
@@ -21550,7 +21550,7 @@
           <p:cNvPr id="2" name="">
             <a:extLst xmlns:a="http://schemas.openxmlformats.org/drawingml/2006/main">
               <a:ext uri="{FF2B5EF4-FFF2-40B4-BE49-F238E27FC236}">
-                <a16:creationId xmlns:a16="http://schemas.microsoft.com/office/drawing/2014/main" id="{F53B08B1-5194-4091-84B6-78DB5AC168E0}"/>
+                <a16:creationId xmlns:a16="http://schemas.microsoft.com/office/drawing/2014/main" id="{78785974-76B8-4C2C-AEF5-DE39BD0BD486}"/>
               </a:ext>
             </a:extLst>
           </p:cNvPr>
@@ -21580,14 +21580,14 @@
             <a:pPr algn="l">
               <a:defRPr sz="1350" b="0" i="0">
                 <a:solidFill>
-                  <a:srgbClr val="111111"/>
+                  <a:srgbClr val="FFFFFF"/>
                 </a:solidFill>
               </a:defRPr>
             </a:pPr>
             <a:r>
               <a:rPr sz="1350" b="0" i="0">
                 <a:solidFill>
-                  <a:srgbClr val="111111"/>
+                  <a:srgbClr val="FFFFFF"/>
                 </a:solidFill>
               </a:rPr>
               <a:t>We keep four climate predictors so the first model is fast enough and interpretable enough for a 90-minute workshop.</a:t>
@@ -21604,7 +21604,7 @@
           <p:nvPr/>
         </p:nvPicPr>
         <p:blipFill>
-          <a:blip xmlns:r="http://schemas.openxmlformats.org/officeDocument/2006/relationships" xmlns:a="http://schemas.openxmlformats.org/drawingml/2006/main" r:embed="R0a88d05257204e0f"/>
+          <a:blip xmlns:r="http://schemas.openxmlformats.org/officeDocument/2006/relationships" xmlns:a="http://schemas.openxmlformats.org/drawingml/2006/main" r:embed="R5a12903ba0d94a9b"/>
           <a:stretch xmlns:a="http://schemas.openxmlformats.org/drawingml/2006/main"/>
         </p:blipFill>
         <p:spPr>
@@ -21622,7 +21622,7 @@
           <p:cNvPr id="4" name="">
             <a:extLst xmlns:a="http://schemas.openxmlformats.org/drawingml/2006/main">
               <a:ext uri="{FF2B5EF4-FFF2-40B4-BE49-F238E27FC236}">
-                <a16:creationId xmlns:a16="http://schemas.microsoft.com/office/drawing/2014/main" id="{63DBC368-AEAA-4D74-BE52-4F3C1A3646F1}"/>
+                <a16:creationId xmlns:a16="http://schemas.microsoft.com/office/drawing/2014/main" id="{6F1ECF50-19B9-4A24-999F-BCBF8C659AEA}"/>
               </a:ext>
             </a:extLst>
           </p:cNvPr>
@@ -21652,14 +21652,14 @@
             <a:pPr algn="l">
               <a:defRPr sz="2100" b="1" i="0">
                 <a:solidFill>
-                  <a:srgbClr val="006B28"/>
+                  <a:srgbClr val="6B173D"/>
                 </a:solidFill>
               </a:defRPr>
             </a:pPr>
             <a:r>
               <a:rPr sz="2100" b="1" i="0">
                 <a:solidFill>
-                  <a:srgbClr val="006B28"/>
+                  <a:srgbClr val="6B173D"/>
                 </a:solidFill>
               </a:rPr>
               <a:t>Workshop predictors</a:t>
@@ -21672,7 +21672,7 @@
           <p:cNvPr id="5" name="">
             <a:extLst xmlns:a="http://schemas.openxmlformats.org/drawingml/2006/main">
               <a:ext uri="{FF2B5EF4-FFF2-40B4-BE49-F238E27FC236}">
-                <a16:creationId xmlns:a16="http://schemas.microsoft.com/office/drawing/2014/main" id="{54978579-A630-48F2-A2BC-AED52963E105}"/>
+                <a16:creationId xmlns:a16="http://schemas.microsoft.com/office/drawing/2014/main" id="{CFBB4C11-EE59-43E6-AA45-A693DF41C271}"/>
               </a:ext>
             </a:extLst>
           </p:cNvPr>
@@ -21690,7 +21690,7 @@
             <a:avLst/>
           </a:prstGeom>
           <a:solidFill xmlns:a="http://schemas.openxmlformats.org/drawingml/2006/main">
-            <a:srgbClr val="E35D2F"/>
+            <a:srgbClr val="B79961"/>
           </a:solidFill>
           <a:ln xmlns:a="http://schemas.openxmlformats.org/drawingml/2006/main" w="0">
             <a:noFill/>
@@ -21703,7 +21703,7 @@
           <p:cNvPr id="6" name="">
             <a:extLst xmlns:a="http://schemas.openxmlformats.org/drawingml/2006/main">
               <a:ext uri="{FF2B5EF4-FFF2-40B4-BE49-F238E27FC236}">
-                <a16:creationId xmlns:a16="http://schemas.microsoft.com/office/drawing/2014/main" id="{E450196E-3988-4E9E-B789-FB62F836EE3D}"/>
+                <a16:creationId xmlns:a16="http://schemas.microsoft.com/office/drawing/2014/main" id="{68FB2B65-BB08-4D71-A801-00CAAADE3509}"/>
               </a:ext>
             </a:extLst>
           </p:cNvPr>
@@ -21753,7 +21753,7 @@
           <p:cNvPr id="7" name="">
             <a:extLst xmlns:a="http://schemas.openxmlformats.org/drawingml/2006/main">
               <a:ext uri="{FF2B5EF4-FFF2-40B4-BE49-F238E27FC236}">
-                <a16:creationId xmlns:a16="http://schemas.microsoft.com/office/drawing/2014/main" id="{D47BD6BC-5044-415E-B6ED-5710744B296F}"/>
+                <a16:creationId xmlns:a16="http://schemas.microsoft.com/office/drawing/2014/main" id="{B5653946-1358-4ABD-95B7-817B3EBF2FB8}"/>
               </a:ext>
             </a:extLst>
           </p:cNvPr>
@@ -21771,7 +21771,7 @@
             <a:avLst/>
           </a:prstGeom>
           <a:solidFill xmlns:a="http://schemas.openxmlformats.org/drawingml/2006/main">
-            <a:srgbClr val="E35D2F"/>
+            <a:srgbClr val="B79961"/>
           </a:solidFill>
           <a:ln xmlns:a="http://schemas.openxmlformats.org/drawingml/2006/main" w="0">
             <a:noFill/>
@@ -21784,7 +21784,7 @@
           <p:cNvPr id="8" name="">
             <a:extLst xmlns:a="http://schemas.openxmlformats.org/drawingml/2006/main">
               <a:ext uri="{FF2B5EF4-FFF2-40B4-BE49-F238E27FC236}">
-                <a16:creationId xmlns:a16="http://schemas.microsoft.com/office/drawing/2014/main" id="{79CC4B4A-5E13-4B40-9EA2-77DA1877C911}"/>
+                <a16:creationId xmlns:a16="http://schemas.microsoft.com/office/drawing/2014/main" id="{56F436E6-9D8A-4584-9F4A-DD11858591F7}"/>
               </a:ext>
             </a:extLst>
           </p:cNvPr>
@@ -21834,7 +21834,7 @@
           <p:cNvPr id="9" name="">
             <a:extLst xmlns:a="http://schemas.openxmlformats.org/drawingml/2006/main">
               <a:ext uri="{FF2B5EF4-FFF2-40B4-BE49-F238E27FC236}">
-                <a16:creationId xmlns:a16="http://schemas.microsoft.com/office/drawing/2014/main" id="{8E55EA8D-D96C-472D-90EA-58DA5ABFCE44}"/>
+                <a16:creationId xmlns:a16="http://schemas.microsoft.com/office/drawing/2014/main" id="{62A0D3D1-D744-4364-9294-EB35FF45F5E8}"/>
               </a:ext>
             </a:extLst>
           </p:cNvPr>
@@ -21852,7 +21852,7 @@
             <a:avLst/>
           </a:prstGeom>
           <a:solidFill xmlns:a="http://schemas.openxmlformats.org/drawingml/2006/main">
-            <a:srgbClr val="E35D2F"/>
+            <a:srgbClr val="B79961"/>
           </a:solidFill>
           <a:ln xmlns:a="http://schemas.openxmlformats.org/drawingml/2006/main" w="0">
             <a:noFill/>
@@ -21865,7 +21865,7 @@
           <p:cNvPr id="10" name="">
             <a:extLst xmlns:a="http://schemas.openxmlformats.org/drawingml/2006/main">
               <a:ext uri="{FF2B5EF4-FFF2-40B4-BE49-F238E27FC236}">
-                <a16:creationId xmlns:a16="http://schemas.microsoft.com/office/drawing/2014/main" id="{4D0076C1-20CB-41C3-ADBF-DECD2E591C0B}"/>
+                <a16:creationId xmlns:a16="http://schemas.microsoft.com/office/drawing/2014/main" id="{8ED23327-1295-40A3-98C5-53BF43BE92BB}"/>
               </a:ext>
             </a:extLst>
           </p:cNvPr>
@@ -21915,7 +21915,7 @@
           <p:cNvPr id="11" name="">
             <a:extLst xmlns:a="http://schemas.openxmlformats.org/drawingml/2006/main">
               <a:ext uri="{FF2B5EF4-FFF2-40B4-BE49-F238E27FC236}">
-                <a16:creationId xmlns:a16="http://schemas.microsoft.com/office/drawing/2014/main" id="{90D64FCF-3AF3-4B29-8DCA-1454F081004D}"/>
+                <a16:creationId xmlns:a16="http://schemas.microsoft.com/office/drawing/2014/main" id="{62EF5BA2-B234-4395-AAD5-60231DCC15E8}"/>
               </a:ext>
             </a:extLst>
           </p:cNvPr>
@@ -21933,7 +21933,7 @@
             <a:avLst/>
           </a:prstGeom>
           <a:solidFill xmlns:a="http://schemas.openxmlformats.org/drawingml/2006/main">
-            <a:srgbClr val="E35D2F"/>
+            <a:srgbClr val="B79961"/>
           </a:solidFill>
           <a:ln xmlns:a="http://schemas.openxmlformats.org/drawingml/2006/main" w="0">
             <a:noFill/>
@@ -21946,7 +21946,7 @@
           <p:cNvPr id="12" name="">
             <a:extLst xmlns:a="http://schemas.openxmlformats.org/drawingml/2006/main">
               <a:ext uri="{FF2B5EF4-FFF2-40B4-BE49-F238E27FC236}">
-                <a16:creationId xmlns:a16="http://schemas.microsoft.com/office/drawing/2014/main" id="{DF4445D6-A95A-47C3-91CC-2ACAF2A3F16B}"/>
+                <a16:creationId xmlns:a16="http://schemas.microsoft.com/office/drawing/2014/main" id="{FD1FF4F2-3FE8-489C-96BC-3C841A30E379}"/>
               </a:ext>
             </a:extLst>
           </p:cNvPr>
@@ -21994,7 +21994,7 @@
     </p:spTree>
     <p:extLst>
       <p:ext uri="{BB962C8B-B14F-4D97-AF65-F5344CB8AC3E}">
-        <p14:creationId xmlns:p14="http://schemas.microsoft.com/office/powerpoint/2010/main" val="1093942105"/>
+        <p14:creationId xmlns:p14="http://schemas.microsoft.com/office/powerpoint/2010/main" val="184329128"/>
       </p:ext>
     </p:extLst>
   </p:cSld>
@@ -22025,7 +22025,7 @@
           <p:cNvPr id="12" name="">
             <a:extLst xmlns:a="http://schemas.openxmlformats.org/drawingml/2006/main">
               <a:ext uri="{FF2B5EF4-FFF2-40B4-BE49-F238E27FC236}">
-                <a16:creationId xmlns:a16="http://schemas.microsoft.com/office/drawing/2014/main" id="{D48F12E1-906A-4826-BE06-4C0968B928DF}"/>
+                <a16:creationId xmlns:a16="http://schemas.microsoft.com/office/drawing/2014/main" id="{6B96A0BB-D2EF-48FB-9D3A-E6BDC3C00CE4}"/>
               </a:ext>
             </a:extLst>
           </p:cNvPr>
@@ -22055,14 +22055,14 @@
             <a:pPr algn="l">
               <a:defRPr sz="2550" b="1" i="0">
                 <a:solidFill>
-                  <a:srgbClr val="00132E"/>
+                  <a:srgbClr val="FFFFFF"/>
                 </a:solidFill>
               </a:defRPr>
             </a:pPr>
             <a:r>
               <a:rPr sz="2550" b="1" i="0">
                 <a:solidFill>
-                  <a:srgbClr val="00132E"/>
+                  <a:srgbClr val="FFFFFF"/>
                 </a:solidFill>
               </a:rPr>
               <a:t>Presence-only data require pseudo-absences</a:t>
@@ -22075,7 +22075,7 @@
           <p:cNvPr id="2" name="">
             <a:extLst xmlns:a="http://schemas.openxmlformats.org/drawingml/2006/main">
               <a:ext uri="{FF2B5EF4-FFF2-40B4-BE49-F238E27FC236}">
-                <a16:creationId xmlns:a16="http://schemas.microsoft.com/office/drawing/2014/main" id="{8A7AB3AA-7F3A-4E64-AA51-40B176F709EC}"/>
+                <a16:creationId xmlns:a16="http://schemas.microsoft.com/office/drawing/2014/main" id="{3E5B37C3-1A55-48B2-A4A3-332BD6B680AD}"/>
               </a:ext>
             </a:extLst>
           </p:cNvPr>
@@ -22105,14 +22105,14 @@
             <a:pPr algn="l">
               <a:defRPr sz="1350" b="0" i="0">
                 <a:solidFill>
-                  <a:srgbClr val="111111"/>
+                  <a:srgbClr val="FFFFFF"/>
                 </a:solidFill>
               </a:defRPr>
             </a:pPr>
             <a:r>
               <a:rPr sz="1350" b="0" i="0">
                 <a:solidFill>
-                  <a:srgbClr val="111111"/>
+                  <a:srgbClr val="FFFFFF"/>
                 </a:solidFill>
               </a:rPr>
               <a:t>Pseudo-absences are comparison points. They are not confirmed absences.</a:t>
@@ -22125,7 +22125,7 @@
           <p:cNvPr id="3" name="">
             <a:extLst xmlns:a="http://schemas.openxmlformats.org/drawingml/2006/main">
               <a:ext uri="{FF2B5EF4-FFF2-40B4-BE49-F238E27FC236}">
-                <a16:creationId xmlns:a16="http://schemas.microsoft.com/office/drawing/2014/main" id="{B21DD9C3-2011-4FF1-876E-CBAD3153A72C}"/>
+                <a16:creationId xmlns:a16="http://schemas.microsoft.com/office/drawing/2014/main" id="{7ECA06E1-450B-41A3-8A6B-965812664710}"/>
               </a:ext>
             </a:extLst>
           </p:cNvPr>
@@ -22155,14 +22155,14 @@
             <a:pPr algn="ctr">
               <a:defRPr sz="2175" b="1" i="0">
                 <a:solidFill>
-                  <a:srgbClr val="006B28"/>
+                  <a:srgbClr val="6B173D"/>
                 </a:solidFill>
               </a:defRPr>
             </a:pPr>
             <a:r>
               <a:rPr sz="2175" b="1" i="0">
                 <a:solidFill>
-                  <a:srgbClr val="006B28"/>
+                  <a:srgbClr val="6B173D"/>
                 </a:solidFill>
               </a:rPr>
               <a:t>Presences</a:t>
@@ -22175,7 +22175,7 @@
           <p:cNvPr id="4" name="">
             <a:extLst xmlns:a="http://schemas.openxmlformats.org/drawingml/2006/main">
               <a:ext uri="{FF2B5EF4-FFF2-40B4-BE49-F238E27FC236}">
-                <a16:creationId xmlns:a16="http://schemas.microsoft.com/office/drawing/2014/main" id="{033ECAF8-A64B-4E5B-86F0-1B3CDC4AD119}"/>
+                <a16:creationId xmlns:a16="http://schemas.microsoft.com/office/drawing/2014/main" id="{2338E133-EDE0-41D6-965C-F85A7CC60FC0}"/>
               </a:ext>
             </a:extLst>
           </p:cNvPr>
@@ -22225,7 +22225,7 @@
           <p:cNvPr id="5" name="">
             <a:extLst xmlns:a="http://schemas.openxmlformats.org/drawingml/2006/main">
               <a:ext uri="{FF2B5EF4-FFF2-40B4-BE49-F238E27FC236}">
-                <a16:creationId xmlns:a16="http://schemas.microsoft.com/office/drawing/2014/main" id="{4EBED333-C1D9-4E3C-A57C-67585DEA07BD}"/>
+                <a16:creationId xmlns:a16="http://schemas.microsoft.com/office/drawing/2014/main" id="{300D0F52-A85F-487E-9CD5-6E16D9CA3FFE}"/>
               </a:ext>
             </a:extLst>
           </p:cNvPr>
@@ -22243,7 +22243,7 @@
             <a:avLst/>
           </a:prstGeom>
           <a:solidFill xmlns:a="http://schemas.openxmlformats.org/drawingml/2006/main">
-            <a:srgbClr val="08A000"/>
+            <a:srgbClr val="6B173D"/>
           </a:solidFill>
           <a:ln xmlns:a="http://schemas.openxmlformats.org/drawingml/2006/main" w="0">
             <a:noFill/>
@@ -22256,7 +22256,7 @@
           <p:cNvPr id="6" name="">
             <a:extLst xmlns:a="http://schemas.openxmlformats.org/drawingml/2006/main">
               <a:ext uri="{FF2B5EF4-FFF2-40B4-BE49-F238E27FC236}">
-                <a16:creationId xmlns:a16="http://schemas.microsoft.com/office/drawing/2014/main" id="{1BCA4677-DA37-4241-93C4-1A7CE25990D6}"/>
+                <a16:creationId xmlns:a16="http://schemas.microsoft.com/office/drawing/2014/main" id="{E31FE33D-23D6-4B9D-BDE7-FD6A8D33691B}"/>
               </a:ext>
             </a:extLst>
           </p:cNvPr>
@@ -22286,14 +22286,14 @@
             <a:pPr algn="ctr">
               <a:defRPr sz="2175" b="1" i="0">
                 <a:solidFill>
-                  <a:srgbClr val="006B28"/>
+                  <a:srgbClr val="6B173D"/>
                 </a:solidFill>
               </a:defRPr>
             </a:pPr>
             <a:r>
               <a:rPr sz="2175" b="1" i="0">
                 <a:solidFill>
-                  <a:srgbClr val="006B28"/>
+                  <a:srgbClr val="6B173D"/>
                 </a:solidFill>
               </a:rPr>
               <a:t>Pseudo-absences</a:t>
@@ -22306,7 +22306,7 @@
           <p:cNvPr id="7" name="">
             <a:extLst xmlns:a="http://schemas.openxmlformats.org/drawingml/2006/main">
               <a:ext uri="{FF2B5EF4-FFF2-40B4-BE49-F238E27FC236}">
-                <a16:creationId xmlns:a16="http://schemas.microsoft.com/office/drawing/2014/main" id="{F8B079A3-DB6C-4CF3-B7F8-096B7319C5CC}"/>
+                <a16:creationId xmlns:a16="http://schemas.microsoft.com/office/drawing/2014/main" id="{F2FB5D20-D111-49C4-AB44-4506AE74DBA5}"/>
               </a:ext>
             </a:extLst>
           </p:cNvPr>
@@ -22356,7 +22356,7 @@
           <p:cNvPr id="8" name="">
             <a:extLst xmlns:a="http://schemas.openxmlformats.org/drawingml/2006/main">
               <a:ext uri="{FF2B5EF4-FFF2-40B4-BE49-F238E27FC236}">
-                <a16:creationId xmlns:a16="http://schemas.microsoft.com/office/drawing/2014/main" id="{4B14FF6B-DDC2-40D2-861E-70AA239A43A6}"/>
+                <a16:creationId xmlns:a16="http://schemas.microsoft.com/office/drawing/2014/main" id="{4B6CF7D5-96C9-433F-A84D-B5306F29E24F}"/>
               </a:ext>
             </a:extLst>
           </p:cNvPr>
@@ -22374,7 +22374,7 @@
             <a:avLst/>
           </a:prstGeom>
           <a:solidFill xmlns:a="http://schemas.openxmlformats.org/drawingml/2006/main">
-            <a:srgbClr val="08A000"/>
+            <a:srgbClr val="6B173D"/>
           </a:solidFill>
           <a:ln xmlns:a="http://schemas.openxmlformats.org/drawingml/2006/main" w="0">
             <a:noFill/>
@@ -22387,7 +22387,7 @@
           <p:cNvPr id="9" name="">
             <a:extLst xmlns:a="http://schemas.openxmlformats.org/drawingml/2006/main">
               <a:ext uri="{FF2B5EF4-FFF2-40B4-BE49-F238E27FC236}">
-                <a16:creationId xmlns:a16="http://schemas.microsoft.com/office/drawing/2014/main" id="{039018EB-927B-485B-A5AF-69B0BE291C84}"/>
+                <a16:creationId xmlns:a16="http://schemas.microsoft.com/office/drawing/2014/main" id="{E994CFFB-5000-40ED-9686-EBE54180401E}"/>
               </a:ext>
             </a:extLst>
           </p:cNvPr>
@@ -22417,14 +22417,14 @@
             <a:pPr algn="ctr">
               <a:defRPr sz="2175" b="1" i="0">
                 <a:solidFill>
-                  <a:srgbClr val="006B28"/>
+                  <a:srgbClr val="6B173D"/>
                 </a:solidFill>
               </a:defRPr>
             </a:pPr>
             <a:r>
               <a:rPr sz="2175" b="1" i="0">
                 <a:solidFill>
-                  <a:srgbClr val="006B28"/>
+                  <a:srgbClr val="6B173D"/>
                 </a:solidFill>
               </a:rPr>
               <a:t>Formatted</a:t>
@@ -22434,14 +22434,14 @@
             <a:pPr algn="ctr">
               <a:defRPr sz="2175" b="1" i="0">
                 <a:solidFill>
-                  <a:srgbClr val="006B28"/>
+                  <a:srgbClr val="6B173D"/>
                 </a:solidFill>
               </a:defRPr>
             </a:pPr>
             <a:r>
               <a:rPr sz="2175" b="1" i="0">
                 <a:solidFill>
-                  <a:srgbClr val="006B28"/>
+                  <a:srgbClr val="6B173D"/>
                 </a:solidFill>
               </a:rPr>
               <a:t>data</a:t>
@@ -22454,7 +22454,7 @@
           <p:cNvPr id="10" name="">
             <a:extLst xmlns:a="http://schemas.openxmlformats.org/drawingml/2006/main">
               <a:ext uri="{FF2B5EF4-FFF2-40B4-BE49-F238E27FC236}">
-                <a16:creationId xmlns:a16="http://schemas.microsoft.com/office/drawing/2014/main" id="{02F3CE97-DC03-44B9-B7BC-DC7AD48AE5C4}"/>
+                <a16:creationId xmlns:a16="http://schemas.microsoft.com/office/drawing/2014/main" id="{85303B10-AE4D-4F99-9BB6-E4FD52EA1818}"/>
               </a:ext>
             </a:extLst>
           </p:cNvPr>
@@ -22504,7 +22504,7 @@
           <p:cNvPr id="11" name="">
             <a:extLst xmlns:a="http://schemas.openxmlformats.org/drawingml/2006/main">
               <a:ext uri="{FF2B5EF4-FFF2-40B4-BE49-F238E27FC236}">
-                <a16:creationId xmlns:a16="http://schemas.microsoft.com/office/drawing/2014/main" id="{434C5ED8-4BCB-47D8-B5A0-7B1BDD03FA69}"/>
+                <a16:creationId xmlns:a16="http://schemas.microsoft.com/office/drawing/2014/main" id="{30A9F9C1-E25E-470B-96A0-3E4A57A97D40}"/>
               </a:ext>
             </a:extLst>
           </p:cNvPr>
@@ -22552,7 +22552,7 @@
     </p:spTree>
     <p:extLst>
       <p:ext uri="{BB962C8B-B14F-4D97-AF65-F5344CB8AC3E}">
-        <p14:creationId xmlns:p14="http://schemas.microsoft.com/office/powerpoint/2010/main" val="1093942105"/>
+        <p14:creationId xmlns:p14="http://schemas.microsoft.com/office/powerpoint/2010/main" val="184329128"/>
       </p:ext>
     </p:extLst>
   </p:cSld>
@@ -22583,7 +22583,7 @@
           <p:cNvPr id="15" name="">
             <a:extLst xmlns:a="http://schemas.openxmlformats.org/drawingml/2006/main">
               <a:ext uri="{FF2B5EF4-FFF2-40B4-BE49-F238E27FC236}">
-                <a16:creationId xmlns:a16="http://schemas.microsoft.com/office/drawing/2014/main" id="{92A6D59A-B68E-42D1-8A06-4ECEAE7D2B66}"/>
+                <a16:creationId xmlns:a16="http://schemas.microsoft.com/office/drawing/2014/main" id="{2C57CF1C-32A9-4701-9A9E-46C65FF420BA}"/>
               </a:ext>
             </a:extLst>
           </p:cNvPr>
@@ -22613,14 +22613,14 @@
             <a:pPr algn="l">
               <a:defRPr sz="2550" b="1" i="0">
                 <a:solidFill>
-                  <a:srgbClr val="00132E"/>
+                  <a:srgbClr val="FFFFFF"/>
                 </a:solidFill>
               </a:defRPr>
             </a:pPr>
             <a:r>
               <a:rPr sz="2550" b="1" i="0">
                 <a:solidFill>
-                  <a:srgbClr val="00132E"/>
+                  <a:srgbClr val="FFFFFF"/>
                 </a:solidFill>
               </a:rPr>
               <a:t>Three algorithms, three modelling assumptions</a:t>
@@ -22633,7 +22633,7 @@
           <p:cNvPr id="2" name="">
             <a:extLst xmlns:a="http://schemas.openxmlformats.org/drawingml/2006/main">
               <a:ext uri="{FF2B5EF4-FFF2-40B4-BE49-F238E27FC236}">
-                <a16:creationId xmlns:a16="http://schemas.microsoft.com/office/drawing/2014/main" id="{1D849A3C-1749-4DC5-BD8D-8B0DAF70DDB0}"/>
+                <a16:creationId xmlns:a16="http://schemas.microsoft.com/office/drawing/2014/main" id="{EF988D19-D5EC-463F-B2BB-F63552E60A83}"/>
               </a:ext>
             </a:extLst>
           </p:cNvPr>
@@ -22663,14 +22663,14 @@
             <a:pPr algn="l">
               <a:defRPr sz="1350" b="0" i="0">
                 <a:solidFill>
-                  <a:srgbClr val="111111"/>
+                  <a:srgbClr val="FFFFFF"/>
                 </a:solidFill>
               </a:defRPr>
             </a:pPr>
             <a:r>
               <a:rPr sz="1350" b="0" i="0">
                 <a:solidFill>
-                  <a:srgbClr val="111111"/>
+                  <a:srgbClr val="FFFFFF"/>
                 </a:solidFill>
               </a:rPr>
               <a:t>We use multiple algorithms to make model behaviour visible.</a:t>
@@ -22683,7 +22683,7 @@
           <p:cNvPr id="3" name="">
             <a:extLst xmlns:a="http://schemas.openxmlformats.org/drawingml/2006/main">
               <a:ext uri="{FF2B5EF4-FFF2-40B4-BE49-F238E27FC236}">
-                <a16:creationId xmlns:a16="http://schemas.microsoft.com/office/drawing/2014/main" id="{6F7DD9ED-1B04-4DD1-A705-80E7BDB75755}"/>
+                <a16:creationId xmlns:a16="http://schemas.microsoft.com/office/drawing/2014/main" id="{4DA279BD-0365-4750-A7D6-9A79BA5954A3}"/>
               </a:ext>
             </a:extLst>
           </p:cNvPr>
@@ -22713,14 +22713,14 @@
             <a:pPr algn="ctr">
               <a:defRPr sz="3300" b="1" i="0">
                 <a:solidFill>
-                  <a:srgbClr val="006B28"/>
+                  <a:srgbClr val="6B173D"/>
                 </a:solidFill>
               </a:defRPr>
             </a:pPr>
             <a:r>
               <a:rPr sz="3300" b="1" i="0">
                 <a:solidFill>
-                  <a:srgbClr val="006B28"/>
+                  <a:srgbClr val="6B173D"/>
                 </a:solidFill>
               </a:rPr>
               <a:t>GLM</a:t>
@@ -22733,7 +22733,7 @@
           <p:cNvPr id="4" name="">
             <a:extLst xmlns:a="http://schemas.openxmlformats.org/drawingml/2006/main">
               <a:ext uri="{FF2B5EF4-FFF2-40B4-BE49-F238E27FC236}">
-                <a16:creationId xmlns:a16="http://schemas.microsoft.com/office/drawing/2014/main" id="{187710E2-0307-4744-AC1B-524FB46E2202}"/>
+                <a16:creationId xmlns:a16="http://schemas.microsoft.com/office/drawing/2014/main" id="{17C7084A-BA41-4C5E-9642-9A4FD588DB6F}"/>
               </a:ext>
             </a:extLst>
           </p:cNvPr>
@@ -22753,7 +22753,7 @@
           <a:noFill xmlns:a="http://schemas.openxmlformats.org/drawingml/2006/main"/>
           <a:ln xmlns:a="http://schemas.openxmlformats.org/drawingml/2006/main" w="28575">
             <a:solidFill>
-              <a:srgbClr val="08A000"/>
+              <a:srgbClr val="6B173D"/>
             </a:solidFill>
             <a:prstDash val="solid"/>
           </a:ln>
@@ -22764,7 +22764,7 @@
           <p:cNvPr id="5" name="">
             <a:extLst xmlns:a="http://schemas.openxmlformats.org/drawingml/2006/main">
               <a:ext uri="{FF2B5EF4-FFF2-40B4-BE49-F238E27FC236}">
-                <a16:creationId xmlns:a16="http://schemas.microsoft.com/office/drawing/2014/main" id="{88B86593-9EC1-4174-80A6-669909B46B3E}"/>
+                <a16:creationId xmlns:a16="http://schemas.microsoft.com/office/drawing/2014/main" id="{FABA67E0-DB1D-4F4F-B159-C6EA3ACA48DF}"/>
               </a:ext>
             </a:extLst>
           </p:cNvPr>
@@ -22814,7 +22814,7 @@
           <p:cNvPr id="6" name="">
             <a:extLst xmlns:a="http://schemas.openxmlformats.org/drawingml/2006/main">
               <a:ext uri="{FF2B5EF4-FFF2-40B4-BE49-F238E27FC236}">
-                <a16:creationId xmlns:a16="http://schemas.microsoft.com/office/drawing/2014/main" id="{8401C3D8-88B0-469B-B7D7-F3C40DF184CC}"/>
+                <a16:creationId xmlns:a16="http://schemas.microsoft.com/office/drawing/2014/main" id="{AB9126E6-A5C5-4D19-91B8-D4734EC6FE3A}"/>
               </a:ext>
             </a:extLst>
           </p:cNvPr>
@@ -22864,7 +22864,7 @@
           <p:cNvPr id="7" name="">
             <a:extLst xmlns:a="http://schemas.openxmlformats.org/drawingml/2006/main">
               <a:ext uri="{FF2B5EF4-FFF2-40B4-BE49-F238E27FC236}">
-                <a16:creationId xmlns:a16="http://schemas.microsoft.com/office/drawing/2014/main" id="{2F04D2EB-240E-460D-8ABB-F48F1CBADE69}"/>
+                <a16:creationId xmlns:a16="http://schemas.microsoft.com/office/drawing/2014/main" id="{C39CD09E-F518-4B26-8906-1B1004F84A75}"/>
               </a:ext>
             </a:extLst>
           </p:cNvPr>
@@ -22894,14 +22894,14 @@
             <a:pPr algn="ctr">
               <a:defRPr sz="3300" b="1" i="0">
                 <a:solidFill>
-                  <a:srgbClr val="006B28"/>
+                  <a:srgbClr val="6B173D"/>
                 </a:solidFill>
               </a:defRPr>
             </a:pPr>
             <a:r>
               <a:rPr sz="3300" b="1" i="0">
                 <a:solidFill>
-                  <a:srgbClr val="006B28"/>
+                  <a:srgbClr val="6B173D"/>
                 </a:solidFill>
               </a:rPr>
               <a:t>GBM</a:t>
@@ -22914,7 +22914,7 @@
           <p:cNvPr id="8" name="">
             <a:extLst xmlns:a="http://schemas.openxmlformats.org/drawingml/2006/main">
               <a:ext uri="{FF2B5EF4-FFF2-40B4-BE49-F238E27FC236}">
-                <a16:creationId xmlns:a16="http://schemas.microsoft.com/office/drawing/2014/main" id="{D59AFB9D-BB38-4638-B519-4A0BA4753B45}"/>
+                <a16:creationId xmlns:a16="http://schemas.microsoft.com/office/drawing/2014/main" id="{7040BD51-EE51-45B6-8E66-8BB74279D60F}"/>
               </a:ext>
             </a:extLst>
           </p:cNvPr>
@@ -22934,7 +22934,7 @@
           <a:noFill xmlns:a="http://schemas.openxmlformats.org/drawingml/2006/main"/>
           <a:ln xmlns:a="http://schemas.openxmlformats.org/drawingml/2006/main" w="28575">
             <a:solidFill>
-              <a:srgbClr val="08A000"/>
+              <a:srgbClr val="6B173D"/>
             </a:solidFill>
             <a:prstDash val="solid"/>
           </a:ln>
@@ -22945,7 +22945,7 @@
           <p:cNvPr id="9" name="">
             <a:extLst xmlns:a="http://schemas.openxmlformats.org/drawingml/2006/main">
               <a:ext uri="{FF2B5EF4-FFF2-40B4-BE49-F238E27FC236}">
-                <a16:creationId xmlns:a16="http://schemas.microsoft.com/office/drawing/2014/main" id="{00D94BB6-5217-4EA2-8666-7113F90D9FB7}"/>
+                <a16:creationId xmlns:a16="http://schemas.microsoft.com/office/drawing/2014/main" id="{35C1F0EB-2CB2-4A60-8572-9358BF53D05D}"/>
               </a:ext>
             </a:extLst>
           </p:cNvPr>
@@ -22995,7 +22995,7 @@
           <p:cNvPr id="10" name="">
             <a:extLst xmlns:a="http://schemas.openxmlformats.org/drawingml/2006/main">
               <a:ext uri="{FF2B5EF4-FFF2-40B4-BE49-F238E27FC236}">
-                <a16:creationId xmlns:a16="http://schemas.microsoft.com/office/drawing/2014/main" id="{2A0D8A7A-9595-42EF-BC20-DB7D869D77D8}"/>
+                <a16:creationId xmlns:a16="http://schemas.microsoft.com/office/drawing/2014/main" id="{CBC824FA-DAB5-4B27-9ED4-306DFA1909AD}"/>
               </a:ext>
             </a:extLst>
           </p:cNvPr>
@@ -23045,7 +23045,7 @@
           <p:cNvPr id="11" name="">
             <a:extLst xmlns:a="http://schemas.openxmlformats.org/drawingml/2006/main">
               <a:ext uri="{FF2B5EF4-FFF2-40B4-BE49-F238E27FC236}">
-                <a16:creationId xmlns:a16="http://schemas.microsoft.com/office/drawing/2014/main" id="{5EA189C4-F81D-4A7B-A9F1-8886F6ECFAEA}"/>
+                <a16:creationId xmlns:a16="http://schemas.microsoft.com/office/drawing/2014/main" id="{A503EAF5-703D-4196-A6B7-3FACA4A4FD71}"/>
               </a:ext>
             </a:extLst>
           </p:cNvPr>
@@ -23075,14 +23075,14 @@
             <a:pPr algn="ctr">
               <a:defRPr sz="3300" b="1" i="0">
                 <a:solidFill>
-                  <a:srgbClr val="006B28"/>
+                  <a:srgbClr val="6B173D"/>
                 </a:solidFill>
               </a:defRPr>
             </a:pPr>
             <a:r>
               <a:rPr sz="3300" b="1" i="0">
                 <a:solidFill>
-                  <a:srgbClr val="006B28"/>
+                  <a:srgbClr val="6B173D"/>
                 </a:solidFill>
               </a:rPr>
               <a:t>RF</a:t>
@@ -23095,7 +23095,7 @@
           <p:cNvPr id="12" name="">
             <a:extLst xmlns:a="http://schemas.openxmlformats.org/drawingml/2006/main">
               <a:ext uri="{FF2B5EF4-FFF2-40B4-BE49-F238E27FC236}">
-                <a16:creationId xmlns:a16="http://schemas.microsoft.com/office/drawing/2014/main" id="{3F3B9903-3AE7-499A-8CFC-45A421A4F259}"/>
+                <a16:creationId xmlns:a16="http://schemas.microsoft.com/office/drawing/2014/main" id="{E04D62CF-21C0-4664-803C-2E74D6A8F073}"/>
               </a:ext>
             </a:extLst>
           </p:cNvPr>
@@ -23115,7 +23115,7 @@
           <a:noFill xmlns:a="http://schemas.openxmlformats.org/drawingml/2006/main"/>
           <a:ln xmlns:a="http://schemas.openxmlformats.org/drawingml/2006/main" w="28575">
             <a:solidFill>
-              <a:srgbClr val="08A000"/>
+              <a:srgbClr val="6B173D"/>
             </a:solidFill>
             <a:prstDash val="solid"/>
           </a:ln>
@@ -23126,7 +23126,7 @@
           <p:cNvPr id="13" name="">
             <a:extLst xmlns:a="http://schemas.openxmlformats.org/drawingml/2006/main">
               <a:ext uri="{FF2B5EF4-FFF2-40B4-BE49-F238E27FC236}">
-                <a16:creationId xmlns:a16="http://schemas.microsoft.com/office/drawing/2014/main" id="{C140F281-3B70-4384-BDCD-0AACEBCCCFC6}"/>
+                <a16:creationId xmlns:a16="http://schemas.microsoft.com/office/drawing/2014/main" id="{C49BE09D-3C16-401D-BC2E-BEF5C3B32023}"/>
               </a:ext>
             </a:extLst>
           </p:cNvPr>
@@ -23176,7 +23176,7 @@
           <p:cNvPr id="14" name="">
             <a:extLst xmlns:a="http://schemas.openxmlformats.org/drawingml/2006/main">
               <a:ext uri="{FF2B5EF4-FFF2-40B4-BE49-F238E27FC236}">
-                <a16:creationId xmlns:a16="http://schemas.microsoft.com/office/drawing/2014/main" id="{9EA9288F-9C61-4677-9DF8-CAB650071280}"/>
+                <a16:creationId xmlns:a16="http://schemas.microsoft.com/office/drawing/2014/main" id="{5C5B3626-97C5-4986-981E-3A261FBF8BB0}"/>
               </a:ext>
             </a:extLst>
           </p:cNvPr>
@@ -23224,7 +23224,7 @@
     </p:spTree>
     <p:extLst>
       <p:ext uri="{BB962C8B-B14F-4D97-AF65-F5344CB8AC3E}">
-        <p14:creationId xmlns:p14="http://schemas.microsoft.com/office/powerpoint/2010/main" val="1093942105"/>
+        <p14:creationId xmlns:p14="http://schemas.microsoft.com/office/powerpoint/2010/main" val="184329128"/>
       </p:ext>
     </p:extLst>
   </p:cSld>
@@ -23255,7 +23255,7 @@
           <p:cNvPr id="12" name="">
             <a:extLst xmlns:a="http://schemas.openxmlformats.org/drawingml/2006/main">
               <a:ext uri="{FF2B5EF4-FFF2-40B4-BE49-F238E27FC236}">
-                <a16:creationId xmlns:a16="http://schemas.microsoft.com/office/drawing/2014/main" id="{7FD7B951-7873-4979-BA06-3EC06CBFF15D}"/>
+                <a16:creationId xmlns:a16="http://schemas.microsoft.com/office/drawing/2014/main" id="{70EC76C5-251E-4974-BC30-D07F57B067A2}"/>
               </a:ext>
             </a:extLst>
           </p:cNvPr>
@@ -23285,14 +23285,14 @@
             <a:pPr algn="l">
               <a:defRPr sz="2550" b="1" i="0">
                 <a:solidFill>
-                  <a:srgbClr val="00132E"/>
+                  <a:srgbClr val="FFFFFF"/>
                 </a:solidFill>
               </a:defRPr>
             </a:pPr>
             <a:r>
               <a:rPr sz="2550" b="1" i="0">
                 <a:solidFill>
-                  <a:srgbClr val="00132E"/>
+                  <a:srgbClr val="FFFFFF"/>
                 </a:solidFill>
               </a:rPr>
               <a:t>Evaluation asks whether predictions generalise</a:t>
@@ -23305,7 +23305,7 @@
           <p:cNvPr id="2" name="">
             <a:extLst xmlns:a="http://schemas.openxmlformats.org/drawingml/2006/main">
               <a:ext uri="{FF2B5EF4-FFF2-40B4-BE49-F238E27FC236}">
-                <a16:creationId xmlns:a16="http://schemas.microsoft.com/office/drawing/2014/main" id="{412A32DE-E522-4311-A99B-EA84B7AD8087}"/>
+                <a16:creationId xmlns:a16="http://schemas.microsoft.com/office/drawing/2014/main" id="{A67A147E-3A75-4A61-A25A-359A2950207D}"/>
               </a:ext>
             </a:extLst>
           </p:cNvPr>
@@ -23335,14 +23335,14 @@
             <a:pPr algn="l">
               <a:defRPr sz="1350" b="0" i="0">
                 <a:solidFill>
-                  <a:srgbClr val="111111"/>
+                  <a:srgbClr val="FFFFFF"/>
                 </a:solidFill>
               </a:defRPr>
             </a:pPr>
             <a:r>
               <a:rPr sz="1350" b="0" i="0">
                 <a:solidFill>
-                  <a:srgbClr val="111111"/>
+                  <a:srgbClr val="FFFFFF"/>
                 </a:solidFill>
               </a:rPr>
               <a:t>Good scores make the model worth inspecting. They do not make the map true.</a:t>
@@ -23355,7 +23355,7 @@
           <p:cNvPr id="3" name="">
             <a:extLst xmlns:a="http://schemas.openxmlformats.org/drawingml/2006/main">
               <a:ext uri="{FF2B5EF4-FFF2-40B4-BE49-F238E27FC236}">
-                <a16:creationId xmlns:a16="http://schemas.microsoft.com/office/drawing/2014/main" id="{88A85ED8-56D1-40B8-8646-5063086FC68D}"/>
+                <a16:creationId xmlns:a16="http://schemas.microsoft.com/office/drawing/2014/main" id="{8FCACF2B-554E-4F28-89C8-CF68C12CC811}"/>
               </a:ext>
             </a:extLst>
           </p:cNvPr>
@@ -23385,14 +23385,14 @@
             <a:pPr algn="ctr">
               <a:defRPr sz="1875" b="1" i="0">
                 <a:solidFill>
-                  <a:srgbClr val="006B28"/>
+                  <a:srgbClr val="6B173D"/>
                 </a:solidFill>
               </a:defRPr>
             </a:pPr>
             <a:r>
               <a:rPr sz="1875" b="1" i="0">
                 <a:solidFill>
-                  <a:srgbClr val="006B28"/>
+                  <a:srgbClr val="6B173D"/>
                 </a:solidFill>
               </a:rPr>
               <a:t>Training data</a:t>
@@ -23405,7 +23405,7 @@
           <p:cNvPr id="4" name="">
             <a:extLst xmlns:a="http://schemas.openxmlformats.org/drawingml/2006/main">
               <a:ext uri="{FF2B5EF4-FFF2-40B4-BE49-F238E27FC236}">
-                <a16:creationId xmlns:a16="http://schemas.microsoft.com/office/drawing/2014/main" id="{ACA006C2-B787-46B4-A7CD-9FD5358809E8}"/>
+                <a16:creationId xmlns:a16="http://schemas.microsoft.com/office/drawing/2014/main" id="{3F9CE381-336D-4A3A-BAC9-5905901BB7DE}"/>
               </a:ext>
             </a:extLst>
           </p:cNvPr>
@@ -23423,7 +23423,7 @@
             <a:avLst/>
           </a:prstGeom>
           <a:solidFill xmlns:a="http://schemas.openxmlformats.org/drawingml/2006/main">
-            <a:srgbClr val="08A000"/>
+            <a:srgbClr val="6B173D"/>
           </a:solidFill>
           <a:ln xmlns:a="http://schemas.openxmlformats.org/drawingml/2006/main" w="0">
             <a:noFill/>
@@ -23436,7 +23436,7 @@
           <p:cNvPr id="5" name="">
             <a:extLst xmlns:a="http://schemas.openxmlformats.org/drawingml/2006/main">
               <a:ext uri="{FF2B5EF4-FFF2-40B4-BE49-F238E27FC236}">
-                <a16:creationId xmlns:a16="http://schemas.microsoft.com/office/drawing/2014/main" id="{238B7672-CB4E-487D-9FA3-6D3B2DBB5C78}"/>
+                <a16:creationId xmlns:a16="http://schemas.microsoft.com/office/drawing/2014/main" id="{9F19EEBA-5A65-4A4C-B581-8FA8508EA6E3}"/>
               </a:ext>
             </a:extLst>
           </p:cNvPr>
@@ -23486,7 +23486,7 @@
           <p:cNvPr id="6" name="">
             <a:extLst xmlns:a="http://schemas.openxmlformats.org/drawingml/2006/main">
               <a:ext uri="{FF2B5EF4-FFF2-40B4-BE49-F238E27FC236}">
-                <a16:creationId xmlns:a16="http://schemas.microsoft.com/office/drawing/2014/main" id="{9210CCB1-974E-497F-8704-8C252ECB9E20}"/>
+                <a16:creationId xmlns:a16="http://schemas.microsoft.com/office/drawing/2014/main" id="{2888033E-0EF9-4DEF-BF93-737F96C02261}"/>
               </a:ext>
             </a:extLst>
           </p:cNvPr>
@@ -23504,7 +23504,7 @@
             <a:avLst/>
           </a:prstGeom>
           <a:solidFill xmlns:a="http://schemas.openxmlformats.org/drawingml/2006/main">
-            <a:srgbClr val="08A000"/>
+            <a:srgbClr val="6B173D"/>
           </a:solidFill>
           <a:ln xmlns:a="http://schemas.openxmlformats.org/drawingml/2006/main" w="0">
             <a:noFill/>
@@ -23517,7 +23517,7 @@
           <p:cNvPr id="7" name="">
             <a:extLst xmlns:a="http://schemas.openxmlformats.org/drawingml/2006/main">
               <a:ext uri="{FF2B5EF4-FFF2-40B4-BE49-F238E27FC236}">
-                <a16:creationId xmlns:a16="http://schemas.microsoft.com/office/drawing/2014/main" id="{D558EEF9-06E5-45F9-AB57-6B4FDD7C03EA}"/>
+                <a16:creationId xmlns:a16="http://schemas.microsoft.com/office/drawing/2014/main" id="{01853A83-0E62-4B9D-A85C-BA56075E1EE0}"/>
               </a:ext>
             </a:extLst>
           </p:cNvPr>
@@ -23547,14 +23547,14 @@
             <a:pPr algn="ctr">
               <a:defRPr sz="1875" b="1" i="0">
                 <a:solidFill>
-                  <a:srgbClr val="006B28"/>
+                  <a:srgbClr val="6B173D"/>
                 </a:solidFill>
               </a:defRPr>
             </a:pPr>
             <a:r>
               <a:rPr sz="1875" b="1" i="0">
                 <a:solidFill>
-                  <a:srgbClr val="006B28"/>
+                  <a:srgbClr val="6B173D"/>
                 </a:solidFill>
               </a:rPr>
               <a:t>Test data</a:t>
@@ -23567,7 +23567,7 @@
           <p:cNvPr id="8" name="">
             <a:extLst xmlns:a="http://schemas.openxmlformats.org/drawingml/2006/main">
               <a:ext uri="{FF2B5EF4-FFF2-40B4-BE49-F238E27FC236}">
-                <a16:creationId xmlns:a16="http://schemas.microsoft.com/office/drawing/2014/main" id="{A69F80AF-B05F-4C85-AF10-38011D7A8395}"/>
+                <a16:creationId xmlns:a16="http://schemas.microsoft.com/office/drawing/2014/main" id="{93075CF1-336B-4BCF-99D6-01CD8169F81D}"/>
               </a:ext>
             </a:extLst>
           </p:cNvPr>
@@ -23617,7 +23617,7 @@
           <p:cNvPr id="9" name="">
             <a:extLst xmlns:a="http://schemas.openxmlformats.org/drawingml/2006/main">
               <a:ext uri="{FF2B5EF4-FFF2-40B4-BE49-F238E27FC236}">
-                <a16:creationId xmlns:a16="http://schemas.microsoft.com/office/drawing/2014/main" id="{67BBDF21-CFF8-490C-874E-84110CB501AB}"/>
+                <a16:creationId xmlns:a16="http://schemas.microsoft.com/office/drawing/2014/main" id="{A2C6F7C3-98AA-4D06-9B59-C9D801A6FE31}"/>
               </a:ext>
             </a:extLst>
           </p:cNvPr>
@@ -23667,7 +23667,7 @@
           <p:cNvPr id="10" name="">
             <a:extLst xmlns:a="http://schemas.openxmlformats.org/drawingml/2006/main">
               <a:ext uri="{FF2B5EF4-FFF2-40B4-BE49-F238E27FC236}">
-                <a16:creationId xmlns:a16="http://schemas.microsoft.com/office/drawing/2014/main" id="{AB503CD4-FD66-4C1F-8C46-4E0A86E0616A}"/>
+                <a16:creationId xmlns:a16="http://schemas.microsoft.com/office/drawing/2014/main" id="{CA95DD61-C217-48B3-8DFB-9B84503B24E4}"/>
               </a:ext>
             </a:extLst>
           </p:cNvPr>
@@ -23717,7 +23717,7 @@
           <p:cNvPr id="11" name="">
             <a:extLst xmlns:a="http://schemas.openxmlformats.org/drawingml/2006/main">
               <a:ext uri="{FF2B5EF4-FFF2-40B4-BE49-F238E27FC236}">
-                <a16:creationId xmlns:a16="http://schemas.microsoft.com/office/drawing/2014/main" id="{23F34C73-06C9-41C5-8030-53E6999254AD}"/>
+                <a16:creationId xmlns:a16="http://schemas.microsoft.com/office/drawing/2014/main" id="{2DBAC69A-F188-43AD-A00A-D7907AF068EF}"/>
               </a:ext>
             </a:extLst>
           </p:cNvPr>
@@ -23765,7 +23765,7 @@
     </p:spTree>
     <p:extLst>
       <p:ext uri="{BB962C8B-B14F-4D97-AF65-F5344CB8AC3E}">
-        <p14:creationId xmlns:p14="http://schemas.microsoft.com/office/powerpoint/2010/main" val="1093942105"/>
+        <p14:creationId xmlns:p14="http://schemas.microsoft.com/office/powerpoint/2010/main" val="184329128"/>
       </p:ext>
     </p:extLst>
   </p:cSld>
@@ -23789,13 +23789,13 @@
         <a:srgbClr val="FFFFFF"/>
       </a:lt2>
       <a:accent1>
-        <a:srgbClr val="18A303"/>
+        <a:srgbClr val="6B173D"/>
       </a:accent1>
       <a:accent2>
-        <a:srgbClr val="0369A3"/>
+        <a:srgbClr val="B79961"/>
       </a:accent2>
       <a:accent3>
-        <a:srgbClr val="A33E03"/>
+        <a:srgbClr val="B79961"/>
       </a:accent3>
       <a:accent4>
         <a:srgbClr val="8E03A3"/>

</xml_diff>